<commit_message>
Upgrade decks to eight slides each
</commit_message>
<xml_diff>
--- a/uganda-p7-mvp/p7_t1_christian_religious_education_0101/p7_t1_christian_religious_education_0101.pptx
+++ b/uganda-p7-mvp/p7_t1_christian_religious_education_0101/p7_t1_christian_religious_education_0101.pptx
@@ -11,6 +11,8 @@
     <p:sldId id="259" r:id="rId10"/>
     <p:sldId id="260" r:id="rId11"/>
     <p:sldId id="261" r:id="rId12"/>
+    <p:sldId id="262" r:id="rId13"/>
+    <p:sldId id="263" r:id="rId14"/>
   </p:sldIdLst>
   <p:sldSz cx="12191695" cy="6858000" type="screen4x3"/>
   <p:notesSz cx="6858000" cy="9144000"/>
@@ -3209,7 +3211,7 @@
           <a:p>
             <a:r>
               <a:rPr sz="3000" b="1"/>
-              <a:t>What is a Spirit?</a:t>
+              <a:t>Learning goal</a:t>
             </a:r>
           </a:p>
         </p:txBody>
@@ -3243,7 +3245,7 @@
               <a:defRPr sz="2200"/>
             </a:pPr>
             <a:r>
-              <a:t>A spirit is invisible.</a:t>
+              <a:t>By the end of the lesson, learners will be able to define the Holy Spirit and</a:t>
             </a:r>
           </a:p>
           <a:p>
@@ -3254,7 +3256,7 @@
               <a:defRPr sz="2200"/>
             </a:pPr>
             <a:r>
-              <a:t>We see the effects of a spirit, like we see wind moving trees.</a:t>
+              <a:t>recognize Him as the third person of the Trinity.</a:t>
             </a:r>
           </a:p>
           <a:p>
@@ -3265,7 +3267,18 @@
               <a:defRPr sz="2200"/>
             </a:pPr>
             <a:r>
-              <a:t>The Spirit is the "breath" of God.</a:t>
+              <a:t>Key words: Vocabulary: Trinity, Spirit, Person, Godhead.</a:t>
+            </a:r>
+          </a:p>
+          <a:p>
+            <a:pPr>
+              <a:spcAft>
+                <a:spcPts val="800"/>
+              </a:spcAft>
+              <a:defRPr sz="2200"/>
+            </a:pPr>
+            <a:r>
+              <a:t>Lesson focus: Christians and the Holy Spirit (Topic 1: Enriched in the Spirit)</a:t>
             </a:r>
           </a:p>
         </p:txBody>
@@ -3312,7 +3325,7 @@
           <a:p>
             <a:r>
               <a:rPr sz="3000" b="1"/>
-              <a:t>Defining the Holy Spirit</a:t>
+              <a:t>What is a Spirit?</a:t>
             </a:r>
           </a:p>
         </p:txBody>
@@ -3346,7 +3359,7 @@
               <a:defRPr sz="2200"/>
             </a:pPr>
             <a:r>
-              <a:t>The Holy Spirit is God in us.</a:t>
+              <a:t>A spirit is invisible.</a:t>
             </a:r>
           </a:p>
           <a:p>
@@ -3357,7 +3370,7 @@
               <a:defRPr sz="2200"/>
             </a:pPr>
             <a:r>
-              <a:t>He is our greatest gift.</a:t>
+              <a:t>We see the effects of a spirit, like we see wind moving trees.</a:t>
             </a:r>
           </a:p>
           <a:p>
@@ -3368,7 +3381,7 @@
               <a:defRPr sz="2200"/>
             </a:pPr>
             <a:r>
-              <a:t>He is the Spirit of truth and love.</a:t>
+              <a:t>The Spirit is the "breath" of God.</a:t>
             </a:r>
           </a:p>
         </p:txBody>
@@ -3415,7 +3428,7 @@
           <a:p>
             <a:r>
               <a:rPr sz="3000" b="1"/>
-              <a:t>The Holy Trinity</a:t>
+              <a:t>Defining the Holy Spirit</a:t>
             </a:r>
           </a:p>
         </p:txBody>
@@ -3449,7 +3462,7 @@
               <a:defRPr sz="2200"/>
             </a:pPr>
             <a:r>
-              <a:t>Trinity means "Three in One."</a:t>
+              <a:t>The Holy Spirit is God in us.</a:t>
             </a:r>
           </a:p>
           <a:p>
@@ -3460,7 +3473,7 @@
               <a:defRPr sz="2200"/>
             </a:pPr>
             <a:r>
-              <a:t>1st Person: God the Father (Creator).</a:t>
+              <a:t>He is our greatest gift.</a:t>
             </a:r>
           </a:p>
           <a:p>
@@ -3471,18 +3484,7 @@
               <a:defRPr sz="2200"/>
             </a:pPr>
             <a:r>
-              <a:t>2nd Person: God the Son (Redeemer).</a:t>
-            </a:r>
-          </a:p>
-          <a:p>
-            <a:pPr>
-              <a:spcAft>
-                <a:spcPts val="800"/>
-              </a:spcAft>
-              <a:defRPr sz="2200"/>
-            </a:pPr>
-            <a:r>
-              <a:t>3rd Person: God the Holy Spirit (Helper).</a:t>
+              <a:t>He is the Spirit of truth and love.</a:t>
             </a:r>
           </a:p>
         </p:txBody>
@@ -3529,7 +3531,7 @@
           <a:p>
             <a:r>
               <a:rPr sz="3000" b="1"/>
-              <a:t>One God, Three Persons</a:t>
+              <a:t>The Holy Trinity</a:t>
             </a:r>
           </a:p>
         </p:txBody>
@@ -3563,7 +3565,7 @@
               <a:defRPr sz="2200"/>
             </a:pPr>
             <a:r>
-              <a:t>All three persons are equal.</a:t>
+              <a:t>Trinity means "Three in One."</a:t>
             </a:r>
           </a:p>
           <a:p>
@@ -3574,7 +3576,7 @@
               <a:defRPr sz="2200"/>
             </a:pPr>
             <a:r>
-              <a:t>They work together in unity.</a:t>
+              <a:t>1st Person: God the Father (Creator).</a:t>
             </a:r>
           </a:p>
           <a:p>
@@ -3585,7 +3587,18 @@
               <a:defRPr sz="2200"/>
             </a:pPr>
             <a:r>
-              <a:t>The Holy Spirit is fully God.</a:t>
+              <a:t>2nd Person: God the Son (Redeemer).</a:t>
+            </a:r>
+          </a:p>
+          <a:p>
+            <a:pPr>
+              <a:spcAft>
+                <a:spcPts val="800"/>
+              </a:spcAft>
+              <a:defRPr sz="2200"/>
+            </a:pPr>
+            <a:r>
+              <a:t>3rd Person: God the Holy Spirit (Helper).</a:t>
             </a:r>
           </a:p>
         </p:txBody>
@@ -3632,7 +3645,7 @@
           <a:p>
             <a:r>
               <a:rPr sz="3000" b="1"/>
-              <a:t>Lesson Summary</a:t>
+              <a:t>One God, Three Persons</a:t>
             </a:r>
           </a:p>
         </p:txBody>
@@ -3666,7 +3679,7 @@
               <a:defRPr sz="2200"/>
             </a:pPr>
             <a:r>
-              <a:t>Definition of Holy Spirit.</a:t>
+              <a:t>All three persons are equal.</a:t>
             </a:r>
           </a:p>
           <a:p>
@@ -3677,7 +3690,7 @@
               <a:defRPr sz="2200"/>
             </a:pPr>
             <a:r>
-              <a:t>The Trinity Structure.</a:t>
+              <a:t>They work together in unity.</a:t>
             </a:r>
           </a:p>
           <a:p>
@@ -3688,7 +3701,235 @@
               <a:defRPr sz="2200"/>
             </a:pPr>
             <a:r>
+              <a:t>The Holy Spirit is fully God.</a:t>
+            </a:r>
+          </a:p>
+        </p:txBody>
+      </p:sp>
+    </p:spTree>
+  </p:cSld>
+  <p:clrMapOvr>
+    <a:masterClrMapping/>
+  </p:clrMapOvr>
+</p:sld>
+</file>
+
+<file path=ppt/slides/slide7.xml><?xml version="1.0" encoding="utf-8"?>
+<p:sld xmlns:a="http://schemas.openxmlformats.org/drawingml/2006/main" xmlns:p="http://schemas.openxmlformats.org/presentationml/2006/main" xmlns:r="http://schemas.openxmlformats.org/officeDocument/2006/relationships">
+  <p:cSld>
+    <p:spTree>
+      <p:nvGrpSpPr>
+        <p:cNvPr id="1" name=""/>
+        <p:cNvGrpSpPr/>
+        <p:nvPr/>
+      </p:nvGrpSpPr>
+      <p:grpSpPr/>
+      <p:sp>
+        <p:nvSpPr>
+          <p:cNvPr id="2" name="TextBox 1"/>
+          <p:cNvSpPr txBox="1"/>
+          <p:nvPr/>
+        </p:nvSpPr>
+        <p:spPr>
+          <a:xfrm>
+            <a:off x="548640" y="320040"/>
+            <a:ext cx="11064240" cy="777240"/>
+          </a:xfrm>
+          <a:prstGeom prst="rect">
+            <a:avLst/>
+          </a:prstGeom>
+          <a:noFill/>
+        </p:spPr>
+        <p:txBody>
+          <a:bodyPr wrap="none">
+            <a:spAutoFit/>
+          </a:bodyPr>
+          <a:lstStyle/>
+          <a:p>
+            <a:r>
+              <a:rPr sz="3000" b="1"/>
+              <a:t>Lesson Summary</a:t>
+            </a:r>
+          </a:p>
+        </p:txBody>
+      </p:sp>
+      <p:sp>
+        <p:nvSpPr>
+          <p:cNvPr id="3" name="TextBox 2"/>
+          <p:cNvSpPr txBox="1"/>
+          <p:nvPr/>
+        </p:nvSpPr>
+        <p:spPr>
+          <a:xfrm>
+            <a:off x="868680" y="1417320"/>
+            <a:ext cx="10424160" cy="4892040"/>
+          </a:xfrm>
+          <a:prstGeom prst="rect">
+            <a:avLst/>
+          </a:prstGeom>
+          <a:noFill/>
+        </p:spPr>
+        <p:txBody>
+          <a:bodyPr wrap="square">
+            <a:spAutoFit/>
+          </a:bodyPr>
+          <a:lstStyle/>
+          <a:p>
+            <a:pPr>
+              <a:spcAft>
+                <a:spcPts val="800"/>
+              </a:spcAft>
+              <a:defRPr sz="2200"/>
+            </a:pPr>
+            <a:r>
+              <a:t>Definition of Holy Spirit.</a:t>
+            </a:r>
+          </a:p>
+          <a:p>
+            <a:pPr>
+              <a:spcAft>
+                <a:spcPts val="800"/>
+              </a:spcAft>
+              <a:defRPr sz="2200"/>
+            </a:pPr>
+            <a:r>
+              <a:t>The Trinity Structure.</a:t>
+            </a:r>
+          </a:p>
+          <a:p>
+            <a:pPr>
+              <a:spcAft>
+                <a:spcPts val="800"/>
+              </a:spcAft>
+              <a:defRPr sz="2200"/>
+            </a:pPr>
+            <a:r>
               <a:t>Our relationship with the Spirit.</a:t>
+            </a:r>
+          </a:p>
+        </p:txBody>
+      </p:sp>
+    </p:spTree>
+  </p:cSld>
+  <p:clrMapOvr>
+    <a:masterClrMapping/>
+  </p:clrMapOvr>
+</p:sld>
+</file>
+
+<file path=ppt/slides/slide8.xml><?xml version="1.0" encoding="utf-8"?>
+<p:sld xmlns:a="http://schemas.openxmlformats.org/drawingml/2006/main" xmlns:p="http://schemas.openxmlformats.org/presentationml/2006/main" xmlns:r="http://schemas.openxmlformats.org/officeDocument/2006/relationships">
+  <p:cSld>
+    <p:spTree>
+      <p:nvGrpSpPr>
+        <p:cNvPr id="1" name=""/>
+        <p:cNvGrpSpPr/>
+        <p:nvPr/>
+      </p:nvGrpSpPr>
+      <p:grpSpPr/>
+      <p:sp>
+        <p:nvSpPr>
+          <p:cNvPr id="2" name="TextBox 1"/>
+          <p:cNvSpPr txBox="1"/>
+          <p:nvPr/>
+        </p:nvSpPr>
+        <p:spPr>
+          <a:xfrm>
+            <a:off x="548640" y="320040"/>
+            <a:ext cx="11064240" cy="777240"/>
+          </a:xfrm>
+          <a:prstGeom prst="rect">
+            <a:avLst/>
+          </a:prstGeom>
+          <a:noFill/>
+        </p:spPr>
+        <p:txBody>
+          <a:bodyPr wrap="none">
+            <a:spAutoFit/>
+          </a:bodyPr>
+          <a:lstStyle/>
+          <a:p>
+            <a:r>
+              <a:rPr sz="3000" b="1"/>
+              <a:t>Check your understanding</a:t>
+            </a:r>
+          </a:p>
+        </p:txBody>
+      </p:sp>
+      <p:sp>
+        <p:nvSpPr>
+          <p:cNvPr id="3" name="TextBox 2"/>
+          <p:cNvSpPr txBox="1"/>
+          <p:nvPr/>
+        </p:nvSpPr>
+        <p:spPr>
+          <a:xfrm>
+            <a:off x="868680" y="1417320"/>
+            <a:ext cx="10424160" cy="4892040"/>
+          </a:xfrm>
+          <a:prstGeom prst="rect">
+            <a:avLst/>
+          </a:prstGeom>
+          <a:noFill/>
+        </p:spPr>
+        <p:txBody>
+          <a:bodyPr wrap="square">
+            <a:spAutoFit/>
+          </a:bodyPr>
+          <a:lstStyle/>
+          <a:p>
+            <a:pPr>
+              <a:spcAft>
+                <a:spcPts val="800"/>
+              </a:spcAft>
+              <a:defRPr sz="2200"/>
+            </a:pPr>
+            <a:r>
+              <a:t>How do you know the wind is there?</a:t>
+            </a:r>
+          </a:p>
+          <a:p>
+            <a:pPr>
+              <a:spcAft>
+                <a:spcPts val="800"/>
+              </a:spcAft>
+              <a:defRPr sz="2200"/>
+            </a:pPr>
+            <a:r>
+              <a:t>Is God visible to our physical eyes?</a:t>
+            </a:r>
+          </a:p>
+          <a:p>
+            <a:pPr>
+              <a:spcAft>
+                <a:spcPts val="800"/>
+              </a:spcAft>
+              <a:defRPr sz="2200"/>
+            </a:pPr>
+            <a:r>
+              <a:t>Who is the Holy Spirit?</a:t>
+            </a:r>
+          </a:p>
+          <a:p>
+            <a:pPr>
+              <a:spcAft>
+                <a:spcPts val="800"/>
+              </a:spcAft>
+              <a:defRPr sz="2200"/>
+            </a:pPr>
+            <a:r>
+              <a:t>Why is He called the greatest gift?</a:t>
+            </a:r>
+          </a:p>
+          <a:p>
+            <a:pPr>
+              <a:spcAft>
+                <a:spcPts val="800"/>
+              </a:spcAft>
+              <a:defRPr sz="2200"/>
+            </a:pPr>
+            <a:r>
+              <a:t>Write one answer clearly in your notebook.</a:t>
             </a:r>
           </a:p>
         </p:txBody>

</xml_diff>

<commit_message>
Publish eight-slide classroom decks
</commit_message>
<xml_diff>
--- a/uganda-p7-mvp/p7_t1_christian_religious_education_0101/p7_t1_christian_religious_education_0101.pptx
+++ b/uganda-p7-mvp/p7_t1_christian_religious_education_0101/p7_t1_christian_religious_education_0101.pptx
@@ -11,6 +11,8 @@
     <p:sldId id="259" r:id="rId10"/>
     <p:sldId id="260" r:id="rId11"/>
     <p:sldId id="261" r:id="rId12"/>
+    <p:sldId id="262" r:id="rId13"/>
+    <p:sldId id="263" r:id="rId14"/>
   </p:sldIdLst>
   <p:sldSz cx="12191695" cy="6858000" type="screen4x3"/>
   <p:notesSz cx="6858000" cy="9144000"/>
@@ -3209,7 +3211,7 @@
           <a:p>
             <a:r>
               <a:rPr sz="3000" b="1"/>
-              <a:t>What is a Spirit?</a:t>
+              <a:t>Learning goal</a:t>
             </a:r>
           </a:p>
         </p:txBody>
@@ -3243,7 +3245,7 @@
               <a:defRPr sz="2200"/>
             </a:pPr>
             <a:r>
-              <a:t>A spirit is invisible.</a:t>
+              <a:t>By the end of the lesson, learners will be able to define the Holy Spirit and</a:t>
             </a:r>
           </a:p>
           <a:p>
@@ -3254,7 +3256,7 @@
               <a:defRPr sz="2200"/>
             </a:pPr>
             <a:r>
-              <a:t>We see the effects of a spirit, like we see wind moving trees.</a:t>
+              <a:t>recognize Him as the third person of the Trinity.</a:t>
             </a:r>
           </a:p>
           <a:p>
@@ -3265,7 +3267,18 @@
               <a:defRPr sz="2200"/>
             </a:pPr>
             <a:r>
-              <a:t>The Spirit is the "breath" of God.</a:t>
+              <a:t>Key words: Vocabulary: Trinity, Spirit, Person, Godhead.</a:t>
+            </a:r>
+          </a:p>
+          <a:p>
+            <a:pPr>
+              <a:spcAft>
+                <a:spcPts val="800"/>
+              </a:spcAft>
+              <a:defRPr sz="2200"/>
+            </a:pPr>
+            <a:r>
+              <a:t>Lesson focus: Christians and the Holy Spirit (Topic 1: Enriched in the Spirit)</a:t>
             </a:r>
           </a:p>
         </p:txBody>
@@ -3312,7 +3325,7 @@
           <a:p>
             <a:r>
               <a:rPr sz="3000" b="1"/>
-              <a:t>Defining the Holy Spirit</a:t>
+              <a:t>What is a Spirit?</a:t>
             </a:r>
           </a:p>
         </p:txBody>
@@ -3346,7 +3359,7 @@
               <a:defRPr sz="2200"/>
             </a:pPr>
             <a:r>
-              <a:t>The Holy Spirit is God in us.</a:t>
+              <a:t>A spirit is invisible.</a:t>
             </a:r>
           </a:p>
           <a:p>
@@ -3357,7 +3370,7 @@
               <a:defRPr sz="2200"/>
             </a:pPr>
             <a:r>
-              <a:t>He is our greatest gift.</a:t>
+              <a:t>We see the effects of a spirit, like we see wind moving trees.</a:t>
             </a:r>
           </a:p>
           <a:p>
@@ -3368,7 +3381,7 @@
               <a:defRPr sz="2200"/>
             </a:pPr>
             <a:r>
-              <a:t>He is the Spirit of truth and love.</a:t>
+              <a:t>The Spirit is the "breath" of God.</a:t>
             </a:r>
           </a:p>
         </p:txBody>
@@ -3415,7 +3428,7 @@
           <a:p>
             <a:r>
               <a:rPr sz="3000" b="1"/>
-              <a:t>The Holy Trinity</a:t>
+              <a:t>Defining the Holy Spirit</a:t>
             </a:r>
           </a:p>
         </p:txBody>
@@ -3449,7 +3462,7 @@
               <a:defRPr sz="2200"/>
             </a:pPr>
             <a:r>
-              <a:t>Trinity means "Three in One."</a:t>
+              <a:t>The Holy Spirit is God in us.</a:t>
             </a:r>
           </a:p>
           <a:p>
@@ -3460,7 +3473,7 @@
               <a:defRPr sz="2200"/>
             </a:pPr>
             <a:r>
-              <a:t>1st Person: God the Father (Creator).</a:t>
+              <a:t>He is our greatest gift.</a:t>
             </a:r>
           </a:p>
           <a:p>
@@ -3471,18 +3484,7 @@
               <a:defRPr sz="2200"/>
             </a:pPr>
             <a:r>
-              <a:t>2nd Person: God the Son (Redeemer).</a:t>
-            </a:r>
-          </a:p>
-          <a:p>
-            <a:pPr>
-              <a:spcAft>
-                <a:spcPts val="800"/>
-              </a:spcAft>
-              <a:defRPr sz="2200"/>
-            </a:pPr>
-            <a:r>
-              <a:t>3rd Person: God the Holy Spirit (Helper).</a:t>
+              <a:t>He is the Spirit of truth and love.</a:t>
             </a:r>
           </a:p>
         </p:txBody>
@@ -3529,7 +3531,7 @@
           <a:p>
             <a:r>
               <a:rPr sz="3000" b="1"/>
-              <a:t>One God, Three Persons</a:t>
+              <a:t>The Holy Trinity</a:t>
             </a:r>
           </a:p>
         </p:txBody>
@@ -3563,7 +3565,7 @@
               <a:defRPr sz="2200"/>
             </a:pPr>
             <a:r>
-              <a:t>All three persons are equal.</a:t>
+              <a:t>Trinity means "Three in One."</a:t>
             </a:r>
           </a:p>
           <a:p>
@@ -3574,7 +3576,7 @@
               <a:defRPr sz="2200"/>
             </a:pPr>
             <a:r>
-              <a:t>They work together in unity.</a:t>
+              <a:t>1st Person: God the Father (Creator).</a:t>
             </a:r>
           </a:p>
           <a:p>
@@ -3585,7 +3587,18 @@
               <a:defRPr sz="2200"/>
             </a:pPr>
             <a:r>
-              <a:t>The Holy Spirit is fully God.</a:t>
+              <a:t>2nd Person: God the Son (Redeemer).</a:t>
+            </a:r>
+          </a:p>
+          <a:p>
+            <a:pPr>
+              <a:spcAft>
+                <a:spcPts val="800"/>
+              </a:spcAft>
+              <a:defRPr sz="2200"/>
+            </a:pPr>
+            <a:r>
+              <a:t>3rd Person: God the Holy Spirit (Helper).</a:t>
             </a:r>
           </a:p>
         </p:txBody>
@@ -3632,7 +3645,7 @@
           <a:p>
             <a:r>
               <a:rPr sz="3000" b="1"/>
-              <a:t>Lesson Summary</a:t>
+              <a:t>One God, Three Persons</a:t>
             </a:r>
           </a:p>
         </p:txBody>
@@ -3666,7 +3679,7 @@
               <a:defRPr sz="2200"/>
             </a:pPr>
             <a:r>
-              <a:t>Definition of Holy Spirit.</a:t>
+              <a:t>All three persons are equal.</a:t>
             </a:r>
           </a:p>
           <a:p>
@@ -3677,7 +3690,7 @@
               <a:defRPr sz="2200"/>
             </a:pPr>
             <a:r>
-              <a:t>The Trinity Structure.</a:t>
+              <a:t>They work together in unity.</a:t>
             </a:r>
           </a:p>
           <a:p>
@@ -3688,7 +3701,235 @@
               <a:defRPr sz="2200"/>
             </a:pPr>
             <a:r>
+              <a:t>The Holy Spirit is fully God.</a:t>
+            </a:r>
+          </a:p>
+        </p:txBody>
+      </p:sp>
+    </p:spTree>
+  </p:cSld>
+  <p:clrMapOvr>
+    <a:masterClrMapping/>
+  </p:clrMapOvr>
+</p:sld>
+</file>
+
+<file path=ppt/slides/slide7.xml><?xml version="1.0" encoding="utf-8"?>
+<p:sld xmlns:a="http://schemas.openxmlformats.org/drawingml/2006/main" xmlns:p="http://schemas.openxmlformats.org/presentationml/2006/main" xmlns:r="http://schemas.openxmlformats.org/officeDocument/2006/relationships">
+  <p:cSld>
+    <p:spTree>
+      <p:nvGrpSpPr>
+        <p:cNvPr id="1" name=""/>
+        <p:cNvGrpSpPr/>
+        <p:nvPr/>
+      </p:nvGrpSpPr>
+      <p:grpSpPr/>
+      <p:sp>
+        <p:nvSpPr>
+          <p:cNvPr id="2" name="TextBox 1"/>
+          <p:cNvSpPr txBox="1"/>
+          <p:nvPr/>
+        </p:nvSpPr>
+        <p:spPr>
+          <a:xfrm>
+            <a:off x="548640" y="320040"/>
+            <a:ext cx="11064240" cy="777240"/>
+          </a:xfrm>
+          <a:prstGeom prst="rect">
+            <a:avLst/>
+          </a:prstGeom>
+          <a:noFill/>
+        </p:spPr>
+        <p:txBody>
+          <a:bodyPr wrap="none">
+            <a:spAutoFit/>
+          </a:bodyPr>
+          <a:lstStyle/>
+          <a:p>
+            <a:r>
+              <a:rPr sz="3000" b="1"/>
+              <a:t>Lesson Summary</a:t>
+            </a:r>
+          </a:p>
+        </p:txBody>
+      </p:sp>
+      <p:sp>
+        <p:nvSpPr>
+          <p:cNvPr id="3" name="TextBox 2"/>
+          <p:cNvSpPr txBox="1"/>
+          <p:nvPr/>
+        </p:nvSpPr>
+        <p:spPr>
+          <a:xfrm>
+            <a:off x="868680" y="1417320"/>
+            <a:ext cx="10424160" cy="4892040"/>
+          </a:xfrm>
+          <a:prstGeom prst="rect">
+            <a:avLst/>
+          </a:prstGeom>
+          <a:noFill/>
+        </p:spPr>
+        <p:txBody>
+          <a:bodyPr wrap="square">
+            <a:spAutoFit/>
+          </a:bodyPr>
+          <a:lstStyle/>
+          <a:p>
+            <a:pPr>
+              <a:spcAft>
+                <a:spcPts val="800"/>
+              </a:spcAft>
+              <a:defRPr sz="2200"/>
+            </a:pPr>
+            <a:r>
+              <a:t>Definition of Holy Spirit.</a:t>
+            </a:r>
+          </a:p>
+          <a:p>
+            <a:pPr>
+              <a:spcAft>
+                <a:spcPts val="800"/>
+              </a:spcAft>
+              <a:defRPr sz="2200"/>
+            </a:pPr>
+            <a:r>
+              <a:t>The Trinity Structure.</a:t>
+            </a:r>
+          </a:p>
+          <a:p>
+            <a:pPr>
+              <a:spcAft>
+                <a:spcPts val="800"/>
+              </a:spcAft>
+              <a:defRPr sz="2200"/>
+            </a:pPr>
+            <a:r>
               <a:t>Our relationship with the Spirit.</a:t>
+            </a:r>
+          </a:p>
+        </p:txBody>
+      </p:sp>
+    </p:spTree>
+  </p:cSld>
+  <p:clrMapOvr>
+    <a:masterClrMapping/>
+  </p:clrMapOvr>
+</p:sld>
+</file>
+
+<file path=ppt/slides/slide8.xml><?xml version="1.0" encoding="utf-8"?>
+<p:sld xmlns:a="http://schemas.openxmlformats.org/drawingml/2006/main" xmlns:p="http://schemas.openxmlformats.org/presentationml/2006/main" xmlns:r="http://schemas.openxmlformats.org/officeDocument/2006/relationships">
+  <p:cSld>
+    <p:spTree>
+      <p:nvGrpSpPr>
+        <p:cNvPr id="1" name=""/>
+        <p:cNvGrpSpPr/>
+        <p:nvPr/>
+      </p:nvGrpSpPr>
+      <p:grpSpPr/>
+      <p:sp>
+        <p:nvSpPr>
+          <p:cNvPr id="2" name="TextBox 1"/>
+          <p:cNvSpPr txBox="1"/>
+          <p:nvPr/>
+        </p:nvSpPr>
+        <p:spPr>
+          <a:xfrm>
+            <a:off x="548640" y="320040"/>
+            <a:ext cx="11064240" cy="777240"/>
+          </a:xfrm>
+          <a:prstGeom prst="rect">
+            <a:avLst/>
+          </a:prstGeom>
+          <a:noFill/>
+        </p:spPr>
+        <p:txBody>
+          <a:bodyPr wrap="none">
+            <a:spAutoFit/>
+          </a:bodyPr>
+          <a:lstStyle/>
+          <a:p>
+            <a:r>
+              <a:rPr sz="3000" b="1"/>
+              <a:t>Check your understanding</a:t>
+            </a:r>
+          </a:p>
+        </p:txBody>
+      </p:sp>
+      <p:sp>
+        <p:nvSpPr>
+          <p:cNvPr id="3" name="TextBox 2"/>
+          <p:cNvSpPr txBox="1"/>
+          <p:nvPr/>
+        </p:nvSpPr>
+        <p:spPr>
+          <a:xfrm>
+            <a:off x="868680" y="1417320"/>
+            <a:ext cx="10424160" cy="4892040"/>
+          </a:xfrm>
+          <a:prstGeom prst="rect">
+            <a:avLst/>
+          </a:prstGeom>
+          <a:noFill/>
+        </p:spPr>
+        <p:txBody>
+          <a:bodyPr wrap="square">
+            <a:spAutoFit/>
+          </a:bodyPr>
+          <a:lstStyle/>
+          <a:p>
+            <a:pPr>
+              <a:spcAft>
+                <a:spcPts val="800"/>
+              </a:spcAft>
+              <a:defRPr sz="2200"/>
+            </a:pPr>
+            <a:r>
+              <a:t>How do you know the wind is there?</a:t>
+            </a:r>
+          </a:p>
+          <a:p>
+            <a:pPr>
+              <a:spcAft>
+                <a:spcPts val="800"/>
+              </a:spcAft>
+              <a:defRPr sz="2200"/>
+            </a:pPr>
+            <a:r>
+              <a:t>Is God visible to our physical eyes?</a:t>
+            </a:r>
+          </a:p>
+          <a:p>
+            <a:pPr>
+              <a:spcAft>
+                <a:spcPts val="800"/>
+              </a:spcAft>
+              <a:defRPr sz="2200"/>
+            </a:pPr>
+            <a:r>
+              <a:t>Who is the Holy Spirit?</a:t>
+            </a:r>
+          </a:p>
+          <a:p>
+            <a:pPr>
+              <a:spcAft>
+                <a:spcPts val="800"/>
+              </a:spcAft>
+              <a:defRPr sz="2200"/>
+            </a:pPr>
+            <a:r>
+              <a:t>Why is He called the greatest gift?</a:t>
+            </a:r>
+          </a:p>
+          <a:p>
+            <a:pPr>
+              <a:spcAft>
+                <a:spcPts val="800"/>
+              </a:spcAft>
+              <a:defRPr sz="2200"/>
+            </a:pPr>
+            <a:r>
+              <a:t>Write one answer clearly in your notebook.</a:t>
             </a:r>
           </a:p>
         </p:txBody>

</xml_diff>

<commit_message>
Upgrade decks to infographic-first slides
</commit_message>
<xml_diff>
--- a/uganda-p7-mvp/p7_t1_christian_religious_education_0101/p7_t1_christian_religious_education_0101.pptx
+++ b/uganda-p7-mvp/p7_t1_christian_religious_education_0101/p7_t1_christian_religious_education_0101.pptx
@@ -3438,7 +3438,7 @@
         </p:nvSpPr>
         <p:spPr>
           <a:xfrm>
-            <a:off x="685800" y="1024128"/>
+            <a:off x="685800" y="987552"/>
             <a:ext cx="10835640" cy="502920"/>
           </a:xfrm>
           <a:prstGeom prst="rect">
@@ -3473,8 +3473,8 @@
         </p:nvSpPr>
         <p:spPr>
           <a:xfrm>
-            <a:off x="777240" y="1783080"/>
-            <a:ext cx="3794760" cy="4343400"/>
+            <a:off x="777240" y="1755648"/>
+            <a:ext cx="10652760" cy="4480560"/>
           </a:xfrm>
           <a:prstGeom prst="roundRect">
             <a:avLst/>
@@ -3482,7 +3482,7 @@
           <a:solidFill>
             <a:srgbClr val="FFFFFF"/>
           </a:solidFill>
-          <a:ln w="17780">
+          <a:ln w="17145">
             <a:solidFill>
               <a:srgbClr val="1D4ED8"/>
             </a:solidFill>
@@ -3503,42 +3503,77 @@
           </a:fontRef>
         </p:style>
         <p:txBody>
-          <a:bodyPr rtlCol="0" anchor="t" wrap="square" lIns="101600" rIns="101600" tIns="152400" bIns="38100"/>
-          <a:lstStyle/>
-          <a:p>
-            <a:pPr algn="ctr"/>
-            <a:r>
-              <a:rPr sz="1800" b="1">
+          <a:bodyPr rtlCol="0" anchor="t" wrap="square" lIns="101600" rIns="101600" tIns="101600" bIns="38100"/>
+          <a:lstStyle/>
+          <a:p>
+            <a:pPr algn="l"/>
+            <a:r>
+              <a:rPr sz="1200" b="1">
                 <a:solidFill>
                   <a:srgbClr val="1D4ED8"/>
                 </a:solidFill>
                 <a:latin typeface="Arial"/>
               </a:rPr>
-              <a:t>Christian Religious Education</a:t>
-            </a:r>
-          </a:p>
-        </p:txBody>
-      </p:sp>
-      <p:sp>
-        <p:nvSpPr>
-          <p:cNvPr id="12" name="Oval 11"/>
+              <a:t>OPENING VISUAL</a:t>
+            </a:r>
+          </a:p>
+        </p:txBody>
+      </p:sp>
+      <p:sp>
+        <p:nvSpPr>
+          <p:cNvPr id="12" name="TextBox 11"/>
+          <p:cNvSpPr txBox="1"/>
+          <p:nvPr/>
+        </p:nvSpPr>
+        <p:spPr>
+          <a:xfrm>
+            <a:off x="1417319" y="2322576"/>
+            <a:ext cx="9372600" cy="411480"/>
+          </a:xfrm>
+          <a:prstGeom prst="rect">
+            <a:avLst/>
+          </a:prstGeom>
+          <a:noFill/>
+        </p:spPr>
+        <p:txBody>
+          <a:bodyPr wrap="square" lIns="0" rIns="0" tIns="0" bIns="0">
+            <a:spAutoFit/>
+          </a:bodyPr>
+          <a:lstStyle/>
+          <a:p>
+            <a:pPr algn="ctr"/>
+            <a:r>
+              <a:rPr sz="1800" b="1">
+                <a:solidFill>
+                  <a:srgbClr val="111827"/>
+                </a:solidFill>
+                <a:latin typeface="Arial"/>
+              </a:rPr>
+              <a:t>Can you see the wind?</a:t>
+            </a:r>
+          </a:p>
+        </p:txBody>
+      </p:sp>
+      <p:sp>
+        <p:nvSpPr>
+          <p:cNvPr id="13" name="Isosceles Triangle 12"/>
           <p:cNvSpPr/>
           <p:nvPr/>
         </p:nvSpPr>
         <p:spPr>
           <a:xfrm>
-            <a:off x="2429560" y="2939796"/>
-            <a:ext cx="551383" cy="452628"/>
-          </a:xfrm>
-          <a:prstGeom prst="ellipse">
-            <a:avLst/>
-          </a:prstGeom>
-          <a:solidFill>
-            <a:srgbClr val="FCD116"/>
-          </a:solidFill>
-          <a:ln w="10160">
+            <a:off x="4754879" y="2990088"/>
+            <a:ext cx="2651760" cy="2651760"/>
+          </a:xfrm>
+          <a:prstGeom prst="triangle">
+            <a:avLst/>
+          </a:prstGeom>
+          <a:solidFill>
+            <a:srgbClr val="FFF7E0"/>
+          </a:solidFill>
+          <a:ln w="22860">
             <a:solidFill>
-              <a:srgbClr val="D97706"/>
+              <a:srgbClr val="111827"/>
             </a:solidFill>
           </a:ln>
         </p:spPr>
@@ -3566,23 +3601,25 @@
       </p:sp>
       <p:sp>
         <p:nvSpPr>
-          <p:cNvPr id="13" name="Rectangle 12"/>
+          <p:cNvPr id="14" name="Oval 13"/>
           <p:cNvSpPr/>
           <p:nvPr/>
         </p:nvSpPr>
         <p:spPr>
           <a:xfrm>
-            <a:off x="2613355" y="3392424"/>
-            <a:ext cx="183794" cy="1056132"/>
-          </a:xfrm>
-          <a:prstGeom prst="rect">
-            <a:avLst/>
-          </a:prstGeom>
-          <a:solidFill>
-            <a:srgbClr val="D97706"/>
-          </a:solidFill>
-          <a:ln>
-            <a:noFill/>
+            <a:off x="5715000" y="2852928"/>
+            <a:ext cx="822960" cy="822960"/>
+          </a:xfrm>
+          <a:prstGeom prst="ellipse">
+            <a:avLst/>
+          </a:prstGeom>
+          <a:solidFill>
+            <a:srgbClr val="FCD116"/>
+          </a:solidFill>
+          <a:ln w="13970">
+            <a:solidFill>
+              <a:srgbClr val="111827"/>
+            </a:solidFill>
           </a:ln>
         </p:spPr>
         <p:style>
@@ -3600,32 +3637,78 @@
           </a:fontRef>
         </p:style>
         <p:txBody>
-          <a:bodyPr rtlCol="0" anchor="ctr"/>
-          <a:lstStyle/>
-          <a:p>
-            <a:pPr algn="ctr"/>
-          </a:p>
-        </p:txBody>
-      </p:sp>
-      <p:sp>
-        <p:nvSpPr>
-          <p:cNvPr id="14" name="Rectangle 13"/>
+          <a:bodyPr rtlCol="0" anchor="ctr" wrap="square" lIns="101600" rIns="101600" tIns="38100" bIns="38100"/>
+          <a:lstStyle/>
+          <a:p>
+            <a:pPr algn="ctr"/>
+            <a:r>
+              <a:rPr sz="1300" b="1">
+                <a:solidFill>
+                  <a:srgbClr val="111827"/>
+                </a:solidFill>
+                <a:latin typeface="Arial"/>
+              </a:rPr>
+              <a:t>1</a:t>
+            </a:r>
+          </a:p>
+        </p:txBody>
+      </p:sp>
+      <p:sp>
+        <p:nvSpPr>
+          <p:cNvPr id="15" name="TextBox 14"/>
+          <p:cNvSpPr txBox="1"/>
+          <p:nvPr/>
+        </p:nvSpPr>
+        <p:spPr>
+          <a:xfrm>
+            <a:off x="4782312" y="3785616"/>
+            <a:ext cx="2697480" cy="402336"/>
+          </a:xfrm>
+          <a:prstGeom prst="rect">
+            <a:avLst/>
+          </a:prstGeom>
+          <a:noFill/>
+        </p:spPr>
+        <p:txBody>
+          <a:bodyPr wrap="square" lIns="0" rIns="0" tIns="0" bIns="0">
+            <a:spAutoFit/>
+          </a:bodyPr>
+          <a:lstStyle/>
+          <a:p>
+            <a:pPr algn="ctr"/>
+            <a:r>
+              <a:rPr sz="1100" b="1">
+                <a:solidFill>
+                  <a:srgbClr val="111827"/>
+                </a:solidFill>
+                <a:latin typeface="Arial"/>
+              </a:rPr>
+              <a:t>Think alone</a:t>
+            </a:r>
+          </a:p>
+        </p:txBody>
+      </p:sp>
+      <p:sp>
+        <p:nvSpPr>
+          <p:cNvPr id="16" name="Oval 15"/>
           <p:cNvSpPr/>
           <p:nvPr/>
         </p:nvSpPr>
         <p:spPr>
           <a:xfrm>
-            <a:off x="2245766" y="3694176"/>
-            <a:ext cx="918971" cy="125730"/>
-          </a:xfrm>
-          <a:prstGeom prst="rect">
-            <a:avLst/>
-          </a:prstGeom>
-          <a:solidFill>
-            <a:srgbClr val="D97706"/>
-          </a:solidFill>
-          <a:ln>
-            <a:noFill/>
+            <a:off x="4251959" y="4910328"/>
+            <a:ext cx="822960" cy="822960"/>
+          </a:xfrm>
+          <a:prstGeom prst="ellipse">
+            <a:avLst/>
+          </a:prstGeom>
+          <a:solidFill>
+            <a:srgbClr val="D90000"/>
+          </a:solidFill>
+          <a:ln w="13970">
+            <a:solidFill>
+              <a:srgbClr val="111827"/>
+            </a:solidFill>
           </a:ln>
         </p:spPr>
         <p:style>
@@ -3643,32 +3726,78 @@
           </a:fontRef>
         </p:style>
         <p:txBody>
-          <a:bodyPr rtlCol="0" anchor="ctr"/>
-          <a:lstStyle/>
-          <a:p>
-            <a:pPr algn="ctr"/>
-          </a:p>
-        </p:txBody>
-      </p:sp>
-      <p:sp>
-        <p:nvSpPr>
-          <p:cNvPr id="15" name="Rounded Rectangle 14"/>
+          <a:bodyPr rtlCol="0" anchor="ctr" wrap="square" lIns="101600" rIns="101600" tIns="38100" bIns="38100"/>
+          <a:lstStyle/>
+          <a:p>
+            <a:pPr algn="ctr"/>
+            <a:r>
+              <a:rPr sz="1300" b="1">
+                <a:solidFill>
+                  <a:srgbClr val="FFFFFF"/>
+                </a:solidFill>
+                <a:latin typeface="Arial"/>
+              </a:rPr>
+              <a:t>2</a:t>
+            </a:r>
+          </a:p>
+        </p:txBody>
+      </p:sp>
+      <p:sp>
+        <p:nvSpPr>
+          <p:cNvPr id="17" name="TextBox 16"/>
+          <p:cNvSpPr txBox="1"/>
+          <p:nvPr/>
+        </p:nvSpPr>
+        <p:spPr>
+          <a:xfrm>
+            <a:off x="3319271" y="5843016"/>
+            <a:ext cx="2697480" cy="402336"/>
+          </a:xfrm>
+          <a:prstGeom prst="rect">
+            <a:avLst/>
+          </a:prstGeom>
+          <a:noFill/>
+        </p:spPr>
+        <p:txBody>
+          <a:bodyPr wrap="square" lIns="0" rIns="0" tIns="0" bIns="0">
+            <a:spAutoFit/>
+          </a:bodyPr>
+          <a:lstStyle/>
+          <a:p>
+            <a:pPr algn="ctr"/>
+            <a:r>
+              <a:rPr sz="1100" b="1">
+                <a:solidFill>
+                  <a:srgbClr val="111827"/>
+                </a:solidFill>
+                <a:latin typeface="Arial"/>
+              </a:rPr>
+              <a:t>Pair talk</a:t>
+            </a:r>
+          </a:p>
+        </p:txBody>
+      </p:sp>
+      <p:sp>
+        <p:nvSpPr>
+          <p:cNvPr id="18" name="Oval 17"/>
           <p:cNvSpPr/>
           <p:nvPr/>
         </p:nvSpPr>
         <p:spPr>
           <a:xfrm>
-            <a:off x="1878177" y="4247388"/>
-            <a:ext cx="1684782" cy="201168"/>
-          </a:xfrm>
-          <a:prstGeom prst="roundRect">
-            <a:avLst/>
-          </a:prstGeom>
-          <a:solidFill>
-            <a:srgbClr val="D90000"/>
-          </a:solidFill>
-          <a:ln>
-            <a:noFill/>
+            <a:off x="7178040" y="4910328"/>
+            <a:ext cx="822960" cy="822960"/>
+          </a:xfrm>
+          <a:prstGeom prst="ellipse">
+            <a:avLst/>
+          </a:prstGeom>
+          <a:solidFill>
+            <a:srgbClr val="1B7F3A"/>
+          </a:solidFill>
+          <a:ln w="13970">
+            <a:solidFill>
+              <a:srgbClr val="111827"/>
+            </a:solidFill>
           </a:ln>
         </p:spPr>
         <p:style>
@@ -3686,23 +3815,32 @@
           </a:fontRef>
         </p:style>
         <p:txBody>
-          <a:bodyPr rtlCol="0" anchor="ctr"/>
-          <a:lstStyle/>
-          <a:p>
-            <a:pPr algn="ctr"/>
-          </a:p>
-        </p:txBody>
-      </p:sp>
-      <p:sp>
-        <p:nvSpPr>
-          <p:cNvPr id="16" name="TextBox 15"/>
+          <a:bodyPr rtlCol="0" anchor="ctr" wrap="square" lIns="101600" rIns="101600" tIns="38100" bIns="38100"/>
+          <a:lstStyle/>
+          <a:p>
+            <a:pPr algn="ctr"/>
+            <a:r>
+              <a:rPr sz="1300" b="1">
+                <a:solidFill>
+                  <a:srgbClr val="FFFFFF"/>
+                </a:solidFill>
+                <a:latin typeface="Arial"/>
+              </a:rPr>
+              <a:t>3</a:t>
+            </a:r>
+          </a:p>
+        </p:txBody>
+      </p:sp>
+      <p:sp>
+        <p:nvSpPr>
+          <p:cNvPr id="19" name="TextBox 18"/>
           <p:cNvSpPr txBox="1"/>
           <p:nvPr/>
         </p:nvSpPr>
         <p:spPr>
           <a:xfrm>
-            <a:off x="1143000" y="4745736"/>
-            <a:ext cx="3063240" cy="228600"/>
+            <a:off x="6245352" y="5843016"/>
+            <a:ext cx="2697480" cy="402336"/>
           </a:xfrm>
           <a:prstGeom prst="rect">
             <a:avLst/>
@@ -3717,198 +3855,13 @@
           <a:p>
             <a:pPr algn="ctr"/>
             <a:r>
-              <a:rPr sz="1000" b="0">
-                <a:solidFill>
-                  <a:srgbClr val="475569"/>
+              <a:rPr sz="1100" b="1">
+                <a:solidFill>
+                  <a:srgbClr val="111827"/>
                 </a:solidFill>
                 <a:latin typeface="Arial"/>
               </a:rPr>
-              <a:t>Christian Religious Education</a:t>
-            </a:r>
-          </a:p>
-        </p:txBody>
-      </p:sp>
-      <p:sp>
-        <p:nvSpPr>
-          <p:cNvPr id="17" name="TextBox 16"/>
-          <p:cNvSpPr txBox="1"/>
-          <p:nvPr/>
-        </p:nvSpPr>
-        <p:spPr>
-          <a:xfrm>
-            <a:off x="960120" y="5504688"/>
-            <a:ext cx="3429000" cy="274320"/>
-          </a:xfrm>
-          <a:prstGeom prst="rect">
-            <a:avLst/>
-          </a:prstGeom>
-          <a:noFill/>
-        </p:spPr>
-        <p:txBody>
-          <a:bodyPr wrap="square" lIns="0" rIns="0" tIns="0" bIns="0">
-            <a:spAutoFit/>
-          </a:bodyPr>
-          <a:lstStyle/>
-          <a:p>
-            <a:pPr algn="ctr"/>
-            <a:r>
-              <a:rPr sz="1200" b="0">
-                <a:solidFill>
-                  <a:srgbClr val="475569"/>
-                </a:solidFill>
-                <a:latin typeface="Arial"/>
-              </a:rPr>
-              <a:t>Look • wonder • predict</a:t>
-            </a:r>
-          </a:p>
-        </p:txBody>
-      </p:sp>
-      <p:sp>
-        <p:nvSpPr>
-          <p:cNvPr id="18" name="Rounded Rectangle 17"/>
-          <p:cNvSpPr/>
-          <p:nvPr/>
-        </p:nvSpPr>
-        <p:spPr>
-          <a:xfrm>
-            <a:off x="4892040" y="1965960"/>
-            <a:ext cx="6355080" cy="3520440"/>
-          </a:xfrm>
-          <a:prstGeom prst="roundRect">
-            <a:avLst/>
-          </a:prstGeom>
-          <a:solidFill>
-            <a:srgbClr val="FFF7E0"/>
-          </a:solidFill>
-          <a:ln w="20320">
-            <a:solidFill>
-              <a:srgbClr val="1D4ED8"/>
-            </a:solidFill>
-          </a:ln>
-        </p:spPr>
-        <p:style>
-          <a:lnRef idx="1">
-            <a:schemeClr val="accent1"/>
-          </a:lnRef>
-          <a:fillRef idx="3">
-            <a:schemeClr val="accent1"/>
-          </a:fillRef>
-          <a:effectRef idx="2">
-            <a:schemeClr val="accent1"/>
-          </a:effectRef>
-          <a:fontRef idx="minor">
-            <a:schemeClr val="lt1"/>
-          </a:fontRef>
-        </p:style>
-        <p:txBody>
-          <a:bodyPr rtlCol="0" anchor="ctr"/>
-          <a:lstStyle/>
-          <a:p>
-            <a:pPr algn="ctr"/>
-          </a:p>
-        </p:txBody>
-      </p:sp>
-      <p:sp>
-        <p:nvSpPr>
-          <p:cNvPr id="19" name="TextBox 18"/>
-          <p:cNvSpPr txBox="1"/>
-          <p:nvPr/>
-        </p:nvSpPr>
-        <p:spPr>
-          <a:xfrm>
-            <a:off x="5257800" y="2267712"/>
-            <a:ext cx="5623560" cy="256032"/>
-          </a:xfrm>
-          <a:prstGeom prst="rect">
-            <a:avLst/>
-          </a:prstGeom>
-          <a:noFill/>
-        </p:spPr>
-        <p:txBody>
-          <a:bodyPr wrap="square" lIns="0" rIns="0" tIns="0" bIns="0">
-            <a:spAutoFit/>
-          </a:bodyPr>
-          <a:lstStyle/>
-          <a:p>
-            <a:pPr algn="ctr"/>
-            <a:r>
-              <a:rPr sz="1200" b="1">
-                <a:solidFill>
-                  <a:srgbClr val="1D4ED8"/>
-                </a:solidFill>
-                <a:latin typeface="Arial"/>
-              </a:rPr>
-              <a:t>OPENING QUESTION</a:t>
-            </a:r>
-          </a:p>
-        </p:txBody>
-      </p:sp>
-      <p:sp>
-        <p:nvSpPr>
-          <p:cNvPr id="20" name="TextBox 19"/>
-          <p:cNvSpPr txBox="1"/>
-          <p:nvPr/>
-        </p:nvSpPr>
-        <p:spPr>
-          <a:xfrm>
-            <a:off x="5285232" y="2788920"/>
-            <a:ext cx="5577840" cy="987552"/>
-          </a:xfrm>
-          <a:prstGeom prst="rect">
-            <a:avLst/>
-          </a:prstGeom>
-          <a:noFill/>
-        </p:spPr>
-        <p:txBody>
-          <a:bodyPr wrap="square" lIns="0" rIns="0" tIns="0" bIns="0">
-            <a:spAutoFit/>
-          </a:bodyPr>
-          <a:lstStyle/>
-          <a:p>
-            <a:pPr algn="ctr"/>
-            <a:r>
-              <a:rPr sz="2600" b="1">
-                <a:solidFill>
-                  <a:srgbClr val="111827"/>
-                </a:solidFill>
-                <a:latin typeface="Arial"/>
-              </a:rPr>
-              <a:t>Big question: Can you see the wind?</a:t>
-            </a:r>
-          </a:p>
-        </p:txBody>
-      </p:sp>
-      <p:sp>
-        <p:nvSpPr>
-          <p:cNvPr id="21" name="TextBox 20"/>
-          <p:cNvSpPr txBox="1"/>
-          <p:nvPr/>
-        </p:nvSpPr>
-        <p:spPr>
-          <a:xfrm>
-            <a:off x="5285232" y="4315968"/>
-            <a:ext cx="5577840" cy="411480"/>
-          </a:xfrm>
-          <a:prstGeom prst="rect">
-            <a:avLst/>
-          </a:prstGeom>
-          <a:noFill/>
-        </p:spPr>
-        <p:txBody>
-          <a:bodyPr wrap="square" lIns="0" rIns="0" tIns="0" bIns="0">
-            <a:spAutoFit/>
-          </a:bodyPr>
-          <a:lstStyle/>
-          <a:p>
-            <a:pPr algn="ctr"/>
-            <a:r>
-              <a:rPr sz="1400" b="0">
-                <a:solidFill>
-                  <a:srgbClr val="475569"/>
-                </a:solidFill>
-                <a:latin typeface="Arial"/>
-              </a:rPr>
-              <a:t>First think alone. Then tell a partner one possible answer.</a:t>
+              <a:t>Share one idea</a:t>
             </a:r>
           </a:p>
         </p:txBody>
@@ -6618,16 +6571,16 @@
         </p:nvSpPr>
         <p:spPr>
           <a:xfrm>
-            <a:off x="777240" y="1828800"/>
-            <a:ext cx="3337560" cy="4160520"/>
+            <a:off x="777240" y="1755648"/>
+            <a:ext cx="10652760" cy="4480560"/>
           </a:xfrm>
           <a:prstGeom prst="roundRect">
             <a:avLst/>
           </a:prstGeom>
           <a:solidFill>
-            <a:srgbClr val="FFF7E0"/>
-          </a:solidFill>
-          <a:ln w="19050">
+            <a:srgbClr val="FFFFFF"/>
+          </a:solidFill>
+          <a:ln w="17145">
             <a:solidFill>
               <a:srgbClr val="087490"/>
             </a:solidFill>
@@ -6648,33 +6601,77 @@
           </a:fontRef>
         </p:style>
         <p:txBody>
-          <a:bodyPr rtlCol="0" anchor="ctr"/>
-          <a:lstStyle/>
-          <a:p>
-            <a:pPr algn="ctr"/>
-          </a:p>
-        </p:txBody>
-      </p:sp>
-      <p:sp>
-        <p:nvSpPr>
-          <p:cNvPr id="12" name="Oval 11"/>
+          <a:bodyPr rtlCol="0" anchor="t" wrap="square" lIns="101600" rIns="101600" tIns="101600" bIns="38100"/>
+          <a:lstStyle/>
+          <a:p>
+            <a:pPr algn="l"/>
+            <a:r>
+              <a:rPr sz="1200" b="1">
+                <a:solidFill>
+                  <a:srgbClr val="087490"/>
+                </a:solidFill>
+                <a:latin typeface="Arial"/>
+              </a:rPr>
+              <a:t>CONTENT MAP</a:t>
+            </a:r>
+          </a:p>
+        </p:txBody>
+      </p:sp>
+      <p:sp>
+        <p:nvSpPr>
+          <p:cNvPr id="12" name="TextBox 11"/>
+          <p:cNvSpPr txBox="1"/>
+          <p:nvPr/>
+        </p:nvSpPr>
+        <p:spPr>
+          <a:xfrm>
+            <a:off x="1417319" y="2322576"/>
+            <a:ext cx="9372600" cy="411480"/>
+          </a:xfrm>
+          <a:prstGeom prst="rect">
+            <a:avLst/>
+          </a:prstGeom>
+          <a:noFill/>
+        </p:spPr>
+        <p:txBody>
+          <a:bodyPr wrap="square" lIns="0" rIns="0" tIns="0" bIns="0">
+            <a:spAutoFit/>
+          </a:bodyPr>
+          <a:lstStyle/>
+          <a:p>
+            <a:pPr algn="ctr"/>
+            <a:r>
+              <a:rPr sz="1800" b="1">
+                <a:solidFill>
+                  <a:srgbClr val="111827"/>
+                </a:solidFill>
+                <a:latin typeface="Arial"/>
+              </a:rPr>
+              <a:t>Introduction to the "Spirit" concept. Just as</a:t>
+            </a:r>
+          </a:p>
+        </p:txBody>
+      </p:sp>
+      <p:sp>
+        <p:nvSpPr>
+          <p:cNvPr id="13" name="Isosceles Triangle 12"/>
           <p:cNvSpPr/>
           <p:nvPr/>
         </p:nvSpPr>
         <p:spPr>
           <a:xfrm>
-            <a:off x="2230221" y="2610612"/>
-            <a:ext cx="485546" cy="370332"/>
-          </a:xfrm>
-          <a:prstGeom prst="ellipse">
-            <a:avLst/>
-          </a:prstGeom>
-          <a:solidFill>
-            <a:srgbClr val="FCD116"/>
-          </a:solidFill>
-          <a:ln w="10160">
+            <a:off x="4754879" y="2990088"/>
+            <a:ext cx="2651760" cy="2651760"/>
+          </a:xfrm>
+          <a:prstGeom prst="triangle">
+            <a:avLst/>
+          </a:prstGeom>
+          <a:solidFill>
+            <a:srgbClr val="FFF7E0"/>
+          </a:solidFill>
+          <a:ln w="22860">
             <a:solidFill>
-              <a:srgbClr val="D97706"/>
+              <a:srgbClr val="111827"/>
             </a:solidFill>
           </a:ln>
         </p:spPr>
@@ -6702,23 +6699,25 @@
       </p:sp>
       <p:sp>
         <p:nvSpPr>
-          <p:cNvPr id="13" name="Rectangle 12"/>
+          <p:cNvPr id="14" name="Oval 13"/>
           <p:cNvSpPr/>
           <p:nvPr/>
         </p:nvSpPr>
         <p:spPr>
           <a:xfrm>
-            <a:off x="2392070" y="2980944"/>
-            <a:ext cx="161848" cy="864108"/>
-          </a:xfrm>
-          <a:prstGeom prst="rect">
-            <a:avLst/>
-          </a:prstGeom>
-          <a:solidFill>
-            <a:srgbClr val="D97706"/>
-          </a:solidFill>
-          <a:ln>
-            <a:noFill/>
+            <a:off x="5715000" y="2852928"/>
+            <a:ext cx="822960" cy="822960"/>
+          </a:xfrm>
+          <a:prstGeom prst="ellipse">
+            <a:avLst/>
+          </a:prstGeom>
+          <a:solidFill>
+            <a:srgbClr val="FCD116"/>
+          </a:solidFill>
+          <a:ln w="13970">
+            <a:solidFill>
+              <a:srgbClr val="111827"/>
+            </a:solidFill>
           </a:ln>
         </p:spPr>
         <p:style>
@@ -6736,32 +6735,78 @@
           </a:fontRef>
         </p:style>
         <p:txBody>
-          <a:bodyPr rtlCol="0" anchor="ctr"/>
-          <a:lstStyle/>
-          <a:p>
-            <a:pPr algn="ctr"/>
-          </a:p>
-        </p:txBody>
-      </p:sp>
-      <p:sp>
-        <p:nvSpPr>
-          <p:cNvPr id="14" name="Rectangle 13"/>
+          <a:bodyPr rtlCol="0" anchor="ctr" wrap="square" lIns="101600" rIns="101600" tIns="38100" bIns="38100"/>
+          <a:lstStyle/>
+          <a:p>
+            <a:pPr algn="ctr"/>
+            <a:r>
+              <a:rPr sz="1300" b="1">
+                <a:solidFill>
+                  <a:srgbClr val="111827"/>
+                </a:solidFill>
+                <a:latin typeface="Arial"/>
+              </a:rPr>
+              <a:t>1</a:t>
+            </a:r>
+          </a:p>
+        </p:txBody>
+      </p:sp>
+      <p:sp>
+        <p:nvSpPr>
+          <p:cNvPr id="15" name="TextBox 14"/>
+          <p:cNvSpPr txBox="1"/>
+          <p:nvPr/>
+        </p:nvSpPr>
+        <p:spPr>
+          <a:xfrm>
+            <a:off x="4782312" y="3785616"/>
+            <a:ext cx="2697480" cy="402336"/>
+          </a:xfrm>
+          <a:prstGeom prst="rect">
+            <a:avLst/>
+          </a:prstGeom>
+          <a:noFill/>
+        </p:spPr>
+        <p:txBody>
+          <a:bodyPr wrap="square" lIns="0" rIns="0" tIns="0" bIns="0">
+            <a:spAutoFit/>
+          </a:bodyPr>
+          <a:lstStyle/>
+          <a:p>
+            <a:pPr algn="ctr"/>
+            <a:r>
+              <a:rPr sz="1100" b="1">
+                <a:solidFill>
+                  <a:srgbClr val="111827"/>
+                </a:solidFill>
+                <a:latin typeface="Arial"/>
+              </a:rPr>
+              <a:t>A spirit is invisible</a:t>
+            </a:r>
+          </a:p>
+        </p:txBody>
+      </p:sp>
+      <p:sp>
+        <p:nvSpPr>
+          <p:cNvPr id="16" name="Oval 15"/>
           <p:cNvSpPr/>
           <p:nvPr/>
         </p:nvSpPr>
         <p:spPr>
           <a:xfrm>
-            <a:off x="2068372" y="3227832"/>
-            <a:ext cx="809244" cy="102870"/>
-          </a:xfrm>
-          <a:prstGeom prst="rect">
-            <a:avLst/>
-          </a:prstGeom>
-          <a:solidFill>
-            <a:srgbClr val="D97706"/>
-          </a:solidFill>
-          <a:ln>
-            <a:noFill/>
+            <a:off x="4251959" y="4910328"/>
+            <a:ext cx="822960" cy="822960"/>
+          </a:xfrm>
+          <a:prstGeom prst="ellipse">
+            <a:avLst/>
+          </a:prstGeom>
+          <a:solidFill>
+            <a:srgbClr val="D90000"/>
+          </a:solidFill>
+          <a:ln w="13970">
+            <a:solidFill>
+              <a:srgbClr val="111827"/>
+            </a:solidFill>
           </a:ln>
         </p:spPr>
         <p:style>
@@ -6779,32 +6824,78 @@
           </a:fontRef>
         </p:style>
         <p:txBody>
-          <a:bodyPr rtlCol="0" anchor="ctr"/>
-          <a:lstStyle/>
-          <a:p>
-            <a:pPr algn="ctr"/>
-          </a:p>
-        </p:txBody>
-      </p:sp>
-      <p:sp>
-        <p:nvSpPr>
-          <p:cNvPr id="15" name="Rounded Rectangle 14"/>
+          <a:bodyPr rtlCol="0" anchor="ctr" wrap="square" lIns="101600" rIns="101600" tIns="38100" bIns="38100"/>
+          <a:lstStyle/>
+          <a:p>
+            <a:pPr algn="ctr"/>
+            <a:r>
+              <a:rPr sz="1300" b="1">
+                <a:solidFill>
+                  <a:srgbClr val="FFFFFF"/>
+                </a:solidFill>
+                <a:latin typeface="Arial"/>
+              </a:rPr>
+              <a:t>2</a:t>
+            </a:r>
+          </a:p>
+        </p:txBody>
+      </p:sp>
+      <p:sp>
+        <p:nvSpPr>
+          <p:cNvPr id="17" name="TextBox 16"/>
+          <p:cNvSpPr txBox="1"/>
+          <p:nvPr/>
+        </p:nvSpPr>
+        <p:spPr>
+          <a:xfrm>
+            <a:off x="3319271" y="5843016"/>
+            <a:ext cx="2697480" cy="402336"/>
+          </a:xfrm>
+          <a:prstGeom prst="rect">
+            <a:avLst/>
+          </a:prstGeom>
+          <a:noFill/>
+        </p:spPr>
+        <p:txBody>
+          <a:bodyPr wrap="square" lIns="0" rIns="0" tIns="0" bIns="0">
+            <a:spAutoFit/>
+          </a:bodyPr>
+          <a:lstStyle/>
+          <a:p>
+            <a:pPr algn="ctr"/>
+            <a:r>
+              <a:rPr sz="1100" b="1">
+                <a:solidFill>
+                  <a:srgbClr val="111827"/>
+                </a:solidFill>
+                <a:latin typeface="Arial"/>
+              </a:rPr>
+              <a:t>We see the effects of a spirit, like we see</a:t>
+            </a:r>
+          </a:p>
+        </p:txBody>
+      </p:sp>
+      <p:sp>
+        <p:nvSpPr>
+          <p:cNvPr id="18" name="Oval 17"/>
           <p:cNvSpPr/>
           <p:nvPr/>
         </p:nvSpPr>
         <p:spPr>
           <a:xfrm>
-            <a:off x="1744675" y="3680460"/>
-            <a:ext cx="1483614" cy="164592"/>
-          </a:xfrm>
-          <a:prstGeom prst="roundRect">
-            <a:avLst/>
-          </a:prstGeom>
-          <a:solidFill>
-            <a:srgbClr val="D90000"/>
-          </a:solidFill>
-          <a:ln>
-            <a:noFill/>
+            <a:off x="7178040" y="4910328"/>
+            <a:ext cx="822960" cy="822960"/>
+          </a:xfrm>
+          <a:prstGeom prst="ellipse">
+            <a:avLst/>
+          </a:prstGeom>
+          <a:solidFill>
+            <a:srgbClr val="1B7F3A"/>
+          </a:solidFill>
+          <a:ln w="13970">
+            <a:solidFill>
+              <a:srgbClr val="111827"/>
+            </a:solidFill>
           </a:ln>
         </p:spPr>
         <p:style>
@@ -6822,23 +6913,32 @@
           </a:fontRef>
         </p:style>
         <p:txBody>
-          <a:bodyPr rtlCol="0" anchor="ctr"/>
-          <a:lstStyle/>
-          <a:p>
-            <a:pPr algn="ctr"/>
-          </a:p>
-        </p:txBody>
-      </p:sp>
-      <p:sp>
-        <p:nvSpPr>
-          <p:cNvPr id="16" name="TextBox 15"/>
+          <a:bodyPr rtlCol="0" anchor="ctr" wrap="square" lIns="101600" rIns="101600" tIns="38100" bIns="38100"/>
+          <a:lstStyle/>
+          <a:p>
+            <a:pPr algn="ctr"/>
+            <a:r>
+              <a:rPr sz="1300" b="1">
+                <a:solidFill>
+                  <a:srgbClr val="FFFFFF"/>
+                </a:solidFill>
+                <a:latin typeface="Arial"/>
+              </a:rPr>
+              <a:t>3</a:t>
+            </a:r>
+          </a:p>
+        </p:txBody>
+      </p:sp>
+      <p:sp>
+        <p:nvSpPr>
+          <p:cNvPr id="19" name="TextBox 18"/>
           <p:cNvSpPr txBox="1"/>
           <p:nvPr/>
         </p:nvSpPr>
         <p:spPr>
           <a:xfrm>
-            <a:off x="1097280" y="4041648"/>
-            <a:ext cx="2697480" cy="228600"/>
+            <a:off x="6245352" y="5843016"/>
+            <a:ext cx="2697480" cy="402336"/>
           </a:xfrm>
           <a:prstGeom prst="rect">
             <a:avLst/>
@@ -6853,561 +6953,20 @@
           <a:p>
             <a:pPr algn="ctr"/>
             <a:r>
-              <a:rPr sz="1000" b="0">
-                <a:solidFill>
-                  <a:srgbClr val="475569"/>
+              <a:rPr sz="1100" b="1">
+                <a:solidFill>
+                  <a:srgbClr val="111827"/>
                 </a:solidFill>
                 <a:latin typeface="Arial"/>
               </a:rPr>
-              <a:t>Christian Religious Education</a:t>
-            </a:r>
-          </a:p>
-        </p:txBody>
-      </p:sp>
-      <p:sp>
-        <p:nvSpPr>
-          <p:cNvPr id="17" name="TextBox 16"/>
-          <p:cNvSpPr txBox="1"/>
-          <p:nvPr/>
-        </p:nvSpPr>
-        <p:spPr>
-          <a:xfrm>
-            <a:off x="987552" y="4617720"/>
-            <a:ext cx="2907792" cy="256032"/>
-          </a:xfrm>
-          <a:prstGeom prst="rect">
-            <a:avLst/>
-          </a:prstGeom>
-          <a:noFill/>
-        </p:spPr>
-        <p:txBody>
-          <a:bodyPr wrap="square" lIns="0" rIns="0" tIns="0" bIns="0">
-            <a:spAutoFit/>
-          </a:bodyPr>
-          <a:lstStyle/>
-          <a:p>
-            <a:pPr algn="ctr"/>
-            <a:r>
-              <a:rPr sz="1200" b="1">
-                <a:solidFill>
-                  <a:srgbClr val="087490"/>
-                </a:solidFill>
-                <a:latin typeface="Arial"/>
-              </a:rPr>
-              <a:t>KEY IDEA</a:t>
-            </a:r>
-          </a:p>
-        </p:txBody>
-      </p:sp>
-      <p:sp>
-        <p:nvSpPr>
-          <p:cNvPr id="18" name="TextBox 17"/>
-          <p:cNvSpPr txBox="1"/>
-          <p:nvPr/>
-        </p:nvSpPr>
-        <p:spPr>
-          <a:xfrm>
-            <a:off x="960120" y="4919472"/>
-            <a:ext cx="2971800" cy="685800"/>
-          </a:xfrm>
-          <a:prstGeom prst="rect">
-            <a:avLst/>
-          </a:prstGeom>
-          <a:noFill/>
-        </p:spPr>
-        <p:txBody>
-          <a:bodyPr wrap="square" lIns="0" rIns="0" tIns="0" bIns="0">
-            <a:spAutoFit/>
-          </a:bodyPr>
-          <a:lstStyle/>
-          <a:p>
-            <a:pPr algn="ctr"/>
-            <a:r>
-              <a:rPr sz="1500" b="1">
-                <a:solidFill>
-                  <a:srgbClr val="111827"/>
-                </a:solidFill>
-                <a:latin typeface="Arial"/>
-              </a:rPr>
-              <a:t>Key idea: Introduction to the "Spirit" concept. Just as wind is invisible but</a:t>
-            </a:r>
-          </a:p>
-        </p:txBody>
-      </p:sp>
-      <p:sp>
-        <p:nvSpPr>
-          <p:cNvPr id="19" name="Rounded Rectangle 18"/>
-          <p:cNvSpPr/>
-          <p:nvPr/>
-        </p:nvSpPr>
-        <p:spPr>
-          <a:xfrm>
-            <a:off x="4572000" y="1874519"/>
-            <a:ext cx="6812280" cy="932688"/>
-          </a:xfrm>
-          <a:prstGeom prst="roundRect">
-            <a:avLst/>
-          </a:prstGeom>
-          <a:solidFill>
-            <a:srgbClr val="FFFFFF"/>
-          </a:solidFill>
-          <a:ln w="11430">
-            <a:solidFill>
-              <a:srgbClr val="CBD5E1"/>
-            </a:solidFill>
-          </a:ln>
-        </p:spPr>
-        <p:style>
-          <a:lnRef idx="1">
-            <a:schemeClr val="accent1"/>
-          </a:lnRef>
-          <a:fillRef idx="3">
-            <a:schemeClr val="accent1"/>
-          </a:fillRef>
-          <a:effectRef idx="2">
-            <a:schemeClr val="accent1"/>
-          </a:effectRef>
-          <a:fontRef idx="minor">
-            <a:schemeClr val="lt1"/>
-          </a:fontRef>
-        </p:style>
-        <p:txBody>
-          <a:bodyPr rtlCol="0" anchor="ctr"/>
-          <a:lstStyle/>
-          <a:p>
-            <a:pPr algn="ctr"/>
-          </a:p>
-        </p:txBody>
-      </p:sp>
-      <p:sp>
-        <p:nvSpPr>
-          <p:cNvPr id="20" name="Rectangle 19"/>
-          <p:cNvSpPr/>
-          <p:nvPr/>
-        </p:nvSpPr>
-        <p:spPr>
-          <a:xfrm>
-            <a:off x="4572000" y="1874519"/>
-            <a:ext cx="566928" cy="932688"/>
-          </a:xfrm>
-          <a:prstGeom prst="rect">
-            <a:avLst/>
-          </a:prstGeom>
-          <a:solidFill>
-            <a:srgbClr val="087490"/>
-          </a:solidFill>
-          <a:ln>
-            <a:noFill/>
-          </a:ln>
-        </p:spPr>
-        <p:style>
-          <a:lnRef idx="1">
-            <a:schemeClr val="accent1"/>
-          </a:lnRef>
-          <a:fillRef idx="3">
-            <a:schemeClr val="accent1"/>
-          </a:fillRef>
-          <a:effectRef idx="2">
-            <a:schemeClr val="accent1"/>
-          </a:effectRef>
-          <a:fontRef idx="minor">
-            <a:schemeClr val="lt1"/>
-          </a:fontRef>
-        </p:style>
-        <p:txBody>
-          <a:bodyPr rtlCol="0" anchor="ctr"/>
-          <a:lstStyle/>
-          <a:p>
-            <a:pPr algn="ctr"/>
-          </a:p>
-        </p:txBody>
-      </p:sp>
-      <p:sp>
-        <p:nvSpPr>
-          <p:cNvPr id="21" name="TextBox 20"/>
-          <p:cNvSpPr txBox="1"/>
-          <p:nvPr/>
-        </p:nvSpPr>
-        <p:spPr>
-          <a:xfrm>
-            <a:off x="4572000" y="2221991"/>
-            <a:ext cx="566928" cy="237744"/>
-          </a:xfrm>
-          <a:prstGeom prst="rect">
-            <a:avLst/>
-          </a:prstGeom>
-          <a:noFill/>
-        </p:spPr>
-        <p:txBody>
-          <a:bodyPr wrap="square" lIns="0" rIns="0" tIns="0" bIns="0">
-            <a:spAutoFit/>
-          </a:bodyPr>
-          <a:lstStyle/>
-          <a:p>
-            <a:pPr algn="ctr"/>
-            <a:r>
-              <a:rPr sz="1400" b="1">
-                <a:solidFill>
-                  <a:srgbClr val="FFFFFF"/>
-                </a:solidFill>
-                <a:latin typeface="Arial"/>
-              </a:rPr>
-              <a:t>1</a:t>
-            </a:r>
-          </a:p>
-        </p:txBody>
-      </p:sp>
-      <p:sp>
-        <p:nvSpPr>
-          <p:cNvPr id="22" name="TextBox 21"/>
-          <p:cNvSpPr txBox="1"/>
-          <p:nvPr/>
-        </p:nvSpPr>
-        <p:spPr>
-          <a:xfrm>
-            <a:off x="5358384" y="2039112"/>
-            <a:ext cx="5788152" cy="694944"/>
-          </a:xfrm>
-          <a:prstGeom prst="rect">
-            <a:avLst/>
-          </a:prstGeom>
-          <a:noFill/>
-        </p:spPr>
-        <p:txBody>
-          <a:bodyPr wrap="square" lIns="0" rIns="0" tIns="0" bIns="0">
-            <a:spAutoFit/>
-          </a:bodyPr>
-          <a:lstStyle/>
-          <a:p>
-            <a:r>
-              <a:rPr sz="1600" b="1">
-                <a:solidFill>
-                  <a:srgbClr val="111827"/>
-                </a:solidFill>
-                <a:latin typeface="Arial"/>
-              </a:rPr>
-              <a:t>A spirit is invisible.</a:t>
-            </a:r>
-          </a:p>
-        </p:txBody>
-      </p:sp>
-      <p:sp>
-        <p:nvSpPr>
-          <p:cNvPr id="23" name="Rounded Rectangle 22"/>
-          <p:cNvSpPr/>
-          <p:nvPr/>
-        </p:nvSpPr>
-        <p:spPr>
-          <a:xfrm>
-            <a:off x="4572000" y="3108960"/>
-            <a:ext cx="6812280" cy="932688"/>
-          </a:xfrm>
-          <a:prstGeom prst="roundRect">
-            <a:avLst/>
-          </a:prstGeom>
-          <a:solidFill>
-            <a:srgbClr val="FFFFFF"/>
-          </a:solidFill>
-          <a:ln w="11430">
-            <a:solidFill>
-              <a:srgbClr val="CBD5E1"/>
-            </a:solidFill>
-          </a:ln>
-        </p:spPr>
-        <p:style>
-          <a:lnRef idx="1">
-            <a:schemeClr val="accent1"/>
-          </a:lnRef>
-          <a:fillRef idx="3">
-            <a:schemeClr val="accent1"/>
-          </a:fillRef>
-          <a:effectRef idx="2">
-            <a:schemeClr val="accent1"/>
-          </a:effectRef>
-          <a:fontRef idx="minor">
-            <a:schemeClr val="lt1"/>
-          </a:fontRef>
-        </p:style>
-        <p:txBody>
-          <a:bodyPr rtlCol="0" anchor="ctr"/>
-          <a:lstStyle/>
-          <a:p>
-            <a:pPr algn="ctr"/>
-          </a:p>
-        </p:txBody>
-      </p:sp>
-      <p:sp>
-        <p:nvSpPr>
-          <p:cNvPr id="24" name="Rectangle 23"/>
-          <p:cNvSpPr/>
-          <p:nvPr/>
-        </p:nvSpPr>
-        <p:spPr>
-          <a:xfrm>
-            <a:off x="4572000" y="3108960"/>
-            <a:ext cx="566928" cy="932688"/>
-          </a:xfrm>
-          <a:prstGeom prst="rect">
-            <a:avLst/>
-          </a:prstGeom>
-          <a:solidFill>
-            <a:srgbClr val="087490"/>
-          </a:solidFill>
-          <a:ln>
-            <a:noFill/>
-          </a:ln>
-        </p:spPr>
-        <p:style>
-          <a:lnRef idx="1">
-            <a:schemeClr val="accent1"/>
-          </a:lnRef>
-          <a:fillRef idx="3">
-            <a:schemeClr val="accent1"/>
-          </a:fillRef>
-          <a:effectRef idx="2">
-            <a:schemeClr val="accent1"/>
-          </a:effectRef>
-          <a:fontRef idx="minor">
-            <a:schemeClr val="lt1"/>
-          </a:fontRef>
-        </p:style>
-        <p:txBody>
-          <a:bodyPr rtlCol="0" anchor="ctr"/>
-          <a:lstStyle/>
-          <a:p>
-            <a:pPr algn="ctr"/>
-          </a:p>
-        </p:txBody>
-      </p:sp>
-      <p:sp>
-        <p:nvSpPr>
-          <p:cNvPr id="25" name="TextBox 24"/>
-          <p:cNvSpPr txBox="1"/>
-          <p:nvPr/>
-        </p:nvSpPr>
-        <p:spPr>
-          <a:xfrm>
-            <a:off x="4572000" y="3456432"/>
-            <a:ext cx="566928" cy="237744"/>
-          </a:xfrm>
-          <a:prstGeom prst="rect">
-            <a:avLst/>
-          </a:prstGeom>
-          <a:noFill/>
-        </p:spPr>
-        <p:txBody>
-          <a:bodyPr wrap="square" lIns="0" rIns="0" tIns="0" bIns="0">
-            <a:spAutoFit/>
-          </a:bodyPr>
-          <a:lstStyle/>
-          <a:p>
-            <a:pPr algn="ctr"/>
-            <a:r>
-              <a:rPr sz="1400" b="1">
-                <a:solidFill>
-                  <a:srgbClr val="FFFFFF"/>
-                </a:solidFill>
-                <a:latin typeface="Arial"/>
-              </a:rPr>
-              <a:t>2</a:t>
-            </a:r>
-          </a:p>
-        </p:txBody>
-      </p:sp>
-      <p:sp>
-        <p:nvSpPr>
-          <p:cNvPr id="26" name="TextBox 25"/>
-          <p:cNvSpPr txBox="1"/>
-          <p:nvPr/>
-        </p:nvSpPr>
-        <p:spPr>
-          <a:xfrm>
-            <a:off x="5358384" y="3273552"/>
-            <a:ext cx="5788152" cy="694944"/>
-          </a:xfrm>
-          <a:prstGeom prst="rect">
-            <a:avLst/>
-          </a:prstGeom>
-          <a:noFill/>
-        </p:spPr>
-        <p:txBody>
-          <a:bodyPr wrap="square" lIns="0" rIns="0" tIns="0" bIns="0">
-            <a:spAutoFit/>
-          </a:bodyPr>
-          <a:lstStyle/>
-          <a:p>
-            <a:r>
-              <a:rPr sz="1400" b="1">
-                <a:solidFill>
-                  <a:srgbClr val="111827"/>
-                </a:solidFill>
-                <a:latin typeface="Arial"/>
-              </a:rPr>
-              <a:t>We see the effects of a spirit, like we see wind moving trees.</a:t>
-            </a:r>
-          </a:p>
-        </p:txBody>
-      </p:sp>
-      <p:sp>
-        <p:nvSpPr>
-          <p:cNvPr id="27" name="Rounded Rectangle 26"/>
-          <p:cNvSpPr/>
-          <p:nvPr/>
-        </p:nvSpPr>
-        <p:spPr>
-          <a:xfrm>
-            <a:off x="4572000" y="4343400"/>
-            <a:ext cx="6812280" cy="932688"/>
-          </a:xfrm>
-          <a:prstGeom prst="roundRect">
-            <a:avLst/>
-          </a:prstGeom>
-          <a:solidFill>
-            <a:srgbClr val="FFFFFF"/>
-          </a:solidFill>
-          <a:ln w="11430">
-            <a:solidFill>
-              <a:srgbClr val="CBD5E1"/>
-            </a:solidFill>
-          </a:ln>
-        </p:spPr>
-        <p:style>
-          <a:lnRef idx="1">
-            <a:schemeClr val="accent1"/>
-          </a:lnRef>
-          <a:fillRef idx="3">
-            <a:schemeClr val="accent1"/>
-          </a:fillRef>
-          <a:effectRef idx="2">
-            <a:schemeClr val="accent1"/>
-          </a:effectRef>
-          <a:fontRef idx="minor">
-            <a:schemeClr val="lt1"/>
-          </a:fontRef>
-        </p:style>
-        <p:txBody>
-          <a:bodyPr rtlCol="0" anchor="ctr"/>
-          <a:lstStyle/>
-          <a:p>
-            <a:pPr algn="ctr"/>
-          </a:p>
-        </p:txBody>
-      </p:sp>
-      <p:sp>
-        <p:nvSpPr>
-          <p:cNvPr id="28" name="Rectangle 27"/>
-          <p:cNvSpPr/>
-          <p:nvPr/>
-        </p:nvSpPr>
-        <p:spPr>
-          <a:xfrm>
-            <a:off x="4572000" y="4343400"/>
-            <a:ext cx="566928" cy="932688"/>
-          </a:xfrm>
-          <a:prstGeom prst="rect">
-            <a:avLst/>
-          </a:prstGeom>
-          <a:solidFill>
-            <a:srgbClr val="087490"/>
-          </a:solidFill>
-          <a:ln>
-            <a:noFill/>
-          </a:ln>
-        </p:spPr>
-        <p:style>
-          <a:lnRef idx="1">
-            <a:schemeClr val="accent1"/>
-          </a:lnRef>
-          <a:fillRef idx="3">
-            <a:schemeClr val="accent1"/>
-          </a:fillRef>
-          <a:effectRef idx="2">
-            <a:schemeClr val="accent1"/>
-          </a:effectRef>
-          <a:fontRef idx="minor">
-            <a:schemeClr val="lt1"/>
-          </a:fontRef>
-        </p:style>
-        <p:txBody>
-          <a:bodyPr rtlCol="0" anchor="ctr"/>
-          <a:lstStyle/>
-          <a:p>
-            <a:pPr algn="ctr"/>
-          </a:p>
-        </p:txBody>
-      </p:sp>
-      <p:sp>
-        <p:nvSpPr>
-          <p:cNvPr id="29" name="TextBox 28"/>
-          <p:cNvSpPr txBox="1"/>
-          <p:nvPr/>
-        </p:nvSpPr>
-        <p:spPr>
-          <a:xfrm>
-            <a:off x="4572000" y="4690872"/>
-            <a:ext cx="566928" cy="237744"/>
-          </a:xfrm>
-          <a:prstGeom prst="rect">
-            <a:avLst/>
-          </a:prstGeom>
-          <a:noFill/>
-        </p:spPr>
-        <p:txBody>
-          <a:bodyPr wrap="square" lIns="0" rIns="0" tIns="0" bIns="0">
-            <a:spAutoFit/>
-          </a:bodyPr>
-          <a:lstStyle/>
-          <a:p>
-            <a:pPr algn="ctr"/>
-            <a:r>
-              <a:rPr sz="1400" b="1">
-                <a:solidFill>
-                  <a:srgbClr val="FFFFFF"/>
-                </a:solidFill>
-                <a:latin typeface="Arial"/>
-              </a:rPr>
-              <a:t>3</a:t>
-            </a:r>
-          </a:p>
-        </p:txBody>
-      </p:sp>
-      <p:sp>
-        <p:nvSpPr>
-          <p:cNvPr id="30" name="TextBox 29"/>
-          <p:cNvSpPr txBox="1"/>
-          <p:nvPr/>
-        </p:nvSpPr>
-        <p:spPr>
-          <a:xfrm>
-            <a:off x="5358384" y="4507992"/>
-            <a:ext cx="5788152" cy="694944"/>
-          </a:xfrm>
-          <a:prstGeom prst="rect">
-            <a:avLst/>
-          </a:prstGeom>
-          <a:noFill/>
-        </p:spPr>
-        <p:txBody>
-          <a:bodyPr wrap="square" lIns="0" rIns="0" tIns="0" bIns="0">
-            <a:spAutoFit/>
-          </a:bodyPr>
-          <a:lstStyle/>
-          <a:p>
-            <a:r>
-              <a:rPr sz="1600" b="1">
-                <a:solidFill>
-                  <a:srgbClr val="111827"/>
-                </a:solidFill>
-                <a:latin typeface="Arial"/>
-              </a:rPr>
-              <a:t>The Spirit is the "breath" of God.</a:t>
-            </a:r>
-          </a:p>
-        </p:txBody>
-      </p:sp>
-      <p:sp>
-        <p:nvSpPr>
-          <p:cNvPr id="31" name="TextBox 30"/>
+              <a:t>The Spirit is the "breath" of God</a:t>
+            </a:r>
+          </a:p>
+        </p:txBody>
+      </p:sp>
+      <p:sp>
+        <p:nvSpPr>
+          <p:cNvPr id="20" name="TextBox 19"/>
           <p:cNvSpPr txBox="1"/>
           <p:nvPr/>
         </p:nvSpPr>
@@ -7835,18 +7394,18 @@
         </p:nvSpPr>
         <p:spPr>
           <a:xfrm>
-            <a:off x="822960" y="1828800"/>
-            <a:ext cx="7360920" cy="4251960"/>
+            <a:off x="777240" y="1755648"/>
+            <a:ext cx="10652760" cy="4480560"/>
           </a:xfrm>
           <a:prstGeom prst="roundRect">
             <a:avLst/>
           </a:prstGeom>
           <a:solidFill>
-            <a:srgbClr val="1F2937"/>
-          </a:solidFill>
-          <a:ln w="19050">
+            <a:srgbClr val="FFFFFF"/>
+          </a:solidFill>
+          <a:ln w="17145">
             <a:solidFill>
-              <a:srgbClr val="FCD116"/>
+              <a:srgbClr val="D97706"/>
             </a:solidFill>
           </a:ln>
         </p:spPr>
@@ -7865,10 +7424,19 @@
           </a:fontRef>
         </p:style>
         <p:txBody>
-          <a:bodyPr rtlCol="0" anchor="ctr"/>
-          <a:lstStyle/>
-          <a:p>
-            <a:pPr algn="ctr"/>
+          <a:bodyPr rtlCol="0" anchor="t" wrap="square" lIns="101600" rIns="101600" tIns="101600" bIns="38100"/>
+          <a:lstStyle/>
+          <a:p>
+            <a:pPr algn="l"/>
+            <a:r>
+              <a:rPr sz="1200" b="1">
+                <a:solidFill>
+                  <a:srgbClr val="D97706"/>
+                </a:solidFill>
+                <a:latin typeface="Arial"/>
+              </a:rPr>
+              <a:t>MODEL MAP</a:t>
+            </a:r>
           </a:p>
         </p:txBody>
       </p:sp>
@@ -7880,8 +7448,8 @@
         </p:nvSpPr>
         <p:spPr>
           <a:xfrm>
-            <a:off x="1097280" y="2084831"/>
-            <a:ext cx="6812280" cy="256032"/>
+            <a:off x="1417319" y="2322576"/>
+            <a:ext cx="9372600" cy="411480"/>
           </a:xfrm>
           <a:prstGeom prst="rect">
             <a:avLst/>
@@ -7894,140 +7462,39 @@
           </a:bodyPr>
           <a:lstStyle/>
           <a:p>
-            <a:r>
-              <a:rPr sz="1200" b="1">
-                <a:solidFill>
-                  <a:srgbClr val="FCD116"/>
+            <a:pPr algn="ctr"/>
+            <a:r>
+              <a:rPr sz="1800" b="1">
+                <a:solidFill>
+                  <a:srgbClr val="111827"/>
                 </a:solidFill>
                 <a:latin typeface="Arial"/>
               </a:rPr>
-              <a:t>BOARD MODEL</a:t>
-            </a:r>
-          </a:p>
-        </p:txBody>
-      </p:sp>
-      <p:sp>
-        <p:nvSpPr>
-          <p:cNvPr id="13" name="TextBox 12"/>
-          <p:cNvSpPr txBox="1"/>
-          <p:nvPr/>
-        </p:nvSpPr>
-        <p:spPr>
-          <a:xfrm>
-            <a:off x="1143000" y="2578608"/>
-            <a:ext cx="6583680" cy="347472"/>
-          </a:xfrm>
-          <a:prstGeom prst="rect">
-            <a:avLst/>
-          </a:prstGeom>
-          <a:noFill/>
-        </p:spPr>
-        <p:txBody>
-          <a:bodyPr wrap="square" lIns="0" rIns="0" tIns="0" bIns="0">
-            <a:spAutoFit/>
-          </a:bodyPr>
-          <a:lstStyle/>
-          <a:p>
-            <a:r>
-              <a:rPr sz="1600" b="0">
-                <a:solidFill>
-                  <a:srgbClr val="FFFFFF"/>
-                </a:solidFill>
-                <a:latin typeface="Arial"/>
-              </a:rPr>
-              <a:t>1. 2. The Holy Spirit</a:t>
-            </a:r>
-          </a:p>
-        </p:txBody>
-      </p:sp>
-      <p:sp>
-        <p:nvSpPr>
-          <p:cNvPr id="14" name="TextBox 13"/>
-          <p:cNvSpPr txBox="1"/>
-          <p:nvPr/>
-        </p:nvSpPr>
-        <p:spPr>
-          <a:xfrm>
-            <a:off x="1143000" y="3154679"/>
-            <a:ext cx="6583680" cy="347472"/>
-          </a:xfrm>
-          <a:prstGeom prst="rect">
-            <a:avLst/>
-          </a:prstGeom>
-          <a:noFill/>
-        </p:spPr>
-        <p:txBody>
-          <a:bodyPr wrap="square" lIns="0" rIns="0" tIns="0" bIns="0">
-            <a:spAutoFit/>
-          </a:bodyPr>
-          <a:lstStyle/>
-          <a:p>
-            <a:r>
-              <a:rPr sz="1600" b="0">
-                <a:solidFill>
-                  <a:srgbClr val="FFFFFF"/>
-                </a:solidFill>
-                <a:latin typeface="Arial"/>
-              </a:rPr>
-              <a:t>2. He is God's presence in us.</a:t>
-            </a:r>
-          </a:p>
-        </p:txBody>
-      </p:sp>
-      <p:sp>
-        <p:nvSpPr>
-          <p:cNvPr id="15" name="TextBox 14"/>
-          <p:cNvSpPr txBox="1"/>
-          <p:nvPr/>
-        </p:nvSpPr>
-        <p:spPr>
-          <a:xfrm>
-            <a:off x="1143000" y="3730752"/>
-            <a:ext cx="6583680" cy="347472"/>
-          </a:xfrm>
-          <a:prstGeom prst="rect">
-            <a:avLst/>
-          </a:prstGeom>
-          <a:noFill/>
-        </p:spPr>
-        <p:txBody>
-          <a:bodyPr wrap="square" lIns="0" rIns="0" tIns="0" bIns="0">
-            <a:spAutoFit/>
-          </a:bodyPr>
-          <a:lstStyle/>
-          <a:p>
-            <a:r>
-              <a:rPr sz="1600" b="0">
-                <a:solidFill>
-                  <a:srgbClr val="FFFFFF"/>
-                </a:solidFill>
-                <a:latin typeface="Arial"/>
-              </a:rPr>
-              <a:t>3. He is the "Gift and the Giver."</a:t>
-            </a:r>
-          </a:p>
-        </p:txBody>
-      </p:sp>
-      <p:sp>
-        <p:nvSpPr>
-          <p:cNvPr id="16" name="Rounded Rectangle 15"/>
+              <a:t>Worked example</a:t>
+            </a:r>
+          </a:p>
+        </p:txBody>
+      </p:sp>
+      <p:sp>
+        <p:nvSpPr>
+          <p:cNvPr id="13" name="Isosceles Triangle 12"/>
           <p:cNvSpPr/>
           <p:nvPr/>
         </p:nvSpPr>
         <p:spPr>
           <a:xfrm>
-            <a:off x="8549640" y="1828800"/>
-            <a:ext cx="2697480" cy="4251960"/>
-          </a:xfrm>
-          <a:prstGeom prst="roundRect">
+            <a:off x="4754879" y="2990088"/>
+            <a:ext cx="2651760" cy="2651760"/>
+          </a:xfrm>
+          <a:prstGeom prst="triangle">
             <a:avLst/>
           </a:prstGeom>
           <a:solidFill>
             <a:srgbClr val="FFF7E0"/>
           </a:solidFill>
-          <a:ln w="16510">
+          <a:ln w="22860">
             <a:solidFill>
-              <a:srgbClr val="D97706"/>
+              <a:srgbClr val="111827"/>
             </a:solidFill>
           </a:ln>
         </p:spPr>
@@ -8055,14 +7522,14 @@
       </p:sp>
       <p:sp>
         <p:nvSpPr>
-          <p:cNvPr id="17" name="Oval 16"/>
+          <p:cNvPr id="14" name="Oval 13"/>
           <p:cNvSpPr/>
           <p:nvPr/>
         </p:nvSpPr>
         <p:spPr>
           <a:xfrm>
-            <a:off x="9748418" y="2636215"/>
-            <a:ext cx="337413" cy="304495"/>
+            <a:off x="5715000" y="2852928"/>
+            <a:ext cx="822960" cy="822960"/>
           </a:xfrm>
           <a:prstGeom prst="ellipse">
             <a:avLst/>
@@ -8070,9 +7537,9 @@
           <a:solidFill>
             <a:srgbClr val="FCD116"/>
           </a:solidFill>
-          <a:ln w="10160">
+          <a:ln w="13970">
             <a:solidFill>
-              <a:srgbClr val="D97706"/>
+              <a:srgbClr val="111827"/>
             </a:solidFill>
           </a:ln>
         </p:spPr>
@@ -8091,32 +7558,78 @@
           </a:fontRef>
         </p:style>
         <p:txBody>
-          <a:bodyPr rtlCol="0" anchor="ctr"/>
-          <a:lstStyle/>
-          <a:p>
-            <a:pPr algn="ctr"/>
-          </a:p>
-        </p:txBody>
-      </p:sp>
-      <p:sp>
-        <p:nvSpPr>
-          <p:cNvPr id="18" name="Rectangle 17"/>
+          <a:bodyPr rtlCol="0" anchor="ctr" wrap="square" lIns="101600" rIns="101600" tIns="38100" bIns="38100"/>
+          <a:lstStyle/>
+          <a:p>
+            <a:pPr algn="ctr"/>
+            <a:r>
+              <a:rPr sz="1300" b="1">
+                <a:solidFill>
+                  <a:srgbClr val="111827"/>
+                </a:solidFill>
+                <a:latin typeface="Arial"/>
+              </a:rPr>
+              <a:t>1</a:t>
+            </a:r>
+          </a:p>
+        </p:txBody>
+      </p:sp>
+      <p:sp>
+        <p:nvSpPr>
+          <p:cNvPr id="15" name="TextBox 14"/>
+          <p:cNvSpPr txBox="1"/>
+          <p:nvPr/>
+        </p:nvSpPr>
+        <p:spPr>
+          <a:xfrm>
+            <a:off x="4782312" y="3785616"/>
+            <a:ext cx="2697480" cy="402336"/>
+          </a:xfrm>
+          <a:prstGeom prst="rect">
+            <a:avLst/>
+          </a:prstGeom>
+          <a:noFill/>
+        </p:spPr>
+        <p:txBody>
+          <a:bodyPr wrap="square" lIns="0" rIns="0" tIns="0" bIns="0">
+            <a:spAutoFit/>
+          </a:bodyPr>
+          <a:lstStyle/>
+          <a:p>
+            <a:pPr algn="ctr"/>
+            <a:r>
+              <a:rPr sz="1100" b="1">
+                <a:solidFill>
+                  <a:srgbClr val="111827"/>
+                </a:solidFill>
+                <a:latin typeface="Arial"/>
+              </a:rPr>
+              <a:t>2. The Holy Spirit</a:t>
+            </a:r>
+          </a:p>
+        </p:txBody>
+      </p:sp>
+      <p:sp>
+        <p:nvSpPr>
+          <p:cNvPr id="16" name="Oval 15"/>
           <p:cNvSpPr/>
           <p:nvPr/>
         </p:nvSpPr>
         <p:spPr>
           <a:xfrm>
-            <a:off x="9860889" y="2940710"/>
-            <a:ext cx="112471" cy="710488"/>
-          </a:xfrm>
-          <a:prstGeom prst="rect">
-            <a:avLst/>
-          </a:prstGeom>
-          <a:solidFill>
-            <a:srgbClr val="D97706"/>
-          </a:solidFill>
-          <a:ln>
-            <a:noFill/>
+            <a:off x="4251959" y="4910328"/>
+            <a:ext cx="822960" cy="822960"/>
+          </a:xfrm>
+          <a:prstGeom prst="ellipse">
+            <a:avLst/>
+          </a:prstGeom>
+          <a:solidFill>
+            <a:srgbClr val="D90000"/>
+          </a:solidFill>
+          <a:ln w="13970">
+            <a:solidFill>
+              <a:srgbClr val="111827"/>
+            </a:solidFill>
           </a:ln>
         </p:spPr>
         <p:style>
@@ -8134,32 +7647,78 @@
           </a:fontRef>
         </p:style>
         <p:txBody>
-          <a:bodyPr rtlCol="0" anchor="ctr"/>
-          <a:lstStyle/>
-          <a:p>
-            <a:pPr algn="ctr"/>
-          </a:p>
-        </p:txBody>
-      </p:sp>
-      <p:sp>
-        <p:nvSpPr>
-          <p:cNvPr id="19" name="Rectangle 18"/>
+          <a:bodyPr rtlCol="0" anchor="ctr" wrap="square" lIns="101600" rIns="101600" tIns="38100" bIns="38100"/>
+          <a:lstStyle/>
+          <a:p>
+            <a:pPr algn="ctr"/>
+            <a:r>
+              <a:rPr sz="1300" b="1">
+                <a:solidFill>
+                  <a:srgbClr val="FFFFFF"/>
+                </a:solidFill>
+                <a:latin typeface="Arial"/>
+              </a:rPr>
+              <a:t>2</a:t>
+            </a:r>
+          </a:p>
+        </p:txBody>
+      </p:sp>
+      <p:sp>
+        <p:nvSpPr>
+          <p:cNvPr id="17" name="TextBox 16"/>
+          <p:cNvSpPr txBox="1"/>
+          <p:nvPr/>
+        </p:nvSpPr>
+        <p:spPr>
+          <a:xfrm>
+            <a:off x="3319271" y="5843016"/>
+            <a:ext cx="2697480" cy="402336"/>
+          </a:xfrm>
+          <a:prstGeom prst="rect">
+            <a:avLst/>
+          </a:prstGeom>
+          <a:noFill/>
+        </p:spPr>
+        <p:txBody>
+          <a:bodyPr wrap="square" lIns="0" rIns="0" tIns="0" bIns="0">
+            <a:spAutoFit/>
+          </a:bodyPr>
+          <a:lstStyle/>
+          <a:p>
+            <a:pPr algn="ctr"/>
+            <a:r>
+              <a:rPr sz="1100" b="1">
+                <a:solidFill>
+                  <a:srgbClr val="111827"/>
+                </a:solidFill>
+                <a:latin typeface="Arial"/>
+              </a:rPr>
+              <a:t>He is God's presence in us</a:t>
+            </a:r>
+          </a:p>
+        </p:txBody>
+      </p:sp>
+      <p:sp>
+        <p:nvSpPr>
+          <p:cNvPr id="18" name="Oval 17"/>
           <p:cNvSpPr/>
           <p:nvPr/>
         </p:nvSpPr>
         <p:spPr>
           <a:xfrm>
-            <a:off x="9635947" y="3143707"/>
-            <a:ext cx="562355" cy="84582"/>
-          </a:xfrm>
-          <a:prstGeom prst="rect">
-            <a:avLst/>
-          </a:prstGeom>
-          <a:solidFill>
-            <a:srgbClr val="D97706"/>
-          </a:solidFill>
-          <a:ln>
-            <a:noFill/>
+            <a:off x="7178040" y="4910328"/>
+            <a:ext cx="822960" cy="822960"/>
+          </a:xfrm>
+          <a:prstGeom prst="ellipse">
+            <a:avLst/>
+          </a:prstGeom>
+          <a:solidFill>
+            <a:srgbClr val="1B7F3A"/>
+          </a:solidFill>
+          <a:ln w="13970">
+            <a:solidFill>
+              <a:srgbClr val="111827"/>
+            </a:solidFill>
           </a:ln>
         </p:spPr>
         <p:style>
@@ -8177,66 +7736,32 @@
           </a:fontRef>
         </p:style>
         <p:txBody>
-          <a:bodyPr rtlCol="0" anchor="ctr"/>
-          <a:lstStyle/>
-          <a:p>
-            <a:pPr algn="ctr"/>
-          </a:p>
-        </p:txBody>
-      </p:sp>
-      <p:sp>
-        <p:nvSpPr>
-          <p:cNvPr id="20" name="Rounded Rectangle 19"/>
-          <p:cNvSpPr/>
-          <p:nvPr/>
-        </p:nvSpPr>
-        <p:spPr>
-          <a:xfrm>
-            <a:off x="9411004" y="3515868"/>
-            <a:ext cx="1030986" cy="135331"/>
-          </a:xfrm>
-          <a:prstGeom prst="roundRect">
-            <a:avLst/>
-          </a:prstGeom>
-          <a:solidFill>
-            <a:srgbClr val="D90000"/>
-          </a:solidFill>
-          <a:ln>
-            <a:noFill/>
-          </a:ln>
-        </p:spPr>
-        <p:style>
-          <a:lnRef idx="1">
-            <a:schemeClr val="accent1"/>
-          </a:lnRef>
-          <a:fillRef idx="3">
-            <a:schemeClr val="accent1"/>
-          </a:fillRef>
-          <a:effectRef idx="2">
-            <a:schemeClr val="accent1"/>
-          </a:effectRef>
-          <a:fontRef idx="minor">
-            <a:schemeClr val="lt1"/>
-          </a:fontRef>
-        </p:style>
-        <p:txBody>
-          <a:bodyPr rtlCol="0" anchor="ctr"/>
-          <a:lstStyle/>
-          <a:p>
-            <a:pPr algn="ctr"/>
-          </a:p>
-        </p:txBody>
-      </p:sp>
-      <p:sp>
-        <p:nvSpPr>
-          <p:cNvPr id="21" name="TextBox 20"/>
+          <a:bodyPr rtlCol="0" anchor="ctr" wrap="square" lIns="101600" rIns="101600" tIns="38100" bIns="38100"/>
+          <a:lstStyle/>
+          <a:p>
+            <a:pPr algn="ctr"/>
+            <a:r>
+              <a:rPr sz="1300" b="1">
+                <a:solidFill>
+                  <a:srgbClr val="FFFFFF"/>
+                </a:solidFill>
+                <a:latin typeface="Arial"/>
+              </a:rPr>
+              <a:t>3</a:t>
+            </a:r>
+          </a:p>
+        </p:txBody>
+      </p:sp>
+      <p:sp>
+        <p:nvSpPr>
+          <p:cNvPr id="19" name="TextBox 18"/>
           <p:cNvSpPr txBox="1"/>
           <p:nvPr/>
         </p:nvSpPr>
         <p:spPr>
           <a:xfrm>
-            <a:off x="8961120" y="3767328"/>
-            <a:ext cx="1874519" cy="228600"/>
+            <a:off x="6245352" y="5843016"/>
+            <a:ext cx="2697480" cy="402336"/>
           </a:xfrm>
           <a:prstGeom prst="rect">
             <a:avLst/>
@@ -8251,55 +7776,20 @@
           <a:p>
             <a:pPr algn="ctr"/>
             <a:r>
-              <a:rPr sz="1000" b="0">
-                <a:solidFill>
-                  <a:srgbClr val="475569"/>
+              <a:rPr sz="1100" b="1">
+                <a:solidFill>
+                  <a:srgbClr val="111827"/>
                 </a:solidFill>
                 <a:latin typeface="Arial"/>
               </a:rPr>
-              <a:t>Christian Religious Education</a:t>
-            </a:r>
-          </a:p>
-        </p:txBody>
-      </p:sp>
-      <p:sp>
-        <p:nvSpPr>
-          <p:cNvPr id="22" name="TextBox 21"/>
-          <p:cNvSpPr txBox="1"/>
-          <p:nvPr/>
-        </p:nvSpPr>
-        <p:spPr>
-          <a:xfrm>
-            <a:off x="8869680" y="4526280"/>
-            <a:ext cx="2057400" cy="804672"/>
-          </a:xfrm>
-          <a:prstGeom prst="rect">
-            <a:avLst/>
-          </a:prstGeom>
-          <a:noFill/>
-        </p:spPr>
-        <p:txBody>
-          <a:bodyPr wrap="square" lIns="0" rIns="0" tIns="0" bIns="0">
-            <a:spAutoFit/>
-          </a:bodyPr>
-          <a:lstStyle/>
-          <a:p>
-            <a:pPr algn="ctr"/>
-            <a:r>
-              <a:rPr sz="1400" b="1">
-                <a:solidFill>
-                  <a:srgbClr val="111827"/>
-                </a:solidFill>
-                <a:latin typeface="Arial"/>
-              </a:rPr>
-              <a:t>Teacher models first. Learners copy the pattern, then explain the step.</a:t>
-            </a:r>
-          </a:p>
-        </p:txBody>
-      </p:sp>
-      <p:sp>
-        <p:nvSpPr>
-          <p:cNvPr id="23" name="TextBox 22"/>
+              <a:t>He is the "Gift and the Giver."</a:t>
+            </a:r>
+          </a:p>
+        </p:txBody>
+      </p:sp>
+      <p:sp>
+        <p:nvSpPr>
+          <p:cNvPr id="20" name="TextBox 19"/>
           <p:cNvSpPr txBox="1"/>
           <p:nvPr/>
         </p:nvSpPr>
@@ -8727,14 +8217,14 @@
         </p:nvSpPr>
         <p:spPr>
           <a:xfrm>
-            <a:off x="777240" y="1719072"/>
-            <a:ext cx="10652760" cy="822960"/>
+            <a:off x="777240" y="1755648"/>
+            <a:ext cx="10652760" cy="4480560"/>
           </a:xfrm>
           <a:prstGeom prst="roundRect">
             <a:avLst/>
           </a:prstGeom>
           <a:solidFill>
-            <a:srgbClr val="FFF7E0"/>
+            <a:srgbClr val="FFFFFF"/>
           </a:solidFill>
           <a:ln w="17780">
             <a:solidFill>
@@ -8757,42 +8247,67 @@
           </a:fontRef>
         </p:style>
         <p:txBody>
-          <a:bodyPr rtlCol="0" anchor="ctr" wrap="square" lIns="101600" rIns="101600" tIns="38100" bIns="38100"/>
-          <a:lstStyle/>
-          <a:p>
-            <a:pPr algn="ctr"/>
-            <a:r>
-              <a:rPr sz="1900" b="1">
-                <a:solidFill>
-                  <a:srgbClr val="111827"/>
+          <a:bodyPr rtlCol="0" anchor="ctr"/>
+          <a:lstStyle/>
+          <a:p>
+            <a:pPr algn="ctr"/>
+          </a:p>
+        </p:txBody>
+      </p:sp>
+      <p:sp>
+        <p:nvSpPr>
+          <p:cNvPr id="12" name="TextBox 11"/>
+          <p:cNvSpPr txBox="1"/>
+          <p:nvPr/>
+        </p:nvSpPr>
+        <p:spPr>
+          <a:xfrm>
+            <a:off x="1051560" y="1975104"/>
+            <a:ext cx="1920240" cy="237744"/>
+          </a:xfrm>
+          <a:prstGeom prst="rect">
+            <a:avLst/>
+          </a:prstGeom>
+          <a:noFill/>
+        </p:spPr>
+        <p:txBody>
+          <a:bodyPr wrap="square" lIns="0" rIns="0" tIns="0" bIns="0">
+            <a:spAutoFit/>
+          </a:bodyPr>
+          <a:lstStyle/>
+          <a:p>
+            <a:r>
+              <a:rPr sz="1200" b="1">
+                <a:solidFill>
+                  <a:srgbClr val="BE123C"/>
                 </a:solidFill>
                 <a:latin typeface="Arial"/>
               </a:rPr>
-              <a:t>Answer with evidence:</a:t>
-            </a:r>
-          </a:p>
-        </p:txBody>
-      </p:sp>
-      <p:sp>
-        <p:nvSpPr>
-          <p:cNvPr id="12" name="Rounded Rectangle 11"/>
+              <a:t>PRACTICE FLOW</a:t>
+            </a:r>
+          </a:p>
+        </p:txBody>
+      </p:sp>
+      <p:sp>
+        <p:nvSpPr>
+          <p:cNvPr id="13" name="Rounded Rectangle 12"/>
           <p:cNvSpPr/>
           <p:nvPr/>
         </p:nvSpPr>
         <p:spPr>
           <a:xfrm>
-            <a:off x="868680" y="2743200"/>
-            <a:ext cx="10378440" cy="804672"/>
+            <a:off x="777240" y="2304288"/>
+            <a:ext cx="10652760" cy="822960"/>
           </a:xfrm>
           <a:prstGeom prst="roundRect">
             <a:avLst/>
           </a:prstGeom>
           <a:solidFill>
-            <a:srgbClr val="FFFFFF"/>
-          </a:solidFill>
-          <a:ln w="11430">
+            <a:srgbClr val="FFF7E0"/>
+          </a:solidFill>
+          <a:ln w="17780">
             <a:solidFill>
-              <a:srgbClr val="CBD5E1"/>
+              <a:srgbClr val="BE123C"/>
             </a:solidFill>
           </a:ln>
         </p:spPr>
@@ -8811,32 +8326,43 @@
           </a:fontRef>
         </p:style>
         <p:txBody>
-          <a:bodyPr rtlCol="0" anchor="ctr"/>
-          <a:lstStyle/>
-          <a:p>
-            <a:pPr algn="ctr"/>
-          </a:p>
-        </p:txBody>
-      </p:sp>
-      <p:sp>
-        <p:nvSpPr>
-          <p:cNvPr id="13" name="Oval 12"/>
+          <a:bodyPr rtlCol="0" anchor="ctr" wrap="square" lIns="101600" rIns="101600" tIns="38100" bIns="38100"/>
+          <a:lstStyle/>
+          <a:p>
+            <a:pPr algn="ctr"/>
+            <a:r>
+              <a:rPr sz="1900" b="1">
+                <a:solidFill>
+                  <a:srgbClr val="111827"/>
+                </a:solidFill>
+                <a:latin typeface="Arial"/>
+              </a:rPr>
+              <a:t>Answer with evidence</a:t>
+            </a:r>
+          </a:p>
+        </p:txBody>
+      </p:sp>
+      <p:sp>
+        <p:nvSpPr>
+          <p:cNvPr id="14" name="Rounded Rectangle 13"/>
           <p:cNvSpPr/>
           <p:nvPr/>
         </p:nvSpPr>
         <p:spPr>
           <a:xfrm>
-            <a:off x="1078992" y="2898648"/>
-            <a:ext cx="475488" cy="475488"/>
-          </a:xfrm>
-          <a:prstGeom prst="ellipse">
-            <a:avLst/>
-          </a:prstGeom>
-          <a:solidFill>
-            <a:srgbClr val="BE123C"/>
-          </a:solidFill>
-          <a:ln>
-            <a:noFill/>
+            <a:off x="960120" y="3401568"/>
+            <a:ext cx="3063240" cy="1691640"/>
+          </a:xfrm>
+          <a:prstGeom prst="roundRect">
+            <a:avLst/>
+          </a:prstGeom>
+          <a:solidFill>
+            <a:srgbClr val="FFFFFF"/>
+          </a:solidFill>
+          <a:ln w="12700">
+            <a:solidFill>
+              <a:srgbClr val="BE123C"/>
+            </a:solidFill>
           </a:ln>
         </p:spPr>
         <p:style>
@@ -8854,72 +8380,29 @@
           </a:fontRef>
         </p:style>
         <p:txBody>
-          <a:bodyPr rtlCol="0" anchor="ctr" wrap="square" lIns="101600" rIns="101600" tIns="38100" bIns="38100"/>
-          <a:lstStyle/>
-          <a:p>
-            <a:pPr algn="ctr"/>
-            <a:r>
-              <a:rPr sz="1500" b="1">
-                <a:solidFill>
-                  <a:srgbClr val="FFFFFF"/>
-                </a:solidFill>
-                <a:latin typeface="Arial"/>
-              </a:rPr>
-              <a:t>?</a:t>
-            </a:r>
-          </a:p>
-        </p:txBody>
-      </p:sp>
-      <p:sp>
-        <p:nvSpPr>
-          <p:cNvPr id="14" name="TextBox 13"/>
-          <p:cNvSpPr txBox="1"/>
-          <p:nvPr/>
-        </p:nvSpPr>
-        <p:spPr>
-          <a:xfrm>
-            <a:off x="1719072" y="2889504"/>
-            <a:ext cx="5623560" cy="384048"/>
-          </a:xfrm>
-          <a:prstGeom prst="rect">
-            <a:avLst/>
-          </a:prstGeom>
-          <a:noFill/>
-        </p:spPr>
-        <p:txBody>
-          <a:bodyPr wrap="square" lIns="0" rIns="0" tIns="0" bIns="0">
-            <a:spAutoFit/>
-          </a:bodyPr>
-          <a:lstStyle/>
-          <a:p>
-            <a:r>
-              <a:rPr sz="1600" b="1">
-                <a:solidFill>
-                  <a:srgbClr val="111827"/>
-                </a:solidFill>
-                <a:latin typeface="Arial"/>
-              </a:rPr>
-              <a:t>How do you know the wind is there?</a:t>
-            </a:r>
-          </a:p>
-        </p:txBody>
-      </p:sp>
-      <p:sp>
-        <p:nvSpPr>
-          <p:cNvPr id="15" name="Rectangle 14"/>
+          <a:bodyPr rtlCol="0" anchor="ctr"/>
+          <a:lstStyle/>
+          <a:p>
+            <a:pPr algn="ctr"/>
+          </a:p>
+        </p:txBody>
+      </p:sp>
+      <p:sp>
+        <p:nvSpPr>
+          <p:cNvPr id="15" name="Oval 14"/>
           <p:cNvSpPr/>
           <p:nvPr/>
         </p:nvSpPr>
         <p:spPr>
           <a:xfrm>
-            <a:off x="7635240" y="3264408"/>
-            <a:ext cx="3246120" cy="36576"/>
-          </a:xfrm>
-          <a:prstGeom prst="rect">
-            <a:avLst/>
-          </a:prstGeom>
-          <a:solidFill>
-            <a:srgbClr val="CBD5E1"/>
+            <a:off x="1106424" y="3584448"/>
+            <a:ext cx="420624" cy="420624"/>
+          </a:xfrm>
+          <a:prstGeom prst="ellipse">
+            <a:avLst/>
+          </a:prstGeom>
+          <a:solidFill>
+            <a:srgbClr val="BE123C"/>
           </a:solidFill>
           <a:ln>
             <a:noFill/>
@@ -8940,34 +8423,76 @@
           </a:fontRef>
         </p:style>
         <p:txBody>
-          <a:bodyPr rtlCol="0" anchor="ctr"/>
-          <a:lstStyle/>
-          <a:p>
-            <a:pPr algn="ctr"/>
-          </a:p>
-        </p:txBody>
-      </p:sp>
-      <p:sp>
-        <p:nvSpPr>
-          <p:cNvPr id="16" name="Rounded Rectangle 15"/>
+          <a:bodyPr rtlCol="0" anchor="ctr" wrap="square" lIns="101600" rIns="101600" tIns="38100" bIns="38100"/>
+          <a:lstStyle/>
+          <a:p>
+            <a:pPr algn="ctr"/>
+            <a:r>
+              <a:rPr sz="1500" b="1">
+                <a:solidFill>
+                  <a:srgbClr val="FFFFFF"/>
+                </a:solidFill>
+                <a:latin typeface="Arial"/>
+              </a:rPr>
+              <a:t>?</a:t>
+            </a:r>
+          </a:p>
+        </p:txBody>
+      </p:sp>
+      <p:sp>
+        <p:nvSpPr>
+          <p:cNvPr id="16" name="TextBox 15"/>
+          <p:cNvSpPr txBox="1"/>
+          <p:nvPr/>
+        </p:nvSpPr>
+        <p:spPr>
+          <a:xfrm>
+            <a:off x="1655064" y="3529584"/>
+            <a:ext cx="2148840" cy="502920"/>
+          </a:xfrm>
+          <a:prstGeom prst="rect">
+            <a:avLst/>
+          </a:prstGeom>
+          <a:noFill/>
+        </p:spPr>
+        <p:txBody>
+          <a:bodyPr wrap="square" lIns="0" rIns="0" tIns="0" bIns="0">
+            <a:spAutoFit/>
+          </a:bodyPr>
+          <a:lstStyle/>
+          <a:p>
+            <a:pPr algn="ctr"/>
+            <a:r>
+              <a:rPr sz="1400" b="1">
+                <a:solidFill>
+                  <a:srgbClr val="111827"/>
+                </a:solidFill>
+                <a:latin typeface="Arial"/>
+              </a:rPr>
+              <a:t>How do you know the wind is there?</a:t>
+            </a:r>
+          </a:p>
+        </p:txBody>
+      </p:sp>
+      <p:sp>
+        <p:nvSpPr>
+          <p:cNvPr id="17" name="Rectangle 16"/>
           <p:cNvSpPr/>
           <p:nvPr/>
         </p:nvSpPr>
         <p:spPr>
           <a:xfrm>
-            <a:off x="868680" y="3822191"/>
-            <a:ext cx="10378440" cy="804672"/>
-          </a:xfrm>
-          <a:prstGeom prst="roundRect">
-            <a:avLst/>
-          </a:prstGeom>
-          <a:solidFill>
-            <a:srgbClr val="FFFFFF"/>
-          </a:solidFill>
-          <a:ln w="11430">
-            <a:solidFill>
-              <a:srgbClr val="CBD5E1"/>
-            </a:solidFill>
+            <a:off x="1463040" y="4553712"/>
+            <a:ext cx="2057400" cy="32004"/>
+          </a:xfrm>
+          <a:prstGeom prst="rect">
+            <a:avLst/>
+          </a:prstGeom>
+          <a:solidFill>
+            <a:srgbClr val="CBD5E1"/>
+          </a:solidFill>
+          <a:ln>
+            <a:noFill/>
           </a:ln>
         </p:spPr>
         <p:style>
@@ -8994,23 +8519,95 @@
       </p:sp>
       <p:sp>
         <p:nvSpPr>
-          <p:cNvPr id="17" name="Oval 16"/>
+          <p:cNvPr id="18" name="TextBox 17"/>
+          <p:cNvSpPr txBox="1"/>
+          <p:nvPr/>
+        </p:nvSpPr>
+        <p:spPr>
+          <a:xfrm>
+            <a:off x="1463040" y="4709160"/>
+            <a:ext cx="2057400" cy="201168"/>
+          </a:xfrm>
+          <a:prstGeom prst="rect">
+            <a:avLst/>
+          </a:prstGeom>
+          <a:noFill/>
+        </p:spPr>
+        <p:txBody>
+          <a:bodyPr wrap="square" lIns="0" rIns="0" tIns="0" bIns="0">
+            <a:spAutoFit/>
+          </a:bodyPr>
+          <a:lstStyle/>
+          <a:p>
+            <a:pPr algn="ctr"/>
+            <a:r>
+              <a:rPr sz="1000" b="0">
+                <a:solidFill>
+                  <a:srgbClr val="475569"/>
+                </a:solidFill>
+                <a:latin typeface="Arial"/>
+              </a:rPr>
+              <a:t>answer + reason</a:t>
+            </a:r>
+          </a:p>
+        </p:txBody>
+      </p:sp>
+      <p:cxnSp>
+        <p:nvCxnSpPr>
+          <p:cNvPr id="19" name="Connector 18"/>
+          <p:cNvCxnSpPr/>
+          <p:nvPr/>
+        </p:nvCxnSpPr>
+        <p:spPr>
+          <a:xfrm>
+            <a:off x="4014215" y="4251960"/>
+            <a:ext cx="402337" cy="0"/>
+          </a:xfrm>
+          <a:prstGeom prst="line">
+            <a:avLst/>
+          </a:prstGeom>
+          <a:ln w="25400">
+            <a:solidFill>
+              <a:srgbClr val="BE123C"/>
+            </a:solidFill>
+          </a:ln>
+        </p:spPr>
+        <p:style>
+          <a:lnRef idx="2">
+            <a:schemeClr val="accent1"/>
+          </a:lnRef>
+          <a:fillRef idx="0">
+            <a:schemeClr val="accent1"/>
+          </a:fillRef>
+          <a:effectRef idx="1">
+            <a:schemeClr val="accent1"/>
+          </a:effectRef>
+          <a:fontRef idx="minor">
+            <a:schemeClr val="tx1"/>
+          </a:fontRef>
+        </p:style>
+      </p:cxnSp>
+      <p:sp>
+        <p:nvSpPr>
+          <p:cNvPr id="20" name="Rounded Rectangle 19"/>
           <p:cNvSpPr/>
           <p:nvPr/>
         </p:nvSpPr>
         <p:spPr>
           <a:xfrm>
-            <a:off x="1078992" y="3977639"/>
-            <a:ext cx="475488" cy="475488"/>
-          </a:xfrm>
-          <a:prstGeom prst="ellipse">
-            <a:avLst/>
-          </a:prstGeom>
-          <a:solidFill>
-            <a:srgbClr val="BE123C"/>
-          </a:solidFill>
-          <a:ln>
-            <a:noFill/>
+            <a:off x="4416552" y="3401568"/>
+            <a:ext cx="3063240" cy="1691640"/>
+          </a:xfrm>
+          <a:prstGeom prst="roundRect">
+            <a:avLst/>
+          </a:prstGeom>
+          <a:solidFill>
+            <a:srgbClr val="FFF7E0"/>
+          </a:solidFill>
+          <a:ln w="12700">
+            <a:solidFill>
+              <a:srgbClr val="BE123C"/>
+            </a:solidFill>
           </a:ln>
         </p:spPr>
         <p:style>
@@ -9028,72 +8625,29 @@
           </a:fontRef>
         </p:style>
         <p:txBody>
-          <a:bodyPr rtlCol="0" anchor="ctr" wrap="square" lIns="101600" rIns="101600" tIns="38100" bIns="38100"/>
-          <a:lstStyle/>
-          <a:p>
-            <a:pPr algn="ctr"/>
-            <a:r>
-              <a:rPr sz="1500" b="1">
-                <a:solidFill>
-                  <a:srgbClr val="FFFFFF"/>
-                </a:solidFill>
-                <a:latin typeface="Arial"/>
-              </a:rPr>
-              <a:t>?</a:t>
-            </a:r>
-          </a:p>
-        </p:txBody>
-      </p:sp>
-      <p:sp>
-        <p:nvSpPr>
-          <p:cNvPr id="18" name="TextBox 17"/>
-          <p:cNvSpPr txBox="1"/>
-          <p:nvPr/>
-        </p:nvSpPr>
-        <p:spPr>
-          <a:xfrm>
-            <a:off x="1719072" y="3968496"/>
-            <a:ext cx="5623560" cy="384048"/>
-          </a:xfrm>
-          <a:prstGeom prst="rect">
-            <a:avLst/>
-          </a:prstGeom>
-          <a:noFill/>
-        </p:spPr>
-        <p:txBody>
-          <a:bodyPr wrap="square" lIns="0" rIns="0" tIns="0" bIns="0">
-            <a:spAutoFit/>
-          </a:bodyPr>
-          <a:lstStyle/>
-          <a:p>
-            <a:r>
-              <a:rPr sz="1600" b="1">
-                <a:solidFill>
-                  <a:srgbClr val="111827"/>
-                </a:solidFill>
-                <a:latin typeface="Arial"/>
-              </a:rPr>
-              <a:t>Is God visible to our physical eyes?</a:t>
-            </a:r>
-          </a:p>
-        </p:txBody>
-      </p:sp>
-      <p:sp>
-        <p:nvSpPr>
-          <p:cNvPr id="19" name="Rectangle 18"/>
+          <a:bodyPr rtlCol="0" anchor="ctr"/>
+          <a:lstStyle/>
+          <a:p>
+            <a:pPr algn="ctr"/>
+          </a:p>
+        </p:txBody>
+      </p:sp>
+      <p:sp>
+        <p:nvSpPr>
+          <p:cNvPr id="21" name="Oval 20"/>
           <p:cNvSpPr/>
           <p:nvPr/>
         </p:nvSpPr>
         <p:spPr>
           <a:xfrm>
-            <a:off x="7635240" y="4343400"/>
-            <a:ext cx="3246120" cy="36576"/>
-          </a:xfrm>
-          <a:prstGeom prst="rect">
-            <a:avLst/>
-          </a:prstGeom>
-          <a:solidFill>
-            <a:srgbClr val="CBD5E1"/>
+            <a:off x="4562856" y="3584448"/>
+            <a:ext cx="420624" cy="420624"/>
+          </a:xfrm>
+          <a:prstGeom prst="ellipse">
+            <a:avLst/>
+          </a:prstGeom>
+          <a:solidFill>
+            <a:srgbClr val="BE123C"/>
           </a:solidFill>
           <a:ln>
             <a:noFill/>
@@ -9114,34 +8668,76 @@
           </a:fontRef>
         </p:style>
         <p:txBody>
-          <a:bodyPr rtlCol="0" anchor="ctr"/>
-          <a:lstStyle/>
-          <a:p>
-            <a:pPr algn="ctr"/>
-          </a:p>
-        </p:txBody>
-      </p:sp>
-      <p:sp>
-        <p:nvSpPr>
-          <p:cNvPr id="20" name="Rounded Rectangle 19"/>
+          <a:bodyPr rtlCol="0" anchor="ctr" wrap="square" lIns="101600" rIns="101600" tIns="38100" bIns="38100"/>
+          <a:lstStyle/>
+          <a:p>
+            <a:pPr algn="ctr"/>
+            <a:r>
+              <a:rPr sz="1500" b="1">
+                <a:solidFill>
+                  <a:srgbClr val="FFFFFF"/>
+                </a:solidFill>
+                <a:latin typeface="Arial"/>
+              </a:rPr>
+              <a:t>?</a:t>
+            </a:r>
+          </a:p>
+        </p:txBody>
+      </p:sp>
+      <p:sp>
+        <p:nvSpPr>
+          <p:cNvPr id="22" name="TextBox 21"/>
+          <p:cNvSpPr txBox="1"/>
+          <p:nvPr/>
+        </p:nvSpPr>
+        <p:spPr>
+          <a:xfrm>
+            <a:off x="5111496" y="3529584"/>
+            <a:ext cx="2148840" cy="502920"/>
+          </a:xfrm>
+          <a:prstGeom prst="rect">
+            <a:avLst/>
+          </a:prstGeom>
+          <a:noFill/>
+        </p:spPr>
+        <p:txBody>
+          <a:bodyPr wrap="square" lIns="0" rIns="0" tIns="0" bIns="0">
+            <a:spAutoFit/>
+          </a:bodyPr>
+          <a:lstStyle/>
+          <a:p>
+            <a:pPr algn="ctr"/>
+            <a:r>
+              <a:rPr sz="1400" b="1">
+                <a:solidFill>
+                  <a:srgbClr val="111827"/>
+                </a:solidFill>
+                <a:latin typeface="Arial"/>
+              </a:rPr>
+              <a:t>Is God visible to our physical eyes?</a:t>
+            </a:r>
+          </a:p>
+        </p:txBody>
+      </p:sp>
+      <p:sp>
+        <p:nvSpPr>
+          <p:cNvPr id="23" name="Rectangle 22"/>
           <p:cNvSpPr/>
           <p:nvPr/>
         </p:nvSpPr>
         <p:spPr>
           <a:xfrm>
-            <a:off x="868680" y="4901183"/>
-            <a:ext cx="10378440" cy="804672"/>
-          </a:xfrm>
-          <a:prstGeom prst="roundRect">
-            <a:avLst/>
-          </a:prstGeom>
-          <a:solidFill>
-            <a:srgbClr val="FFFFFF"/>
-          </a:solidFill>
-          <a:ln w="11430">
-            <a:solidFill>
-              <a:srgbClr val="CBD5E1"/>
-            </a:solidFill>
+            <a:off x="4919472" y="4553712"/>
+            <a:ext cx="2057400" cy="32004"/>
+          </a:xfrm>
+          <a:prstGeom prst="rect">
+            <a:avLst/>
+          </a:prstGeom>
+          <a:solidFill>
+            <a:srgbClr val="CBD5E1"/>
+          </a:solidFill>
+          <a:ln>
+            <a:noFill/>
           </a:ln>
         </p:spPr>
         <p:style>
@@ -9168,23 +8764,95 @@
       </p:sp>
       <p:sp>
         <p:nvSpPr>
-          <p:cNvPr id="21" name="Oval 20"/>
+          <p:cNvPr id="24" name="TextBox 23"/>
+          <p:cNvSpPr txBox="1"/>
+          <p:nvPr/>
+        </p:nvSpPr>
+        <p:spPr>
+          <a:xfrm>
+            <a:off x="4919472" y="4709160"/>
+            <a:ext cx="2057400" cy="201168"/>
+          </a:xfrm>
+          <a:prstGeom prst="rect">
+            <a:avLst/>
+          </a:prstGeom>
+          <a:noFill/>
+        </p:spPr>
+        <p:txBody>
+          <a:bodyPr wrap="square" lIns="0" rIns="0" tIns="0" bIns="0">
+            <a:spAutoFit/>
+          </a:bodyPr>
+          <a:lstStyle/>
+          <a:p>
+            <a:pPr algn="ctr"/>
+            <a:r>
+              <a:rPr sz="1000" b="0">
+                <a:solidFill>
+                  <a:srgbClr val="475569"/>
+                </a:solidFill>
+                <a:latin typeface="Arial"/>
+              </a:rPr>
+              <a:t>answer + reason</a:t>
+            </a:r>
+          </a:p>
+        </p:txBody>
+      </p:sp>
+      <p:cxnSp>
+        <p:nvCxnSpPr>
+          <p:cNvPr id="25" name="Connector 24"/>
+          <p:cNvCxnSpPr/>
+          <p:nvPr/>
+        </p:nvCxnSpPr>
+        <p:spPr>
+          <a:xfrm>
+            <a:off x="7470648" y="4251960"/>
+            <a:ext cx="402335" cy="0"/>
+          </a:xfrm>
+          <a:prstGeom prst="line">
+            <a:avLst/>
+          </a:prstGeom>
+          <a:ln w="25400">
+            <a:solidFill>
+              <a:srgbClr val="BE123C"/>
+            </a:solidFill>
+          </a:ln>
+        </p:spPr>
+        <p:style>
+          <a:lnRef idx="2">
+            <a:schemeClr val="accent1"/>
+          </a:lnRef>
+          <a:fillRef idx="0">
+            <a:schemeClr val="accent1"/>
+          </a:fillRef>
+          <a:effectRef idx="1">
+            <a:schemeClr val="accent1"/>
+          </a:effectRef>
+          <a:fontRef idx="minor">
+            <a:schemeClr val="tx1"/>
+          </a:fontRef>
+        </p:style>
+      </p:cxnSp>
+      <p:sp>
+        <p:nvSpPr>
+          <p:cNvPr id="26" name="Rounded Rectangle 25"/>
           <p:cNvSpPr/>
           <p:nvPr/>
         </p:nvSpPr>
         <p:spPr>
           <a:xfrm>
-            <a:off x="1078992" y="5056631"/>
-            <a:ext cx="475488" cy="475488"/>
-          </a:xfrm>
-          <a:prstGeom prst="ellipse">
-            <a:avLst/>
-          </a:prstGeom>
-          <a:solidFill>
-            <a:srgbClr val="BE123C"/>
-          </a:solidFill>
-          <a:ln>
-            <a:noFill/>
+            <a:off x="7872983" y="3401568"/>
+            <a:ext cx="3063240" cy="1691640"/>
+          </a:xfrm>
+          <a:prstGeom prst="roundRect">
+            <a:avLst/>
+          </a:prstGeom>
+          <a:solidFill>
+            <a:srgbClr val="FFFFFF"/>
+          </a:solidFill>
+          <a:ln w="12700">
+            <a:solidFill>
+              <a:srgbClr val="BE123C"/>
+            </a:solidFill>
           </a:ln>
         </p:spPr>
         <p:style>
@@ -9202,72 +8870,29 @@
           </a:fontRef>
         </p:style>
         <p:txBody>
-          <a:bodyPr rtlCol="0" anchor="ctr" wrap="square" lIns="101600" rIns="101600" tIns="38100" bIns="38100"/>
-          <a:lstStyle/>
-          <a:p>
-            <a:pPr algn="ctr"/>
-            <a:r>
-              <a:rPr sz="1500" b="1">
-                <a:solidFill>
-                  <a:srgbClr val="FFFFFF"/>
-                </a:solidFill>
-                <a:latin typeface="Arial"/>
-              </a:rPr>
-              <a:t>?</a:t>
-            </a:r>
-          </a:p>
-        </p:txBody>
-      </p:sp>
-      <p:sp>
-        <p:nvSpPr>
-          <p:cNvPr id="22" name="TextBox 21"/>
-          <p:cNvSpPr txBox="1"/>
-          <p:nvPr/>
-        </p:nvSpPr>
-        <p:spPr>
-          <a:xfrm>
-            <a:off x="1719072" y="5047488"/>
-            <a:ext cx="5623560" cy="384048"/>
-          </a:xfrm>
-          <a:prstGeom prst="rect">
-            <a:avLst/>
-          </a:prstGeom>
-          <a:noFill/>
-        </p:spPr>
-        <p:txBody>
-          <a:bodyPr wrap="square" lIns="0" rIns="0" tIns="0" bIns="0">
-            <a:spAutoFit/>
-          </a:bodyPr>
-          <a:lstStyle/>
-          <a:p>
-            <a:r>
-              <a:rPr sz="1600" b="1">
-                <a:solidFill>
-                  <a:srgbClr val="111827"/>
-                </a:solidFill>
-                <a:latin typeface="Arial"/>
-              </a:rPr>
-              <a:t>Who is the Holy Spirit?</a:t>
-            </a:r>
-          </a:p>
-        </p:txBody>
-      </p:sp>
-      <p:sp>
-        <p:nvSpPr>
-          <p:cNvPr id="23" name="Rectangle 22"/>
+          <a:bodyPr rtlCol="0" anchor="ctr"/>
+          <a:lstStyle/>
+          <a:p>
+            <a:pPr algn="ctr"/>
+          </a:p>
+        </p:txBody>
+      </p:sp>
+      <p:sp>
+        <p:nvSpPr>
+          <p:cNvPr id="27" name="Oval 26"/>
           <p:cNvSpPr/>
           <p:nvPr/>
         </p:nvSpPr>
         <p:spPr>
           <a:xfrm>
-            <a:off x="7635240" y="5422392"/>
-            <a:ext cx="3246120" cy="36576"/>
-          </a:xfrm>
-          <a:prstGeom prst="rect">
-            <a:avLst/>
-          </a:prstGeom>
-          <a:solidFill>
-            <a:srgbClr val="CBD5E1"/>
+            <a:off x="8019288" y="3584448"/>
+            <a:ext cx="420624" cy="420624"/>
+          </a:xfrm>
+          <a:prstGeom prst="ellipse">
+            <a:avLst/>
+          </a:prstGeom>
+          <a:solidFill>
+            <a:srgbClr val="BE123C"/>
           </a:solidFill>
           <a:ln>
             <a:noFill/>
@@ -9288,23 +8913,32 @@
           </a:fontRef>
         </p:style>
         <p:txBody>
-          <a:bodyPr rtlCol="0" anchor="ctr"/>
-          <a:lstStyle/>
-          <a:p>
-            <a:pPr algn="ctr"/>
-          </a:p>
-        </p:txBody>
-      </p:sp>
-      <p:sp>
-        <p:nvSpPr>
-          <p:cNvPr id="24" name="TextBox 23"/>
+          <a:bodyPr rtlCol="0" anchor="ctr" wrap="square" lIns="101600" rIns="101600" tIns="38100" bIns="38100"/>
+          <a:lstStyle/>
+          <a:p>
+            <a:pPr algn="ctr"/>
+            <a:r>
+              <a:rPr sz="1500" b="1">
+                <a:solidFill>
+                  <a:srgbClr val="FFFFFF"/>
+                </a:solidFill>
+                <a:latin typeface="Arial"/>
+              </a:rPr>
+              <a:t>?</a:t>
+            </a:r>
+          </a:p>
+        </p:txBody>
+      </p:sp>
+      <p:sp>
+        <p:nvSpPr>
+          <p:cNvPr id="28" name="TextBox 27"/>
           <p:cNvSpPr txBox="1"/>
           <p:nvPr/>
         </p:nvSpPr>
         <p:spPr>
           <a:xfrm>
-            <a:off x="896112" y="5989320"/>
-            <a:ext cx="10287000" cy="274320"/>
+            <a:off x="8567928" y="3529584"/>
+            <a:ext cx="2148840" cy="502920"/>
           </a:xfrm>
           <a:prstGeom prst="rect">
             <a:avLst/>
@@ -9319,20 +8953,133 @@
           <a:p>
             <a:pPr algn="ctr"/>
             <a:r>
-              <a:rPr sz="1200" b="0">
-                <a:solidFill>
-                  <a:srgbClr val="475569"/>
+              <a:rPr sz="1400" b="1">
+                <a:solidFill>
+                  <a:srgbClr val="111827"/>
                 </a:solidFill>
                 <a:latin typeface="Arial"/>
               </a:rPr>
-              <a:t>Use the source idea, not guessing.</a:t>
-            </a:r>
-          </a:p>
-        </p:txBody>
-      </p:sp>
-      <p:sp>
-        <p:nvSpPr>
-          <p:cNvPr id="25" name="TextBox 24"/>
+              <a:t>Who is the Holy Spirit?</a:t>
+            </a:r>
+          </a:p>
+        </p:txBody>
+      </p:sp>
+      <p:sp>
+        <p:nvSpPr>
+          <p:cNvPr id="29" name="Rectangle 28"/>
+          <p:cNvSpPr/>
+          <p:nvPr/>
+        </p:nvSpPr>
+        <p:spPr>
+          <a:xfrm>
+            <a:off x="8375904" y="4553712"/>
+            <a:ext cx="2057400" cy="32004"/>
+          </a:xfrm>
+          <a:prstGeom prst="rect">
+            <a:avLst/>
+          </a:prstGeom>
+          <a:solidFill>
+            <a:srgbClr val="CBD5E1"/>
+          </a:solidFill>
+          <a:ln>
+            <a:noFill/>
+          </a:ln>
+        </p:spPr>
+        <p:style>
+          <a:lnRef idx="1">
+            <a:schemeClr val="accent1"/>
+          </a:lnRef>
+          <a:fillRef idx="3">
+            <a:schemeClr val="accent1"/>
+          </a:fillRef>
+          <a:effectRef idx="2">
+            <a:schemeClr val="accent1"/>
+          </a:effectRef>
+          <a:fontRef idx="minor">
+            <a:schemeClr val="lt1"/>
+          </a:fontRef>
+        </p:style>
+        <p:txBody>
+          <a:bodyPr rtlCol="0" anchor="ctr"/>
+          <a:lstStyle/>
+          <a:p>
+            <a:pPr algn="ctr"/>
+          </a:p>
+        </p:txBody>
+      </p:sp>
+      <p:sp>
+        <p:nvSpPr>
+          <p:cNvPr id="30" name="TextBox 29"/>
+          <p:cNvSpPr txBox="1"/>
+          <p:nvPr/>
+        </p:nvSpPr>
+        <p:spPr>
+          <a:xfrm>
+            <a:off x="8375904" y="4709160"/>
+            <a:ext cx="2057400" cy="201168"/>
+          </a:xfrm>
+          <a:prstGeom prst="rect">
+            <a:avLst/>
+          </a:prstGeom>
+          <a:noFill/>
+        </p:spPr>
+        <p:txBody>
+          <a:bodyPr wrap="square" lIns="0" rIns="0" tIns="0" bIns="0">
+            <a:spAutoFit/>
+          </a:bodyPr>
+          <a:lstStyle/>
+          <a:p>
+            <a:pPr algn="ctr"/>
+            <a:r>
+              <a:rPr sz="1000" b="0">
+                <a:solidFill>
+                  <a:srgbClr val="475569"/>
+                </a:solidFill>
+                <a:latin typeface="Arial"/>
+              </a:rPr>
+              <a:t>answer + reason</a:t>
+            </a:r>
+          </a:p>
+        </p:txBody>
+      </p:sp>
+      <p:sp>
+        <p:nvSpPr>
+          <p:cNvPr id="31" name="TextBox 30"/>
+          <p:cNvSpPr txBox="1"/>
+          <p:nvPr/>
+        </p:nvSpPr>
+        <p:spPr>
+          <a:xfrm>
+            <a:off x="914400" y="5907024"/>
+            <a:ext cx="10287000" cy="274320"/>
+          </a:xfrm>
+          <a:prstGeom prst="rect">
+            <a:avLst/>
+          </a:prstGeom>
+          <a:noFill/>
+        </p:spPr>
+        <p:txBody>
+          <a:bodyPr wrap="square" lIns="0" rIns="0" tIns="0" bIns="0">
+            <a:spAutoFit/>
+          </a:bodyPr>
+          <a:lstStyle/>
+          <a:p>
+            <a:pPr algn="ctr"/>
+            <a:r>
+              <a:rPr sz="1200" b="0">
+                <a:solidFill>
+                  <a:srgbClr val="475569"/>
+                </a:solidFill>
+                <a:latin typeface="Arial"/>
+              </a:rPr>
+              <a:t>Use evidence from the lesson, not guessing.</a:t>
+            </a:r>
+          </a:p>
+        </p:txBody>
+      </p:sp>
+      <p:sp>
+        <p:nvSpPr>
+          <p:cNvPr id="32" name="TextBox 31"/>
           <p:cNvSpPr txBox="1"/>
           <p:nvPr/>
         </p:nvSpPr>
@@ -9760,16 +9507,16 @@
         </p:nvSpPr>
         <p:spPr>
           <a:xfrm>
-            <a:off x="777240" y="1783080"/>
-            <a:ext cx="3063240" cy="4343400"/>
+            <a:off x="777240" y="1755648"/>
+            <a:ext cx="10652760" cy="4480560"/>
           </a:xfrm>
           <a:prstGeom prst="roundRect">
             <a:avLst/>
           </a:prstGeom>
           <a:solidFill>
-            <a:srgbClr val="FFF7E0"/>
-          </a:solidFill>
-          <a:ln w="17780">
+            <a:srgbClr val="FFFFFF"/>
+          </a:solidFill>
+          <a:ln w="17145">
             <a:solidFill>
               <a:srgbClr val="1B7F3A"/>
             </a:solidFill>
@@ -9790,33 +9537,77 @@
           </a:fontRef>
         </p:style>
         <p:txBody>
-          <a:bodyPr rtlCol="0" anchor="ctr"/>
-          <a:lstStyle/>
-          <a:p>
-            <a:pPr algn="ctr"/>
-          </a:p>
-        </p:txBody>
-      </p:sp>
-      <p:sp>
-        <p:nvSpPr>
-          <p:cNvPr id="12" name="Oval 11"/>
+          <a:bodyPr rtlCol="0" anchor="t" wrap="square" lIns="101600" rIns="101600" tIns="101600" bIns="38100"/>
+          <a:lstStyle/>
+          <a:p>
+            <a:pPr algn="l"/>
+            <a:r>
+              <a:rPr sz="1200" b="1">
+                <a:solidFill>
+                  <a:srgbClr val="1B7F3A"/>
+                </a:solidFill>
+                <a:latin typeface="Arial"/>
+              </a:rPr>
+              <a:t>GROUP INFOGRAPHIC</a:t>
+            </a:r>
+          </a:p>
+        </p:txBody>
+      </p:sp>
+      <p:sp>
+        <p:nvSpPr>
+          <p:cNvPr id="12" name="TextBox 11"/>
+          <p:cNvSpPr txBox="1"/>
+          <p:nvPr/>
+        </p:nvSpPr>
+        <p:spPr>
+          <a:xfrm>
+            <a:off x="1417319" y="2322576"/>
+            <a:ext cx="9372600" cy="411480"/>
+          </a:xfrm>
+          <a:prstGeom prst="rect">
+            <a:avLst/>
+          </a:prstGeom>
+          <a:noFill/>
+        </p:spPr>
+        <p:txBody>
+          <a:bodyPr wrap="square" lIns="0" rIns="0" tIns="0" bIns="0">
+            <a:spAutoFit/>
+          </a:bodyPr>
+          <a:lstStyle/>
+          <a:p>
+            <a:pPr algn="ctr"/>
+            <a:r>
+              <a:rPr sz="1800" b="1">
+                <a:solidFill>
+                  <a:srgbClr val="111827"/>
+                </a:solidFill>
+                <a:latin typeface="Arial"/>
+              </a:rPr>
+              <a:t>Challenge</a:t>
+            </a:r>
+          </a:p>
+        </p:txBody>
+      </p:sp>
+      <p:sp>
+        <p:nvSpPr>
+          <p:cNvPr id="13" name="Isosceles Triangle 12"/>
           <p:cNvSpPr/>
           <p:nvPr/>
         </p:nvSpPr>
         <p:spPr>
           <a:xfrm>
-            <a:off x="2122322" y="2461564"/>
-            <a:ext cx="419709" cy="312724"/>
-          </a:xfrm>
-          <a:prstGeom prst="ellipse">
-            <a:avLst/>
-          </a:prstGeom>
-          <a:solidFill>
-            <a:srgbClr val="FCD116"/>
-          </a:solidFill>
-          <a:ln w="10160">
+            <a:off x="4754879" y="2990088"/>
+            <a:ext cx="2651760" cy="2651760"/>
+          </a:xfrm>
+          <a:prstGeom prst="triangle">
+            <a:avLst/>
+          </a:prstGeom>
+          <a:solidFill>
+            <a:srgbClr val="FFF7E0"/>
+          </a:solidFill>
+          <a:ln w="22860">
             <a:solidFill>
-              <a:srgbClr val="D97706"/>
+              <a:srgbClr val="111827"/>
             </a:solidFill>
           </a:ln>
         </p:spPr>
@@ -9844,23 +9635,25 @@
       </p:sp>
       <p:sp>
         <p:nvSpPr>
-          <p:cNvPr id="13" name="Rectangle 12"/>
+          <p:cNvPr id="14" name="Oval 13"/>
           <p:cNvSpPr/>
           <p:nvPr/>
         </p:nvSpPr>
         <p:spPr>
           <a:xfrm>
-            <a:off x="2262225" y="2774289"/>
-            <a:ext cx="139903" cy="729691"/>
-          </a:xfrm>
-          <a:prstGeom prst="rect">
-            <a:avLst/>
-          </a:prstGeom>
-          <a:solidFill>
-            <a:srgbClr val="D97706"/>
-          </a:solidFill>
-          <a:ln>
-            <a:noFill/>
+            <a:off x="5715000" y="2852928"/>
+            <a:ext cx="822960" cy="822960"/>
+          </a:xfrm>
+          <a:prstGeom prst="ellipse">
+            <a:avLst/>
+          </a:prstGeom>
+          <a:solidFill>
+            <a:srgbClr val="FCD116"/>
+          </a:solidFill>
+          <a:ln w="13970">
+            <a:solidFill>
+              <a:srgbClr val="111827"/>
+            </a:solidFill>
           </a:ln>
         </p:spPr>
         <p:style>
@@ -9878,32 +9671,78 @@
           </a:fontRef>
         </p:style>
         <p:txBody>
-          <a:bodyPr rtlCol="0" anchor="ctr"/>
-          <a:lstStyle/>
-          <a:p>
-            <a:pPr algn="ctr"/>
-          </a:p>
-        </p:txBody>
-      </p:sp>
-      <p:sp>
-        <p:nvSpPr>
-          <p:cNvPr id="14" name="Rectangle 13"/>
+          <a:bodyPr rtlCol="0" anchor="ctr" wrap="square" lIns="101600" rIns="101600" tIns="38100" bIns="38100"/>
+          <a:lstStyle/>
+          <a:p>
+            <a:pPr algn="ctr"/>
+            <a:r>
+              <a:rPr sz="1300" b="1">
+                <a:solidFill>
+                  <a:srgbClr val="111827"/>
+                </a:solidFill>
+                <a:latin typeface="Arial"/>
+              </a:rPr>
+              <a:t>1</a:t>
+            </a:r>
+          </a:p>
+        </p:txBody>
+      </p:sp>
+      <p:sp>
+        <p:nvSpPr>
+          <p:cNvPr id="15" name="TextBox 14"/>
+          <p:cNvSpPr txBox="1"/>
+          <p:nvPr/>
+        </p:nvSpPr>
+        <p:spPr>
+          <a:xfrm>
+            <a:off x="4782312" y="3785616"/>
+            <a:ext cx="2697480" cy="402336"/>
+          </a:xfrm>
+          <a:prstGeom prst="rect">
+            <a:avLst/>
+          </a:prstGeom>
+          <a:noFill/>
+        </p:spPr>
+        <p:txBody>
+          <a:bodyPr wrap="square" lIns="0" rIns="0" tIns="0" bIns="0">
+            <a:spAutoFit/>
+          </a:bodyPr>
+          <a:lstStyle/>
+          <a:p>
+            <a:pPr algn="ctr"/>
+            <a:r>
+              <a:rPr sz="1100" b="1">
+                <a:solidFill>
+                  <a:srgbClr val="111827"/>
+                </a:solidFill>
+                <a:latin typeface="Arial"/>
+              </a:rPr>
+              <a:t>Blow on their hands and observe trees moving</a:t>
+            </a:r>
+          </a:p>
+        </p:txBody>
+      </p:sp>
+      <p:sp>
+        <p:nvSpPr>
+          <p:cNvPr id="16" name="Oval 15"/>
           <p:cNvSpPr/>
           <p:nvPr/>
         </p:nvSpPr>
         <p:spPr>
           <a:xfrm>
-            <a:off x="1982419" y="2982772"/>
-            <a:ext cx="699515" cy="86868"/>
-          </a:xfrm>
-          <a:prstGeom prst="rect">
-            <a:avLst/>
-          </a:prstGeom>
-          <a:solidFill>
-            <a:srgbClr val="D97706"/>
-          </a:solidFill>
-          <a:ln>
-            <a:noFill/>
+            <a:off x="4251959" y="4910328"/>
+            <a:ext cx="822960" cy="822960"/>
+          </a:xfrm>
+          <a:prstGeom prst="ellipse">
+            <a:avLst/>
+          </a:prstGeom>
+          <a:solidFill>
+            <a:srgbClr val="D90000"/>
+          </a:solidFill>
+          <a:ln w="13970">
+            <a:solidFill>
+              <a:srgbClr val="111827"/>
+            </a:solidFill>
           </a:ln>
         </p:spPr>
         <p:style>
@@ -9921,32 +9760,78 @@
           </a:fontRef>
         </p:style>
         <p:txBody>
-          <a:bodyPr rtlCol="0" anchor="ctr"/>
-          <a:lstStyle/>
-          <a:p>
-            <a:pPr algn="ctr"/>
-          </a:p>
-        </p:txBody>
-      </p:sp>
-      <p:sp>
-        <p:nvSpPr>
-          <p:cNvPr id="15" name="Rounded Rectangle 14"/>
+          <a:bodyPr rtlCol="0" anchor="ctr" wrap="square" lIns="101600" rIns="101600" tIns="38100" bIns="38100"/>
+          <a:lstStyle/>
+          <a:p>
+            <a:pPr algn="ctr"/>
+            <a:r>
+              <a:rPr sz="1300" b="1">
+                <a:solidFill>
+                  <a:srgbClr val="FFFFFF"/>
+                </a:solidFill>
+                <a:latin typeface="Arial"/>
+              </a:rPr>
+              <a:t>2</a:t>
+            </a:r>
+          </a:p>
+        </p:txBody>
+      </p:sp>
+      <p:sp>
+        <p:nvSpPr>
+          <p:cNvPr id="17" name="TextBox 16"/>
+          <p:cNvSpPr txBox="1"/>
+          <p:nvPr/>
+        </p:nvSpPr>
+        <p:spPr>
+          <a:xfrm>
+            <a:off x="3319271" y="5843016"/>
+            <a:ext cx="2697480" cy="402336"/>
+          </a:xfrm>
+          <a:prstGeom prst="rect">
+            <a:avLst/>
+          </a:prstGeom>
+          <a:noFill/>
+        </p:spPr>
+        <p:txBody>
+          <a:bodyPr wrap="square" lIns="0" rIns="0" tIns="0" bIns="0">
+            <a:spAutoFit/>
+          </a:bodyPr>
+          <a:lstStyle/>
+          <a:p>
+            <a:pPr algn="ctr"/>
+            <a:r>
+              <a:rPr sz="1100" b="1">
+                <a:solidFill>
+                  <a:srgbClr val="111827"/>
+                </a:solidFill>
+                <a:latin typeface="Arial"/>
+              </a:rPr>
+              <a:t>Discuss in pairs what it means to receive a</a:t>
+            </a:r>
+          </a:p>
+        </p:txBody>
+      </p:sp>
+      <p:sp>
+        <p:nvSpPr>
+          <p:cNvPr id="18" name="Oval 17"/>
           <p:cNvSpPr/>
           <p:nvPr/>
         </p:nvSpPr>
         <p:spPr>
           <a:xfrm>
-            <a:off x="1702612" y="3364991"/>
-            <a:ext cx="1282446" cy="138988"/>
-          </a:xfrm>
-          <a:prstGeom prst="roundRect">
-            <a:avLst/>
-          </a:prstGeom>
-          <a:solidFill>
-            <a:srgbClr val="D90000"/>
-          </a:solidFill>
-          <a:ln>
-            <a:noFill/>
+            <a:off x="7178040" y="4910328"/>
+            <a:ext cx="822960" cy="822960"/>
+          </a:xfrm>
+          <a:prstGeom prst="ellipse">
+            <a:avLst/>
+          </a:prstGeom>
+          <a:solidFill>
+            <a:srgbClr val="1B7F3A"/>
+          </a:solidFill>
+          <a:ln w="13970">
+            <a:solidFill>
+              <a:srgbClr val="111827"/>
+            </a:solidFill>
           </a:ln>
         </p:spPr>
         <p:style>
@@ -9964,23 +9849,32 @@
           </a:fontRef>
         </p:style>
         <p:txBody>
-          <a:bodyPr rtlCol="0" anchor="ctr"/>
-          <a:lstStyle/>
-          <a:p>
-            <a:pPr algn="ctr"/>
-          </a:p>
-        </p:txBody>
-      </p:sp>
-      <p:sp>
-        <p:nvSpPr>
-          <p:cNvPr id="16" name="TextBox 15"/>
+          <a:bodyPr rtlCol="0" anchor="ctr" wrap="square" lIns="101600" rIns="101600" tIns="38100" bIns="38100"/>
+          <a:lstStyle/>
+          <a:p>
+            <a:pPr algn="ctr"/>
+            <a:r>
+              <a:rPr sz="1300" b="1">
+                <a:solidFill>
+                  <a:srgbClr val="FFFFFF"/>
+                </a:solidFill>
+                <a:latin typeface="Arial"/>
+              </a:rPr>
+              <a:t>3</a:t>
+            </a:r>
+          </a:p>
+        </p:txBody>
+      </p:sp>
+      <p:sp>
+        <p:nvSpPr>
+          <p:cNvPr id="19" name="TextBox 18"/>
           <p:cNvSpPr txBox="1"/>
           <p:nvPr/>
         </p:nvSpPr>
         <p:spPr>
           <a:xfrm>
-            <a:off x="1143000" y="3630168"/>
-            <a:ext cx="2331720" cy="228600"/>
+            <a:off x="6245352" y="5843016"/>
+            <a:ext cx="2697480" cy="402336"/>
           </a:xfrm>
           <a:prstGeom prst="rect">
             <a:avLst/>
@@ -9995,97 +9889,27 @@
           <a:p>
             <a:pPr algn="ctr"/>
             <a:r>
-              <a:rPr sz="1000" b="0">
-                <a:solidFill>
-                  <a:srgbClr val="475569"/>
+              <a:rPr sz="1100" b="1">
+                <a:solidFill>
+                  <a:srgbClr val="111827"/>
                 </a:solidFill>
                 <a:latin typeface="Arial"/>
               </a:rPr>
-              <a:t>Christian Religious Education</a:t>
-            </a:r>
-          </a:p>
-        </p:txBody>
-      </p:sp>
-      <p:sp>
-        <p:nvSpPr>
-          <p:cNvPr id="17" name="TextBox 16"/>
-          <p:cNvSpPr txBox="1"/>
-          <p:nvPr/>
-        </p:nvSpPr>
-        <p:spPr>
-          <a:xfrm>
-            <a:off x="960120" y="4315968"/>
-            <a:ext cx="2697480" cy="310896"/>
-          </a:xfrm>
-          <a:prstGeom prst="rect">
-            <a:avLst/>
-          </a:prstGeom>
-          <a:noFill/>
-        </p:spPr>
-        <p:txBody>
-          <a:bodyPr wrap="square" lIns="0" rIns="0" tIns="0" bIns="0">
-            <a:spAutoFit/>
-          </a:bodyPr>
-          <a:lstStyle/>
-          <a:p>
-            <a:pPr algn="ctr"/>
-            <a:r>
-              <a:rPr sz="1300" b="1">
-                <a:solidFill>
-                  <a:srgbClr val="1B7F3A"/>
-                </a:solidFill>
-                <a:latin typeface="Arial"/>
-              </a:rPr>
-              <a:t>GROUP CHALLENGE</a:t>
-            </a:r>
-          </a:p>
-        </p:txBody>
-      </p:sp>
-      <p:sp>
-        <p:nvSpPr>
-          <p:cNvPr id="18" name="TextBox 17"/>
-          <p:cNvSpPr txBox="1"/>
-          <p:nvPr/>
-        </p:nvSpPr>
-        <p:spPr>
-          <a:xfrm>
-            <a:off x="1005840" y="4754880"/>
-            <a:ext cx="2606040" cy="640080"/>
-          </a:xfrm>
-          <a:prstGeom prst="rect">
-            <a:avLst/>
-          </a:prstGeom>
-          <a:noFill/>
-        </p:spPr>
-        <p:txBody>
-          <a:bodyPr wrap="square" lIns="0" rIns="0" tIns="0" bIns="0">
-            <a:spAutoFit/>
-          </a:bodyPr>
-          <a:lstStyle/>
-          <a:p>
-            <a:pPr algn="ctr"/>
-            <a:r>
-              <a:rPr sz="1500" b="1">
-                <a:solidFill>
-                  <a:srgbClr val="111827"/>
-                </a:solidFill>
-                <a:latin typeface="Arial"/>
-              </a:rPr>
-              <a:t>Produce one answer the class can check.</a:t>
-            </a:r>
-          </a:p>
-        </p:txBody>
-      </p:sp>
-      <p:sp>
-        <p:nvSpPr>
-          <p:cNvPr id="19" name="Rounded Rectangle 18"/>
+              <a:t>Teacher demonstrates the Trinity using the</a:t>
+            </a:r>
+          </a:p>
+        </p:txBody>
+      </p:sp>
+      <p:sp>
+        <p:nvSpPr>
+          <p:cNvPr id="20" name="Rounded Rectangle 19"/>
           <p:cNvSpPr/>
           <p:nvPr/>
         </p:nvSpPr>
         <p:spPr>
           <a:xfrm>
-            <a:off x="4343400" y="1828800"/>
-            <a:ext cx="6903720" cy="868680"/>
+            <a:off x="3703320" y="5650992"/>
+            <a:ext cx="5440680" cy="457200"/>
           </a:xfrm>
           <a:prstGeom prst="roundRect">
             <a:avLst/>
@@ -10093,9 +9917,9 @@
           <a:solidFill>
             <a:srgbClr val="FFFFFF"/>
           </a:solidFill>
-          <a:ln w="11430">
+          <a:ln w="12700">
             <a:solidFill>
-              <a:srgbClr val="CBD5E1"/>
+              <a:srgbClr val="D90000"/>
             </a:solidFill>
           </a:ln>
         </p:spPr>
@@ -10123,57 +9947,14 @@
       </p:sp>
       <p:sp>
         <p:nvSpPr>
-          <p:cNvPr id="20" name="Rectangle 19"/>
-          <p:cNvSpPr/>
-          <p:nvPr/>
-        </p:nvSpPr>
-        <p:spPr>
-          <a:xfrm>
-            <a:off x="4343400" y="1828800"/>
-            <a:ext cx="566928" cy="868680"/>
-          </a:xfrm>
-          <a:prstGeom prst="rect">
-            <a:avLst/>
-          </a:prstGeom>
-          <a:solidFill>
-            <a:srgbClr val="1B7F3A"/>
-          </a:solidFill>
-          <a:ln>
-            <a:noFill/>
-          </a:ln>
-        </p:spPr>
-        <p:style>
-          <a:lnRef idx="1">
-            <a:schemeClr val="accent1"/>
-          </a:lnRef>
-          <a:fillRef idx="3">
-            <a:schemeClr val="accent1"/>
-          </a:fillRef>
-          <a:effectRef idx="2">
-            <a:schemeClr val="accent1"/>
-          </a:effectRef>
-          <a:fontRef idx="minor">
-            <a:schemeClr val="lt1"/>
-          </a:fontRef>
-        </p:style>
-        <p:txBody>
-          <a:bodyPr rtlCol="0" anchor="ctr"/>
-          <a:lstStyle/>
-          <a:p>
-            <a:pPr algn="ctr"/>
-          </a:p>
-        </p:txBody>
-      </p:sp>
-      <p:sp>
-        <p:nvSpPr>
           <p:cNvPr id="21" name="TextBox 20"/>
           <p:cNvSpPr txBox="1"/>
           <p:nvPr/>
         </p:nvSpPr>
         <p:spPr>
           <a:xfrm>
-            <a:off x="4343400" y="2144268"/>
-            <a:ext cx="566928" cy="237744"/>
+            <a:off x="3886200" y="5769864"/>
+            <a:ext cx="5074920" cy="164592"/>
           </a:xfrm>
           <a:prstGeom prst="rect">
             <a:avLst/>
@@ -10188,13 +9969,13 @@
           <a:p>
             <a:pPr algn="ctr"/>
             <a:r>
-              <a:rPr sz="1400" b="1">
-                <a:solidFill>
-                  <a:srgbClr val="FFFFFF"/>
+              <a:rPr sz="1100" b="1">
+                <a:solidFill>
+                  <a:srgbClr val="D90000"/>
                 </a:solidFill>
                 <a:latin typeface="Arial"/>
               </a:rPr>
-              <a:t>1</a:t>
+              <a:t>Share-out: explain one result, then improve it.</a:t>
             </a:r>
           </a:p>
         </p:txBody>
@@ -10202,434 +9983,6 @@
       <p:sp>
         <p:nvSpPr>
           <p:cNvPr id="22" name="TextBox 21"/>
-          <p:cNvSpPr txBox="1"/>
-          <p:nvPr/>
-        </p:nvSpPr>
-        <p:spPr>
-          <a:xfrm>
-            <a:off x="5129784" y="1993392"/>
-            <a:ext cx="5879592" cy="630936"/>
-          </a:xfrm>
-          <a:prstGeom prst="rect">
-            <a:avLst/>
-          </a:prstGeom>
-          <a:noFill/>
-        </p:spPr>
-        <p:txBody>
-          <a:bodyPr wrap="square" lIns="0" rIns="0" tIns="0" bIns="0">
-            <a:spAutoFit/>
-          </a:bodyPr>
-          <a:lstStyle/>
-          <a:p>
-            <a:r>
-              <a:rPr sz="1200" b="1">
-                <a:solidFill>
-                  <a:srgbClr val="111827"/>
-                </a:solidFill>
-                <a:latin typeface="Arial"/>
-              </a:rPr>
-              <a:t>Blow on their hands and observe trees moving outside to understand the concept</a:t>
-            </a:r>
-          </a:p>
-        </p:txBody>
-      </p:sp>
-      <p:sp>
-        <p:nvSpPr>
-          <p:cNvPr id="23" name="Rounded Rectangle 22"/>
-          <p:cNvSpPr/>
-          <p:nvPr/>
-        </p:nvSpPr>
-        <p:spPr>
-          <a:xfrm>
-            <a:off x="4343400" y="2999232"/>
-            <a:ext cx="6903720" cy="868680"/>
-          </a:xfrm>
-          <a:prstGeom prst="roundRect">
-            <a:avLst/>
-          </a:prstGeom>
-          <a:solidFill>
-            <a:srgbClr val="FFFFFF"/>
-          </a:solidFill>
-          <a:ln w="11430">
-            <a:solidFill>
-              <a:srgbClr val="CBD5E1"/>
-            </a:solidFill>
-          </a:ln>
-        </p:spPr>
-        <p:style>
-          <a:lnRef idx="1">
-            <a:schemeClr val="accent1"/>
-          </a:lnRef>
-          <a:fillRef idx="3">
-            <a:schemeClr val="accent1"/>
-          </a:fillRef>
-          <a:effectRef idx="2">
-            <a:schemeClr val="accent1"/>
-          </a:effectRef>
-          <a:fontRef idx="minor">
-            <a:schemeClr val="lt1"/>
-          </a:fontRef>
-        </p:style>
-        <p:txBody>
-          <a:bodyPr rtlCol="0" anchor="ctr"/>
-          <a:lstStyle/>
-          <a:p>
-            <a:pPr algn="ctr"/>
-          </a:p>
-        </p:txBody>
-      </p:sp>
-      <p:sp>
-        <p:nvSpPr>
-          <p:cNvPr id="24" name="Rectangle 23"/>
-          <p:cNvSpPr/>
-          <p:nvPr/>
-        </p:nvSpPr>
-        <p:spPr>
-          <a:xfrm>
-            <a:off x="4343400" y="2999232"/>
-            <a:ext cx="566928" cy="868680"/>
-          </a:xfrm>
-          <a:prstGeom prst="rect">
-            <a:avLst/>
-          </a:prstGeom>
-          <a:solidFill>
-            <a:srgbClr val="1B7F3A"/>
-          </a:solidFill>
-          <a:ln>
-            <a:noFill/>
-          </a:ln>
-        </p:spPr>
-        <p:style>
-          <a:lnRef idx="1">
-            <a:schemeClr val="accent1"/>
-          </a:lnRef>
-          <a:fillRef idx="3">
-            <a:schemeClr val="accent1"/>
-          </a:fillRef>
-          <a:effectRef idx="2">
-            <a:schemeClr val="accent1"/>
-          </a:effectRef>
-          <a:fontRef idx="minor">
-            <a:schemeClr val="lt1"/>
-          </a:fontRef>
-        </p:style>
-        <p:txBody>
-          <a:bodyPr rtlCol="0" anchor="ctr"/>
-          <a:lstStyle/>
-          <a:p>
-            <a:pPr algn="ctr"/>
-          </a:p>
-        </p:txBody>
-      </p:sp>
-      <p:sp>
-        <p:nvSpPr>
-          <p:cNvPr id="25" name="TextBox 24"/>
-          <p:cNvSpPr txBox="1"/>
-          <p:nvPr/>
-        </p:nvSpPr>
-        <p:spPr>
-          <a:xfrm>
-            <a:off x="4343400" y="3314700"/>
-            <a:ext cx="566928" cy="237744"/>
-          </a:xfrm>
-          <a:prstGeom prst="rect">
-            <a:avLst/>
-          </a:prstGeom>
-          <a:noFill/>
-        </p:spPr>
-        <p:txBody>
-          <a:bodyPr wrap="square" lIns="0" rIns="0" tIns="0" bIns="0">
-            <a:spAutoFit/>
-          </a:bodyPr>
-          <a:lstStyle/>
-          <a:p>
-            <a:pPr algn="ctr"/>
-            <a:r>
-              <a:rPr sz="1400" b="1">
-                <a:solidFill>
-                  <a:srgbClr val="FFFFFF"/>
-                </a:solidFill>
-                <a:latin typeface="Arial"/>
-              </a:rPr>
-              <a:t>2</a:t>
-            </a:r>
-          </a:p>
-        </p:txBody>
-      </p:sp>
-      <p:sp>
-        <p:nvSpPr>
-          <p:cNvPr id="26" name="TextBox 25"/>
-          <p:cNvSpPr txBox="1"/>
-          <p:nvPr/>
-        </p:nvSpPr>
-        <p:spPr>
-          <a:xfrm>
-            <a:off x="5129784" y="3163824"/>
-            <a:ext cx="5879592" cy="630936"/>
-          </a:xfrm>
-          <a:prstGeom prst="rect">
-            <a:avLst/>
-          </a:prstGeom>
-          <a:noFill/>
-        </p:spPr>
-        <p:txBody>
-          <a:bodyPr wrap="square" lIns="0" rIns="0" tIns="0" bIns="0">
-            <a:spAutoFit/>
-          </a:bodyPr>
-          <a:lstStyle/>
-          <a:p>
-            <a:r>
-              <a:rPr sz="1200" b="1">
-                <a:solidFill>
-                  <a:srgbClr val="111827"/>
-                </a:solidFill>
-                <a:latin typeface="Arial"/>
-              </a:rPr>
-              <a:t>Discuss in pairs what it means to receive a gift that is also the person who gave</a:t>
-            </a:r>
-          </a:p>
-        </p:txBody>
-      </p:sp>
-      <p:sp>
-        <p:nvSpPr>
-          <p:cNvPr id="27" name="Rounded Rectangle 26"/>
-          <p:cNvSpPr/>
-          <p:nvPr/>
-        </p:nvSpPr>
-        <p:spPr>
-          <a:xfrm>
-            <a:off x="4343400" y="4169664"/>
-            <a:ext cx="6903720" cy="868680"/>
-          </a:xfrm>
-          <a:prstGeom prst="roundRect">
-            <a:avLst/>
-          </a:prstGeom>
-          <a:solidFill>
-            <a:srgbClr val="FFFFFF"/>
-          </a:solidFill>
-          <a:ln w="11430">
-            <a:solidFill>
-              <a:srgbClr val="CBD5E1"/>
-            </a:solidFill>
-          </a:ln>
-        </p:spPr>
-        <p:style>
-          <a:lnRef idx="1">
-            <a:schemeClr val="accent1"/>
-          </a:lnRef>
-          <a:fillRef idx="3">
-            <a:schemeClr val="accent1"/>
-          </a:fillRef>
-          <a:effectRef idx="2">
-            <a:schemeClr val="accent1"/>
-          </a:effectRef>
-          <a:fontRef idx="minor">
-            <a:schemeClr val="lt1"/>
-          </a:fontRef>
-        </p:style>
-        <p:txBody>
-          <a:bodyPr rtlCol="0" anchor="ctr"/>
-          <a:lstStyle/>
-          <a:p>
-            <a:pPr algn="ctr"/>
-          </a:p>
-        </p:txBody>
-      </p:sp>
-      <p:sp>
-        <p:nvSpPr>
-          <p:cNvPr id="28" name="Rectangle 27"/>
-          <p:cNvSpPr/>
-          <p:nvPr/>
-        </p:nvSpPr>
-        <p:spPr>
-          <a:xfrm>
-            <a:off x="4343400" y="4169664"/>
-            <a:ext cx="566928" cy="868680"/>
-          </a:xfrm>
-          <a:prstGeom prst="rect">
-            <a:avLst/>
-          </a:prstGeom>
-          <a:solidFill>
-            <a:srgbClr val="1B7F3A"/>
-          </a:solidFill>
-          <a:ln>
-            <a:noFill/>
-          </a:ln>
-        </p:spPr>
-        <p:style>
-          <a:lnRef idx="1">
-            <a:schemeClr val="accent1"/>
-          </a:lnRef>
-          <a:fillRef idx="3">
-            <a:schemeClr val="accent1"/>
-          </a:fillRef>
-          <a:effectRef idx="2">
-            <a:schemeClr val="accent1"/>
-          </a:effectRef>
-          <a:fontRef idx="minor">
-            <a:schemeClr val="lt1"/>
-          </a:fontRef>
-        </p:style>
-        <p:txBody>
-          <a:bodyPr rtlCol="0" anchor="ctr"/>
-          <a:lstStyle/>
-          <a:p>
-            <a:pPr algn="ctr"/>
-          </a:p>
-        </p:txBody>
-      </p:sp>
-      <p:sp>
-        <p:nvSpPr>
-          <p:cNvPr id="29" name="TextBox 28"/>
-          <p:cNvSpPr txBox="1"/>
-          <p:nvPr/>
-        </p:nvSpPr>
-        <p:spPr>
-          <a:xfrm>
-            <a:off x="4343400" y="4485132"/>
-            <a:ext cx="566928" cy="237744"/>
-          </a:xfrm>
-          <a:prstGeom prst="rect">
-            <a:avLst/>
-          </a:prstGeom>
-          <a:noFill/>
-        </p:spPr>
-        <p:txBody>
-          <a:bodyPr wrap="square" lIns="0" rIns="0" tIns="0" bIns="0">
-            <a:spAutoFit/>
-          </a:bodyPr>
-          <a:lstStyle/>
-          <a:p>
-            <a:pPr algn="ctr"/>
-            <a:r>
-              <a:rPr sz="1400" b="1">
-                <a:solidFill>
-                  <a:srgbClr val="FFFFFF"/>
-                </a:solidFill>
-                <a:latin typeface="Arial"/>
-              </a:rPr>
-              <a:t>3</a:t>
-            </a:r>
-          </a:p>
-        </p:txBody>
-      </p:sp>
-      <p:sp>
-        <p:nvSpPr>
-          <p:cNvPr id="30" name="TextBox 29"/>
-          <p:cNvSpPr txBox="1"/>
-          <p:nvPr/>
-        </p:nvSpPr>
-        <p:spPr>
-          <a:xfrm>
-            <a:off x="5129784" y="4334256"/>
-            <a:ext cx="5879592" cy="630936"/>
-          </a:xfrm>
-          <a:prstGeom prst="rect">
-            <a:avLst/>
-          </a:prstGeom>
-          <a:noFill/>
-        </p:spPr>
-        <p:txBody>
-          <a:bodyPr wrap="square" lIns="0" rIns="0" tIns="0" bIns="0">
-            <a:spAutoFit/>
-          </a:bodyPr>
-          <a:lstStyle/>
-          <a:p>
-            <a:r>
-              <a:rPr sz="1200" b="1">
-                <a:solidFill>
-                  <a:srgbClr val="111827"/>
-                </a:solidFill>
-                <a:latin typeface="Arial"/>
-              </a:rPr>
-              <a:t>Teacher demonstrates the Trinity using the three-stone stove analogy while</a:t>
-            </a:r>
-          </a:p>
-        </p:txBody>
-      </p:sp>
-      <p:sp>
-        <p:nvSpPr>
-          <p:cNvPr id="31" name="Rounded Rectangle 30"/>
-          <p:cNvSpPr/>
-          <p:nvPr/>
-        </p:nvSpPr>
-        <p:spPr>
-          <a:xfrm>
-            <a:off x="4343400" y="5413248"/>
-            <a:ext cx="6903720" cy="658368"/>
-          </a:xfrm>
-          <a:prstGeom prst="roundRect">
-            <a:avLst/>
-          </a:prstGeom>
-          <a:solidFill>
-            <a:srgbClr val="FFFFFF"/>
-          </a:solidFill>
-          <a:ln w="13970">
-            <a:solidFill>
-              <a:srgbClr val="D90000"/>
-            </a:solidFill>
-          </a:ln>
-        </p:spPr>
-        <p:style>
-          <a:lnRef idx="1">
-            <a:schemeClr val="accent1"/>
-          </a:lnRef>
-          <a:fillRef idx="3">
-            <a:schemeClr val="accent1"/>
-          </a:fillRef>
-          <a:effectRef idx="2">
-            <a:schemeClr val="accent1"/>
-          </a:effectRef>
-          <a:fontRef idx="minor">
-            <a:schemeClr val="lt1"/>
-          </a:fontRef>
-        </p:style>
-        <p:txBody>
-          <a:bodyPr rtlCol="0" anchor="ctr"/>
-          <a:lstStyle/>
-          <a:p>
-            <a:pPr algn="ctr"/>
-          </a:p>
-        </p:txBody>
-      </p:sp>
-      <p:sp>
-        <p:nvSpPr>
-          <p:cNvPr id="32" name="TextBox 31"/>
-          <p:cNvSpPr txBox="1"/>
-          <p:nvPr/>
-        </p:nvSpPr>
-        <p:spPr>
-          <a:xfrm>
-            <a:off x="4572000" y="5577840"/>
-            <a:ext cx="6446520" cy="274320"/>
-          </a:xfrm>
-          <a:prstGeom prst="rect">
-            <a:avLst/>
-          </a:prstGeom>
-          <a:noFill/>
-        </p:spPr>
-        <p:txBody>
-          <a:bodyPr wrap="square" lIns="0" rIns="0" tIns="0" bIns="0">
-            <a:spAutoFit/>
-          </a:bodyPr>
-          <a:lstStyle/>
-          <a:p>
-            <a:pPr algn="ctr"/>
-            <a:r>
-              <a:rPr sz="1400" b="1">
-                <a:solidFill>
-                  <a:srgbClr val="D90000"/>
-                </a:solidFill>
-                <a:latin typeface="Arial"/>
-              </a:rPr>
-              <a:t>Class share-out: one group explains, one group improves it.</a:t>
-            </a:r>
-          </a:p>
-        </p:txBody>
-      </p:sp>
-      <p:sp>
-        <p:nvSpPr>
-          <p:cNvPr id="33" name="TextBox 32"/>
           <p:cNvSpPr txBox="1"/>
           <p:nvPr/>
         </p:nvSpPr>

</xml_diff>

<commit_message>
Add content-specific classroom visuals
</commit_message>
<xml_diff>
--- a/uganda-p7-mvp/p7_t1_christian_religious_education_0101/p7_t1_christian_religious_education_0101.pptx
+++ b/uganda-p7-mvp/p7_t1_christian_religious_education_0101/p7_t1_christian_religious_education_0101.pptx
@@ -3527,8 +3527,8 @@
         </p:nvSpPr>
         <p:spPr>
           <a:xfrm>
-            <a:off x="1417319" y="2322576"/>
-            <a:ext cx="9372600" cy="411480"/>
+            <a:off x="1417319" y="2286000"/>
+            <a:ext cx="9372600" cy="310896"/>
           </a:xfrm>
           <a:prstGeom prst="rect">
             <a:avLst/>
@@ -3543,7 +3543,7 @@
           <a:p>
             <a:pPr algn="ctr"/>
             <a:r>
-              <a:rPr sz="1800" b="1">
+              <a:rPr sz="1700" b="1">
                 <a:solidFill>
                   <a:srgbClr val="111827"/>
                 </a:solidFill>
@@ -3556,22 +3556,65 @@
       </p:sp>
       <p:sp>
         <p:nvSpPr>
-          <p:cNvPr id="13" name="Isosceles Triangle 12"/>
-          <p:cNvSpPr/>
-          <p:nvPr/>
-        </p:nvSpPr>
-        <p:spPr>
-          <a:xfrm>
-            <a:off x="4754879" y="2990088"/>
-            <a:ext cx="2651760" cy="2651760"/>
-          </a:xfrm>
-          <a:prstGeom prst="triangle">
-            <a:avLst/>
-          </a:prstGeom>
-          <a:solidFill>
-            <a:srgbClr val="FFF7E0"/>
-          </a:solidFill>
-          <a:ln w="22860">
+          <p:cNvPr id="13" name="Rectangle 12"/>
+          <p:cNvSpPr/>
+          <p:nvPr/>
+        </p:nvSpPr>
+        <p:spPr>
+          <a:xfrm>
+            <a:off x="2194560" y="4178808"/>
+            <a:ext cx="146304" cy="658368"/>
+          </a:xfrm>
+          <a:prstGeom prst="rect">
+            <a:avLst/>
+          </a:prstGeom>
+          <a:solidFill>
+            <a:srgbClr val="78350F"/>
+          </a:solidFill>
+          <a:ln>
+            <a:noFill/>
+          </a:ln>
+        </p:spPr>
+        <p:style>
+          <a:lnRef idx="1">
+            <a:schemeClr val="accent1"/>
+          </a:lnRef>
+          <a:fillRef idx="3">
+            <a:schemeClr val="accent1"/>
+          </a:fillRef>
+          <a:effectRef idx="2">
+            <a:schemeClr val="accent1"/>
+          </a:effectRef>
+          <a:fontRef idx="minor">
+            <a:schemeClr val="lt1"/>
+          </a:fontRef>
+        </p:style>
+        <p:txBody>
+          <a:bodyPr rtlCol="0" anchor="ctr"/>
+          <a:lstStyle/>
+          <a:p>
+            <a:pPr algn="ctr"/>
+          </a:p>
+        </p:txBody>
+      </p:sp>
+      <p:sp>
+        <p:nvSpPr>
+          <p:cNvPr id="14" name="Oval 13"/>
+          <p:cNvSpPr/>
+          <p:nvPr/>
+        </p:nvSpPr>
+        <p:spPr>
+          <a:xfrm>
+            <a:off x="1874519" y="3584448"/>
+            <a:ext cx="786384" cy="786384"/>
+          </a:xfrm>
+          <a:prstGeom prst="ellipse">
+            <a:avLst/>
+          </a:prstGeom>
+          <a:solidFill>
+            <a:srgbClr val="1B7F3A"/>
+          </a:solidFill>
+          <a:ln w="7620">
             <a:solidFill>
               <a:srgbClr val="111827"/>
             </a:solidFill>
@@ -3601,22 +3644,65 @@
       </p:sp>
       <p:sp>
         <p:nvSpPr>
-          <p:cNvPr id="14" name="Oval 13"/>
-          <p:cNvSpPr/>
-          <p:nvPr/>
-        </p:nvSpPr>
-        <p:spPr>
-          <a:xfrm>
-            <a:off x="5715000" y="2852928"/>
-            <a:ext cx="822960" cy="822960"/>
+          <p:cNvPr id="15" name="Rectangle 14"/>
+          <p:cNvSpPr/>
+          <p:nvPr/>
+        </p:nvSpPr>
+        <p:spPr>
+          <a:xfrm>
+            <a:off x="3259836" y="4347972"/>
+            <a:ext cx="131673" cy="592531"/>
+          </a:xfrm>
+          <a:prstGeom prst="rect">
+            <a:avLst/>
+          </a:prstGeom>
+          <a:solidFill>
+            <a:srgbClr val="78350F"/>
+          </a:solidFill>
+          <a:ln>
+            <a:noFill/>
+          </a:ln>
+        </p:spPr>
+        <p:style>
+          <a:lnRef idx="1">
+            <a:schemeClr val="accent1"/>
+          </a:lnRef>
+          <a:fillRef idx="3">
+            <a:schemeClr val="accent1"/>
+          </a:fillRef>
+          <a:effectRef idx="2">
+            <a:schemeClr val="accent1"/>
+          </a:effectRef>
+          <a:fontRef idx="minor">
+            <a:schemeClr val="lt1"/>
+          </a:fontRef>
+        </p:style>
+        <p:txBody>
+          <a:bodyPr rtlCol="0" anchor="ctr"/>
+          <a:lstStyle/>
+          <a:p>
+            <a:pPr algn="ctr"/>
+          </a:p>
+        </p:txBody>
+      </p:sp>
+      <p:sp>
+        <p:nvSpPr>
+          <p:cNvPr id="16" name="Oval 15"/>
+          <p:cNvSpPr/>
+          <p:nvPr/>
+        </p:nvSpPr>
+        <p:spPr>
+          <a:xfrm>
+            <a:off x="2971800" y="3813048"/>
+            <a:ext cx="707745" cy="707745"/>
           </a:xfrm>
           <a:prstGeom prst="ellipse">
             <a:avLst/>
           </a:prstGeom>
           <a:solidFill>
-            <a:srgbClr val="FCD116"/>
-          </a:solidFill>
-          <a:ln w="13970">
+            <a:srgbClr val="1B7F3A"/>
+          </a:solidFill>
+          <a:ln w="7620">
             <a:solidFill>
               <a:srgbClr val="111827"/>
             </a:solidFill>
@@ -3637,32 +3723,513 @@
           </a:fontRef>
         </p:style>
         <p:txBody>
-          <a:bodyPr rtlCol="0" anchor="ctr" wrap="square" lIns="101600" rIns="101600" tIns="38100" bIns="38100"/>
-          <a:lstStyle/>
-          <a:p>
-            <a:pPr algn="ctr"/>
-            <a:r>
-              <a:rPr sz="1300" b="1">
-                <a:solidFill>
-                  <a:srgbClr val="111827"/>
-                </a:solidFill>
-                <a:latin typeface="Arial"/>
-              </a:rPr>
-              <a:t>1</a:t>
-            </a:r>
-          </a:p>
-        </p:txBody>
-      </p:sp>
-      <p:sp>
-        <p:nvSpPr>
-          <p:cNvPr id="15" name="TextBox 14"/>
+          <a:bodyPr rtlCol="0" anchor="ctr"/>
+          <a:lstStyle/>
+          <a:p>
+            <a:pPr algn="ctr"/>
+          </a:p>
+        </p:txBody>
+      </p:sp>
+      <p:cxnSp>
+        <p:nvCxnSpPr>
+          <p:cNvPr id="17" name="Connector 16"/>
+          <p:cNvCxnSpPr/>
+          <p:nvPr/>
+        </p:nvCxnSpPr>
+        <p:spPr>
+          <a:xfrm flipV="1">
+            <a:off x="4434840" y="3401568"/>
+            <a:ext cx="1920239" cy="320040"/>
+          </a:xfrm>
+          <a:prstGeom prst="line">
+            <a:avLst/>
+          </a:prstGeom>
+          <a:ln w="22860">
+            <a:solidFill>
+              <a:srgbClr val="1D4ED8"/>
+            </a:solidFill>
+          </a:ln>
+        </p:spPr>
+        <p:style>
+          <a:lnRef idx="2">
+            <a:schemeClr val="accent1"/>
+          </a:lnRef>
+          <a:fillRef idx="0">
+            <a:schemeClr val="accent1"/>
+          </a:fillRef>
+          <a:effectRef idx="1">
+            <a:schemeClr val="accent1"/>
+          </a:effectRef>
+          <a:fontRef idx="minor">
+            <a:schemeClr val="tx1"/>
+          </a:fontRef>
+        </p:style>
+      </p:cxnSp>
+      <p:cxnSp>
+        <p:nvCxnSpPr>
+          <p:cNvPr id="18" name="Connector 17"/>
+          <p:cNvCxnSpPr/>
+          <p:nvPr/>
+        </p:nvCxnSpPr>
+        <p:spPr>
+          <a:xfrm flipV="1">
+            <a:off x="4434840" y="3813048"/>
+            <a:ext cx="1920239" cy="320040"/>
+          </a:xfrm>
+          <a:prstGeom prst="line">
+            <a:avLst/>
+          </a:prstGeom>
+          <a:ln w="22860">
+            <a:solidFill>
+              <a:srgbClr val="1D4ED8"/>
+            </a:solidFill>
+          </a:ln>
+        </p:spPr>
+        <p:style>
+          <a:lnRef idx="2">
+            <a:schemeClr val="accent1"/>
+          </a:lnRef>
+          <a:fillRef idx="0">
+            <a:schemeClr val="accent1"/>
+          </a:fillRef>
+          <a:effectRef idx="1">
+            <a:schemeClr val="accent1"/>
+          </a:effectRef>
+          <a:fontRef idx="minor">
+            <a:schemeClr val="tx1"/>
+          </a:fontRef>
+        </p:style>
+      </p:cxnSp>
+      <p:cxnSp>
+        <p:nvCxnSpPr>
+          <p:cNvPr id="19" name="Connector 18"/>
+          <p:cNvCxnSpPr/>
+          <p:nvPr/>
+        </p:nvCxnSpPr>
+        <p:spPr>
+          <a:xfrm flipV="1">
+            <a:off x="4434840" y="4224528"/>
+            <a:ext cx="1920239" cy="320040"/>
+          </a:xfrm>
+          <a:prstGeom prst="line">
+            <a:avLst/>
+          </a:prstGeom>
+          <a:ln w="22860">
+            <a:solidFill>
+              <a:srgbClr val="1D4ED8"/>
+            </a:solidFill>
+          </a:ln>
+        </p:spPr>
+        <p:style>
+          <a:lnRef idx="2">
+            <a:schemeClr val="accent1"/>
+          </a:lnRef>
+          <a:fillRef idx="0">
+            <a:schemeClr val="accent1"/>
+          </a:fillRef>
+          <a:effectRef idx="1">
+            <a:schemeClr val="accent1"/>
+          </a:effectRef>
+          <a:fontRef idx="minor">
+            <a:schemeClr val="tx1"/>
+          </a:fontRef>
+        </p:style>
+      </p:cxnSp>
+      <p:sp>
+        <p:nvSpPr>
+          <p:cNvPr id="20" name="Oval 19"/>
+          <p:cNvSpPr/>
+          <p:nvPr/>
+        </p:nvSpPr>
+        <p:spPr>
+          <a:xfrm>
+            <a:off x="7156094" y="3767328"/>
+            <a:ext cx="181051" cy="197510"/>
+          </a:xfrm>
+          <a:prstGeom prst="ellipse">
+            <a:avLst/>
+          </a:prstGeom>
+          <a:solidFill>
+            <a:srgbClr val="FCD116"/>
+          </a:solidFill>
+          <a:ln w="7620">
+            <a:solidFill>
+              <a:srgbClr val="111827"/>
+            </a:solidFill>
+          </a:ln>
+        </p:spPr>
+        <p:style>
+          <a:lnRef idx="1">
+            <a:schemeClr val="accent1"/>
+          </a:lnRef>
+          <a:fillRef idx="3">
+            <a:schemeClr val="accent1"/>
+          </a:fillRef>
+          <a:effectRef idx="2">
+            <a:schemeClr val="accent1"/>
+          </a:effectRef>
+          <a:fontRef idx="minor">
+            <a:schemeClr val="lt1"/>
+          </a:fontRef>
+        </p:style>
+        <p:txBody>
+          <a:bodyPr rtlCol="0" anchor="ctr"/>
+          <a:lstStyle/>
+          <a:p>
+            <a:pPr algn="ctr"/>
+          </a:p>
+        </p:txBody>
+      </p:sp>
+      <p:sp>
+        <p:nvSpPr>
+          <p:cNvPr id="21" name="Rounded Rectangle 20"/>
+          <p:cNvSpPr/>
+          <p:nvPr/>
+        </p:nvSpPr>
+        <p:spPr>
+          <a:xfrm>
+            <a:off x="7120890" y="4004340"/>
+            <a:ext cx="251460" cy="395020"/>
+          </a:xfrm>
+          <a:prstGeom prst="roundRect">
+            <a:avLst/>
+          </a:prstGeom>
+          <a:solidFill>
+            <a:srgbClr val="D90000"/>
+          </a:solidFill>
+          <a:ln w="7620">
+            <a:solidFill>
+              <a:srgbClr val="111827"/>
+            </a:solidFill>
+          </a:ln>
+        </p:spPr>
+        <p:style>
+          <a:lnRef idx="1">
+            <a:schemeClr val="accent1"/>
+          </a:lnRef>
+          <a:fillRef idx="3">
+            <a:schemeClr val="accent1"/>
+          </a:fillRef>
+          <a:effectRef idx="2">
+            <a:schemeClr val="accent1"/>
+          </a:effectRef>
+          <a:fontRef idx="minor">
+            <a:schemeClr val="lt1"/>
+          </a:fontRef>
+        </p:style>
+        <p:txBody>
+          <a:bodyPr rtlCol="0" anchor="ctr"/>
+          <a:lstStyle/>
+          <a:p>
+            <a:pPr algn="ctr"/>
+          </a:p>
+        </p:txBody>
+      </p:sp>
+      <p:cxnSp>
+        <p:nvCxnSpPr>
+          <p:cNvPr id="22" name="Connector 21"/>
+          <p:cNvCxnSpPr/>
+          <p:nvPr/>
+        </p:nvCxnSpPr>
+        <p:spPr>
+          <a:xfrm flipH="1">
+            <a:off x="7135977" y="4379610"/>
+            <a:ext cx="110643" cy="375270"/>
+          </a:xfrm>
+          <a:prstGeom prst="line">
+            <a:avLst/>
+          </a:prstGeom>
+          <a:ln w="12700">
+            <a:solidFill>
+              <a:srgbClr val="111827"/>
+            </a:solidFill>
+          </a:ln>
+        </p:spPr>
+        <p:style>
+          <a:lnRef idx="2">
+            <a:schemeClr val="accent1"/>
+          </a:lnRef>
+          <a:fillRef idx="0">
+            <a:schemeClr val="accent1"/>
+          </a:fillRef>
+          <a:effectRef idx="1">
+            <a:schemeClr val="accent1"/>
+          </a:effectRef>
+          <a:fontRef idx="minor">
+            <a:schemeClr val="tx1"/>
+          </a:fontRef>
+        </p:style>
+      </p:cxnSp>
+      <p:cxnSp>
+        <p:nvCxnSpPr>
+          <p:cNvPr id="23" name="Connector 22"/>
+          <p:cNvCxnSpPr/>
+          <p:nvPr/>
+        </p:nvCxnSpPr>
+        <p:spPr>
+          <a:xfrm>
+            <a:off x="7246620" y="4379610"/>
+            <a:ext cx="110642" cy="375270"/>
+          </a:xfrm>
+          <a:prstGeom prst="line">
+            <a:avLst/>
+          </a:prstGeom>
+          <a:ln w="12700">
+            <a:solidFill>
+              <a:srgbClr val="111827"/>
+            </a:solidFill>
+          </a:ln>
+        </p:spPr>
+        <p:style>
+          <a:lnRef idx="2">
+            <a:schemeClr val="accent1"/>
+          </a:lnRef>
+          <a:fillRef idx="0">
+            <a:schemeClr val="accent1"/>
+          </a:fillRef>
+          <a:effectRef idx="1">
+            <a:schemeClr val="accent1"/>
+          </a:effectRef>
+          <a:fontRef idx="minor">
+            <a:schemeClr val="tx1"/>
+          </a:fontRef>
+        </p:style>
+      </p:cxnSp>
+      <p:sp>
+        <p:nvSpPr>
+          <p:cNvPr id="24" name="Oval 23"/>
+          <p:cNvSpPr/>
+          <p:nvPr/>
+        </p:nvSpPr>
+        <p:spPr>
+          <a:xfrm>
+            <a:off x="8458200" y="4548225"/>
+            <a:ext cx="652881" cy="528523"/>
+          </a:xfrm>
+          <a:prstGeom prst="ellipse">
+            <a:avLst/>
+          </a:prstGeom>
+          <a:solidFill>
+            <a:srgbClr val="475569"/>
+          </a:solidFill>
+          <a:ln w="7620">
+            <a:solidFill>
+              <a:srgbClr val="111827"/>
+            </a:solidFill>
+          </a:ln>
+        </p:spPr>
+        <p:style>
+          <a:lnRef idx="1">
+            <a:schemeClr val="accent1"/>
+          </a:lnRef>
+          <a:fillRef idx="3">
+            <a:schemeClr val="accent1"/>
+          </a:fillRef>
+          <a:effectRef idx="2">
+            <a:schemeClr val="accent1"/>
+          </a:effectRef>
+          <a:fontRef idx="minor">
+            <a:schemeClr val="lt1"/>
+          </a:fontRef>
+        </p:style>
+        <p:txBody>
+          <a:bodyPr rtlCol="0" anchor="ctr"/>
+          <a:lstStyle/>
+          <a:p>
+            <a:pPr algn="ctr"/>
+          </a:p>
+        </p:txBody>
+      </p:sp>
+      <p:sp>
+        <p:nvSpPr>
+          <p:cNvPr id="25" name="Oval 24"/>
+          <p:cNvSpPr/>
+          <p:nvPr/>
+        </p:nvSpPr>
+        <p:spPr>
+          <a:xfrm>
+            <a:off x="9359798" y="3584448"/>
+            <a:ext cx="652881" cy="528523"/>
+          </a:xfrm>
+          <a:prstGeom prst="ellipse">
+            <a:avLst/>
+          </a:prstGeom>
+          <a:solidFill>
+            <a:srgbClr val="475569"/>
+          </a:solidFill>
+          <a:ln w="7620">
+            <a:solidFill>
+              <a:srgbClr val="111827"/>
+            </a:solidFill>
+          </a:ln>
+        </p:spPr>
+        <p:style>
+          <a:lnRef idx="1">
+            <a:schemeClr val="accent1"/>
+          </a:lnRef>
+          <a:fillRef idx="3">
+            <a:schemeClr val="accent1"/>
+          </a:fillRef>
+          <a:effectRef idx="2">
+            <a:schemeClr val="accent1"/>
+          </a:effectRef>
+          <a:fontRef idx="minor">
+            <a:schemeClr val="lt1"/>
+          </a:fontRef>
+        </p:style>
+        <p:txBody>
+          <a:bodyPr rtlCol="0" anchor="ctr"/>
+          <a:lstStyle/>
+          <a:p>
+            <a:pPr algn="ctr"/>
+          </a:p>
+        </p:txBody>
+      </p:sp>
+      <p:sp>
+        <p:nvSpPr>
+          <p:cNvPr id="26" name="Oval 25"/>
+          <p:cNvSpPr/>
+          <p:nvPr/>
+        </p:nvSpPr>
+        <p:spPr>
+          <a:xfrm>
+            <a:off x="10261396" y="4548225"/>
+            <a:ext cx="652881" cy="528523"/>
+          </a:xfrm>
+          <a:prstGeom prst="ellipse">
+            <a:avLst/>
+          </a:prstGeom>
+          <a:solidFill>
+            <a:srgbClr val="475569"/>
+          </a:solidFill>
+          <a:ln w="7620">
+            <a:solidFill>
+              <a:srgbClr val="111827"/>
+            </a:solidFill>
+          </a:ln>
+        </p:spPr>
+        <p:style>
+          <a:lnRef idx="1">
+            <a:schemeClr val="accent1"/>
+          </a:lnRef>
+          <a:fillRef idx="3">
+            <a:schemeClr val="accent1"/>
+          </a:fillRef>
+          <a:effectRef idx="2">
+            <a:schemeClr val="accent1"/>
+          </a:effectRef>
+          <a:fontRef idx="minor">
+            <a:schemeClr val="lt1"/>
+          </a:fontRef>
+        </p:style>
+        <p:txBody>
+          <a:bodyPr rtlCol="0" anchor="ctr"/>
+          <a:lstStyle/>
+          <a:p>
+            <a:pPr algn="ctr"/>
+          </a:p>
+        </p:txBody>
+      </p:sp>
+      <p:sp>
+        <p:nvSpPr>
+          <p:cNvPr id="27" name="Oval 26"/>
+          <p:cNvSpPr/>
+          <p:nvPr/>
+        </p:nvSpPr>
+        <p:spPr>
+          <a:xfrm>
+            <a:off x="9235440" y="4392777"/>
+            <a:ext cx="854964" cy="590702"/>
+          </a:xfrm>
+          <a:prstGeom prst="ellipse">
+            <a:avLst/>
+          </a:prstGeom>
+          <a:solidFill>
+            <a:srgbClr val="FCD116"/>
+          </a:solidFill>
+          <a:ln w="10160">
+            <a:solidFill>
+              <a:srgbClr val="D90000"/>
+            </a:solidFill>
+          </a:ln>
+        </p:spPr>
+        <p:style>
+          <a:lnRef idx="1">
+            <a:schemeClr val="accent1"/>
+          </a:lnRef>
+          <a:fillRef idx="3">
+            <a:schemeClr val="accent1"/>
+          </a:fillRef>
+          <a:effectRef idx="2">
+            <a:schemeClr val="accent1"/>
+          </a:effectRef>
+          <a:fontRef idx="minor">
+            <a:schemeClr val="lt1"/>
+          </a:fontRef>
+        </p:style>
+        <p:txBody>
+          <a:bodyPr rtlCol="0" anchor="ctr"/>
+          <a:lstStyle/>
+          <a:p>
+            <a:pPr algn="ctr"/>
+          </a:p>
+        </p:txBody>
+      </p:sp>
+      <p:sp>
+        <p:nvSpPr>
+          <p:cNvPr id="28" name="Rounded Rectangle 27"/>
+          <p:cNvSpPr/>
+          <p:nvPr/>
+        </p:nvSpPr>
+        <p:spPr>
+          <a:xfrm>
+            <a:off x="1645919" y="5705856"/>
+            <a:ext cx="2758440" cy="713232"/>
+          </a:xfrm>
+          <a:prstGeom prst="roundRect">
+            <a:avLst/>
+          </a:prstGeom>
+          <a:solidFill>
+            <a:srgbClr val="FFFFFF"/>
+          </a:solidFill>
+          <a:ln w="11430">
+            <a:solidFill>
+              <a:srgbClr val="1D4ED8"/>
+            </a:solidFill>
+          </a:ln>
+        </p:spPr>
+        <p:style>
+          <a:lnRef idx="1">
+            <a:schemeClr val="accent1"/>
+          </a:lnRef>
+          <a:fillRef idx="3">
+            <a:schemeClr val="accent1"/>
+          </a:fillRef>
+          <a:effectRef idx="2">
+            <a:schemeClr val="accent1"/>
+          </a:effectRef>
+          <a:fontRef idx="minor">
+            <a:schemeClr val="lt1"/>
+          </a:fontRef>
+        </p:style>
+        <p:txBody>
+          <a:bodyPr rtlCol="0" anchor="ctr"/>
+          <a:lstStyle/>
+          <a:p>
+            <a:pPr algn="ctr"/>
+          </a:p>
+        </p:txBody>
+      </p:sp>
+      <p:sp>
+        <p:nvSpPr>
+          <p:cNvPr id="29" name="TextBox 28"/>
           <p:cNvSpPr txBox="1"/>
           <p:nvPr/>
         </p:nvSpPr>
         <p:spPr>
           <a:xfrm>
-            <a:off x="4782312" y="3785616"/>
-            <a:ext cx="2697480" cy="402336"/>
+            <a:off x="1755648" y="5843016"/>
+            <a:ext cx="2538984" cy="329184"/>
           </a:xfrm>
           <a:prstGeom prst="rect">
             <a:avLst/>
@@ -3690,24 +4257,24 @@
       </p:sp>
       <p:sp>
         <p:nvSpPr>
-          <p:cNvPr id="16" name="Oval 15"/>
-          <p:cNvSpPr/>
-          <p:nvPr/>
-        </p:nvSpPr>
-        <p:spPr>
-          <a:xfrm>
-            <a:off x="4251959" y="4910328"/>
-            <a:ext cx="822960" cy="822960"/>
-          </a:xfrm>
-          <a:prstGeom prst="ellipse">
-            <a:avLst/>
-          </a:prstGeom>
-          <a:solidFill>
-            <a:srgbClr val="D90000"/>
-          </a:solidFill>
-          <a:ln w="13970">
+          <p:cNvPr id="30" name="Rounded Rectangle 29"/>
+          <p:cNvSpPr/>
+          <p:nvPr/>
+        </p:nvSpPr>
+        <p:spPr>
+          <a:xfrm>
+            <a:off x="4724400" y="5705856"/>
+            <a:ext cx="2758440" cy="713232"/>
+          </a:xfrm>
+          <a:prstGeom prst="roundRect">
+            <a:avLst/>
+          </a:prstGeom>
+          <a:solidFill>
+            <a:srgbClr val="FFFFFF"/>
+          </a:solidFill>
+          <a:ln w="11430">
             <a:solidFill>
-              <a:srgbClr val="111827"/>
+              <a:srgbClr val="1D4ED8"/>
             </a:solidFill>
           </a:ln>
         </p:spPr>
@@ -3726,32 +4293,23 @@
           </a:fontRef>
         </p:style>
         <p:txBody>
-          <a:bodyPr rtlCol="0" anchor="ctr" wrap="square" lIns="101600" rIns="101600" tIns="38100" bIns="38100"/>
-          <a:lstStyle/>
-          <a:p>
-            <a:pPr algn="ctr"/>
-            <a:r>
-              <a:rPr sz="1300" b="1">
-                <a:solidFill>
-                  <a:srgbClr val="FFFFFF"/>
-                </a:solidFill>
-                <a:latin typeface="Arial"/>
-              </a:rPr>
-              <a:t>2</a:t>
-            </a:r>
-          </a:p>
-        </p:txBody>
-      </p:sp>
-      <p:sp>
-        <p:nvSpPr>
-          <p:cNvPr id="17" name="TextBox 16"/>
+          <a:bodyPr rtlCol="0" anchor="ctr"/>
+          <a:lstStyle/>
+          <a:p>
+            <a:pPr algn="ctr"/>
+          </a:p>
+        </p:txBody>
+      </p:sp>
+      <p:sp>
+        <p:nvSpPr>
+          <p:cNvPr id="31" name="TextBox 30"/>
           <p:cNvSpPr txBox="1"/>
           <p:nvPr/>
         </p:nvSpPr>
         <p:spPr>
           <a:xfrm>
-            <a:off x="3319271" y="5843016"/>
-            <a:ext cx="2697480" cy="402336"/>
+            <a:off x="4834128" y="5843016"/>
+            <a:ext cx="2538984" cy="329184"/>
           </a:xfrm>
           <a:prstGeom prst="rect">
             <a:avLst/>
@@ -3779,24 +4337,24 @@
       </p:sp>
       <p:sp>
         <p:nvSpPr>
-          <p:cNvPr id="18" name="Oval 17"/>
-          <p:cNvSpPr/>
-          <p:nvPr/>
-        </p:nvSpPr>
-        <p:spPr>
-          <a:xfrm>
-            <a:off x="7178040" y="4910328"/>
-            <a:ext cx="822960" cy="822960"/>
-          </a:xfrm>
-          <a:prstGeom prst="ellipse">
-            <a:avLst/>
-          </a:prstGeom>
-          <a:solidFill>
-            <a:srgbClr val="1B7F3A"/>
-          </a:solidFill>
-          <a:ln w="13970">
+          <p:cNvPr id="32" name="Rounded Rectangle 31"/>
+          <p:cNvSpPr/>
+          <p:nvPr/>
+        </p:nvSpPr>
+        <p:spPr>
+          <a:xfrm>
+            <a:off x="7802880" y="5705856"/>
+            <a:ext cx="2758440" cy="713232"/>
+          </a:xfrm>
+          <a:prstGeom prst="roundRect">
+            <a:avLst/>
+          </a:prstGeom>
+          <a:solidFill>
+            <a:srgbClr val="FFFFFF"/>
+          </a:solidFill>
+          <a:ln w="11430">
             <a:solidFill>
-              <a:srgbClr val="111827"/>
+              <a:srgbClr val="1D4ED8"/>
             </a:solidFill>
           </a:ln>
         </p:spPr>
@@ -3815,32 +4373,23 @@
           </a:fontRef>
         </p:style>
         <p:txBody>
-          <a:bodyPr rtlCol="0" anchor="ctr" wrap="square" lIns="101600" rIns="101600" tIns="38100" bIns="38100"/>
-          <a:lstStyle/>
-          <a:p>
-            <a:pPr algn="ctr"/>
-            <a:r>
-              <a:rPr sz="1300" b="1">
-                <a:solidFill>
-                  <a:srgbClr val="FFFFFF"/>
-                </a:solidFill>
-                <a:latin typeface="Arial"/>
-              </a:rPr>
-              <a:t>3</a:t>
-            </a:r>
-          </a:p>
-        </p:txBody>
-      </p:sp>
-      <p:sp>
-        <p:nvSpPr>
-          <p:cNvPr id="19" name="TextBox 18"/>
+          <a:bodyPr rtlCol="0" anchor="ctr"/>
+          <a:lstStyle/>
+          <a:p>
+            <a:pPr algn="ctr"/>
+          </a:p>
+        </p:txBody>
+      </p:sp>
+      <p:sp>
+        <p:nvSpPr>
+          <p:cNvPr id="33" name="TextBox 32"/>
           <p:cNvSpPr txBox="1"/>
           <p:nvPr/>
         </p:nvSpPr>
         <p:spPr>
           <a:xfrm>
-            <a:off x="6245352" y="5843016"/>
-            <a:ext cx="2697480" cy="402336"/>
+            <a:off x="7912608" y="5843016"/>
+            <a:ext cx="2538984" cy="329184"/>
           </a:xfrm>
           <a:prstGeom prst="rect">
             <a:avLst/>
@@ -6625,8 +7174,8 @@
         </p:nvSpPr>
         <p:spPr>
           <a:xfrm>
-            <a:off x="1417319" y="2322576"/>
-            <a:ext cx="9372600" cy="411480"/>
+            <a:off x="1417319" y="2286000"/>
+            <a:ext cx="9372600" cy="310896"/>
           </a:xfrm>
           <a:prstGeom prst="rect">
             <a:avLst/>
@@ -6641,7 +7190,7 @@
           <a:p>
             <a:pPr algn="ctr"/>
             <a:r>
-              <a:rPr sz="1800" b="1">
+              <a:rPr sz="1700" b="1">
                 <a:solidFill>
                   <a:srgbClr val="111827"/>
                 </a:solidFill>
@@ -6654,22 +7203,65 @@
       </p:sp>
       <p:sp>
         <p:nvSpPr>
-          <p:cNvPr id="13" name="Isosceles Triangle 12"/>
-          <p:cNvSpPr/>
-          <p:nvPr/>
-        </p:nvSpPr>
-        <p:spPr>
-          <a:xfrm>
-            <a:off x="4754879" y="2990088"/>
-            <a:ext cx="2651760" cy="2651760"/>
-          </a:xfrm>
-          <a:prstGeom prst="triangle">
-            <a:avLst/>
-          </a:prstGeom>
-          <a:solidFill>
-            <a:srgbClr val="FFF7E0"/>
-          </a:solidFill>
-          <a:ln w="22860">
+          <p:cNvPr id="13" name="Rectangle 12"/>
+          <p:cNvSpPr/>
+          <p:nvPr/>
+        </p:nvSpPr>
+        <p:spPr>
+          <a:xfrm>
+            <a:off x="2194560" y="4178808"/>
+            <a:ext cx="146304" cy="658368"/>
+          </a:xfrm>
+          <a:prstGeom prst="rect">
+            <a:avLst/>
+          </a:prstGeom>
+          <a:solidFill>
+            <a:srgbClr val="78350F"/>
+          </a:solidFill>
+          <a:ln>
+            <a:noFill/>
+          </a:ln>
+        </p:spPr>
+        <p:style>
+          <a:lnRef idx="1">
+            <a:schemeClr val="accent1"/>
+          </a:lnRef>
+          <a:fillRef idx="3">
+            <a:schemeClr val="accent1"/>
+          </a:fillRef>
+          <a:effectRef idx="2">
+            <a:schemeClr val="accent1"/>
+          </a:effectRef>
+          <a:fontRef idx="minor">
+            <a:schemeClr val="lt1"/>
+          </a:fontRef>
+        </p:style>
+        <p:txBody>
+          <a:bodyPr rtlCol="0" anchor="ctr"/>
+          <a:lstStyle/>
+          <a:p>
+            <a:pPr algn="ctr"/>
+          </a:p>
+        </p:txBody>
+      </p:sp>
+      <p:sp>
+        <p:nvSpPr>
+          <p:cNvPr id="14" name="Oval 13"/>
+          <p:cNvSpPr/>
+          <p:nvPr/>
+        </p:nvSpPr>
+        <p:spPr>
+          <a:xfrm>
+            <a:off x="1874519" y="3584448"/>
+            <a:ext cx="786384" cy="786384"/>
+          </a:xfrm>
+          <a:prstGeom prst="ellipse">
+            <a:avLst/>
+          </a:prstGeom>
+          <a:solidFill>
+            <a:srgbClr val="1B7F3A"/>
+          </a:solidFill>
+          <a:ln w="7620">
             <a:solidFill>
               <a:srgbClr val="111827"/>
             </a:solidFill>
@@ -6699,22 +7291,65 @@
       </p:sp>
       <p:sp>
         <p:nvSpPr>
-          <p:cNvPr id="14" name="Oval 13"/>
-          <p:cNvSpPr/>
-          <p:nvPr/>
-        </p:nvSpPr>
-        <p:spPr>
-          <a:xfrm>
-            <a:off x="5715000" y="2852928"/>
-            <a:ext cx="822960" cy="822960"/>
+          <p:cNvPr id="15" name="Rectangle 14"/>
+          <p:cNvSpPr/>
+          <p:nvPr/>
+        </p:nvSpPr>
+        <p:spPr>
+          <a:xfrm>
+            <a:off x="3259836" y="4347972"/>
+            <a:ext cx="131673" cy="592531"/>
+          </a:xfrm>
+          <a:prstGeom prst="rect">
+            <a:avLst/>
+          </a:prstGeom>
+          <a:solidFill>
+            <a:srgbClr val="78350F"/>
+          </a:solidFill>
+          <a:ln>
+            <a:noFill/>
+          </a:ln>
+        </p:spPr>
+        <p:style>
+          <a:lnRef idx="1">
+            <a:schemeClr val="accent1"/>
+          </a:lnRef>
+          <a:fillRef idx="3">
+            <a:schemeClr val="accent1"/>
+          </a:fillRef>
+          <a:effectRef idx="2">
+            <a:schemeClr val="accent1"/>
+          </a:effectRef>
+          <a:fontRef idx="minor">
+            <a:schemeClr val="lt1"/>
+          </a:fontRef>
+        </p:style>
+        <p:txBody>
+          <a:bodyPr rtlCol="0" anchor="ctr"/>
+          <a:lstStyle/>
+          <a:p>
+            <a:pPr algn="ctr"/>
+          </a:p>
+        </p:txBody>
+      </p:sp>
+      <p:sp>
+        <p:nvSpPr>
+          <p:cNvPr id="16" name="Oval 15"/>
+          <p:cNvSpPr/>
+          <p:nvPr/>
+        </p:nvSpPr>
+        <p:spPr>
+          <a:xfrm>
+            <a:off x="2971800" y="3813048"/>
+            <a:ext cx="707745" cy="707745"/>
           </a:xfrm>
           <a:prstGeom prst="ellipse">
             <a:avLst/>
           </a:prstGeom>
           <a:solidFill>
-            <a:srgbClr val="FCD116"/>
-          </a:solidFill>
-          <a:ln w="13970">
+            <a:srgbClr val="1B7F3A"/>
+          </a:solidFill>
+          <a:ln w="7620">
             <a:solidFill>
               <a:srgbClr val="111827"/>
             </a:solidFill>
@@ -6735,32 +7370,513 @@
           </a:fontRef>
         </p:style>
         <p:txBody>
-          <a:bodyPr rtlCol="0" anchor="ctr" wrap="square" lIns="101600" rIns="101600" tIns="38100" bIns="38100"/>
-          <a:lstStyle/>
-          <a:p>
-            <a:pPr algn="ctr"/>
-            <a:r>
-              <a:rPr sz="1300" b="1">
-                <a:solidFill>
-                  <a:srgbClr val="111827"/>
-                </a:solidFill>
-                <a:latin typeface="Arial"/>
-              </a:rPr>
-              <a:t>1</a:t>
-            </a:r>
-          </a:p>
-        </p:txBody>
-      </p:sp>
-      <p:sp>
-        <p:nvSpPr>
-          <p:cNvPr id="15" name="TextBox 14"/>
+          <a:bodyPr rtlCol="0" anchor="ctr"/>
+          <a:lstStyle/>
+          <a:p>
+            <a:pPr algn="ctr"/>
+          </a:p>
+        </p:txBody>
+      </p:sp>
+      <p:cxnSp>
+        <p:nvCxnSpPr>
+          <p:cNvPr id="17" name="Connector 16"/>
+          <p:cNvCxnSpPr/>
+          <p:nvPr/>
+        </p:nvCxnSpPr>
+        <p:spPr>
+          <a:xfrm flipV="1">
+            <a:off x="4434840" y="3401568"/>
+            <a:ext cx="1920239" cy="320040"/>
+          </a:xfrm>
+          <a:prstGeom prst="line">
+            <a:avLst/>
+          </a:prstGeom>
+          <a:ln w="22860">
+            <a:solidFill>
+              <a:srgbClr val="1D4ED8"/>
+            </a:solidFill>
+          </a:ln>
+        </p:spPr>
+        <p:style>
+          <a:lnRef idx="2">
+            <a:schemeClr val="accent1"/>
+          </a:lnRef>
+          <a:fillRef idx="0">
+            <a:schemeClr val="accent1"/>
+          </a:fillRef>
+          <a:effectRef idx="1">
+            <a:schemeClr val="accent1"/>
+          </a:effectRef>
+          <a:fontRef idx="minor">
+            <a:schemeClr val="tx1"/>
+          </a:fontRef>
+        </p:style>
+      </p:cxnSp>
+      <p:cxnSp>
+        <p:nvCxnSpPr>
+          <p:cNvPr id="18" name="Connector 17"/>
+          <p:cNvCxnSpPr/>
+          <p:nvPr/>
+        </p:nvCxnSpPr>
+        <p:spPr>
+          <a:xfrm flipV="1">
+            <a:off x="4434840" y="3813048"/>
+            <a:ext cx="1920239" cy="320040"/>
+          </a:xfrm>
+          <a:prstGeom prst="line">
+            <a:avLst/>
+          </a:prstGeom>
+          <a:ln w="22860">
+            <a:solidFill>
+              <a:srgbClr val="1D4ED8"/>
+            </a:solidFill>
+          </a:ln>
+        </p:spPr>
+        <p:style>
+          <a:lnRef idx="2">
+            <a:schemeClr val="accent1"/>
+          </a:lnRef>
+          <a:fillRef idx="0">
+            <a:schemeClr val="accent1"/>
+          </a:fillRef>
+          <a:effectRef idx="1">
+            <a:schemeClr val="accent1"/>
+          </a:effectRef>
+          <a:fontRef idx="minor">
+            <a:schemeClr val="tx1"/>
+          </a:fontRef>
+        </p:style>
+      </p:cxnSp>
+      <p:cxnSp>
+        <p:nvCxnSpPr>
+          <p:cNvPr id="19" name="Connector 18"/>
+          <p:cNvCxnSpPr/>
+          <p:nvPr/>
+        </p:nvCxnSpPr>
+        <p:spPr>
+          <a:xfrm flipV="1">
+            <a:off x="4434840" y="4224528"/>
+            <a:ext cx="1920239" cy="320040"/>
+          </a:xfrm>
+          <a:prstGeom prst="line">
+            <a:avLst/>
+          </a:prstGeom>
+          <a:ln w="22860">
+            <a:solidFill>
+              <a:srgbClr val="1D4ED8"/>
+            </a:solidFill>
+          </a:ln>
+        </p:spPr>
+        <p:style>
+          <a:lnRef idx="2">
+            <a:schemeClr val="accent1"/>
+          </a:lnRef>
+          <a:fillRef idx="0">
+            <a:schemeClr val="accent1"/>
+          </a:fillRef>
+          <a:effectRef idx="1">
+            <a:schemeClr val="accent1"/>
+          </a:effectRef>
+          <a:fontRef idx="minor">
+            <a:schemeClr val="tx1"/>
+          </a:fontRef>
+        </p:style>
+      </p:cxnSp>
+      <p:sp>
+        <p:nvSpPr>
+          <p:cNvPr id="20" name="Oval 19"/>
+          <p:cNvSpPr/>
+          <p:nvPr/>
+        </p:nvSpPr>
+        <p:spPr>
+          <a:xfrm>
+            <a:off x="7156094" y="3767328"/>
+            <a:ext cx="181051" cy="197510"/>
+          </a:xfrm>
+          <a:prstGeom prst="ellipse">
+            <a:avLst/>
+          </a:prstGeom>
+          <a:solidFill>
+            <a:srgbClr val="FCD116"/>
+          </a:solidFill>
+          <a:ln w="7620">
+            <a:solidFill>
+              <a:srgbClr val="111827"/>
+            </a:solidFill>
+          </a:ln>
+        </p:spPr>
+        <p:style>
+          <a:lnRef idx="1">
+            <a:schemeClr val="accent1"/>
+          </a:lnRef>
+          <a:fillRef idx="3">
+            <a:schemeClr val="accent1"/>
+          </a:fillRef>
+          <a:effectRef idx="2">
+            <a:schemeClr val="accent1"/>
+          </a:effectRef>
+          <a:fontRef idx="minor">
+            <a:schemeClr val="lt1"/>
+          </a:fontRef>
+        </p:style>
+        <p:txBody>
+          <a:bodyPr rtlCol="0" anchor="ctr"/>
+          <a:lstStyle/>
+          <a:p>
+            <a:pPr algn="ctr"/>
+          </a:p>
+        </p:txBody>
+      </p:sp>
+      <p:sp>
+        <p:nvSpPr>
+          <p:cNvPr id="21" name="Rounded Rectangle 20"/>
+          <p:cNvSpPr/>
+          <p:nvPr/>
+        </p:nvSpPr>
+        <p:spPr>
+          <a:xfrm>
+            <a:off x="7120890" y="4004340"/>
+            <a:ext cx="251460" cy="395020"/>
+          </a:xfrm>
+          <a:prstGeom prst="roundRect">
+            <a:avLst/>
+          </a:prstGeom>
+          <a:solidFill>
+            <a:srgbClr val="D90000"/>
+          </a:solidFill>
+          <a:ln w="7620">
+            <a:solidFill>
+              <a:srgbClr val="111827"/>
+            </a:solidFill>
+          </a:ln>
+        </p:spPr>
+        <p:style>
+          <a:lnRef idx="1">
+            <a:schemeClr val="accent1"/>
+          </a:lnRef>
+          <a:fillRef idx="3">
+            <a:schemeClr val="accent1"/>
+          </a:fillRef>
+          <a:effectRef idx="2">
+            <a:schemeClr val="accent1"/>
+          </a:effectRef>
+          <a:fontRef idx="minor">
+            <a:schemeClr val="lt1"/>
+          </a:fontRef>
+        </p:style>
+        <p:txBody>
+          <a:bodyPr rtlCol="0" anchor="ctr"/>
+          <a:lstStyle/>
+          <a:p>
+            <a:pPr algn="ctr"/>
+          </a:p>
+        </p:txBody>
+      </p:sp>
+      <p:cxnSp>
+        <p:nvCxnSpPr>
+          <p:cNvPr id="22" name="Connector 21"/>
+          <p:cNvCxnSpPr/>
+          <p:nvPr/>
+        </p:nvCxnSpPr>
+        <p:spPr>
+          <a:xfrm flipH="1">
+            <a:off x="7135977" y="4379610"/>
+            <a:ext cx="110643" cy="375270"/>
+          </a:xfrm>
+          <a:prstGeom prst="line">
+            <a:avLst/>
+          </a:prstGeom>
+          <a:ln w="12700">
+            <a:solidFill>
+              <a:srgbClr val="111827"/>
+            </a:solidFill>
+          </a:ln>
+        </p:spPr>
+        <p:style>
+          <a:lnRef idx="2">
+            <a:schemeClr val="accent1"/>
+          </a:lnRef>
+          <a:fillRef idx="0">
+            <a:schemeClr val="accent1"/>
+          </a:fillRef>
+          <a:effectRef idx="1">
+            <a:schemeClr val="accent1"/>
+          </a:effectRef>
+          <a:fontRef idx="minor">
+            <a:schemeClr val="tx1"/>
+          </a:fontRef>
+        </p:style>
+      </p:cxnSp>
+      <p:cxnSp>
+        <p:nvCxnSpPr>
+          <p:cNvPr id="23" name="Connector 22"/>
+          <p:cNvCxnSpPr/>
+          <p:nvPr/>
+        </p:nvCxnSpPr>
+        <p:spPr>
+          <a:xfrm>
+            <a:off x="7246620" y="4379610"/>
+            <a:ext cx="110642" cy="375270"/>
+          </a:xfrm>
+          <a:prstGeom prst="line">
+            <a:avLst/>
+          </a:prstGeom>
+          <a:ln w="12700">
+            <a:solidFill>
+              <a:srgbClr val="111827"/>
+            </a:solidFill>
+          </a:ln>
+        </p:spPr>
+        <p:style>
+          <a:lnRef idx="2">
+            <a:schemeClr val="accent1"/>
+          </a:lnRef>
+          <a:fillRef idx="0">
+            <a:schemeClr val="accent1"/>
+          </a:fillRef>
+          <a:effectRef idx="1">
+            <a:schemeClr val="accent1"/>
+          </a:effectRef>
+          <a:fontRef idx="minor">
+            <a:schemeClr val="tx1"/>
+          </a:fontRef>
+        </p:style>
+      </p:cxnSp>
+      <p:sp>
+        <p:nvSpPr>
+          <p:cNvPr id="24" name="Oval 23"/>
+          <p:cNvSpPr/>
+          <p:nvPr/>
+        </p:nvSpPr>
+        <p:spPr>
+          <a:xfrm>
+            <a:off x="8458200" y="4548225"/>
+            <a:ext cx="652881" cy="528523"/>
+          </a:xfrm>
+          <a:prstGeom prst="ellipse">
+            <a:avLst/>
+          </a:prstGeom>
+          <a:solidFill>
+            <a:srgbClr val="475569"/>
+          </a:solidFill>
+          <a:ln w="7620">
+            <a:solidFill>
+              <a:srgbClr val="111827"/>
+            </a:solidFill>
+          </a:ln>
+        </p:spPr>
+        <p:style>
+          <a:lnRef idx="1">
+            <a:schemeClr val="accent1"/>
+          </a:lnRef>
+          <a:fillRef idx="3">
+            <a:schemeClr val="accent1"/>
+          </a:fillRef>
+          <a:effectRef idx="2">
+            <a:schemeClr val="accent1"/>
+          </a:effectRef>
+          <a:fontRef idx="minor">
+            <a:schemeClr val="lt1"/>
+          </a:fontRef>
+        </p:style>
+        <p:txBody>
+          <a:bodyPr rtlCol="0" anchor="ctr"/>
+          <a:lstStyle/>
+          <a:p>
+            <a:pPr algn="ctr"/>
+          </a:p>
+        </p:txBody>
+      </p:sp>
+      <p:sp>
+        <p:nvSpPr>
+          <p:cNvPr id="25" name="Oval 24"/>
+          <p:cNvSpPr/>
+          <p:nvPr/>
+        </p:nvSpPr>
+        <p:spPr>
+          <a:xfrm>
+            <a:off x="9359798" y="3584448"/>
+            <a:ext cx="652881" cy="528523"/>
+          </a:xfrm>
+          <a:prstGeom prst="ellipse">
+            <a:avLst/>
+          </a:prstGeom>
+          <a:solidFill>
+            <a:srgbClr val="475569"/>
+          </a:solidFill>
+          <a:ln w="7620">
+            <a:solidFill>
+              <a:srgbClr val="111827"/>
+            </a:solidFill>
+          </a:ln>
+        </p:spPr>
+        <p:style>
+          <a:lnRef idx="1">
+            <a:schemeClr val="accent1"/>
+          </a:lnRef>
+          <a:fillRef idx="3">
+            <a:schemeClr val="accent1"/>
+          </a:fillRef>
+          <a:effectRef idx="2">
+            <a:schemeClr val="accent1"/>
+          </a:effectRef>
+          <a:fontRef idx="minor">
+            <a:schemeClr val="lt1"/>
+          </a:fontRef>
+        </p:style>
+        <p:txBody>
+          <a:bodyPr rtlCol="0" anchor="ctr"/>
+          <a:lstStyle/>
+          <a:p>
+            <a:pPr algn="ctr"/>
+          </a:p>
+        </p:txBody>
+      </p:sp>
+      <p:sp>
+        <p:nvSpPr>
+          <p:cNvPr id="26" name="Oval 25"/>
+          <p:cNvSpPr/>
+          <p:nvPr/>
+        </p:nvSpPr>
+        <p:spPr>
+          <a:xfrm>
+            <a:off x="10261396" y="4548225"/>
+            <a:ext cx="652881" cy="528523"/>
+          </a:xfrm>
+          <a:prstGeom prst="ellipse">
+            <a:avLst/>
+          </a:prstGeom>
+          <a:solidFill>
+            <a:srgbClr val="475569"/>
+          </a:solidFill>
+          <a:ln w="7620">
+            <a:solidFill>
+              <a:srgbClr val="111827"/>
+            </a:solidFill>
+          </a:ln>
+        </p:spPr>
+        <p:style>
+          <a:lnRef idx="1">
+            <a:schemeClr val="accent1"/>
+          </a:lnRef>
+          <a:fillRef idx="3">
+            <a:schemeClr val="accent1"/>
+          </a:fillRef>
+          <a:effectRef idx="2">
+            <a:schemeClr val="accent1"/>
+          </a:effectRef>
+          <a:fontRef idx="minor">
+            <a:schemeClr val="lt1"/>
+          </a:fontRef>
+        </p:style>
+        <p:txBody>
+          <a:bodyPr rtlCol="0" anchor="ctr"/>
+          <a:lstStyle/>
+          <a:p>
+            <a:pPr algn="ctr"/>
+          </a:p>
+        </p:txBody>
+      </p:sp>
+      <p:sp>
+        <p:nvSpPr>
+          <p:cNvPr id="27" name="Oval 26"/>
+          <p:cNvSpPr/>
+          <p:nvPr/>
+        </p:nvSpPr>
+        <p:spPr>
+          <a:xfrm>
+            <a:off x="9235440" y="4392777"/>
+            <a:ext cx="854964" cy="590702"/>
+          </a:xfrm>
+          <a:prstGeom prst="ellipse">
+            <a:avLst/>
+          </a:prstGeom>
+          <a:solidFill>
+            <a:srgbClr val="FCD116"/>
+          </a:solidFill>
+          <a:ln w="10160">
+            <a:solidFill>
+              <a:srgbClr val="D90000"/>
+            </a:solidFill>
+          </a:ln>
+        </p:spPr>
+        <p:style>
+          <a:lnRef idx="1">
+            <a:schemeClr val="accent1"/>
+          </a:lnRef>
+          <a:fillRef idx="3">
+            <a:schemeClr val="accent1"/>
+          </a:fillRef>
+          <a:effectRef idx="2">
+            <a:schemeClr val="accent1"/>
+          </a:effectRef>
+          <a:fontRef idx="minor">
+            <a:schemeClr val="lt1"/>
+          </a:fontRef>
+        </p:style>
+        <p:txBody>
+          <a:bodyPr rtlCol="0" anchor="ctr"/>
+          <a:lstStyle/>
+          <a:p>
+            <a:pPr algn="ctr"/>
+          </a:p>
+        </p:txBody>
+      </p:sp>
+      <p:sp>
+        <p:nvSpPr>
+          <p:cNvPr id="28" name="Rounded Rectangle 27"/>
+          <p:cNvSpPr/>
+          <p:nvPr/>
+        </p:nvSpPr>
+        <p:spPr>
+          <a:xfrm>
+            <a:off x="1645919" y="5705856"/>
+            <a:ext cx="2758440" cy="713232"/>
+          </a:xfrm>
+          <a:prstGeom prst="roundRect">
+            <a:avLst/>
+          </a:prstGeom>
+          <a:solidFill>
+            <a:srgbClr val="FFFFFF"/>
+          </a:solidFill>
+          <a:ln w="11430">
+            <a:solidFill>
+              <a:srgbClr val="087490"/>
+            </a:solidFill>
+          </a:ln>
+        </p:spPr>
+        <p:style>
+          <a:lnRef idx="1">
+            <a:schemeClr val="accent1"/>
+          </a:lnRef>
+          <a:fillRef idx="3">
+            <a:schemeClr val="accent1"/>
+          </a:fillRef>
+          <a:effectRef idx="2">
+            <a:schemeClr val="accent1"/>
+          </a:effectRef>
+          <a:fontRef idx="minor">
+            <a:schemeClr val="lt1"/>
+          </a:fontRef>
+        </p:style>
+        <p:txBody>
+          <a:bodyPr rtlCol="0" anchor="ctr"/>
+          <a:lstStyle/>
+          <a:p>
+            <a:pPr algn="ctr"/>
+          </a:p>
+        </p:txBody>
+      </p:sp>
+      <p:sp>
+        <p:nvSpPr>
+          <p:cNvPr id="29" name="TextBox 28"/>
           <p:cNvSpPr txBox="1"/>
           <p:nvPr/>
         </p:nvSpPr>
         <p:spPr>
           <a:xfrm>
-            <a:off x="4782312" y="3785616"/>
-            <a:ext cx="2697480" cy="402336"/>
+            <a:off x="1755648" y="5843016"/>
+            <a:ext cx="2538984" cy="329184"/>
           </a:xfrm>
           <a:prstGeom prst="rect">
             <a:avLst/>
@@ -6788,24 +7904,24 @@
       </p:sp>
       <p:sp>
         <p:nvSpPr>
-          <p:cNvPr id="16" name="Oval 15"/>
-          <p:cNvSpPr/>
-          <p:nvPr/>
-        </p:nvSpPr>
-        <p:spPr>
-          <a:xfrm>
-            <a:off x="4251959" y="4910328"/>
-            <a:ext cx="822960" cy="822960"/>
-          </a:xfrm>
-          <a:prstGeom prst="ellipse">
-            <a:avLst/>
-          </a:prstGeom>
-          <a:solidFill>
-            <a:srgbClr val="D90000"/>
-          </a:solidFill>
-          <a:ln w="13970">
+          <p:cNvPr id="30" name="Rounded Rectangle 29"/>
+          <p:cNvSpPr/>
+          <p:nvPr/>
+        </p:nvSpPr>
+        <p:spPr>
+          <a:xfrm>
+            <a:off x="4724400" y="5705856"/>
+            <a:ext cx="2758440" cy="713232"/>
+          </a:xfrm>
+          <a:prstGeom prst="roundRect">
+            <a:avLst/>
+          </a:prstGeom>
+          <a:solidFill>
+            <a:srgbClr val="FFFFFF"/>
+          </a:solidFill>
+          <a:ln w="11430">
             <a:solidFill>
-              <a:srgbClr val="111827"/>
+              <a:srgbClr val="087490"/>
             </a:solidFill>
           </a:ln>
         </p:spPr>
@@ -6824,32 +7940,23 @@
           </a:fontRef>
         </p:style>
         <p:txBody>
-          <a:bodyPr rtlCol="0" anchor="ctr" wrap="square" lIns="101600" rIns="101600" tIns="38100" bIns="38100"/>
-          <a:lstStyle/>
-          <a:p>
-            <a:pPr algn="ctr"/>
-            <a:r>
-              <a:rPr sz="1300" b="1">
-                <a:solidFill>
-                  <a:srgbClr val="FFFFFF"/>
-                </a:solidFill>
-                <a:latin typeface="Arial"/>
-              </a:rPr>
-              <a:t>2</a:t>
-            </a:r>
-          </a:p>
-        </p:txBody>
-      </p:sp>
-      <p:sp>
-        <p:nvSpPr>
-          <p:cNvPr id="17" name="TextBox 16"/>
+          <a:bodyPr rtlCol="0" anchor="ctr"/>
+          <a:lstStyle/>
+          <a:p>
+            <a:pPr algn="ctr"/>
+          </a:p>
+        </p:txBody>
+      </p:sp>
+      <p:sp>
+        <p:nvSpPr>
+          <p:cNvPr id="31" name="TextBox 30"/>
           <p:cNvSpPr txBox="1"/>
           <p:nvPr/>
         </p:nvSpPr>
         <p:spPr>
           <a:xfrm>
-            <a:off x="3319271" y="5843016"/>
-            <a:ext cx="2697480" cy="402336"/>
+            <a:off x="4834128" y="5843016"/>
+            <a:ext cx="2538984" cy="329184"/>
           </a:xfrm>
           <a:prstGeom prst="rect">
             <a:avLst/>
@@ -6877,24 +7984,24 @@
       </p:sp>
       <p:sp>
         <p:nvSpPr>
-          <p:cNvPr id="18" name="Oval 17"/>
-          <p:cNvSpPr/>
-          <p:nvPr/>
-        </p:nvSpPr>
-        <p:spPr>
-          <a:xfrm>
-            <a:off x="7178040" y="4910328"/>
-            <a:ext cx="822960" cy="822960"/>
-          </a:xfrm>
-          <a:prstGeom prst="ellipse">
-            <a:avLst/>
-          </a:prstGeom>
-          <a:solidFill>
-            <a:srgbClr val="1B7F3A"/>
-          </a:solidFill>
-          <a:ln w="13970">
+          <p:cNvPr id="32" name="Rounded Rectangle 31"/>
+          <p:cNvSpPr/>
+          <p:nvPr/>
+        </p:nvSpPr>
+        <p:spPr>
+          <a:xfrm>
+            <a:off x="7802880" y="5705856"/>
+            <a:ext cx="2758440" cy="713232"/>
+          </a:xfrm>
+          <a:prstGeom prst="roundRect">
+            <a:avLst/>
+          </a:prstGeom>
+          <a:solidFill>
+            <a:srgbClr val="FFFFFF"/>
+          </a:solidFill>
+          <a:ln w="11430">
             <a:solidFill>
-              <a:srgbClr val="111827"/>
+              <a:srgbClr val="087490"/>
             </a:solidFill>
           </a:ln>
         </p:spPr>
@@ -6913,32 +8020,23 @@
           </a:fontRef>
         </p:style>
         <p:txBody>
-          <a:bodyPr rtlCol="0" anchor="ctr" wrap="square" lIns="101600" rIns="101600" tIns="38100" bIns="38100"/>
-          <a:lstStyle/>
-          <a:p>
-            <a:pPr algn="ctr"/>
-            <a:r>
-              <a:rPr sz="1300" b="1">
-                <a:solidFill>
-                  <a:srgbClr val="FFFFFF"/>
-                </a:solidFill>
-                <a:latin typeface="Arial"/>
-              </a:rPr>
-              <a:t>3</a:t>
-            </a:r>
-          </a:p>
-        </p:txBody>
-      </p:sp>
-      <p:sp>
-        <p:nvSpPr>
-          <p:cNvPr id="19" name="TextBox 18"/>
+          <a:bodyPr rtlCol="0" anchor="ctr"/>
+          <a:lstStyle/>
+          <a:p>
+            <a:pPr algn="ctr"/>
+          </a:p>
+        </p:txBody>
+      </p:sp>
+      <p:sp>
+        <p:nvSpPr>
+          <p:cNvPr id="33" name="TextBox 32"/>
           <p:cNvSpPr txBox="1"/>
           <p:nvPr/>
         </p:nvSpPr>
         <p:spPr>
           <a:xfrm>
-            <a:off x="6245352" y="5843016"/>
-            <a:ext cx="2697480" cy="402336"/>
+            <a:off x="7912608" y="5843016"/>
+            <a:ext cx="2538984" cy="329184"/>
           </a:xfrm>
           <a:prstGeom prst="rect">
             <a:avLst/>
@@ -6966,7 +8064,7 @@
       </p:sp>
       <p:sp>
         <p:nvSpPr>
-          <p:cNvPr id="20" name="TextBox 19"/>
+          <p:cNvPr id="34" name="TextBox 33"/>
           <p:cNvSpPr txBox="1"/>
           <p:nvPr/>
         </p:nvSpPr>
@@ -7448,8 +8546,8 @@
         </p:nvSpPr>
         <p:spPr>
           <a:xfrm>
-            <a:off x="1417319" y="2322576"/>
-            <a:ext cx="9372600" cy="411480"/>
+            <a:off x="1417319" y="2286000"/>
+            <a:ext cx="9372600" cy="310896"/>
           </a:xfrm>
           <a:prstGeom prst="rect">
             <a:avLst/>
@@ -7464,7 +8562,7 @@
           <a:p>
             <a:pPr algn="ctr"/>
             <a:r>
-              <a:rPr sz="1800" b="1">
+              <a:rPr sz="1700" b="1">
                 <a:solidFill>
                   <a:srgbClr val="111827"/>
                 </a:solidFill>
@@ -7477,22 +8575,65 @@
       </p:sp>
       <p:sp>
         <p:nvSpPr>
-          <p:cNvPr id="13" name="Isosceles Triangle 12"/>
-          <p:cNvSpPr/>
-          <p:nvPr/>
-        </p:nvSpPr>
-        <p:spPr>
-          <a:xfrm>
-            <a:off x="4754879" y="2990088"/>
-            <a:ext cx="2651760" cy="2651760"/>
-          </a:xfrm>
-          <a:prstGeom prst="triangle">
-            <a:avLst/>
-          </a:prstGeom>
-          <a:solidFill>
-            <a:srgbClr val="FFF7E0"/>
-          </a:solidFill>
-          <a:ln w="22860">
+          <p:cNvPr id="13" name="Rectangle 12"/>
+          <p:cNvSpPr/>
+          <p:nvPr/>
+        </p:nvSpPr>
+        <p:spPr>
+          <a:xfrm>
+            <a:off x="2194560" y="4178808"/>
+            <a:ext cx="146304" cy="658368"/>
+          </a:xfrm>
+          <a:prstGeom prst="rect">
+            <a:avLst/>
+          </a:prstGeom>
+          <a:solidFill>
+            <a:srgbClr val="78350F"/>
+          </a:solidFill>
+          <a:ln>
+            <a:noFill/>
+          </a:ln>
+        </p:spPr>
+        <p:style>
+          <a:lnRef idx="1">
+            <a:schemeClr val="accent1"/>
+          </a:lnRef>
+          <a:fillRef idx="3">
+            <a:schemeClr val="accent1"/>
+          </a:fillRef>
+          <a:effectRef idx="2">
+            <a:schemeClr val="accent1"/>
+          </a:effectRef>
+          <a:fontRef idx="minor">
+            <a:schemeClr val="lt1"/>
+          </a:fontRef>
+        </p:style>
+        <p:txBody>
+          <a:bodyPr rtlCol="0" anchor="ctr"/>
+          <a:lstStyle/>
+          <a:p>
+            <a:pPr algn="ctr"/>
+          </a:p>
+        </p:txBody>
+      </p:sp>
+      <p:sp>
+        <p:nvSpPr>
+          <p:cNvPr id="14" name="Oval 13"/>
+          <p:cNvSpPr/>
+          <p:nvPr/>
+        </p:nvSpPr>
+        <p:spPr>
+          <a:xfrm>
+            <a:off x="1874519" y="3584448"/>
+            <a:ext cx="786384" cy="786384"/>
+          </a:xfrm>
+          <a:prstGeom prst="ellipse">
+            <a:avLst/>
+          </a:prstGeom>
+          <a:solidFill>
+            <a:srgbClr val="1B7F3A"/>
+          </a:solidFill>
+          <a:ln w="7620">
             <a:solidFill>
               <a:srgbClr val="111827"/>
             </a:solidFill>
@@ -7522,22 +8663,65 @@
       </p:sp>
       <p:sp>
         <p:nvSpPr>
-          <p:cNvPr id="14" name="Oval 13"/>
-          <p:cNvSpPr/>
-          <p:nvPr/>
-        </p:nvSpPr>
-        <p:spPr>
-          <a:xfrm>
-            <a:off x="5715000" y="2852928"/>
-            <a:ext cx="822960" cy="822960"/>
+          <p:cNvPr id="15" name="Rectangle 14"/>
+          <p:cNvSpPr/>
+          <p:nvPr/>
+        </p:nvSpPr>
+        <p:spPr>
+          <a:xfrm>
+            <a:off x="3259836" y="4347972"/>
+            <a:ext cx="131673" cy="592531"/>
+          </a:xfrm>
+          <a:prstGeom prst="rect">
+            <a:avLst/>
+          </a:prstGeom>
+          <a:solidFill>
+            <a:srgbClr val="78350F"/>
+          </a:solidFill>
+          <a:ln>
+            <a:noFill/>
+          </a:ln>
+        </p:spPr>
+        <p:style>
+          <a:lnRef idx="1">
+            <a:schemeClr val="accent1"/>
+          </a:lnRef>
+          <a:fillRef idx="3">
+            <a:schemeClr val="accent1"/>
+          </a:fillRef>
+          <a:effectRef idx="2">
+            <a:schemeClr val="accent1"/>
+          </a:effectRef>
+          <a:fontRef idx="minor">
+            <a:schemeClr val="lt1"/>
+          </a:fontRef>
+        </p:style>
+        <p:txBody>
+          <a:bodyPr rtlCol="0" anchor="ctr"/>
+          <a:lstStyle/>
+          <a:p>
+            <a:pPr algn="ctr"/>
+          </a:p>
+        </p:txBody>
+      </p:sp>
+      <p:sp>
+        <p:nvSpPr>
+          <p:cNvPr id="16" name="Oval 15"/>
+          <p:cNvSpPr/>
+          <p:nvPr/>
+        </p:nvSpPr>
+        <p:spPr>
+          <a:xfrm>
+            <a:off x="2971800" y="3813048"/>
+            <a:ext cx="707745" cy="707745"/>
           </a:xfrm>
           <a:prstGeom prst="ellipse">
             <a:avLst/>
           </a:prstGeom>
           <a:solidFill>
-            <a:srgbClr val="FCD116"/>
-          </a:solidFill>
-          <a:ln w="13970">
+            <a:srgbClr val="1B7F3A"/>
+          </a:solidFill>
+          <a:ln w="7620">
             <a:solidFill>
               <a:srgbClr val="111827"/>
             </a:solidFill>
@@ -7558,32 +8742,513 @@
           </a:fontRef>
         </p:style>
         <p:txBody>
-          <a:bodyPr rtlCol="0" anchor="ctr" wrap="square" lIns="101600" rIns="101600" tIns="38100" bIns="38100"/>
-          <a:lstStyle/>
-          <a:p>
-            <a:pPr algn="ctr"/>
-            <a:r>
-              <a:rPr sz="1300" b="1">
-                <a:solidFill>
-                  <a:srgbClr val="111827"/>
-                </a:solidFill>
-                <a:latin typeface="Arial"/>
-              </a:rPr>
-              <a:t>1</a:t>
-            </a:r>
-          </a:p>
-        </p:txBody>
-      </p:sp>
-      <p:sp>
-        <p:nvSpPr>
-          <p:cNvPr id="15" name="TextBox 14"/>
+          <a:bodyPr rtlCol="0" anchor="ctr"/>
+          <a:lstStyle/>
+          <a:p>
+            <a:pPr algn="ctr"/>
+          </a:p>
+        </p:txBody>
+      </p:sp>
+      <p:cxnSp>
+        <p:nvCxnSpPr>
+          <p:cNvPr id="17" name="Connector 16"/>
+          <p:cNvCxnSpPr/>
+          <p:nvPr/>
+        </p:nvCxnSpPr>
+        <p:spPr>
+          <a:xfrm flipV="1">
+            <a:off x="4434840" y="3401568"/>
+            <a:ext cx="1920239" cy="320040"/>
+          </a:xfrm>
+          <a:prstGeom prst="line">
+            <a:avLst/>
+          </a:prstGeom>
+          <a:ln w="22860">
+            <a:solidFill>
+              <a:srgbClr val="1D4ED8"/>
+            </a:solidFill>
+          </a:ln>
+        </p:spPr>
+        <p:style>
+          <a:lnRef idx="2">
+            <a:schemeClr val="accent1"/>
+          </a:lnRef>
+          <a:fillRef idx="0">
+            <a:schemeClr val="accent1"/>
+          </a:fillRef>
+          <a:effectRef idx="1">
+            <a:schemeClr val="accent1"/>
+          </a:effectRef>
+          <a:fontRef idx="minor">
+            <a:schemeClr val="tx1"/>
+          </a:fontRef>
+        </p:style>
+      </p:cxnSp>
+      <p:cxnSp>
+        <p:nvCxnSpPr>
+          <p:cNvPr id="18" name="Connector 17"/>
+          <p:cNvCxnSpPr/>
+          <p:nvPr/>
+        </p:nvCxnSpPr>
+        <p:spPr>
+          <a:xfrm flipV="1">
+            <a:off x="4434840" y="3813048"/>
+            <a:ext cx="1920239" cy="320040"/>
+          </a:xfrm>
+          <a:prstGeom prst="line">
+            <a:avLst/>
+          </a:prstGeom>
+          <a:ln w="22860">
+            <a:solidFill>
+              <a:srgbClr val="1D4ED8"/>
+            </a:solidFill>
+          </a:ln>
+        </p:spPr>
+        <p:style>
+          <a:lnRef idx="2">
+            <a:schemeClr val="accent1"/>
+          </a:lnRef>
+          <a:fillRef idx="0">
+            <a:schemeClr val="accent1"/>
+          </a:fillRef>
+          <a:effectRef idx="1">
+            <a:schemeClr val="accent1"/>
+          </a:effectRef>
+          <a:fontRef idx="minor">
+            <a:schemeClr val="tx1"/>
+          </a:fontRef>
+        </p:style>
+      </p:cxnSp>
+      <p:cxnSp>
+        <p:nvCxnSpPr>
+          <p:cNvPr id="19" name="Connector 18"/>
+          <p:cNvCxnSpPr/>
+          <p:nvPr/>
+        </p:nvCxnSpPr>
+        <p:spPr>
+          <a:xfrm flipV="1">
+            <a:off x="4434840" y="4224528"/>
+            <a:ext cx="1920239" cy="320040"/>
+          </a:xfrm>
+          <a:prstGeom prst="line">
+            <a:avLst/>
+          </a:prstGeom>
+          <a:ln w="22860">
+            <a:solidFill>
+              <a:srgbClr val="1D4ED8"/>
+            </a:solidFill>
+          </a:ln>
+        </p:spPr>
+        <p:style>
+          <a:lnRef idx="2">
+            <a:schemeClr val="accent1"/>
+          </a:lnRef>
+          <a:fillRef idx="0">
+            <a:schemeClr val="accent1"/>
+          </a:fillRef>
+          <a:effectRef idx="1">
+            <a:schemeClr val="accent1"/>
+          </a:effectRef>
+          <a:fontRef idx="minor">
+            <a:schemeClr val="tx1"/>
+          </a:fontRef>
+        </p:style>
+      </p:cxnSp>
+      <p:sp>
+        <p:nvSpPr>
+          <p:cNvPr id="20" name="Oval 19"/>
+          <p:cNvSpPr/>
+          <p:nvPr/>
+        </p:nvSpPr>
+        <p:spPr>
+          <a:xfrm>
+            <a:off x="7156094" y="3767328"/>
+            <a:ext cx="181051" cy="197510"/>
+          </a:xfrm>
+          <a:prstGeom prst="ellipse">
+            <a:avLst/>
+          </a:prstGeom>
+          <a:solidFill>
+            <a:srgbClr val="FCD116"/>
+          </a:solidFill>
+          <a:ln w="7620">
+            <a:solidFill>
+              <a:srgbClr val="111827"/>
+            </a:solidFill>
+          </a:ln>
+        </p:spPr>
+        <p:style>
+          <a:lnRef idx="1">
+            <a:schemeClr val="accent1"/>
+          </a:lnRef>
+          <a:fillRef idx="3">
+            <a:schemeClr val="accent1"/>
+          </a:fillRef>
+          <a:effectRef idx="2">
+            <a:schemeClr val="accent1"/>
+          </a:effectRef>
+          <a:fontRef idx="minor">
+            <a:schemeClr val="lt1"/>
+          </a:fontRef>
+        </p:style>
+        <p:txBody>
+          <a:bodyPr rtlCol="0" anchor="ctr"/>
+          <a:lstStyle/>
+          <a:p>
+            <a:pPr algn="ctr"/>
+          </a:p>
+        </p:txBody>
+      </p:sp>
+      <p:sp>
+        <p:nvSpPr>
+          <p:cNvPr id="21" name="Rounded Rectangle 20"/>
+          <p:cNvSpPr/>
+          <p:nvPr/>
+        </p:nvSpPr>
+        <p:spPr>
+          <a:xfrm>
+            <a:off x="7120890" y="4004340"/>
+            <a:ext cx="251460" cy="395020"/>
+          </a:xfrm>
+          <a:prstGeom prst="roundRect">
+            <a:avLst/>
+          </a:prstGeom>
+          <a:solidFill>
+            <a:srgbClr val="D90000"/>
+          </a:solidFill>
+          <a:ln w="7620">
+            <a:solidFill>
+              <a:srgbClr val="111827"/>
+            </a:solidFill>
+          </a:ln>
+        </p:spPr>
+        <p:style>
+          <a:lnRef idx="1">
+            <a:schemeClr val="accent1"/>
+          </a:lnRef>
+          <a:fillRef idx="3">
+            <a:schemeClr val="accent1"/>
+          </a:fillRef>
+          <a:effectRef idx="2">
+            <a:schemeClr val="accent1"/>
+          </a:effectRef>
+          <a:fontRef idx="minor">
+            <a:schemeClr val="lt1"/>
+          </a:fontRef>
+        </p:style>
+        <p:txBody>
+          <a:bodyPr rtlCol="0" anchor="ctr"/>
+          <a:lstStyle/>
+          <a:p>
+            <a:pPr algn="ctr"/>
+          </a:p>
+        </p:txBody>
+      </p:sp>
+      <p:cxnSp>
+        <p:nvCxnSpPr>
+          <p:cNvPr id="22" name="Connector 21"/>
+          <p:cNvCxnSpPr/>
+          <p:nvPr/>
+        </p:nvCxnSpPr>
+        <p:spPr>
+          <a:xfrm flipH="1">
+            <a:off x="7135977" y="4379610"/>
+            <a:ext cx="110643" cy="375270"/>
+          </a:xfrm>
+          <a:prstGeom prst="line">
+            <a:avLst/>
+          </a:prstGeom>
+          <a:ln w="12700">
+            <a:solidFill>
+              <a:srgbClr val="111827"/>
+            </a:solidFill>
+          </a:ln>
+        </p:spPr>
+        <p:style>
+          <a:lnRef idx="2">
+            <a:schemeClr val="accent1"/>
+          </a:lnRef>
+          <a:fillRef idx="0">
+            <a:schemeClr val="accent1"/>
+          </a:fillRef>
+          <a:effectRef idx="1">
+            <a:schemeClr val="accent1"/>
+          </a:effectRef>
+          <a:fontRef idx="minor">
+            <a:schemeClr val="tx1"/>
+          </a:fontRef>
+        </p:style>
+      </p:cxnSp>
+      <p:cxnSp>
+        <p:nvCxnSpPr>
+          <p:cNvPr id="23" name="Connector 22"/>
+          <p:cNvCxnSpPr/>
+          <p:nvPr/>
+        </p:nvCxnSpPr>
+        <p:spPr>
+          <a:xfrm>
+            <a:off x="7246620" y="4379610"/>
+            <a:ext cx="110642" cy="375270"/>
+          </a:xfrm>
+          <a:prstGeom prst="line">
+            <a:avLst/>
+          </a:prstGeom>
+          <a:ln w="12700">
+            <a:solidFill>
+              <a:srgbClr val="111827"/>
+            </a:solidFill>
+          </a:ln>
+        </p:spPr>
+        <p:style>
+          <a:lnRef idx="2">
+            <a:schemeClr val="accent1"/>
+          </a:lnRef>
+          <a:fillRef idx="0">
+            <a:schemeClr val="accent1"/>
+          </a:fillRef>
+          <a:effectRef idx="1">
+            <a:schemeClr val="accent1"/>
+          </a:effectRef>
+          <a:fontRef idx="minor">
+            <a:schemeClr val="tx1"/>
+          </a:fontRef>
+        </p:style>
+      </p:cxnSp>
+      <p:sp>
+        <p:nvSpPr>
+          <p:cNvPr id="24" name="Oval 23"/>
+          <p:cNvSpPr/>
+          <p:nvPr/>
+        </p:nvSpPr>
+        <p:spPr>
+          <a:xfrm>
+            <a:off x="8458200" y="4548225"/>
+            <a:ext cx="652881" cy="528523"/>
+          </a:xfrm>
+          <a:prstGeom prst="ellipse">
+            <a:avLst/>
+          </a:prstGeom>
+          <a:solidFill>
+            <a:srgbClr val="475569"/>
+          </a:solidFill>
+          <a:ln w="7620">
+            <a:solidFill>
+              <a:srgbClr val="111827"/>
+            </a:solidFill>
+          </a:ln>
+        </p:spPr>
+        <p:style>
+          <a:lnRef idx="1">
+            <a:schemeClr val="accent1"/>
+          </a:lnRef>
+          <a:fillRef idx="3">
+            <a:schemeClr val="accent1"/>
+          </a:fillRef>
+          <a:effectRef idx="2">
+            <a:schemeClr val="accent1"/>
+          </a:effectRef>
+          <a:fontRef idx="minor">
+            <a:schemeClr val="lt1"/>
+          </a:fontRef>
+        </p:style>
+        <p:txBody>
+          <a:bodyPr rtlCol="0" anchor="ctr"/>
+          <a:lstStyle/>
+          <a:p>
+            <a:pPr algn="ctr"/>
+          </a:p>
+        </p:txBody>
+      </p:sp>
+      <p:sp>
+        <p:nvSpPr>
+          <p:cNvPr id="25" name="Oval 24"/>
+          <p:cNvSpPr/>
+          <p:nvPr/>
+        </p:nvSpPr>
+        <p:spPr>
+          <a:xfrm>
+            <a:off x="9359798" y="3584448"/>
+            <a:ext cx="652881" cy="528523"/>
+          </a:xfrm>
+          <a:prstGeom prst="ellipse">
+            <a:avLst/>
+          </a:prstGeom>
+          <a:solidFill>
+            <a:srgbClr val="475569"/>
+          </a:solidFill>
+          <a:ln w="7620">
+            <a:solidFill>
+              <a:srgbClr val="111827"/>
+            </a:solidFill>
+          </a:ln>
+        </p:spPr>
+        <p:style>
+          <a:lnRef idx="1">
+            <a:schemeClr val="accent1"/>
+          </a:lnRef>
+          <a:fillRef idx="3">
+            <a:schemeClr val="accent1"/>
+          </a:fillRef>
+          <a:effectRef idx="2">
+            <a:schemeClr val="accent1"/>
+          </a:effectRef>
+          <a:fontRef idx="minor">
+            <a:schemeClr val="lt1"/>
+          </a:fontRef>
+        </p:style>
+        <p:txBody>
+          <a:bodyPr rtlCol="0" anchor="ctr"/>
+          <a:lstStyle/>
+          <a:p>
+            <a:pPr algn="ctr"/>
+          </a:p>
+        </p:txBody>
+      </p:sp>
+      <p:sp>
+        <p:nvSpPr>
+          <p:cNvPr id="26" name="Oval 25"/>
+          <p:cNvSpPr/>
+          <p:nvPr/>
+        </p:nvSpPr>
+        <p:spPr>
+          <a:xfrm>
+            <a:off x="10261396" y="4548225"/>
+            <a:ext cx="652881" cy="528523"/>
+          </a:xfrm>
+          <a:prstGeom prst="ellipse">
+            <a:avLst/>
+          </a:prstGeom>
+          <a:solidFill>
+            <a:srgbClr val="475569"/>
+          </a:solidFill>
+          <a:ln w="7620">
+            <a:solidFill>
+              <a:srgbClr val="111827"/>
+            </a:solidFill>
+          </a:ln>
+        </p:spPr>
+        <p:style>
+          <a:lnRef idx="1">
+            <a:schemeClr val="accent1"/>
+          </a:lnRef>
+          <a:fillRef idx="3">
+            <a:schemeClr val="accent1"/>
+          </a:fillRef>
+          <a:effectRef idx="2">
+            <a:schemeClr val="accent1"/>
+          </a:effectRef>
+          <a:fontRef idx="minor">
+            <a:schemeClr val="lt1"/>
+          </a:fontRef>
+        </p:style>
+        <p:txBody>
+          <a:bodyPr rtlCol="0" anchor="ctr"/>
+          <a:lstStyle/>
+          <a:p>
+            <a:pPr algn="ctr"/>
+          </a:p>
+        </p:txBody>
+      </p:sp>
+      <p:sp>
+        <p:nvSpPr>
+          <p:cNvPr id="27" name="Oval 26"/>
+          <p:cNvSpPr/>
+          <p:nvPr/>
+        </p:nvSpPr>
+        <p:spPr>
+          <a:xfrm>
+            <a:off x="9235440" y="4392777"/>
+            <a:ext cx="854964" cy="590702"/>
+          </a:xfrm>
+          <a:prstGeom prst="ellipse">
+            <a:avLst/>
+          </a:prstGeom>
+          <a:solidFill>
+            <a:srgbClr val="FCD116"/>
+          </a:solidFill>
+          <a:ln w="10160">
+            <a:solidFill>
+              <a:srgbClr val="D90000"/>
+            </a:solidFill>
+          </a:ln>
+        </p:spPr>
+        <p:style>
+          <a:lnRef idx="1">
+            <a:schemeClr val="accent1"/>
+          </a:lnRef>
+          <a:fillRef idx="3">
+            <a:schemeClr val="accent1"/>
+          </a:fillRef>
+          <a:effectRef idx="2">
+            <a:schemeClr val="accent1"/>
+          </a:effectRef>
+          <a:fontRef idx="minor">
+            <a:schemeClr val="lt1"/>
+          </a:fontRef>
+        </p:style>
+        <p:txBody>
+          <a:bodyPr rtlCol="0" anchor="ctr"/>
+          <a:lstStyle/>
+          <a:p>
+            <a:pPr algn="ctr"/>
+          </a:p>
+        </p:txBody>
+      </p:sp>
+      <p:sp>
+        <p:nvSpPr>
+          <p:cNvPr id="28" name="Rounded Rectangle 27"/>
+          <p:cNvSpPr/>
+          <p:nvPr/>
+        </p:nvSpPr>
+        <p:spPr>
+          <a:xfrm>
+            <a:off x="1645919" y="5705856"/>
+            <a:ext cx="2758440" cy="713232"/>
+          </a:xfrm>
+          <a:prstGeom prst="roundRect">
+            <a:avLst/>
+          </a:prstGeom>
+          <a:solidFill>
+            <a:srgbClr val="FFFFFF"/>
+          </a:solidFill>
+          <a:ln w="11430">
+            <a:solidFill>
+              <a:srgbClr val="D97706"/>
+            </a:solidFill>
+          </a:ln>
+        </p:spPr>
+        <p:style>
+          <a:lnRef idx="1">
+            <a:schemeClr val="accent1"/>
+          </a:lnRef>
+          <a:fillRef idx="3">
+            <a:schemeClr val="accent1"/>
+          </a:fillRef>
+          <a:effectRef idx="2">
+            <a:schemeClr val="accent1"/>
+          </a:effectRef>
+          <a:fontRef idx="minor">
+            <a:schemeClr val="lt1"/>
+          </a:fontRef>
+        </p:style>
+        <p:txBody>
+          <a:bodyPr rtlCol="0" anchor="ctr"/>
+          <a:lstStyle/>
+          <a:p>
+            <a:pPr algn="ctr"/>
+          </a:p>
+        </p:txBody>
+      </p:sp>
+      <p:sp>
+        <p:nvSpPr>
+          <p:cNvPr id="29" name="TextBox 28"/>
           <p:cNvSpPr txBox="1"/>
           <p:nvPr/>
         </p:nvSpPr>
         <p:spPr>
           <a:xfrm>
-            <a:off x="4782312" y="3785616"/>
-            <a:ext cx="2697480" cy="402336"/>
+            <a:off x="1755648" y="5843016"/>
+            <a:ext cx="2538984" cy="329184"/>
           </a:xfrm>
           <a:prstGeom prst="rect">
             <a:avLst/>
@@ -7611,24 +9276,24 @@
       </p:sp>
       <p:sp>
         <p:nvSpPr>
-          <p:cNvPr id="16" name="Oval 15"/>
-          <p:cNvSpPr/>
-          <p:nvPr/>
-        </p:nvSpPr>
-        <p:spPr>
-          <a:xfrm>
-            <a:off x="4251959" y="4910328"/>
-            <a:ext cx="822960" cy="822960"/>
-          </a:xfrm>
-          <a:prstGeom prst="ellipse">
-            <a:avLst/>
-          </a:prstGeom>
-          <a:solidFill>
-            <a:srgbClr val="D90000"/>
-          </a:solidFill>
-          <a:ln w="13970">
+          <p:cNvPr id="30" name="Rounded Rectangle 29"/>
+          <p:cNvSpPr/>
+          <p:nvPr/>
+        </p:nvSpPr>
+        <p:spPr>
+          <a:xfrm>
+            <a:off x="4724400" y="5705856"/>
+            <a:ext cx="2758440" cy="713232"/>
+          </a:xfrm>
+          <a:prstGeom prst="roundRect">
+            <a:avLst/>
+          </a:prstGeom>
+          <a:solidFill>
+            <a:srgbClr val="FFFFFF"/>
+          </a:solidFill>
+          <a:ln w="11430">
             <a:solidFill>
-              <a:srgbClr val="111827"/>
+              <a:srgbClr val="D97706"/>
             </a:solidFill>
           </a:ln>
         </p:spPr>
@@ -7647,32 +9312,23 @@
           </a:fontRef>
         </p:style>
         <p:txBody>
-          <a:bodyPr rtlCol="0" anchor="ctr" wrap="square" lIns="101600" rIns="101600" tIns="38100" bIns="38100"/>
-          <a:lstStyle/>
-          <a:p>
-            <a:pPr algn="ctr"/>
-            <a:r>
-              <a:rPr sz="1300" b="1">
-                <a:solidFill>
-                  <a:srgbClr val="FFFFFF"/>
-                </a:solidFill>
-                <a:latin typeface="Arial"/>
-              </a:rPr>
-              <a:t>2</a:t>
-            </a:r>
-          </a:p>
-        </p:txBody>
-      </p:sp>
-      <p:sp>
-        <p:nvSpPr>
-          <p:cNvPr id="17" name="TextBox 16"/>
+          <a:bodyPr rtlCol="0" anchor="ctr"/>
+          <a:lstStyle/>
+          <a:p>
+            <a:pPr algn="ctr"/>
+          </a:p>
+        </p:txBody>
+      </p:sp>
+      <p:sp>
+        <p:nvSpPr>
+          <p:cNvPr id="31" name="TextBox 30"/>
           <p:cNvSpPr txBox="1"/>
           <p:nvPr/>
         </p:nvSpPr>
         <p:spPr>
           <a:xfrm>
-            <a:off x="3319271" y="5843016"/>
-            <a:ext cx="2697480" cy="402336"/>
+            <a:off x="4834128" y="5843016"/>
+            <a:ext cx="2538984" cy="329184"/>
           </a:xfrm>
           <a:prstGeom prst="rect">
             <a:avLst/>
@@ -7700,24 +9356,24 @@
       </p:sp>
       <p:sp>
         <p:nvSpPr>
-          <p:cNvPr id="18" name="Oval 17"/>
-          <p:cNvSpPr/>
-          <p:nvPr/>
-        </p:nvSpPr>
-        <p:spPr>
-          <a:xfrm>
-            <a:off x="7178040" y="4910328"/>
-            <a:ext cx="822960" cy="822960"/>
-          </a:xfrm>
-          <a:prstGeom prst="ellipse">
-            <a:avLst/>
-          </a:prstGeom>
-          <a:solidFill>
-            <a:srgbClr val="1B7F3A"/>
-          </a:solidFill>
-          <a:ln w="13970">
+          <p:cNvPr id="32" name="Rounded Rectangle 31"/>
+          <p:cNvSpPr/>
+          <p:nvPr/>
+        </p:nvSpPr>
+        <p:spPr>
+          <a:xfrm>
+            <a:off x="7802880" y="5705856"/>
+            <a:ext cx="2758440" cy="713232"/>
+          </a:xfrm>
+          <a:prstGeom prst="roundRect">
+            <a:avLst/>
+          </a:prstGeom>
+          <a:solidFill>
+            <a:srgbClr val="FFFFFF"/>
+          </a:solidFill>
+          <a:ln w="11430">
             <a:solidFill>
-              <a:srgbClr val="111827"/>
+              <a:srgbClr val="D97706"/>
             </a:solidFill>
           </a:ln>
         </p:spPr>
@@ -7736,32 +9392,23 @@
           </a:fontRef>
         </p:style>
         <p:txBody>
-          <a:bodyPr rtlCol="0" anchor="ctr" wrap="square" lIns="101600" rIns="101600" tIns="38100" bIns="38100"/>
-          <a:lstStyle/>
-          <a:p>
-            <a:pPr algn="ctr"/>
-            <a:r>
-              <a:rPr sz="1300" b="1">
-                <a:solidFill>
-                  <a:srgbClr val="FFFFFF"/>
-                </a:solidFill>
-                <a:latin typeface="Arial"/>
-              </a:rPr>
-              <a:t>3</a:t>
-            </a:r>
-          </a:p>
-        </p:txBody>
-      </p:sp>
-      <p:sp>
-        <p:nvSpPr>
-          <p:cNvPr id="19" name="TextBox 18"/>
+          <a:bodyPr rtlCol="0" anchor="ctr"/>
+          <a:lstStyle/>
+          <a:p>
+            <a:pPr algn="ctr"/>
+          </a:p>
+        </p:txBody>
+      </p:sp>
+      <p:sp>
+        <p:nvSpPr>
+          <p:cNvPr id="33" name="TextBox 32"/>
           <p:cNvSpPr txBox="1"/>
           <p:nvPr/>
         </p:nvSpPr>
         <p:spPr>
           <a:xfrm>
-            <a:off x="6245352" y="5843016"/>
-            <a:ext cx="2697480" cy="402336"/>
+            <a:off x="7912608" y="5843016"/>
+            <a:ext cx="2538984" cy="329184"/>
           </a:xfrm>
           <a:prstGeom prst="rect">
             <a:avLst/>
@@ -7789,7 +9436,7 @@
       </p:sp>
       <p:sp>
         <p:nvSpPr>
-          <p:cNvPr id="20" name="TextBox 19"/>
+          <p:cNvPr id="34" name="TextBox 33"/>
           <p:cNvSpPr txBox="1"/>
           <p:nvPr/>
         </p:nvSpPr>
@@ -9561,8 +11208,8 @@
         </p:nvSpPr>
         <p:spPr>
           <a:xfrm>
-            <a:off x="1417319" y="2322576"/>
-            <a:ext cx="9372600" cy="411480"/>
+            <a:off x="1417319" y="2286000"/>
+            <a:ext cx="9372600" cy="310896"/>
           </a:xfrm>
           <a:prstGeom prst="rect">
             <a:avLst/>
@@ -9577,7 +11224,7 @@
           <a:p>
             <a:pPr algn="ctr"/>
             <a:r>
-              <a:rPr sz="1800" b="1">
+              <a:rPr sz="1700" b="1">
                 <a:solidFill>
                   <a:srgbClr val="111827"/>
                 </a:solidFill>
@@ -9590,22 +11237,65 @@
       </p:sp>
       <p:sp>
         <p:nvSpPr>
-          <p:cNvPr id="13" name="Isosceles Triangle 12"/>
-          <p:cNvSpPr/>
-          <p:nvPr/>
-        </p:nvSpPr>
-        <p:spPr>
-          <a:xfrm>
-            <a:off x="4754879" y="2990088"/>
-            <a:ext cx="2651760" cy="2651760"/>
-          </a:xfrm>
-          <a:prstGeom prst="triangle">
-            <a:avLst/>
-          </a:prstGeom>
-          <a:solidFill>
-            <a:srgbClr val="FFF7E0"/>
-          </a:solidFill>
-          <a:ln w="22860">
+          <p:cNvPr id="13" name="Rectangle 12"/>
+          <p:cNvSpPr/>
+          <p:nvPr/>
+        </p:nvSpPr>
+        <p:spPr>
+          <a:xfrm>
+            <a:off x="2194560" y="4178808"/>
+            <a:ext cx="146304" cy="658368"/>
+          </a:xfrm>
+          <a:prstGeom prst="rect">
+            <a:avLst/>
+          </a:prstGeom>
+          <a:solidFill>
+            <a:srgbClr val="78350F"/>
+          </a:solidFill>
+          <a:ln>
+            <a:noFill/>
+          </a:ln>
+        </p:spPr>
+        <p:style>
+          <a:lnRef idx="1">
+            <a:schemeClr val="accent1"/>
+          </a:lnRef>
+          <a:fillRef idx="3">
+            <a:schemeClr val="accent1"/>
+          </a:fillRef>
+          <a:effectRef idx="2">
+            <a:schemeClr val="accent1"/>
+          </a:effectRef>
+          <a:fontRef idx="minor">
+            <a:schemeClr val="lt1"/>
+          </a:fontRef>
+        </p:style>
+        <p:txBody>
+          <a:bodyPr rtlCol="0" anchor="ctr"/>
+          <a:lstStyle/>
+          <a:p>
+            <a:pPr algn="ctr"/>
+          </a:p>
+        </p:txBody>
+      </p:sp>
+      <p:sp>
+        <p:nvSpPr>
+          <p:cNvPr id="14" name="Oval 13"/>
+          <p:cNvSpPr/>
+          <p:nvPr/>
+        </p:nvSpPr>
+        <p:spPr>
+          <a:xfrm>
+            <a:off x="1874519" y="3584448"/>
+            <a:ext cx="786384" cy="786384"/>
+          </a:xfrm>
+          <a:prstGeom prst="ellipse">
+            <a:avLst/>
+          </a:prstGeom>
+          <a:solidFill>
+            <a:srgbClr val="1B7F3A"/>
+          </a:solidFill>
+          <a:ln w="7620">
             <a:solidFill>
               <a:srgbClr val="111827"/>
             </a:solidFill>
@@ -9635,22 +11325,65 @@
       </p:sp>
       <p:sp>
         <p:nvSpPr>
-          <p:cNvPr id="14" name="Oval 13"/>
-          <p:cNvSpPr/>
-          <p:nvPr/>
-        </p:nvSpPr>
-        <p:spPr>
-          <a:xfrm>
-            <a:off x="5715000" y="2852928"/>
-            <a:ext cx="822960" cy="822960"/>
+          <p:cNvPr id="15" name="Rectangle 14"/>
+          <p:cNvSpPr/>
+          <p:nvPr/>
+        </p:nvSpPr>
+        <p:spPr>
+          <a:xfrm>
+            <a:off x="3259836" y="4347972"/>
+            <a:ext cx="131673" cy="592531"/>
+          </a:xfrm>
+          <a:prstGeom prst="rect">
+            <a:avLst/>
+          </a:prstGeom>
+          <a:solidFill>
+            <a:srgbClr val="78350F"/>
+          </a:solidFill>
+          <a:ln>
+            <a:noFill/>
+          </a:ln>
+        </p:spPr>
+        <p:style>
+          <a:lnRef idx="1">
+            <a:schemeClr val="accent1"/>
+          </a:lnRef>
+          <a:fillRef idx="3">
+            <a:schemeClr val="accent1"/>
+          </a:fillRef>
+          <a:effectRef idx="2">
+            <a:schemeClr val="accent1"/>
+          </a:effectRef>
+          <a:fontRef idx="minor">
+            <a:schemeClr val="lt1"/>
+          </a:fontRef>
+        </p:style>
+        <p:txBody>
+          <a:bodyPr rtlCol="0" anchor="ctr"/>
+          <a:lstStyle/>
+          <a:p>
+            <a:pPr algn="ctr"/>
+          </a:p>
+        </p:txBody>
+      </p:sp>
+      <p:sp>
+        <p:nvSpPr>
+          <p:cNvPr id="16" name="Oval 15"/>
+          <p:cNvSpPr/>
+          <p:nvPr/>
+        </p:nvSpPr>
+        <p:spPr>
+          <a:xfrm>
+            <a:off x="2971800" y="3813048"/>
+            <a:ext cx="707745" cy="707745"/>
           </a:xfrm>
           <a:prstGeom prst="ellipse">
             <a:avLst/>
           </a:prstGeom>
           <a:solidFill>
-            <a:srgbClr val="FCD116"/>
-          </a:solidFill>
-          <a:ln w="13970">
+            <a:srgbClr val="1B7F3A"/>
+          </a:solidFill>
+          <a:ln w="7620">
             <a:solidFill>
               <a:srgbClr val="111827"/>
             </a:solidFill>
@@ -9671,32 +11404,513 @@
           </a:fontRef>
         </p:style>
         <p:txBody>
-          <a:bodyPr rtlCol="0" anchor="ctr" wrap="square" lIns="101600" rIns="101600" tIns="38100" bIns="38100"/>
-          <a:lstStyle/>
-          <a:p>
-            <a:pPr algn="ctr"/>
-            <a:r>
-              <a:rPr sz="1300" b="1">
-                <a:solidFill>
-                  <a:srgbClr val="111827"/>
-                </a:solidFill>
-                <a:latin typeface="Arial"/>
-              </a:rPr>
-              <a:t>1</a:t>
-            </a:r>
-          </a:p>
-        </p:txBody>
-      </p:sp>
-      <p:sp>
-        <p:nvSpPr>
-          <p:cNvPr id="15" name="TextBox 14"/>
+          <a:bodyPr rtlCol="0" anchor="ctr"/>
+          <a:lstStyle/>
+          <a:p>
+            <a:pPr algn="ctr"/>
+          </a:p>
+        </p:txBody>
+      </p:sp>
+      <p:cxnSp>
+        <p:nvCxnSpPr>
+          <p:cNvPr id="17" name="Connector 16"/>
+          <p:cNvCxnSpPr/>
+          <p:nvPr/>
+        </p:nvCxnSpPr>
+        <p:spPr>
+          <a:xfrm flipV="1">
+            <a:off x="4434840" y="3401568"/>
+            <a:ext cx="1920239" cy="320040"/>
+          </a:xfrm>
+          <a:prstGeom prst="line">
+            <a:avLst/>
+          </a:prstGeom>
+          <a:ln w="22860">
+            <a:solidFill>
+              <a:srgbClr val="1D4ED8"/>
+            </a:solidFill>
+          </a:ln>
+        </p:spPr>
+        <p:style>
+          <a:lnRef idx="2">
+            <a:schemeClr val="accent1"/>
+          </a:lnRef>
+          <a:fillRef idx="0">
+            <a:schemeClr val="accent1"/>
+          </a:fillRef>
+          <a:effectRef idx="1">
+            <a:schemeClr val="accent1"/>
+          </a:effectRef>
+          <a:fontRef idx="minor">
+            <a:schemeClr val="tx1"/>
+          </a:fontRef>
+        </p:style>
+      </p:cxnSp>
+      <p:cxnSp>
+        <p:nvCxnSpPr>
+          <p:cNvPr id="18" name="Connector 17"/>
+          <p:cNvCxnSpPr/>
+          <p:nvPr/>
+        </p:nvCxnSpPr>
+        <p:spPr>
+          <a:xfrm flipV="1">
+            <a:off x="4434840" y="3813048"/>
+            <a:ext cx="1920239" cy="320040"/>
+          </a:xfrm>
+          <a:prstGeom prst="line">
+            <a:avLst/>
+          </a:prstGeom>
+          <a:ln w="22860">
+            <a:solidFill>
+              <a:srgbClr val="1D4ED8"/>
+            </a:solidFill>
+          </a:ln>
+        </p:spPr>
+        <p:style>
+          <a:lnRef idx="2">
+            <a:schemeClr val="accent1"/>
+          </a:lnRef>
+          <a:fillRef idx="0">
+            <a:schemeClr val="accent1"/>
+          </a:fillRef>
+          <a:effectRef idx="1">
+            <a:schemeClr val="accent1"/>
+          </a:effectRef>
+          <a:fontRef idx="minor">
+            <a:schemeClr val="tx1"/>
+          </a:fontRef>
+        </p:style>
+      </p:cxnSp>
+      <p:cxnSp>
+        <p:nvCxnSpPr>
+          <p:cNvPr id="19" name="Connector 18"/>
+          <p:cNvCxnSpPr/>
+          <p:nvPr/>
+        </p:nvCxnSpPr>
+        <p:spPr>
+          <a:xfrm flipV="1">
+            <a:off x="4434840" y="4224528"/>
+            <a:ext cx="1920239" cy="320040"/>
+          </a:xfrm>
+          <a:prstGeom prst="line">
+            <a:avLst/>
+          </a:prstGeom>
+          <a:ln w="22860">
+            <a:solidFill>
+              <a:srgbClr val="1D4ED8"/>
+            </a:solidFill>
+          </a:ln>
+        </p:spPr>
+        <p:style>
+          <a:lnRef idx="2">
+            <a:schemeClr val="accent1"/>
+          </a:lnRef>
+          <a:fillRef idx="0">
+            <a:schemeClr val="accent1"/>
+          </a:fillRef>
+          <a:effectRef idx="1">
+            <a:schemeClr val="accent1"/>
+          </a:effectRef>
+          <a:fontRef idx="minor">
+            <a:schemeClr val="tx1"/>
+          </a:fontRef>
+        </p:style>
+      </p:cxnSp>
+      <p:sp>
+        <p:nvSpPr>
+          <p:cNvPr id="20" name="Oval 19"/>
+          <p:cNvSpPr/>
+          <p:nvPr/>
+        </p:nvSpPr>
+        <p:spPr>
+          <a:xfrm>
+            <a:off x="7156094" y="3767328"/>
+            <a:ext cx="181051" cy="197510"/>
+          </a:xfrm>
+          <a:prstGeom prst="ellipse">
+            <a:avLst/>
+          </a:prstGeom>
+          <a:solidFill>
+            <a:srgbClr val="FCD116"/>
+          </a:solidFill>
+          <a:ln w="7620">
+            <a:solidFill>
+              <a:srgbClr val="111827"/>
+            </a:solidFill>
+          </a:ln>
+        </p:spPr>
+        <p:style>
+          <a:lnRef idx="1">
+            <a:schemeClr val="accent1"/>
+          </a:lnRef>
+          <a:fillRef idx="3">
+            <a:schemeClr val="accent1"/>
+          </a:fillRef>
+          <a:effectRef idx="2">
+            <a:schemeClr val="accent1"/>
+          </a:effectRef>
+          <a:fontRef idx="minor">
+            <a:schemeClr val="lt1"/>
+          </a:fontRef>
+        </p:style>
+        <p:txBody>
+          <a:bodyPr rtlCol="0" anchor="ctr"/>
+          <a:lstStyle/>
+          <a:p>
+            <a:pPr algn="ctr"/>
+          </a:p>
+        </p:txBody>
+      </p:sp>
+      <p:sp>
+        <p:nvSpPr>
+          <p:cNvPr id="21" name="Rounded Rectangle 20"/>
+          <p:cNvSpPr/>
+          <p:nvPr/>
+        </p:nvSpPr>
+        <p:spPr>
+          <a:xfrm>
+            <a:off x="7120890" y="4004340"/>
+            <a:ext cx="251460" cy="395020"/>
+          </a:xfrm>
+          <a:prstGeom prst="roundRect">
+            <a:avLst/>
+          </a:prstGeom>
+          <a:solidFill>
+            <a:srgbClr val="D90000"/>
+          </a:solidFill>
+          <a:ln w="7620">
+            <a:solidFill>
+              <a:srgbClr val="111827"/>
+            </a:solidFill>
+          </a:ln>
+        </p:spPr>
+        <p:style>
+          <a:lnRef idx="1">
+            <a:schemeClr val="accent1"/>
+          </a:lnRef>
+          <a:fillRef idx="3">
+            <a:schemeClr val="accent1"/>
+          </a:fillRef>
+          <a:effectRef idx="2">
+            <a:schemeClr val="accent1"/>
+          </a:effectRef>
+          <a:fontRef idx="minor">
+            <a:schemeClr val="lt1"/>
+          </a:fontRef>
+        </p:style>
+        <p:txBody>
+          <a:bodyPr rtlCol="0" anchor="ctr"/>
+          <a:lstStyle/>
+          <a:p>
+            <a:pPr algn="ctr"/>
+          </a:p>
+        </p:txBody>
+      </p:sp>
+      <p:cxnSp>
+        <p:nvCxnSpPr>
+          <p:cNvPr id="22" name="Connector 21"/>
+          <p:cNvCxnSpPr/>
+          <p:nvPr/>
+        </p:nvCxnSpPr>
+        <p:spPr>
+          <a:xfrm flipH="1">
+            <a:off x="7135977" y="4379610"/>
+            <a:ext cx="110643" cy="375270"/>
+          </a:xfrm>
+          <a:prstGeom prst="line">
+            <a:avLst/>
+          </a:prstGeom>
+          <a:ln w="12700">
+            <a:solidFill>
+              <a:srgbClr val="111827"/>
+            </a:solidFill>
+          </a:ln>
+        </p:spPr>
+        <p:style>
+          <a:lnRef idx="2">
+            <a:schemeClr val="accent1"/>
+          </a:lnRef>
+          <a:fillRef idx="0">
+            <a:schemeClr val="accent1"/>
+          </a:fillRef>
+          <a:effectRef idx="1">
+            <a:schemeClr val="accent1"/>
+          </a:effectRef>
+          <a:fontRef idx="minor">
+            <a:schemeClr val="tx1"/>
+          </a:fontRef>
+        </p:style>
+      </p:cxnSp>
+      <p:cxnSp>
+        <p:nvCxnSpPr>
+          <p:cNvPr id="23" name="Connector 22"/>
+          <p:cNvCxnSpPr/>
+          <p:nvPr/>
+        </p:nvCxnSpPr>
+        <p:spPr>
+          <a:xfrm>
+            <a:off x="7246620" y="4379610"/>
+            <a:ext cx="110642" cy="375270"/>
+          </a:xfrm>
+          <a:prstGeom prst="line">
+            <a:avLst/>
+          </a:prstGeom>
+          <a:ln w="12700">
+            <a:solidFill>
+              <a:srgbClr val="111827"/>
+            </a:solidFill>
+          </a:ln>
+        </p:spPr>
+        <p:style>
+          <a:lnRef idx="2">
+            <a:schemeClr val="accent1"/>
+          </a:lnRef>
+          <a:fillRef idx="0">
+            <a:schemeClr val="accent1"/>
+          </a:fillRef>
+          <a:effectRef idx="1">
+            <a:schemeClr val="accent1"/>
+          </a:effectRef>
+          <a:fontRef idx="minor">
+            <a:schemeClr val="tx1"/>
+          </a:fontRef>
+        </p:style>
+      </p:cxnSp>
+      <p:sp>
+        <p:nvSpPr>
+          <p:cNvPr id="24" name="Oval 23"/>
+          <p:cNvSpPr/>
+          <p:nvPr/>
+        </p:nvSpPr>
+        <p:spPr>
+          <a:xfrm>
+            <a:off x="8458200" y="4548225"/>
+            <a:ext cx="652881" cy="528523"/>
+          </a:xfrm>
+          <a:prstGeom prst="ellipse">
+            <a:avLst/>
+          </a:prstGeom>
+          <a:solidFill>
+            <a:srgbClr val="475569"/>
+          </a:solidFill>
+          <a:ln w="7620">
+            <a:solidFill>
+              <a:srgbClr val="111827"/>
+            </a:solidFill>
+          </a:ln>
+        </p:spPr>
+        <p:style>
+          <a:lnRef idx="1">
+            <a:schemeClr val="accent1"/>
+          </a:lnRef>
+          <a:fillRef idx="3">
+            <a:schemeClr val="accent1"/>
+          </a:fillRef>
+          <a:effectRef idx="2">
+            <a:schemeClr val="accent1"/>
+          </a:effectRef>
+          <a:fontRef idx="minor">
+            <a:schemeClr val="lt1"/>
+          </a:fontRef>
+        </p:style>
+        <p:txBody>
+          <a:bodyPr rtlCol="0" anchor="ctr"/>
+          <a:lstStyle/>
+          <a:p>
+            <a:pPr algn="ctr"/>
+          </a:p>
+        </p:txBody>
+      </p:sp>
+      <p:sp>
+        <p:nvSpPr>
+          <p:cNvPr id="25" name="Oval 24"/>
+          <p:cNvSpPr/>
+          <p:nvPr/>
+        </p:nvSpPr>
+        <p:spPr>
+          <a:xfrm>
+            <a:off x="9359798" y="3584448"/>
+            <a:ext cx="652881" cy="528523"/>
+          </a:xfrm>
+          <a:prstGeom prst="ellipse">
+            <a:avLst/>
+          </a:prstGeom>
+          <a:solidFill>
+            <a:srgbClr val="475569"/>
+          </a:solidFill>
+          <a:ln w="7620">
+            <a:solidFill>
+              <a:srgbClr val="111827"/>
+            </a:solidFill>
+          </a:ln>
+        </p:spPr>
+        <p:style>
+          <a:lnRef idx="1">
+            <a:schemeClr val="accent1"/>
+          </a:lnRef>
+          <a:fillRef idx="3">
+            <a:schemeClr val="accent1"/>
+          </a:fillRef>
+          <a:effectRef idx="2">
+            <a:schemeClr val="accent1"/>
+          </a:effectRef>
+          <a:fontRef idx="minor">
+            <a:schemeClr val="lt1"/>
+          </a:fontRef>
+        </p:style>
+        <p:txBody>
+          <a:bodyPr rtlCol="0" anchor="ctr"/>
+          <a:lstStyle/>
+          <a:p>
+            <a:pPr algn="ctr"/>
+          </a:p>
+        </p:txBody>
+      </p:sp>
+      <p:sp>
+        <p:nvSpPr>
+          <p:cNvPr id="26" name="Oval 25"/>
+          <p:cNvSpPr/>
+          <p:nvPr/>
+        </p:nvSpPr>
+        <p:spPr>
+          <a:xfrm>
+            <a:off x="10261396" y="4548225"/>
+            <a:ext cx="652881" cy="528523"/>
+          </a:xfrm>
+          <a:prstGeom prst="ellipse">
+            <a:avLst/>
+          </a:prstGeom>
+          <a:solidFill>
+            <a:srgbClr val="475569"/>
+          </a:solidFill>
+          <a:ln w="7620">
+            <a:solidFill>
+              <a:srgbClr val="111827"/>
+            </a:solidFill>
+          </a:ln>
+        </p:spPr>
+        <p:style>
+          <a:lnRef idx="1">
+            <a:schemeClr val="accent1"/>
+          </a:lnRef>
+          <a:fillRef idx="3">
+            <a:schemeClr val="accent1"/>
+          </a:fillRef>
+          <a:effectRef idx="2">
+            <a:schemeClr val="accent1"/>
+          </a:effectRef>
+          <a:fontRef idx="minor">
+            <a:schemeClr val="lt1"/>
+          </a:fontRef>
+        </p:style>
+        <p:txBody>
+          <a:bodyPr rtlCol="0" anchor="ctr"/>
+          <a:lstStyle/>
+          <a:p>
+            <a:pPr algn="ctr"/>
+          </a:p>
+        </p:txBody>
+      </p:sp>
+      <p:sp>
+        <p:nvSpPr>
+          <p:cNvPr id="27" name="Oval 26"/>
+          <p:cNvSpPr/>
+          <p:nvPr/>
+        </p:nvSpPr>
+        <p:spPr>
+          <a:xfrm>
+            <a:off x="9235440" y="4392777"/>
+            <a:ext cx="854964" cy="590702"/>
+          </a:xfrm>
+          <a:prstGeom prst="ellipse">
+            <a:avLst/>
+          </a:prstGeom>
+          <a:solidFill>
+            <a:srgbClr val="FCD116"/>
+          </a:solidFill>
+          <a:ln w="10160">
+            <a:solidFill>
+              <a:srgbClr val="D90000"/>
+            </a:solidFill>
+          </a:ln>
+        </p:spPr>
+        <p:style>
+          <a:lnRef idx="1">
+            <a:schemeClr val="accent1"/>
+          </a:lnRef>
+          <a:fillRef idx="3">
+            <a:schemeClr val="accent1"/>
+          </a:fillRef>
+          <a:effectRef idx="2">
+            <a:schemeClr val="accent1"/>
+          </a:effectRef>
+          <a:fontRef idx="minor">
+            <a:schemeClr val="lt1"/>
+          </a:fontRef>
+        </p:style>
+        <p:txBody>
+          <a:bodyPr rtlCol="0" anchor="ctr"/>
+          <a:lstStyle/>
+          <a:p>
+            <a:pPr algn="ctr"/>
+          </a:p>
+        </p:txBody>
+      </p:sp>
+      <p:sp>
+        <p:nvSpPr>
+          <p:cNvPr id="28" name="Rounded Rectangle 27"/>
+          <p:cNvSpPr/>
+          <p:nvPr/>
+        </p:nvSpPr>
+        <p:spPr>
+          <a:xfrm>
+            <a:off x="1645919" y="5705856"/>
+            <a:ext cx="2758440" cy="713232"/>
+          </a:xfrm>
+          <a:prstGeom prst="roundRect">
+            <a:avLst/>
+          </a:prstGeom>
+          <a:solidFill>
+            <a:srgbClr val="FFFFFF"/>
+          </a:solidFill>
+          <a:ln w="11430">
+            <a:solidFill>
+              <a:srgbClr val="1B7F3A"/>
+            </a:solidFill>
+          </a:ln>
+        </p:spPr>
+        <p:style>
+          <a:lnRef idx="1">
+            <a:schemeClr val="accent1"/>
+          </a:lnRef>
+          <a:fillRef idx="3">
+            <a:schemeClr val="accent1"/>
+          </a:fillRef>
+          <a:effectRef idx="2">
+            <a:schemeClr val="accent1"/>
+          </a:effectRef>
+          <a:fontRef idx="minor">
+            <a:schemeClr val="lt1"/>
+          </a:fontRef>
+        </p:style>
+        <p:txBody>
+          <a:bodyPr rtlCol="0" anchor="ctr"/>
+          <a:lstStyle/>
+          <a:p>
+            <a:pPr algn="ctr"/>
+          </a:p>
+        </p:txBody>
+      </p:sp>
+      <p:sp>
+        <p:nvSpPr>
+          <p:cNvPr id="29" name="TextBox 28"/>
           <p:cNvSpPr txBox="1"/>
           <p:nvPr/>
         </p:nvSpPr>
         <p:spPr>
           <a:xfrm>
-            <a:off x="4782312" y="3785616"/>
-            <a:ext cx="2697480" cy="402336"/>
+            <a:off x="1755648" y="5843016"/>
+            <a:ext cx="2538984" cy="329184"/>
           </a:xfrm>
           <a:prstGeom prst="rect">
             <a:avLst/>
@@ -9724,24 +11938,24 @@
       </p:sp>
       <p:sp>
         <p:nvSpPr>
-          <p:cNvPr id="16" name="Oval 15"/>
-          <p:cNvSpPr/>
-          <p:nvPr/>
-        </p:nvSpPr>
-        <p:spPr>
-          <a:xfrm>
-            <a:off x="4251959" y="4910328"/>
-            <a:ext cx="822960" cy="822960"/>
-          </a:xfrm>
-          <a:prstGeom prst="ellipse">
-            <a:avLst/>
-          </a:prstGeom>
-          <a:solidFill>
-            <a:srgbClr val="D90000"/>
-          </a:solidFill>
-          <a:ln w="13970">
+          <p:cNvPr id="30" name="Rounded Rectangle 29"/>
+          <p:cNvSpPr/>
+          <p:nvPr/>
+        </p:nvSpPr>
+        <p:spPr>
+          <a:xfrm>
+            <a:off x="4724400" y="5705856"/>
+            <a:ext cx="2758440" cy="713232"/>
+          </a:xfrm>
+          <a:prstGeom prst="roundRect">
+            <a:avLst/>
+          </a:prstGeom>
+          <a:solidFill>
+            <a:srgbClr val="FFFFFF"/>
+          </a:solidFill>
+          <a:ln w="11430">
             <a:solidFill>
-              <a:srgbClr val="111827"/>
+              <a:srgbClr val="1B7F3A"/>
             </a:solidFill>
           </a:ln>
         </p:spPr>
@@ -9760,32 +11974,23 @@
           </a:fontRef>
         </p:style>
         <p:txBody>
-          <a:bodyPr rtlCol="0" anchor="ctr" wrap="square" lIns="101600" rIns="101600" tIns="38100" bIns="38100"/>
-          <a:lstStyle/>
-          <a:p>
-            <a:pPr algn="ctr"/>
-            <a:r>
-              <a:rPr sz="1300" b="1">
-                <a:solidFill>
-                  <a:srgbClr val="FFFFFF"/>
-                </a:solidFill>
-                <a:latin typeface="Arial"/>
-              </a:rPr>
-              <a:t>2</a:t>
-            </a:r>
-          </a:p>
-        </p:txBody>
-      </p:sp>
-      <p:sp>
-        <p:nvSpPr>
-          <p:cNvPr id="17" name="TextBox 16"/>
+          <a:bodyPr rtlCol="0" anchor="ctr"/>
+          <a:lstStyle/>
+          <a:p>
+            <a:pPr algn="ctr"/>
+          </a:p>
+        </p:txBody>
+      </p:sp>
+      <p:sp>
+        <p:nvSpPr>
+          <p:cNvPr id="31" name="TextBox 30"/>
           <p:cNvSpPr txBox="1"/>
           <p:nvPr/>
         </p:nvSpPr>
         <p:spPr>
           <a:xfrm>
-            <a:off x="3319271" y="5843016"/>
-            <a:ext cx="2697480" cy="402336"/>
+            <a:off x="4834128" y="5843016"/>
+            <a:ext cx="2538984" cy="329184"/>
           </a:xfrm>
           <a:prstGeom prst="rect">
             <a:avLst/>
@@ -9813,24 +12018,24 @@
       </p:sp>
       <p:sp>
         <p:nvSpPr>
-          <p:cNvPr id="18" name="Oval 17"/>
-          <p:cNvSpPr/>
-          <p:nvPr/>
-        </p:nvSpPr>
-        <p:spPr>
-          <a:xfrm>
-            <a:off x="7178040" y="4910328"/>
-            <a:ext cx="822960" cy="822960"/>
-          </a:xfrm>
-          <a:prstGeom prst="ellipse">
-            <a:avLst/>
-          </a:prstGeom>
-          <a:solidFill>
-            <a:srgbClr val="1B7F3A"/>
-          </a:solidFill>
-          <a:ln w="13970">
+          <p:cNvPr id="32" name="Rounded Rectangle 31"/>
+          <p:cNvSpPr/>
+          <p:nvPr/>
+        </p:nvSpPr>
+        <p:spPr>
+          <a:xfrm>
+            <a:off x="7802880" y="5705856"/>
+            <a:ext cx="2758440" cy="713232"/>
+          </a:xfrm>
+          <a:prstGeom prst="roundRect">
+            <a:avLst/>
+          </a:prstGeom>
+          <a:solidFill>
+            <a:srgbClr val="FFFFFF"/>
+          </a:solidFill>
+          <a:ln w="11430">
             <a:solidFill>
-              <a:srgbClr val="111827"/>
+              <a:srgbClr val="1B7F3A"/>
             </a:solidFill>
           </a:ln>
         </p:spPr>
@@ -9849,32 +12054,23 @@
           </a:fontRef>
         </p:style>
         <p:txBody>
-          <a:bodyPr rtlCol="0" anchor="ctr" wrap="square" lIns="101600" rIns="101600" tIns="38100" bIns="38100"/>
-          <a:lstStyle/>
-          <a:p>
-            <a:pPr algn="ctr"/>
-            <a:r>
-              <a:rPr sz="1300" b="1">
-                <a:solidFill>
-                  <a:srgbClr val="FFFFFF"/>
-                </a:solidFill>
-                <a:latin typeface="Arial"/>
-              </a:rPr>
-              <a:t>3</a:t>
-            </a:r>
-          </a:p>
-        </p:txBody>
-      </p:sp>
-      <p:sp>
-        <p:nvSpPr>
-          <p:cNvPr id="19" name="TextBox 18"/>
+          <a:bodyPr rtlCol="0" anchor="ctr"/>
+          <a:lstStyle/>
+          <a:p>
+            <a:pPr algn="ctr"/>
+          </a:p>
+        </p:txBody>
+      </p:sp>
+      <p:sp>
+        <p:nvSpPr>
+          <p:cNvPr id="33" name="TextBox 32"/>
           <p:cNvSpPr txBox="1"/>
           <p:nvPr/>
         </p:nvSpPr>
         <p:spPr>
           <a:xfrm>
-            <a:off x="6245352" y="5843016"/>
-            <a:ext cx="2697480" cy="402336"/>
+            <a:off x="7912608" y="5843016"/>
+            <a:ext cx="2538984" cy="329184"/>
           </a:xfrm>
           <a:prstGeom prst="rect">
             <a:avLst/>
@@ -9902,7 +12098,7 @@
       </p:sp>
       <p:sp>
         <p:nvSpPr>
-          <p:cNvPr id="20" name="Rounded Rectangle 19"/>
+          <p:cNvPr id="34" name="Rounded Rectangle 33"/>
           <p:cNvSpPr/>
           <p:nvPr/>
         </p:nvSpPr>
@@ -9947,7 +12143,7 @@
       </p:sp>
       <p:sp>
         <p:nvSpPr>
-          <p:cNvPr id="21" name="TextBox 20"/>
+          <p:cNvPr id="35" name="TextBox 34"/>
           <p:cNvSpPr txBox="1"/>
           <p:nvPr/>
         </p:nvSpPr>
@@ -9982,7 +12178,7 @@
       </p:sp>
       <p:sp>
         <p:nvSpPr>
-          <p:cNvPr id="22" name="TextBox 21"/>
+          <p:cNvPr id="36" name="TextBox 35"/>
           <p:cNvSpPr txBox="1"/>
           <p:nvPr/>
         </p:nvSpPr>

</xml_diff>

<commit_message>
Publish content-specific classroom visuals
</commit_message>
<xml_diff>
--- a/uganda-p7-mvp/p7_t1_christian_religious_education_0101/p7_t1_christian_religious_education_0101.pptx
+++ b/uganda-p7-mvp/p7_t1_christian_religious_education_0101/p7_t1_christian_religious_education_0101.pptx
@@ -3527,8 +3527,8 @@
         </p:nvSpPr>
         <p:spPr>
           <a:xfrm>
-            <a:off x="1417319" y="2322576"/>
-            <a:ext cx="9372600" cy="411480"/>
+            <a:off x="1417319" y="2286000"/>
+            <a:ext cx="9372600" cy="310896"/>
           </a:xfrm>
           <a:prstGeom prst="rect">
             <a:avLst/>
@@ -3543,7 +3543,7 @@
           <a:p>
             <a:pPr algn="ctr"/>
             <a:r>
-              <a:rPr sz="1800" b="1">
+              <a:rPr sz="1700" b="1">
                 <a:solidFill>
                   <a:srgbClr val="111827"/>
                 </a:solidFill>
@@ -3556,22 +3556,65 @@
       </p:sp>
       <p:sp>
         <p:nvSpPr>
-          <p:cNvPr id="13" name="Isosceles Triangle 12"/>
-          <p:cNvSpPr/>
-          <p:nvPr/>
-        </p:nvSpPr>
-        <p:spPr>
-          <a:xfrm>
-            <a:off x="4754879" y="2990088"/>
-            <a:ext cx="2651760" cy="2651760"/>
-          </a:xfrm>
-          <a:prstGeom prst="triangle">
-            <a:avLst/>
-          </a:prstGeom>
-          <a:solidFill>
-            <a:srgbClr val="FFF7E0"/>
-          </a:solidFill>
-          <a:ln w="22860">
+          <p:cNvPr id="13" name="Rectangle 12"/>
+          <p:cNvSpPr/>
+          <p:nvPr/>
+        </p:nvSpPr>
+        <p:spPr>
+          <a:xfrm>
+            <a:off x="2194560" y="4178808"/>
+            <a:ext cx="146304" cy="658368"/>
+          </a:xfrm>
+          <a:prstGeom prst="rect">
+            <a:avLst/>
+          </a:prstGeom>
+          <a:solidFill>
+            <a:srgbClr val="78350F"/>
+          </a:solidFill>
+          <a:ln>
+            <a:noFill/>
+          </a:ln>
+        </p:spPr>
+        <p:style>
+          <a:lnRef idx="1">
+            <a:schemeClr val="accent1"/>
+          </a:lnRef>
+          <a:fillRef idx="3">
+            <a:schemeClr val="accent1"/>
+          </a:fillRef>
+          <a:effectRef idx="2">
+            <a:schemeClr val="accent1"/>
+          </a:effectRef>
+          <a:fontRef idx="minor">
+            <a:schemeClr val="lt1"/>
+          </a:fontRef>
+        </p:style>
+        <p:txBody>
+          <a:bodyPr rtlCol="0" anchor="ctr"/>
+          <a:lstStyle/>
+          <a:p>
+            <a:pPr algn="ctr"/>
+          </a:p>
+        </p:txBody>
+      </p:sp>
+      <p:sp>
+        <p:nvSpPr>
+          <p:cNvPr id="14" name="Oval 13"/>
+          <p:cNvSpPr/>
+          <p:nvPr/>
+        </p:nvSpPr>
+        <p:spPr>
+          <a:xfrm>
+            <a:off x="1874519" y="3584448"/>
+            <a:ext cx="786384" cy="786384"/>
+          </a:xfrm>
+          <a:prstGeom prst="ellipse">
+            <a:avLst/>
+          </a:prstGeom>
+          <a:solidFill>
+            <a:srgbClr val="1B7F3A"/>
+          </a:solidFill>
+          <a:ln w="7620">
             <a:solidFill>
               <a:srgbClr val="111827"/>
             </a:solidFill>
@@ -3601,22 +3644,65 @@
       </p:sp>
       <p:sp>
         <p:nvSpPr>
-          <p:cNvPr id="14" name="Oval 13"/>
-          <p:cNvSpPr/>
-          <p:nvPr/>
-        </p:nvSpPr>
-        <p:spPr>
-          <a:xfrm>
-            <a:off x="5715000" y="2852928"/>
-            <a:ext cx="822960" cy="822960"/>
+          <p:cNvPr id="15" name="Rectangle 14"/>
+          <p:cNvSpPr/>
+          <p:nvPr/>
+        </p:nvSpPr>
+        <p:spPr>
+          <a:xfrm>
+            <a:off x="3259836" y="4347972"/>
+            <a:ext cx="131673" cy="592531"/>
+          </a:xfrm>
+          <a:prstGeom prst="rect">
+            <a:avLst/>
+          </a:prstGeom>
+          <a:solidFill>
+            <a:srgbClr val="78350F"/>
+          </a:solidFill>
+          <a:ln>
+            <a:noFill/>
+          </a:ln>
+        </p:spPr>
+        <p:style>
+          <a:lnRef idx="1">
+            <a:schemeClr val="accent1"/>
+          </a:lnRef>
+          <a:fillRef idx="3">
+            <a:schemeClr val="accent1"/>
+          </a:fillRef>
+          <a:effectRef idx="2">
+            <a:schemeClr val="accent1"/>
+          </a:effectRef>
+          <a:fontRef idx="minor">
+            <a:schemeClr val="lt1"/>
+          </a:fontRef>
+        </p:style>
+        <p:txBody>
+          <a:bodyPr rtlCol="0" anchor="ctr"/>
+          <a:lstStyle/>
+          <a:p>
+            <a:pPr algn="ctr"/>
+          </a:p>
+        </p:txBody>
+      </p:sp>
+      <p:sp>
+        <p:nvSpPr>
+          <p:cNvPr id="16" name="Oval 15"/>
+          <p:cNvSpPr/>
+          <p:nvPr/>
+        </p:nvSpPr>
+        <p:spPr>
+          <a:xfrm>
+            <a:off x="2971800" y="3813048"/>
+            <a:ext cx="707745" cy="707745"/>
           </a:xfrm>
           <a:prstGeom prst="ellipse">
             <a:avLst/>
           </a:prstGeom>
           <a:solidFill>
-            <a:srgbClr val="FCD116"/>
-          </a:solidFill>
-          <a:ln w="13970">
+            <a:srgbClr val="1B7F3A"/>
+          </a:solidFill>
+          <a:ln w="7620">
             <a:solidFill>
               <a:srgbClr val="111827"/>
             </a:solidFill>
@@ -3637,32 +3723,513 @@
           </a:fontRef>
         </p:style>
         <p:txBody>
-          <a:bodyPr rtlCol="0" anchor="ctr" wrap="square" lIns="101600" rIns="101600" tIns="38100" bIns="38100"/>
-          <a:lstStyle/>
-          <a:p>
-            <a:pPr algn="ctr"/>
-            <a:r>
-              <a:rPr sz="1300" b="1">
-                <a:solidFill>
-                  <a:srgbClr val="111827"/>
-                </a:solidFill>
-                <a:latin typeface="Arial"/>
-              </a:rPr>
-              <a:t>1</a:t>
-            </a:r>
-          </a:p>
-        </p:txBody>
-      </p:sp>
-      <p:sp>
-        <p:nvSpPr>
-          <p:cNvPr id="15" name="TextBox 14"/>
+          <a:bodyPr rtlCol="0" anchor="ctr"/>
+          <a:lstStyle/>
+          <a:p>
+            <a:pPr algn="ctr"/>
+          </a:p>
+        </p:txBody>
+      </p:sp>
+      <p:cxnSp>
+        <p:nvCxnSpPr>
+          <p:cNvPr id="17" name="Connector 16"/>
+          <p:cNvCxnSpPr/>
+          <p:nvPr/>
+        </p:nvCxnSpPr>
+        <p:spPr>
+          <a:xfrm flipV="1">
+            <a:off x="4434840" y="3401568"/>
+            <a:ext cx="1920239" cy="320040"/>
+          </a:xfrm>
+          <a:prstGeom prst="line">
+            <a:avLst/>
+          </a:prstGeom>
+          <a:ln w="22860">
+            <a:solidFill>
+              <a:srgbClr val="1D4ED8"/>
+            </a:solidFill>
+          </a:ln>
+        </p:spPr>
+        <p:style>
+          <a:lnRef idx="2">
+            <a:schemeClr val="accent1"/>
+          </a:lnRef>
+          <a:fillRef idx="0">
+            <a:schemeClr val="accent1"/>
+          </a:fillRef>
+          <a:effectRef idx="1">
+            <a:schemeClr val="accent1"/>
+          </a:effectRef>
+          <a:fontRef idx="minor">
+            <a:schemeClr val="tx1"/>
+          </a:fontRef>
+        </p:style>
+      </p:cxnSp>
+      <p:cxnSp>
+        <p:nvCxnSpPr>
+          <p:cNvPr id="18" name="Connector 17"/>
+          <p:cNvCxnSpPr/>
+          <p:nvPr/>
+        </p:nvCxnSpPr>
+        <p:spPr>
+          <a:xfrm flipV="1">
+            <a:off x="4434840" y="3813048"/>
+            <a:ext cx="1920239" cy="320040"/>
+          </a:xfrm>
+          <a:prstGeom prst="line">
+            <a:avLst/>
+          </a:prstGeom>
+          <a:ln w="22860">
+            <a:solidFill>
+              <a:srgbClr val="1D4ED8"/>
+            </a:solidFill>
+          </a:ln>
+        </p:spPr>
+        <p:style>
+          <a:lnRef idx="2">
+            <a:schemeClr val="accent1"/>
+          </a:lnRef>
+          <a:fillRef idx="0">
+            <a:schemeClr val="accent1"/>
+          </a:fillRef>
+          <a:effectRef idx="1">
+            <a:schemeClr val="accent1"/>
+          </a:effectRef>
+          <a:fontRef idx="minor">
+            <a:schemeClr val="tx1"/>
+          </a:fontRef>
+        </p:style>
+      </p:cxnSp>
+      <p:cxnSp>
+        <p:nvCxnSpPr>
+          <p:cNvPr id="19" name="Connector 18"/>
+          <p:cNvCxnSpPr/>
+          <p:nvPr/>
+        </p:nvCxnSpPr>
+        <p:spPr>
+          <a:xfrm flipV="1">
+            <a:off x="4434840" y="4224528"/>
+            <a:ext cx="1920239" cy="320040"/>
+          </a:xfrm>
+          <a:prstGeom prst="line">
+            <a:avLst/>
+          </a:prstGeom>
+          <a:ln w="22860">
+            <a:solidFill>
+              <a:srgbClr val="1D4ED8"/>
+            </a:solidFill>
+          </a:ln>
+        </p:spPr>
+        <p:style>
+          <a:lnRef idx="2">
+            <a:schemeClr val="accent1"/>
+          </a:lnRef>
+          <a:fillRef idx="0">
+            <a:schemeClr val="accent1"/>
+          </a:fillRef>
+          <a:effectRef idx="1">
+            <a:schemeClr val="accent1"/>
+          </a:effectRef>
+          <a:fontRef idx="minor">
+            <a:schemeClr val="tx1"/>
+          </a:fontRef>
+        </p:style>
+      </p:cxnSp>
+      <p:sp>
+        <p:nvSpPr>
+          <p:cNvPr id="20" name="Oval 19"/>
+          <p:cNvSpPr/>
+          <p:nvPr/>
+        </p:nvSpPr>
+        <p:spPr>
+          <a:xfrm>
+            <a:off x="7156094" y="3767328"/>
+            <a:ext cx="181051" cy="197510"/>
+          </a:xfrm>
+          <a:prstGeom prst="ellipse">
+            <a:avLst/>
+          </a:prstGeom>
+          <a:solidFill>
+            <a:srgbClr val="FCD116"/>
+          </a:solidFill>
+          <a:ln w="7620">
+            <a:solidFill>
+              <a:srgbClr val="111827"/>
+            </a:solidFill>
+          </a:ln>
+        </p:spPr>
+        <p:style>
+          <a:lnRef idx="1">
+            <a:schemeClr val="accent1"/>
+          </a:lnRef>
+          <a:fillRef idx="3">
+            <a:schemeClr val="accent1"/>
+          </a:fillRef>
+          <a:effectRef idx="2">
+            <a:schemeClr val="accent1"/>
+          </a:effectRef>
+          <a:fontRef idx="minor">
+            <a:schemeClr val="lt1"/>
+          </a:fontRef>
+        </p:style>
+        <p:txBody>
+          <a:bodyPr rtlCol="0" anchor="ctr"/>
+          <a:lstStyle/>
+          <a:p>
+            <a:pPr algn="ctr"/>
+          </a:p>
+        </p:txBody>
+      </p:sp>
+      <p:sp>
+        <p:nvSpPr>
+          <p:cNvPr id="21" name="Rounded Rectangle 20"/>
+          <p:cNvSpPr/>
+          <p:nvPr/>
+        </p:nvSpPr>
+        <p:spPr>
+          <a:xfrm>
+            <a:off x="7120890" y="4004340"/>
+            <a:ext cx="251460" cy="395020"/>
+          </a:xfrm>
+          <a:prstGeom prst="roundRect">
+            <a:avLst/>
+          </a:prstGeom>
+          <a:solidFill>
+            <a:srgbClr val="D90000"/>
+          </a:solidFill>
+          <a:ln w="7620">
+            <a:solidFill>
+              <a:srgbClr val="111827"/>
+            </a:solidFill>
+          </a:ln>
+        </p:spPr>
+        <p:style>
+          <a:lnRef idx="1">
+            <a:schemeClr val="accent1"/>
+          </a:lnRef>
+          <a:fillRef idx="3">
+            <a:schemeClr val="accent1"/>
+          </a:fillRef>
+          <a:effectRef idx="2">
+            <a:schemeClr val="accent1"/>
+          </a:effectRef>
+          <a:fontRef idx="minor">
+            <a:schemeClr val="lt1"/>
+          </a:fontRef>
+        </p:style>
+        <p:txBody>
+          <a:bodyPr rtlCol="0" anchor="ctr"/>
+          <a:lstStyle/>
+          <a:p>
+            <a:pPr algn="ctr"/>
+          </a:p>
+        </p:txBody>
+      </p:sp>
+      <p:cxnSp>
+        <p:nvCxnSpPr>
+          <p:cNvPr id="22" name="Connector 21"/>
+          <p:cNvCxnSpPr/>
+          <p:nvPr/>
+        </p:nvCxnSpPr>
+        <p:spPr>
+          <a:xfrm flipH="1">
+            <a:off x="7135977" y="4379610"/>
+            <a:ext cx="110643" cy="375270"/>
+          </a:xfrm>
+          <a:prstGeom prst="line">
+            <a:avLst/>
+          </a:prstGeom>
+          <a:ln w="12700">
+            <a:solidFill>
+              <a:srgbClr val="111827"/>
+            </a:solidFill>
+          </a:ln>
+        </p:spPr>
+        <p:style>
+          <a:lnRef idx="2">
+            <a:schemeClr val="accent1"/>
+          </a:lnRef>
+          <a:fillRef idx="0">
+            <a:schemeClr val="accent1"/>
+          </a:fillRef>
+          <a:effectRef idx="1">
+            <a:schemeClr val="accent1"/>
+          </a:effectRef>
+          <a:fontRef idx="minor">
+            <a:schemeClr val="tx1"/>
+          </a:fontRef>
+        </p:style>
+      </p:cxnSp>
+      <p:cxnSp>
+        <p:nvCxnSpPr>
+          <p:cNvPr id="23" name="Connector 22"/>
+          <p:cNvCxnSpPr/>
+          <p:nvPr/>
+        </p:nvCxnSpPr>
+        <p:spPr>
+          <a:xfrm>
+            <a:off x="7246620" y="4379610"/>
+            <a:ext cx="110642" cy="375270"/>
+          </a:xfrm>
+          <a:prstGeom prst="line">
+            <a:avLst/>
+          </a:prstGeom>
+          <a:ln w="12700">
+            <a:solidFill>
+              <a:srgbClr val="111827"/>
+            </a:solidFill>
+          </a:ln>
+        </p:spPr>
+        <p:style>
+          <a:lnRef idx="2">
+            <a:schemeClr val="accent1"/>
+          </a:lnRef>
+          <a:fillRef idx="0">
+            <a:schemeClr val="accent1"/>
+          </a:fillRef>
+          <a:effectRef idx="1">
+            <a:schemeClr val="accent1"/>
+          </a:effectRef>
+          <a:fontRef idx="minor">
+            <a:schemeClr val="tx1"/>
+          </a:fontRef>
+        </p:style>
+      </p:cxnSp>
+      <p:sp>
+        <p:nvSpPr>
+          <p:cNvPr id="24" name="Oval 23"/>
+          <p:cNvSpPr/>
+          <p:nvPr/>
+        </p:nvSpPr>
+        <p:spPr>
+          <a:xfrm>
+            <a:off x="8458200" y="4548225"/>
+            <a:ext cx="652881" cy="528523"/>
+          </a:xfrm>
+          <a:prstGeom prst="ellipse">
+            <a:avLst/>
+          </a:prstGeom>
+          <a:solidFill>
+            <a:srgbClr val="475569"/>
+          </a:solidFill>
+          <a:ln w="7620">
+            <a:solidFill>
+              <a:srgbClr val="111827"/>
+            </a:solidFill>
+          </a:ln>
+        </p:spPr>
+        <p:style>
+          <a:lnRef idx="1">
+            <a:schemeClr val="accent1"/>
+          </a:lnRef>
+          <a:fillRef idx="3">
+            <a:schemeClr val="accent1"/>
+          </a:fillRef>
+          <a:effectRef idx="2">
+            <a:schemeClr val="accent1"/>
+          </a:effectRef>
+          <a:fontRef idx="minor">
+            <a:schemeClr val="lt1"/>
+          </a:fontRef>
+        </p:style>
+        <p:txBody>
+          <a:bodyPr rtlCol="0" anchor="ctr"/>
+          <a:lstStyle/>
+          <a:p>
+            <a:pPr algn="ctr"/>
+          </a:p>
+        </p:txBody>
+      </p:sp>
+      <p:sp>
+        <p:nvSpPr>
+          <p:cNvPr id="25" name="Oval 24"/>
+          <p:cNvSpPr/>
+          <p:nvPr/>
+        </p:nvSpPr>
+        <p:spPr>
+          <a:xfrm>
+            <a:off x="9359798" y="3584448"/>
+            <a:ext cx="652881" cy="528523"/>
+          </a:xfrm>
+          <a:prstGeom prst="ellipse">
+            <a:avLst/>
+          </a:prstGeom>
+          <a:solidFill>
+            <a:srgbClr val="475569"/>
+          </a:solidFill>
+          <a:ln w="7620">
+            <a:solidFill>
+              <a:srgbClr val="111827"/>
+            </a:solidFill>
+          </a:ln>
+        </p:spPr>
+        <p:style>
+          <a:lnRef idx="1">
+            <a:schemeClr val="accent1"/>
+          </a:lnRef>
+          <a:fillRef idx="3">
+            <a:schemeClr val="accent1"/>
+          </a:fillRef>
+          <a:effectRef idx="2">
+            <a:schemeClr val="accent1"/>
+          </a:effectRef>
+          <a:fontRef idx="minor">
+            <a:schemeClr val="lt1"/>
+          </a:fontRef>
+        </p:style>
+        <p:txBody>
+          <a:bodyPr rtlCol="0" anchor="ctr"/>
+          <a:lstStyle/>
+          <a:p>
+            <a:pPr algn="ctr"/>
+          </a:p>
+        </p:txBody>
+      </p:sp>
+      <p:sp>
+        <p:nvSpPr>
+          <p:cNvPr id="26" name="Oval 25"/>
+          <p:cNvSpPr/>
+          <p:nvPr/>
+        </p:nvSpPr>
+        <p:spPr>
+          <a:xfrm>
+            <a:off x="10261396" y="4548225"/>
+            <a:ext cx="652881" cy="528523"/>
+          </a:xfrm>
+          <a:prstGeom prst="ellipse">
+            <a:avLst/>
+          </a:prstGeom>
+          <a:solidFill>
+            <a:srgbClr val="475569"/>
+          </a:solidFill>
+          <a:ln w="7620">
+            <a:solidFill>
+              <a:srgbClr val="111827"/>
+            </a:solidFill>
+          </a:ln>
+        </p:spPr>
+        <p:style>
+          <a:lnRef idx="1">
+            <a:schemeClr val="accent1"/>
+          </a:lnRef>
+          <a:fillRef idx="3">
+            <a:schemeClr val="accent1"/>
+          </a:fillRef>
+          <a:effectRef idx="2">
+            <a:schemeClr val="accent1"/>
+          </a:effectRef>
+          <a:fontRef idx="minor">
+            <a:schemeClr val="lt1"/>
+          </a:fontRef>
+        </p:style>
+        <p:txBody>
+          <a:bodyPr rtlCol="0" anchor="ctr"/>
+          <a:lstStyle/>
+          <a:p>
+            <a:pPr algn="ctr"/>
+          </a:p>
+        </p:txBody>
+      </p:sp>
+      <p:sp>
+        <p:nvSpPr>
+          <p:cNvPr id="27" name="Oval 26"/>
+          <p:cNvSpPr/>
+          <p:nvPr/>
+        </p:nvSpPr>
+        <p:spPr>
+          <a:xfrm>
+            <a:off x="9235440" y="4392777"/>
+            <a:ext cx="854964" cy="590702"/>
+          </a:xfrm>
+          <a:prstGeom prst="ellipse">
+            <a:avLst/>
+          </a:prstGeom>
+          <a:solidFill>
+            <a:srgbClr val="FCD116"/>
+          </a:solidFill>
+          <a:ln w="10160">
+            <a:solidFill>
+              <a:srgbClr val="D90000"/>
+            </a:solidFill>
+          </a:ln>
+        </p:spPr>
+        <p:style>
+          <a:lnRef idx="1">
+            <a:schemeClr val="accent1"/>
+          </a:lnRef>
+          <a:fillRef idx="3">
+            <a:schemeClr val="accent1"/>
+          </a:fillRef>
+          <a:effectRef idx="2">
+            <a:schemeClr val="accent1"/>
+          </a:effectRef>
+          <a:fontRef idx="minor">
+            <a:schemeClr val="lt1"/>
+          </a:fontRef>
+        </p:style>
+        <p:txBody>
+          <a:bodyPr rtlCol="0" anchor="ctr"/>
+          <a:lstStyle/>
+          <a:p>
+            <a:pPr algn="ctr"/>
+          </a:p>
+        </p:txBody>
+      </p:sp>
+      <p:sp>
+        <p:nvSpPr>
+          <p:cNvPr id="28" name="Rounded Rectangle 27"/>
+          <p:cNvSpPr/>
+          <p:nvPr/>
+        </p:nvSpPr>
+        <p:spPr>
+          <a:xfrm>
+            <a:off x="1645919" y="5705856"/>
+            <a:ext cx="2758440" cy="713232"/>
+          </a:xfrm>
+          <a:prstGeom prst="roundRect">
+            <a:avLst/>
+          </a:prstGeom>
+          <a:solidFill>
+            <a:srgbClr val="FFFFFF"/>
+          </a:solidFill>
+          <a:ln w="11430">
+            <a:solidFill>
+              <a:srgbClr val="1D4ED8"/>
+            </a:solidFill>
+          </a:ln>
+        </p:spPr>
+        <p:style>
+          <a:lnRef idx="1">
+            <a:schemeClr val="accent1"/>
+          </a:lnRef>
+          <a:fillRef idx="3">
+            <a:schemeClr val="accent1"/>
+          </a:fillRef>
+          <a:effectRef idx="2">
+            <a:schemeClr val="accent1"/>
+          </a:effectRef>
+          <a:fontRef idx="minor">
+            <a:schemeClr val="lt1"/>
+          </a:fontRef>
+        </p:style>
+        <p:txBody>
+          <a:bodyPr rtlCol="0" anchor="ctr"/>
+          <a:lstStyle/>
+          <a:p>
+            <a:pPr algn="ctr"/>
+          </a:p>
+        </p:txBody>
+      </p:sp>
+      <p:sp>
+        <p:nvSpPr>
+          <p:cNvPr id="29" name="TextBox 28"/>
           <p:cNvSpPr txBox="1"/>
           <p:nvPr/>
         </p:nvSpPr>
         <p:spPr>
           <a:xfrm>
-            <a:off x="4782312" y="3785616"/>
-            <a:ext cx="2697480" cy="402336"/>
+            <a:off x="1755648" y="5843016"/>
+            <a:ext cx="2538984" cy="329184"/>
           </a:xfrm>
           <a:prstGeom prst="rect">
             <a:avLst/>
@@ -3690,24 +4257,24 @@
       </p:sp>
       <p:sp>
         <p:nvSpPr>
-          <p:cNvPr id="16" name="Oval 15"/>
-          <p:cNvSpPr/>
-          <p:nvPr/>
-        </p:nvSpPr>
-        <p:spPr>
-          <a:xfrm>
-            <a:off x="4251959" y="4910328"/>
-            <a:ext cx="822960" cy="822960"/>
-          </a:xfrm>
-          <a:prstGeom prst="ellipse">
-            <a:avLst/>
-          </a:prstGeom>
-          <a:solidFill>
-            <a:srgbClr val="D90000"/>
-          </a:solidFill>
-          <a:ln w="13970">
+          <p:cNvPr id="30" name="Rounded Rectangle 29"/>
+          <p:cNvSpPr/>
+          <p:nvPr/>
+        </p:nvSpPr>
+        <p:spPr>
+          <a:xfrm>
+            <a:off x="4724400" y="5705856"/>
+            <a:ext cx="2758440" cy="713232"/>
+          </a:xfrm>
+          <a:prstGeom prst="roundRect">
+            <a:avLst/>
+          </a:prstGeom>
+          <a:solidFill>
+            <a:srgbClr val="FFFFFF"/>
+          </a:solidFill>
+          <a:ln w="11430">
             <a:solidFill>
-              <a:srgbClr val="111827"/>
+              <a:srgbClr val="1D4ED8"/>
             </a:solidFill>
           </a:ln>
         </p:spPr>
@@ -3726,32 +4293,23 @@
           </a:fontRef>
         </p:style>
         <p:txBody>
-          <a:bodyPr rtlCol="0" anchor="ctr" wrap="square" lIns="101600" rIns="101600" tIns="38100" bIns="38100"/>
-          <a:lstStyle/>
-          <a:p>
-            <a:pPr algn="ctr"/>
-            <a:r>
-              <a:rPr sz="1300" b="1">
-                <a:solidFill>
-                  <a:srgbClr val="FFFFFF"/>
-                </a:solidFill>
-                <a:latin typeface="Arial"/>
-              </a:rPr>
-              <a:t>2</a:t>
-            </a:r>
-          </a:p>
-        </p:txBody>
-      </p:sp>
-      <p:sp>
-        <p:nvSpPr>
-          <p:cNvPr id="17" name="TextBox 16"/>
+          <a:bodyPr rtlCol="0" anchor="ctr"/>
+          <a:lstStyle/>
+          <a:p>
+            <a:pPr algn="ctr"/>
+          </a:p>
+        </p:txBody>
+      </p:sp>
+      <p:sp>
+        <p:nvSpPr>
+          <p:cNvPr id="31" name="TextBox 30"/>
           <p:cNvSpPr txBox="1"/>
           <p:nvPr/>
         </p:nvSpPr>
         <p:spPr>
           <a:xfrm>
-            <a:off x="3319271" y="5843016"/>
-            <a:ext cx="2697480" cy="402336"/>
+            <a:off x="4834128" y="5843016"/>
+            <a:ext cx="2538984" cy="329184"/>
           </a:xfrm>
           <a:prstGeom prst="rect">
             <a:avLst/>
@@ -3779,24 +4337,24 @@
       </p:sp>
       <p:sp>
         <p:nvSpPr>
-          <p:cNvPr id="18" name="Oval 17"/>
-          <p:cNvSpPr/>
-          <p:nvPr/>
-        </p:nvSpPr>
-        <p:spPr>
-          <a:xfrm>
-            <a:off x="7178040" y="4910328"/>
-            <a:ext cx="822960" cy="822960"/>
-          </a:xfrm>
-          <a:prstGeom prst="ellipse">
-            <a:avLst/>
-          </a:prstGeom>
-          <a:solidFill>
-            <a:srgbClr val="1B7F3A"/>
-          </a:solidFill>
-          <a:ln w="13970">
+          <p:cNvPr id="32" name="Rounded Rectangle 31"/>
+          <p:cNvSpPr/>
+          <p:nvPr/>
+        </p:nvSpPr>
+        <p:spPr>
+          <a:xfrm>
+            <a:off x="7802880" y="5705856"/>
+            <a:ext cx="2758440" cy="713232"/>
+          </a:xfrm>
+          <a:prstGeom prst="roundRect">
+            <a:avLst/>
+          </a:prstGeom>
+          <a:solidFill>
+            <a:srgbClr val="FFFFFF"/>
+          </a:solidFill>
+          <a:ln w="11430">
             <a:solidFill>
-              <a:srgbClr val="111827"/>
+              <a:srgbClr val="1D4ED8"/>
             </a:solidFill>
           </a:ln>
         </p:spPr>
@@ -3815,32 +4373,23 @@
           </a:fontRef>
         </p:style>
         <p:txBody>
-          <a:bodyPr rtlCol="0" anchor="ctr" wrap="square" lIns="101600" rIns="101600" tIns="38100" bIns="38100"/>
-          <a:lstStyle/>
-          <a:p>
-            <a:pPr algn="ctr"/>
-            <a:r>
-              <a:rPr sz="1300" b="1">
-                <a:solidFill>
-                  <a:srgbClr val="FFFFFF"/>
-                </a:solidFill>
-                <a:latin typeface="Arial"/>
-              </a:rPr>
-              <a:t>3</a:t>
-            </a:r>
-          </a:p>
-        </p:txBody>
-      </p:sp>
-      <p:sp>
-        <p:nvSpPr>
-          <p:cNvPr id="19" name="TextBox 18"/>
+          <a:bodyPr rtlCol="0" anchor="ctr"/>
+          <a:lstStyle/>
+          <a:p>
+            <a:pPr algn="ctr"/>
+          </a:p>
+        </p:txBody>
+      </p:sp>
+      <p:sp>
+        <p:nvSpPr>
+          <p:cNvPr id="33" name="TextBox 32"/>
           <p:cNvSpPr txBox="1"/>
           <p:nvPr/>
         </p:nvSpPr>
         <p:spPr>
           <a:xfrm>
-            <a:off x="6245352" y="5843016"/>
-            <a:ext cx="2697480" cy="402336"/>
+            <a:off x="7912608" y="5843016"/>
+            <a:ext cx="2538984" cy="329184"/>
           </a:xfrm>
           <a:prstGeom prst="rect">
             <a:avLst/>
@@ -6625,8 +7174,8 @@
         </p:nvSpPr>
         <p:spPr>
           <a:xfrm>
-            <a:off x="1417319" y="2322576"/>
-            <a:ext cx="9372600" cy="411480"/>
+            <a:off x="1417319" y="2286000"/>
+            <a:ext cx="9372600" cy="310896"/>
           </a:xfrm>
           <a:prstGeom prst="rect">
             <a:avLst/>
@@ -6641,7 +7190,7 @@
           <a:p>
             <a:pPr algn="ctr"/>
             <a:r>
-              <a:rPr sz="1800" b="1">
+              <a:rPr sz="1700" b="1">
                 <a:solidFill>
                   <a:srgbClr val="111827"/>
                 </a:solidFill>
@@ -6654,22 +7203,65 @@
       </p:sp>
       <p:sp>
         <p:nvSpPr>
-          <p:cNvPr id="13" name="Isosceles Triangle 12"/>
-          <p:cNvSpPr/>
-          <p:nvPr/>
-        </p:nvSpPr>
-        <p:spPr>
-          <a:xfrm>
-            <a:off x="4754879" y="2990088"/>
-            <a:ext cx="2651760" cy="2651760"/>
-          </a:xfrm>
-          <a:prstGeom prst="triangle">
-            <a:avLst/>
-          </a:prstGeom>
-          <a:solidFill>
-            <a:srgbClr val="FFF7E0"/>
-          </a:solidFill>
-          <a:ln w="22860">
+          <p:cNvPr id="13" name="Rectangle 12"/>
+          <p:cNvSpPr/>
+          <p:nvPr/>
+        </p:nvSpPr>
+        <p:spPr>
+          <a:xfrm>
+            <a:off x="2194560" y="4178808"/>
+            <a:ext cx="146304" cy="658368"/>
+          </a:xfrm>
+          <a:prstGeom prst="rect">
+            <a:avLst/>
+          </a:prstGeom>
+          <a:solidFill>
+            <a:srgbClr val="78350F"/>
+          </a:solidFill>
+          <a:ln>
+            <a:noFill/>
+          </a:ln>
+        </p:spPr>
+        <p:style>
+          <a:lnRef idx="1">
+            <a:schemeClr val="accent1"/>
+          </a:lnRef>
+          <a:fillRef idx="3">
+            <a:schemeClr val="accent1"/>
+          </a:fillRef>
+          <a:effectRef idx="2">
+            <a:schemeClr val="accent1"/>
+          </a:effectRef>
+          <a:fontRef idx="minor">
+            <a:schemeClr val="lt1"/>
+          </a:fontRef>
+        </p:style>
+        <p:txBody>
+          <a:bodyPr rtlCol="0" anchor="ctr"/>
+          <a:lstStyle/>
+          <a:p>
+            <a:pPr algn="ctr"/>
+          </a:p>
+        </p:txBody>
+      </p:sp>
+      <p:sp>
+        <p:nvSpPr>
+          <p:cNvPr id="14" name="Oval 13"/>
+          <p:cNvSpPr/>
+          <p:nvPr/>
+        </p:nvSpPr>
+        <p:spPr>
+          <a:xfrm>
+            <a:off x="1874519" y="3584448"/>
+            <a:ext cx="786384" cy="786384"/>
+          </a:xfrm>
+          <a:prstGeom prst="ellipse">
+            <a:avLst/>
+          </a:prstGeom>
+          <a:solidFill>
+            <a:srgbClr val="1B7F3A"/>
+          </a:solidFill>
+          <a:ln w="7620">
             <a:solidFill>
               <a:srgbClr val="111827"/>
             </a:solidFill>
@@ -6699,22 +7291,65 @@
       </p:sp>
       <p:sp>
         <p:nvSpPr>
-          <p:cNvPr id="14" name="Oval 13"/>
-          <p:cNvSpPr/>
-          <p:nvPr/>
-        </p:nvSpPr>
-        <p:spPr>
-          <a:xfrm>
-            <a:off x="5715000" y="2852928"/>
-            <a:ext cx="822960" cy="822960"/>
+          <p:cNvPr id="15" name="Rectangle 14"/>
+          <p:cNvSpPr/>
+          <p:nvPr/>
+        </p:nvSpPr>
+        <p:spPr>
+          <a:xfrm>
+            <a:off x="3259836" y="4347972"/>
+            <a:ext cx="131673" cy="592531"/>
+          </a:xfrm>
+          <a:prstGeom prst="rect">
+            <a:avLst/>
+          </a:prstGeom>
+          <a:solidFill>
+            <a:srgbClr val="78350F"/>
+          </a:solidFill>
+          <a:ln>
+            <a:noFill/>
+          </a:ln>
+        </p:spPr>
+        <p:style>
+          <a:lnRef idx="1">
+            <a:schemeClr val="accent1"/>
+          </a:lnRef>
+          <a:fillRef idx="3">
+            <a:schemeClr val="accent1"/>
+          </a:fillRef>
+          <a:effectRef idx="2">
+            <a:schemeClr val="accent1"/>
+          </a:effectRef>
+          <a:fontRef idx="minor">
+            <a:schemeClr val="lt1"/>
+          </a:fontRef>
+        </p:style>
+        <p:txBody>
+          <a:bodyPr rtlCol="0" anchor="ctr"/>
+          <a:lstStyle/>
+          <a:p>
+            <a:pPr algn="ctr"/>
+          </a:p>
+        </p:txBody>
+      </p:sp>
+      <p:sp>
+        <p:nvSpPr>
+          <p:cNvPr id="16" name="Oval 15"/>
+          <p:cNvSpPr/>
+          <p:nvPr/>
+        </p:nvSpPr>
+        <p:spPr>
+          <a:xfrm>
+            <a:off x="2971800" y="3813048"/>
+            <a:ext cx="707745" cy="707745"/>
           </a:xfrm>
           <a:prstGeom prst="ellipse">
             <a:avLst/>
           </a:prstGeom>
           <a:solidFill>
-            <a:srgbClr val="FCD116"/>
-          </a:solidFill>
-          <a:ln w="13970">
+            <a:srgbClr val="1B7F3A"/>
+          </a:solidFill>
+          <a:ln w="7620">
             <a:solidFill>
               <a:srgbClr val="111827"/>
             </a:solidFill>
@@ -6735,32 +7370,513 @@
           </a:fontRef>
         </p:style>
         <p:txBody>
-          <a:bodyPr rtlCol="0" anchor="ctr" wrap="square" lIns="101600" rIns="101600" tIns="38100" bIns="38100"/>
-          <a:lstStyle/>
-          <a:p>
-            <a:pPr algn="ctr"/>
-            <a:r>
-              <a:rPr sz="1300" b="1">
-                <a:solidFill>
-                  <a:srgbClr val="111827"/>
-                </a:solidFill>
-                <a:latin typeface="Arial"/>
-              </a:rPr>
-              <a:t>1</a:t>
-            </a:r>
-          </a:p>
-        </p:txBody>
-      </p:sp>
-      <p:sp>
-        <p:nvSpPr>
-          <p:cNvPr id="15" name="TextBox 14"/>
+          <a:bodyPr rtlCol="0" anchor="ctr"/>
+          <a:lstStyle/>
+          <a:p>
+            <a:pPr algn="ctr"/>
+          </a:p>
+        </p:txBody>
+      </p:sp>
+      <p:cxnSp>
+        <p:nvCxnSpPr>
+          <p:cNvPr id="17" name="Connector 16"/>
+          <p:cNvCxnSpPr/>
+          <p:nvPr/>
+        </p:nvCxnSpPr>
+        <p:spPr>
+          <a:xfrm flipV="1">
+            <a:off x="4434840" y="3401568"/>
+            <a:ext cx="1920239" cy="320040"/>
+          </a:xfrm>
+          <a:prstGeom prst="line">
+            <a:avLst/>
+          </a:prstGeom>
+          <a:ln w="22860">
+            <a:solidFill>
+              <a:srgbClr val="1D4ED8"/>
+            </a:solidFill>
+          </a:ln>
+        </p:spPr>
+        <p:style>
+          <a:lnRef idx="2">
+            <a:schemeClr val="accent1"/>
+          </a:lnRef>
+          <a:fillRef idx="0">
+            <a:schemeClr val="accent1"/>
+          </a:fillRef>
+          <a:effectRef idx="1">
+            <a:schemeClr val="accent1"/>
+          </a:effectRef>
+          <a:fontRef idx="minor">
+            <a:schemeClr val="tx1"/>
+          </a:fontRef>
+        </p:style>
+      </p:cxnSp>
+      <p:cxnSp>
+        <p:nvCxnSpPr>
+          <p:cNvPr id="18" name="Connector 17"/>
+          <p:cNvCxnSpPr/>
+          <p:nvPr/>
+        </p:nvCxnSpPr>
+        <p:spPr>
+          <a:xfrm flipV="1">
+            <a:off x="4434840" y="3813048"/>
+            <a:ext cx="1920239" cy="320040"/>
+          </a:xfrm>
+          <a:prstGeom prst="line">
+            <a:avLst/>
+          </a:prstGeom>
+          <a:ln w="22860">
+            <a:solidFill>
+              <a:srgbClr val="1D4ED8"/>
+            </a:solidFill>
+          </a:ln>
+        </p:spPr>
+        <p:style>
+          <a:lnRef idx="2">
+            <a:schemeClr val="accent1"/>
+          </a:lnRef>
+          <a:fillRef idx="0">
+            <a:schemeClr val="accent1"/>
+          </a:fillRef>
+          <a:effectRef idx="1">
+            <a:schemeClr val="accent1"/>
+          </a:effectRef>
+          <a:fontRef idx="minor">
+            <a:schemeClr val="tx1"/>
+          </a:fontRef>
+        </p:style>
+      </p:cxnSp>
+      <p:cxnSp>
+        <p:nvCxnSpPr>
+          <p:cNvPr id="19" name="Connector 18"/>
+          <p:cNvCxnSpPr/>
+          <p:nvPr/>
+        </p:nvCxnSpPr>
+        <p:spPr>
+          <a:xfrm flipV="1">
+            <a:off x="4434840" y="4224528"/>
+            <a:ext cx="1920239" cy="320040"/>
+          </a:xfrm>
+          <a:prstGeom prst="line">
+            <a:avLst/>
+          </a:prstGeom>
+          <a:ln w="22860">
+            <a:solidFill>
+              <a:srgbClr val="1D4ED8"/>
+            </a:solidFill>
+          </a:ln>
+        </p:spPr>
+        <p:style>
+          <a:lnRef idx="2">
+            <a:schemeClr val="accent1"/>
+          </a:lnRef>
+          <a:fillRef idx="0">
+            <a:schemeClr val="accent1"/>
+          </a:fillRef>
+          <a:effectRef idx="1">
+            <a:schemeClr val="accent1"/>
+          </a:effectRef>
+          <a:fontRef idx="minor">
+            <a:schemeClr val="tx1"/>
+          </a:fontRef>
+        </p:style>
+      </p:cxnSp>
+      <p:sp>
+        <p:nvSpPr>
+          <p:cNvPr id="20" name="Oval 19"/>
+          <p:cNvSpPr/>
+          <p:nvPr/>
+        </p:nvSpPr>
+        <p:spPr>
+          <a:xfrm>
+            <a:off x="7156094" y="3767328"/>
+            <a:ext cx="181051" cy="197510"/>
+          </a:xfrm>
+          <a:prstGeom prst="ellipse">
+            <a:avLst/>
+          </a:prstGeom>
+          <a:solidFill>
+            <a:srgbClr val="FCD116"/>
+          </a:solidFill>
+          <a:ln w="7620">
+            <a:solidFill>
+              <a:srgbClr val="111827"/>
+            </a:solidFill>
+          </a:ln>
+        </p:spPr>
+        <p:style>
+          <a:lnRef idx="1">
+            <a:schemeClr val="accent1"/>
+          </a:lnRef>
+          <a:fillRef idx="3">
+            <a:schemeClr val="accent1"/>
+          </a:fillRef>
+          <a:effectRef idx="2">
+            <a:schemeClr val="accent1"/>
+          </a:effectRef>
+          <a:fontRef idx="minor">
+            <a:schemeClr val="lt1"/>
+          </a:fontRef>
+        </p:style>
+        <p:txBody>
+          <a:bodyPr rtlCol="0" anchor="ctr"/>
+          <a:lstStyle/>
+          <a:p>
+            <a:pPr algn="ctr"/>
+          </a:p>
+        </p:txBody>
+      </p:sp>
+      <p:sp>
+        <p:nvSpPr>
+          <p:cNvPr id="21" name="Rounded Rectangle 20"/>
+          <p:cNvSpPr/>
+          <p:nvPr/>
+        </p:nvSpPr>
+        <p:spPr>
+          <a:xfrm>
+            <a:off x="7120890" y="4004340"/>
+            <a:ext cx="251460" cy="395020"/>
+          </a:xfrm>
+          <a:prstGeom prst="roundRect">
+            <a:avLst/>
+          </a:prstGeom>
+          <a:solidFill>
+            <a:srgbClr val="D90000"/>
+          </a:solidFill>
+          <a:ln w="7620">
+            <a:solidFill>
+              <a:srgbClr val="111827"/>
+            </a:solidFill>
+          </a:ln>
+        </p:spPr>
+        <p:style>
+          <a:lnRef idx="1">
+            <a:schemeClr val="accent1"/>
+          </a:lnRef>
+          <a:fillRef idx="3">
+            <a:schemeClr val="accent1"/>
+          </a:fillRef>
+          <a:effectRef idx="2">
+            <a:schemeClr val="accent1"/>
+          </a:effectRef>
+          <a:fontRef idx="minor">
+            <a:schemeClr val="lt1"/>
+          </a:fontRef>
+        </p:style>
+        <p:txBody>
+          <a:bodyPr rtlCol="0" anchor="ctr"/>
+          <a:lstStyle/>
+          <a:p>
+            <a:pPr algn="ctr"/>
+          </a:p>
+        </p:txBody>
+      </p:sp>
+      <p:cxnSp>
+        <p:nvCxnSpPr>
+          <p:cNvPr id="22" name="Connector 21"/>
+          <p:cNvCxnSpPr/>
+          <p:nvPr/>
+        </p:nvCxnSpPr>
+        <p:spPr>
+          <a:xfrm flipH="1">
+            <a:off x="7135977" y="4379610"/>
+            <a:ext cx="110643" cy="375270"/>
+          </a:xfrm>
+          <a:prstGeom prst="line">
+            <a:avLst/>
+          </a:prstGeom>
+          <a:ln w="12700">
+            <a:solidFill>
+              <a:srgbClr val="111827"/>
+            </a:solidFill>
+          </a:ln>
+        </p:spPr>
+        <p:style>
+          <a:lnRef idx="2">
+            <a:schemeClr val="accent1"/>
+          </a:lnRef>
+          <a:fillRef idx="0">
+            <a:schemeClr val="accent1"/>
+          </a:fillRef>
+          <a:effectRef idx="1">
+            <a:schemeClr val="accent1"/>
+          </a:effectRef>
+          <a:fontRef idx="minor">
+            <a:schemeClr val="tx1"/>
+          </a:fontRef>
+        </p:style>
+      </p:cxnSp>
+      <p:cxnSp>
+        <p:nvCxnSpPr>
+          <p:cNvPr id="23" name="Connector 22"/>
+          <p:cNvCxnSpPr/>
+          <p:nvPr/>
+        </p:nvCxnSpPr>
+        <p:spPr>
+          <a:xfrm>
+            <a:off x="7246620" y="4379610"/>
+            <a:ext cx="110642" cy="375270"/>
+          </a:xfrm>
+          <a:prstGeom prst="line">
+            <a:avLst/>
+          </a:prstGeom>
+          <a:ln w="12700">
+            <a:solidFill>
+              <a:srgbClr val="111827"/>
+            </a:solidFill>
+          </a:ln>
+        </p:spPr>
+        <p:style>
+          <a:lnRef idx="2">
+            <a:schemeClr val="accent1"/>
+          </a:lnRef>
+          <a:fillRef idx="0">
+            <a:schemeClr val="accent1"/>
+          </a:fillRef>
+          <a:effectRef idx="1">
+            <a:schemeClr val="accent1"/>
+          </a:effectRef>
+          <a:fontRef idx="minor">
+            <a:schemeClr val="tx1"/>
+          </a:fontRef>
+        </p:style>
+      </p:cxnSp>
+      <p:sp>
+        <p:nvSpPr>
+          <p:cNvPr id="24" name="Oval 23"/>
+          <p:cNvSpPr/>
+          <p:nvPr/>
+        </p:nvSpPr>
+        <p:spPr>
+          <a:xfrm>
+            <a:off x="8458200" y="4548225"/>
+            <a:ext cx="652881" cy="528523"/>
+          </a:xfrm>
+          <a:prstGeom prst="ellipse">
+            <a:avLst/>
+          </a:prstGeom>
+          <a:solidFill>
+            <a:srgbClr val="475569"/>
+          </a:solidFill>
+          <a:ln w="7620">
+            <a:solidFill>
+              <a:srgbClr val="111827"/>
+            </a:solidFill>
+          </a:ln>
+        </p:spPr>
+        <p:style>
+          <a:lnRef idx="1">
+            <a:schemeClr val="accent1"/>
+          </a:lnRef>
+          <a:fillRef idx="3">
+            <a:schemeClr val="accent1"/>
+          </a:fillRef>
+          <a:effectRef idx="2">
+            <a:schemeClr val="accent1"/>
+          </a:effectRef>
+          <a:fontRef idx="minor">
+            <a:schemeClr val="lt1"/>
+          </a:fontRef>
+        </p:style>
+        <p:txBody>
+          <a:bodyPr rtlCol="0" anchor="ctr"/>
+          <a:lstStyle/>
+          <a:p>
+            <a:pPr algn="ctr"/>
+          </a:p>
+        </p:txBody>
+      </p:sp>
+      <p:sp>
+        <p:nvSpPr>
+          <p:cNvPr id="25" name="Oval 24"/>
+          <p:cNvSpPr/>
+          <p:nvPr/>
+        </p:nvSpPr>
+        <p:spPr>
+          <a:xfrm>
+            <a:off x="9359798" y="3584448"/>
+            <a:ext cx="652881" cy="528523"/>
+          </a:xfrm>
+          <a:prstGeom prst="ellipse">
+            <a:avLst/>
+          </a:prstGeom>
+          <a:solidFill>
+            <a:srgbClr val="475569"/>
+          </a:solidFill>
+          <a:ln w="7620">
+            <a:solidFill>
+              <a:srgbClr val="111827"/>
+            </a:solidFill>
+          </a:ln>
+        </p:spPr>
+        <p:style>
+          <a:lnRef idx="1">
+            <a:schemeClr val="accent1"/>
+          </a:lnRef>
+          <a:fillRef idx="3">
+            <a:schemeClr val="accent1"/>
+          </a:fillRef>
+          <a:effectRef idx="2">
+            <a:schemeClr val="accent1"/>
+          </a:effectRef>
+          <a:fontRef idx="minor">
+            <a:schemeClr val="lt1"/>
+          </a:fontRef>
+        </p:style>
+        <p:txBody>
+          <a:bodyPr rtlCol="0" anchor="ctr"/>
+          <a:lstStyle/>
+          <a:p>
+            <a:pPr algn="ctr"/>
+          </a:p>
+        </p:txBody>
+      </p:sp>
+      <p:sp>
+        <p:nvSpPr>
+          <p:cNvPr id="26" name="Oval 25"/>
+          <p:cNvSpPr/>
+          <p:nvPr/>
+        </p:nvSpPr>
+        <p:spPr>
+          <a:xfrm>
+            <a:off x="10261396" y="4548225"/>
+            <a:ext cx="652881" cy="528523"/>
+          </a:xfrm>
+          <a:prstGeom prst="ellipse">
+            <a:avLst/>
+          </a:prstGeom>
+          <a:solidFill>
+            <a:srgbClr val="475569"/>
+          </a:solidFill>
+          <a:ln w="7620">
+            <a:solidFill>
+              <a:srgbClr val="111827"/>
+            </a:solidFill>
+          </a:ln>
+        </p:spPr>
+        <p:style>
+          <a:lnRef idx="1">
+            <a:schemeClr val="accent1"/>
+          </a:lnRef>
+          <a:fillRef idx="3">
+            <a:schemeClr val="accent1"/>
+          </a:fillRef>
+          <a:effectRef idx="2">
+            <a:schemeClr val="accent1"/>
+          </a:effectRef>
+          <a:fontRef idx="minor">
+            <a:schemeClr val="lt1"/>
+          </a:fontRef>
+        </p:style>
+        <p:txBody>
+          <a:bodyPr rtlCol="0" anchor="ctr"/>
+          <a:lstStyle/>
+          <a:p>
+            <a:pPr algn="ctr"/>
+          </a:p>
+        </p:txBody>
+      </p:sp>
+      <p:sp>
+        <p:nvSpPr>
+          <p:cNvPr id="27" name="Oval 26"/>
+          <p:cNvSpPr/>
+          <p:nvPr/>
+        </p:nvSpPr>
+        <p:spPr>
+          <a:xfrm>
+            <a:off x="9235440" y="4392777"/>
+            <a:ext cx="854964" cy="590702"/>
+          </a:xfrm>
+          <a:prstGeom prst="ellipse">
+            <a:avLst/>
+          </a:prstGeom>
+          <a:solidFill>
+            <a:srgbClr val="FCD116"/>
+          </a:solidFill>
+          <a:ln w="10160">
+            <a:solidFill>
+              <a:srgbClr val="D90000"/>
+            </a:solidFill>
+          </a:ln>
+        </p:spPr>
+        <p:style>
+          <a:lnRef idx="1">
+            <a:schemeClr val="accent1"/>
+          </a:lnRef>
+          <a:fillRef idx="3">
+            <a:schemeClr val="accent1"/>
+          </a:fillRef>
+          <a:effectRef idx="2">
+            <a:schemeClr val="accent1"/>
+          </a:effectRef>
+          <a:fontRef idx="minor">
+            <a:schemeClr val="lt1"/>
+          </a:fontRef>
+        </p:style>
+        <p:txBody>
+          <a:bodyPr rtlCol="0" anchor="ctr"/>
+          <a:lstStyle/>
+          <a:p>
+            <a:pPr algn="ctr"/>
+          </a:p>
+        </p:txBody>
+      </p:sp>
+      <p:sp>
+        <p:nvSpPr>
+          <p:cNvPr id="28" name="Rounded Rectangle 27"/>
+          <p:cNvSpPr/>
+          <p:nvPr/>
+        </p:nvSpPr>
+        <p:spPr>
+          <a:xfrm>
+            <a:off x="1645919" y="5705856"/>
+            <a:ext cx="2758440" cy="713232"/>
+          </a:xfrm>
+          <a:prstGeom prst="roundRect">
+            <a:avLst/>
+          </a:prstGeom>
+          <a:solidFill>
+            <a:srgbClr val="FFFFFF"/>
+          </a:solidFill>
+          <a:ln w="11430">
+            <a:solidFill>
+              <a:srgbClr val="087490"/>
+            </a:solidFill>
+          </a:ln>
+        </p:spPr>
+        <p:style>
+          <a:lnRef idx="1">
+            <a:schemeClr val="accent1"/>
+          </a:lnRef>
+          <a:fillRef idx="3">
+            <a:schemeClr val="accent1"/>
+          </a:fillRef>
+          <a:effectRef idx="2">
+            <a:schemeClr val="accent1"/>
+          </a:effectRef>
+          <a:fontRef idx="minor">
+            <a:schemeClr val="lt1"/>
+          </a:fontRef>
+        </p:style>
+        <p:txBody>
+          <a:bodyPr rtlCol="0" anchor="ctr"/>
+          <a:lstStyle/>
+          <a:p>
+            <a:pPr algn="ctr"/>
+          </a:p>
+        </p:txBody>
+      </p:sp>
+      <p:sp>
+        <p:nvSpPr>
+          <p:cNvPr id="29" name="TextBox 28"/>
           <p:cNvSpPr txBox="1"/>
           <p:nvPr/>
         </p:nvSpPr>
         <p:spPr>
           <a:xfrm>
-            <a:off x="4782312" y="3785616"/>
-            <a:ext cx="2697480" cy="402336"/>
+            <a:off x="1755648" y="5843016"/>
+            <a:ext cx="2538984" cy="329184"/>
           </a:xfrm>
           <a:prstGeom prst="rect">
             <a:avLst/>
@@ -6788,24 +7904,24 @@
       </p:sp>
       <p:sp>
         <p:nvSpPr>
-          <p:cNvPr id="16" name="Oval 15"/>
-          <p:cNvSpPr/>
-          <p:nvPr/>
-        </p:nvSpPr>
-        <p:spPr>
-          <a:xfrm>
-            <a:off x="4251959" y="4910328"/>
-            <a:ext cx="822960" cy="822960"/>
-          </a:xfrm>
-          <a:prstGeom prst="ellipse">
-            <a:avLst/>
-          </a:prstGeom>
-          <a:solidFill>
-            <a:srgbClr val="D90000"/>
-          </a:solidFill>
-          <a:ln w="13970">
+          <p:cNvPr id="30" name="Rounded Rectangle 29"/>
+          <p:cNvSpPr/>
+          <p:nvPr/>
+        </p:nvSpPr>
+        <p:spPr>
+          <a:xfrm>
+            <a:off x="4724400" y="5705856"/>
+            <a:ext cx="2758440" cy="713232"/>
+          </a:xfrm>
+          <a:prstGeom prst="roundRect">
+            <a:avLst/>
+          </a:prstGeom>
+          <a:solidFill>
+            <a:srgbClr val="FFFFFF"/>
+          </a:solidFill>
+          <a:ln w="11430">
             <a:solidFill>
-              <a:srgbClr val="111827"/>
+              <a:srgbClr val="087490"/>
             </a:solidFill>
           </a:ln>
         </p:spPr>
@@ -6824,32 +7940,23 @@
           </a:fontRef>
         </p:style>
         <p:txBody>
-          <a:bodyPr rtlCol="0" anchor="ctr" wrap="square" lIns="101600" rIns="101600" tIns="38100" bIns="38100"/>
-          <a:lstStyle/>
-          <a:p>
-            <a:pPr algn="ctr"/>
-            <a:r>
-              <a:rPr sz="1300" b="1">
-                <a:solidFill>
-                  <a:srgbClr val="FFFFFF"/>
-                </a:solidFill>
-                <a:latin typeface="Arial"/>
-              </a:rPr>
-              <a:t>2</a:t>
-            </a:r>
-          </a:p>
-        </p:txBody>
-      </p:sp>
-      <p:sp>
-        <p:nvSpPr>
-          <p:cNvPr id="17" name="TextBox 16"/>
+          <a:bodyPr rtlCol="0" anchor="ctr"/>
+          <a:lstStyle/>
+          <a:p>
+            <a:pPr algn="ctr"/>
+          </a:p>
+        </p:txBody>
+      </p:sp>
+      <p:sp>
+        <p:nvSpPr>
+          <p:cNvPr id="31" name="TextBox 30"/>
           <p:cNvSpPr txBox="1"/>
           <p:nvPr/>
         </p:nvSpPr>
         <p:spPr>
           <a:xfrm>
-            <a:off x="3319271" y="5843016"/>
-            <a:ext cx="2697480" cy="402336"/>
+            <a:off x="4834128" y="5843016"/>
+            <a:ext cx="2538984" cy="329184"/>
           </a:xfrm>
           <a:prstGeom prst="rect">
             <a:avLst/>
@@ -6877,24 +7984,24 @@
       </p:sp>
       <p:sp>
         <p:nvSpPr>
-          <p:cNvPr id="18" name="Oval 17"/>
-          <p:cNvSpPr/>
-          <p:nvPr/>
-        </p:nvSpPr>
-        <p:spPr>
-          <a:xfrm>
-            <a:off x="7178040" y="4910328"/>
-            <a:ext cx="822960" cy="822960"/>
-          </a:xfrm>
-          <a:prstGeom prst="ellipse">
-            <a:avLst/>
-          </a:prstGeom>
-          <a:solidFill>
-            <a:srgbClr val="1B7F3A"/>
-          </a:solidFill>
-          <a:ln w="13970">
+          <p:cNvPr id="32" name="Rounded Rectangle 31"/>
+          <p:cNvSpPr/>
+          <p:nvPr/>
+        </p:nvSpPr>
+        <p:spPr>
+          <a:xfrm>
+            <a:off x="7802880" y="5705856"/>
+            <a:ext cx="2758440" cy="713232"/>
+          </a:xfrm>
+          <a:prstGeom prst="roundRect">
+            <a:avLst/>
+          </a:prstGeom>
+          <a:solidFill>
+            <a:srgbClr val="FFFFFF"/>
+          </a:solidFill>
+          <a:ln w="11430">
             <a:solidFill>
-              <a:srgbClr val="111827"/>
+              <a:srgbClr val="087490"/>
             </a:solidFill>
           </a:ln>
         </p:spPr>
@@ -6913,32 +8020,23 @@
           </a:fontRef>
         </p:style>
         <p:txBody>
-          <a:bodyPr rtlCol="0" anchor="ctr" wrap="square" lIns="101600" rIns="101600" tIns="38100" bIns="38100"/>
-          <a:lstStyle/>
-          <a:p>
-            <a:pPr algn="ctr"/>
-            <a:r>
-              <a:rPr sz="1300" b="1">
-                <a:solidFill>
-                  <a:srgbClr val="FFFFFF"/>
-                </a:solidFill>
-                <a:latin typeface="Arial"/>
-              </a:rPr>
-              <a:t>3</a:t>
-            </a:r>
-          </a:p>
-        </p:txBody>
-      </p:sp>
-      <p:sp>
-        <p:nvSpPr>
-          <p:cNvPr id="19" name="TextBox 18"/>
+          <a:bodyPr rtlCol="0" anchor="ctr"/>
+          <a:lstStyle/>
+          <a:p>
+            <a:pPr algn="ctr"/>
+          </a:p>
+        </p:txBody>
+      </p:sp>
+      <p:sp>
+        <p:nvSpPr>
+          <p:cNvPr id="33" name="TextBox 32"/>
           <p:cNvSpPr txBox="1"/>
           <p:nvPr/>
         </p:nvSpPr>
         <p:spPr>
           <a:xfrm>
-            <a:off x="6245352" y="5843016"/>
-            <a:ext cx="2697480" cy="402336"/>
+            <a:off x="7912608" y="5843016"/>
+            <a:ext cx="2538984" cy="329184"/>
           </a:xfrm>
           <a:prstGeom prst="rect">
             <a:avLst/>
@@ -6966,7 +8064,7 @@
       </p:sp>
       <p:sp>
         <p:nvSpPr>
-          <p:cNvPr id="20" name="TextBox 19"/>
+          <p:cNvPr id="34" name="TextBox 33"/>
           <p:cNvSpPr txBox="1"/>
           <p:nvPr/>
         </p:nvSpPr>
@@ -7448,8 +8546,8 @@
         </p:nvSpPr>
         <p:spPr>
           <a:xfrm>
-            <a:off x="1417319" y="2322576"/>
-            <a:ext cx="9372600" cy="411480"/>
+            <a:off x="1417319" y="2286000"/>
+            <a:ext cx="9372600" cy="310896"/>
           </a:xfrm>
           <a:prstGeom prst="rect">
             <a:avLst/>
@@ -7464,7 +8562,7 @@
           <a:p>
             <a:pPr algn="ctr"/>
             <a:r>
-              <a:rPr sz="1800" b="1">
+              <a:rPr sz="1700" b="1">
                 <a:solidFill>
                   <a:srgbClr val="111827"/>
                 </a:solidFill>
@@ -7477,22 +8575,65 @@
       </p:sp>
       <p:sp>
         <p:nvSpPr>
-          <p:cNvPr id="13" name="Isosceles Triangle 12"/>
-          <p:cNvSpPr/>
-          <p:nvPr/>
-        </p:nvSpPr>
-        <p:spPr>
-          <a:xfrm>
-            <a:off x="4754879" y="2990088"/>
-            <a:ext cx="2651760" cy="2651760"/>
-          </a:xfrm>
-          <a:prstGeom prst="triangle">
-            <a:avLst/>
-          </a:prstGeom>
-          <a:solidFill>
-            <a:srgbClr val="FFF7E0"/>
-          </a:solidFill>
-          <a:ln w="22860">
+          <p:cNvPr id="13" name="Rectangle 12"/>
+          <p:cNvSpPr/>
+          <p:nvPr/>
+        </p:nvSpPr>
+        <p:spPr>
+          <a:xfrm>
+            <a:off x="2194560" y="4178808"/>
+            <a:ext cx="146304" cy="658368"/>
+          </a:xfrm>
+          <a:prstGeom prst="rect">
+            <a:avLst/>
+          </a:prstGeom>
+          <a:solidFill>
+            <a:srgbClr val="78350F"/>
+          </a:solidFill>
+          <a:ln>
+            <a:noFill/>
+          </a:ln>
+        </p:spPr>
+        <p:style>
+          <a:lnRef idx="1">
+            <a:schemeClr val="accent1"/>
+          </a:lnRef>
+          <a:fillRef idx="3">
+            <a:schemeClr val="accent1"/>
+          </a:fillRef>
+          <a:effectRef idx="2">
+            <a:schemeClr val="accent1"/>
+          </a:effectRef>
+          <a:fontRef idx="minor">
+            <a:schemeClr val="lt1"/>
+          </a:fontRef>
+        </p:style>
+        <p:txBody>
+          <a:bodyPr rtlCol="0" anchor="ctr"/>
+          <a:lstStyle/>
+          <a:p>
+            <a:pPr algn="ctr"/>
+          </a:p>
+        </p:txBody>
+      </p:sp>
+      <p:sp>
+        <p:nvSpPr>
+          <p:cNvPr id="14" name="Oval 13"/>
+          <p:cNvSpPr/>
+          <p:nvPr/>
+        </p:nvSpPr>
+        <p:spPr>
+          <a:xfrm>
+            <a:off x="1874519" y="3584448"/>
+            <a:ext cx="786384" cy="786384"/>
+          </a:xfrm>
+          <a:prstGeom prst="ellipse">
+            <a:avLst/>
+          </a:prstGeom>
+          <a:solidFill>
+            <a:srgbClr val="1B7F3A"/>
+          </a:solidFill>
+          <a:ln w="7620">
             <a:solidFill>
               <a:srgbClr val="111827"/>
             </a:solidFill>
@@ -7522,22 +8663,65 @@
       </p:sp>
       <p:sp>
         <p:nvSpPr>
-          <p:cNvPr id="14" name="Oval 13"/>
-          <p:cNvSpPr/>
-          <p:nvPr/>
-        </p:nvSpPr>
-        <p:spPr>
-          <a:xfrm>
-            <a:off x="5715000" y="2852928"/>
-            <a:ext cx="822960" cy="822960"/>
+          <p:cNvPr id="15" name="Rectangle 14"/>
+          <p:cNvSpPr/>
+          <p:nvPr/>
+        </p:nvSpPr>
+        <p:spPr>
+          <a:xfrm>
+            <a:off x="3259836" y="4347972"/>
+            <a:ext cx="131673" cy="592531"/>
+          </a:xfrm>
+          <a:prstGeom prst="rect">
+            <a:avLst/>
+          </a:prstGeom>
+          <a:solidFill>
+            <a:srgbClr val="78350F"/>
+          </a:solidFill>
+          <a:ln>
+            <a:noFill/>
+          </a:ln>
+        </p:spPr>
+        <p:style>
+          <a:lnRef idx="1">
+            <a:schemeClr val="accent1"/>
+          </a:lnRef>
+          <a:fillRef idx="3">
+            <a:schemeClr val="accent1"/>
+          </a:fillRef>
+          <a:effectRef idx="2">
+            <a:schemeClr val="accent1"/>
+          </a:effectRef>
+          <a:fontRef idx="minor">
+            <a:schemeClr val="lt1"/>
+          </a:fontRef>
+        </p:style>
+        <p:txBody>
+          <a:bodyPr rtlCol="0" anchor="ctr"/>
+          <a:lstStyle/>
+          <a:p>
+            <a:pPr algn="ctr"/>
+          </a:p>
+        </p:txBody>
+      </p:sp>
+      <p:sp>
+        <p:nvSpPr>
+          <p:cNvPr id="16" name="Oval 15"/>
+          <p:cNvSpPr/>
+          <p:nvPr/>
+        </p:nvSpPr>
+        <p:spPr>
+          <a:xfrm>
+            <a:off x="2971800" y="3813048"/>
+            <a:ext cx="707745" cy="707745"/>
           </a:xfrm>
           <a:prstGeom prst="ellipse">
             <a:avLst/>
           </a:prstGeom>
           <a:solidFill>
-            <a:srgbClr val="FCD116"/>
-          </a:solidFill>
-          <a:ln w="13970">
+            <a:srgbClr val="1B7F3A"/>
+          </a:solidFill>
+          <a:ln w="7620">
             <a:solidFill>
               <a:srgbClr val="111827"/>
             </a:solidFill>
@@ -7558,32 +8742,513 @@
           </a:fontRef>
         </p:style>
         <p:txBody>
-          <a:bodyPr rtlCol="0" anchor="ctr" wrap="square" lIns="101600" rIns="101600" tIns="38100" bIns="38100"/>
-          <a:lstStyle/>
-          <a:p>
-            <a:pPr algn="ctr"/>
-            <a:r>
-              <a:rPr sz="1300" b="1">
-                <a:solidFill>
-                  <a:srgbClr val="111827"/>
-                </a:solidFill>
-                <a:latin typeface="Arial"/>
-              </a:rPr>
-              <a:t>1</a:t>
-            </a:r>
-          </a:p>
-        </p:txBody>
-      </p:sp>
-      <p:sp>
-        <p:nvSpPr>
-          <p:cNvPr id="15" name="TextBox 14"/>
+          <a:bodyPr rtlCol="0" anchor="ctr"/>
+          <a:lstStyle/>
+          <a:p>
+            <a:pPr algn="ctr"/>
+          </a:p>
+        </p:txBody>
+      </p:sp>
+      <p:cxnSp>
+        <p:nvCxnSpPr>
+          <p:cNvPr id="17" name="Connector 16"/>
+          <p:cNvCxnSpPr/>
+          <p:nvPr/>
+        </p:nvCxnSpPr>
+        <p:spPr>
+          <a:xfrm flipV="1">
+            <a:off x="4434840" y="3401568"/>
+            <a:ext cx="1920239" cy="320040"/>
+          </a:xfrm>
+          <a:prstGeom prst="line">
+            <a:avLst/>
+          </a:prstGeom>
+          <a:ln w="22860">
+            <a:solidFill>
+              <a:srgbClr val="1D4ED8"/>
+            </a:solidFill>
+          </a:ln>
+        </p:spPr>
+        <p:style>
+          <a:lnRef idx="2">
+            <a:schemeClr val="accent1"/>
+          </a:lnRef>
+          <a:fillRef idx="0">
+            <a:schemeClr val="accent1"/>
+          </a:fillRef>
+          <a:effectRef idx="1">
+            <a:schemeClr val="accent1"/>
+          </a:effectRef>
+          <a:fontRef idx="minor">
+            <a:schemeClr val="tx1"/>
+          </a:fontRef>
+        </p:style>
+      </p:cxnSp>
+      <p:cxnSp>
+        <p:nvCxnSpPr>
+          <p:cNvPr id="18" name="Connector 17"/>
+          <p:cNvCxnSpPr/>
+          <p:nvPr/>
+        </p:nvCxnSpPr>
+        <p:spPr>
+          <a:xfrm flipV="1">
+            <a:off x="4434840" y="3813048"/>
+            <a:ext cx="1920239" cy="320040"/>
+          </a:xfrm>
+          <a:prstGeom prst="line">
+            <a:avLst/>
+          </a:prstGeom>
+          <a:ln w="22860">
+            <a:solidFill>
+              <a:srgbClr val="1D4ED8"/>
+            </a:solidFill>
+          </a:ln>
+        </p:spPr>
+        <p:style>
+          <a:lnRef idx="2">
+            <a:schemeClr val="accent1"/>
+          </a:lnRef>
+          <a:fillRef idx="0">
+            <a:schemeClr val="accent1"/>
+          </a:fillRef>
+          <a:effectRef idx="1">
+            <a:schemeClr val="accent1"/>
+          </a:effectRef>
+          <a:fontRef idx="minor">
+            <a:schemeClr val="tx1"/>
+          </a:fontRef>
+        </p:style>
+      </p:cxnSp>
+      <p:cxnSp>
+        <p:nvCxnSpPr>
+          <p:cNvPr id="19" name="Connector 18"/>
+          <p:cNvCxnSpPr/>
+          <p:nvPr/>
+        </p:nvCxnSpPr>
+        <p:spPr>
+          <a:xfrm flipV="1">
+            <a:off x="4434840" y="4224528"/>
+            <a:ext cx="1920239" cy="320040"/>
+          </a:xfrm>
+          <a:prstGeom prst="line">
+            <a:avLst/>
+          </a:prstGeom>
+          <a:ln w="22860">
+            <a:solidFill>
+              <a:srgbClr val="1D4ED8"/>
+            </a:solidFill>
+          </a:ln>
+        </p:spPr>
+        <p:style>
+          <a:lnRef idx="2">
+            <a:schemeClr val="accent1"/>
+          </a:lnRef>
+          <a:fillRef idx="0">
+            <a:schemeClr val="accent1"/>
+          </a:fillRef>
+          <a:effectRef idx="1">
+            <a:schemeClr val="accent1"/>
+          </a:effectRef>
+          <a:fontRef idx="minor">
+            <a:schemeClr val="tx1"/>
+          </a:fontRef>
+        </p:style>
+      </p:cxnSp>
+      <p:sp>
+        <p:nvSpPr>
+          <p:cNvPr id="20" name="Oval 19"/>
+          <p:cNvSpPr/>
+          <p:nvPr/>
+        </p:nvSpPr>
+        <p:spPr>
+          <a:xfrm>
+            <a:off x="7156094" y="3767328"/>
+            <a:ext cx="181051" cy="197510"/>
+          </a:xfrm>
+          <a:prstGeom prst="ellipse">
+            <a:avLst/>
+          </a:prstGeom>
+          <a:solidFill>
+            <a:srgbClr val="FCD116"/>
+          </a:solidFill>
+          <a:ln w="7620">
+            <a:solidFill>
+              <a:srgbClr val="111827"/>
+            </a:solidFill>
+          </a:ln>
+        </p:spPr>
+        <p:style>
+          <a:lnRef idx="1">
+            <a:schemeClr val="accent1"/>
+          </a:lnRef>
+          <a:fillRef idx="3">
+            <a:schemeClr val="accent1"/>
+          </a:fillRef>
+          <a:effectRef idx="2">
+            <a:schemeClr val="accent1"/>
+          </a:effectRef>
+          <a:fontRef idx="minor">
+            <a:schemeClr val="lt1"/>
+          </a:fontRef>
+        </p:style>
+        <p:txBody>
+          <a:bodyPr rtlCol="0" anchor="ctr"/>
+          <a:lstStyle/>
+          <a:p>
+            <a:pPr algn="ctr"/>
+          </a:p>
+        </p:txBody>
+      </p:sp>
+      <p:sp>
+        <p:nvSpPr>
+          <p:cNvPr id="21" name="Rounded Rectangle 20"/>
+          <p:cNvSpPr/>
+          <p:nvPr/>
+        </p:nvSpPr>
+        <p:spPr>
+          <a:xfrm>
+            <a:off x="7120890" y="4004340"/>
+            <a:ext cx="251460" cy="395020"/>
+          </a:xfrm>
+          <a:prstGeom prst="roundRect">
+            <a:avLst/>
+          </a:prstGeom>
+          <a:solidFill>
+            <a:srgbClr val="D90000"/>
+          </a:solidFill>
+          <a:ln w="7620">
+            <a:solidFill>
+              <a:srgbClr val="111827"/>
+            </a:solidFill>
+          </a:ln>
+        </p:spPr>
+        <p:style>
+          <a:lnRef idx="1">
+            <a:schemeClr val="accent1"/>
+          </a:lnRef>
+          <a:fillRef idx="3">
+            <a:schemeClr val="accent1"/>
+          </a:fillRef>
+          <a:effectRef idx="2">
+            <a:schemeClr val="accent1"/>
+          </a:effectRef>
+          <a:fontRef idx="minor">
+            <a:schemeClr val="lt1"/>
+          </a:fontRef>
+        </p:style>
+        <p:txBody>
+          <a:bodyPr rtlCol="0" anchor="ctr"/>
+          <a:lstStyle/>
+          <a:p>
+            <a:pPr algn="ctr"/>
+          </a:p>
+        </p:txBody>
+      </p:sp>
+      <p:cxnSp>
+        <p:nvCxnSpPr>
+          <p:cNvPr id="22" name="Connector 21"/>
+          <p:cNvCxnSpPr/>
+          <p:nvPr/>
+        </p:nvCxnSpPr>
+        <p:spPr>
+          <a:xfrm flipH="1">
+            <a:off x="7135977" y="4379610"/>
+            <a:ext cx="110643" cy="375270"/>
+          </a:xfrm>
+          <a:prstGeom prst="line">
+            <a:avLst/>
+          </a:prstGeom>
+          <a:ln w="12700">
+            <a:solidFill>
+              <a:srgbClr val="111827"/>
+            </a:solidFill>
+          </a:ln>
+        </p:spPr>
+        <p:style>
+          <a:lnRef idx="2">
+            <a:schemeClr val="accent1"/>
+          </a:lnRef>
+          <a:fillRef idx="0">
+            <a:schemeClr val="accent1"/>
+          </a:fillRef>
+          <a:effectRef idx="1">
+            <a:schemeClr val="accent1"/>
+          </a:effectRef>
+          <a:fontRef idx="minor">
+            <a:schemeClr val="tx1"/>
+          </a:fontRef>
+        </p:style>
+      </p:cxnSp>
+      <p:cxnSp>
+        <p:nvCxnSpPr>
+          <p:cNvPr id="23" name="Connector 22"/>
+          <p:cNvCxnSpPr/>
+          <p:nvPr/>
+        </p:nvCxnSpPr>
+        <p:spPr>
+          <a:xfrm>
+            <a:off x="7246620" y="4379610"/>
+            <a:ext cx="110642" cy="375270"/>
+          </a:xfrm>
+          <a:prstGeom prst="line">
+            <a:avLst/>
+          </a:prstGeom>
+          <a:ln w="12700">
+            <a:solidFill>
+              <a:srgbClr val="111827"/>
+            </a:solidFill>
+          </a:ln>
+        </p:spPr>
+        <p:style>
+          <a:lnRef idx="2">
+            <a:schemeClr val="accent1"/>
+          </a:lnRef>
+          <a:fillRef idx="0">
+            <a:schemeClr val="accent1"/>
+          </a:fillRef>
+          <a:effectRef idx="1">
+            <a:schemeClr val="accent1"/>
+          </a:effectRef>
+          <a:fontRef idx="minor">
+            <a:schemeClr val="tx1"/>
+          </a:fontRef>
+        </p:style>
+      </p:cxnSp>
+      <p:sp>
+        <p:nvSpPr>
+          <p:cNvPr id="24" name="Oval 23"/>
+          <p:cNvSpPr/>
+          <p:nvPr/>
+        </p:nvSpPr>
+        <p:spPr>
+          <a:xfrm>
+            <a:off x="8458200" y="4548225"/>
+            <a:ext cx="652881" cy="528523"/>
+          </a:xfrm>
+          <a:prstGeom prst="ellipse">
+            <a:avLst/>
+          </a:prstGeom>
+          <a:solidFill>
+            <a:srgbClr val="475569"/>
+          </a:solidFill>
+          <a:ln w="7620">
+            <a:solidFill>
+              <a:srgbClr val="111827"/>
+            </a:solidFill>
+          </a:ln>
+        </p:spPr>
+        <p:style>
+          <a:lnRef idx="1">
+            <a:schemeClr val="accent1"/>
+          </a:lnRef>
+          <a:fillRef idx="3">
+            <a:schemeClr val="accent1"/>
+          </a:fillRef>
+          <a:effectRef idx="2">
+            <a:schemeClr val="accent1"/>
+          </a:effectRef>
+          <a:fontRef idx="minor">
+            <a:schemeClr val="lt1"/>
+          </a:fontRef>
+        </p:style>
+        <p:txBody>
+          <a:bodyPr rtlCol="0" anchor="ctr"/>
+          <a:lstStyle/>
+          <a:p>
+            <a:pPr algn="ctr"/>
+          </a:p>
+        </p:txBody>
+      </p:sp>
+      <p:sp>
+        <p:nvSpPr>
+          <p:cNvPr id="25" name="Oval 24"/>
+          <p:cNvSpPr/>
+          <p:nvPr/>
+        </p:nvSpPr>
+        <p:spPr>
+          <a:xfrm>
+            <a:off x="9359798" y="3584448"/>
+            <a:ext cx="652881" cy="528523"/>
+          </a:xfrm>
+          <a:prstGeom prst="ellipse">
+            <a:avLst/>
+          </a:prstGeom>
+          <a:solidFill>
+            <a:srgbClr val="475569"/>
+          </a:solidFill>
+          <a:ln w="7620">
+            <a:solidFill>
+              <a:srgbClr val="111827"/>
+            </a:solidFill>
+          </a:ln>
+        </p:spPr>
+        <p:style>
+          <a:lnRef idx="1">
+            <a:schemeClr val="accent1"/>
+          </a:lnRef>
+          <a:fillRef idx="3">
+            <a:schemeClr val="accent1"/>
+          </a:fillRef>
+          <a:effectRef idx="2">
+            <a:schemeClr val="accent1"/>
+          </a:effectRef>
+          <a:fontRef idx="minor">
+            <a:schemeClr val="lt1"/>
+          </a:fontRef>
+        </p:style>
+        <p:txBody>
+          <a:bodyPr rtlCol="0" anchor="ctr"/>
+          <a:lstStyle/>
+          <a:p>
+            <a:pPr algn="ctr"/>
+          </a:p>
+        </p:txBody>
+      </p:sp>
+      <p:sp>
+        <p:nvSpPr>
+          <p:cNvPr id="26" name="Oval 25"/>
+          <p:cNvSpPr/>
+          <p:nvPr/>
+        </p:nvSpPr>
+        <p:spPr>
+          <a:xfrm>
+            <a:off x="10261396" y="4548225"/>
+            <a:ext cx="652881" cy="528523"/>
+          </a:xfrm>
+          <a:prstGeom prst="ellipse">
+            <a:avLst/>
+          </a:prstGeom>
+          <a:solidFill>
+            <a:srgbClr val="475569"/>
+          </a:solidFill>
+          <a:ln w="7620">
+            <a:solidFill>
+              <a:srgbClr val="111827"/>
+            </a:solidFill>
+          </a:ln>
+        </p:spPr>
+        <p:style>
+          <a:lnRef idx="1">
+            <a:schemeClr val="accent1"/>
+          </a:lnRef>
+          <a:fillRef idx="3">
+            <a:schemeClr val="accent1"/>
+          </a:fillRef>
+          <a:effectRef idx="2">
+            <a:schemeClr val="accent1"/>
+          </a:effectRef>
+          <a:fontRef idx="minor">
+            <a:schemeClr val="lt1"/>
+          </a:fontRef>
+        </p:style>
+        <p:txBody>
+          <a:bodyPr rtlCol="0" anchor="ctr"/>
+          <a:lstStyle/>
+          <a:p>
+            <a:pPr algn="ctr"/>
+          </a:p>
+        </p:txBody>
+      </p:sp>
+      <p:sp>
+        <p:nvSpPr>
+          <p:cNvPr id="27" name="Oval 26"/>
+          <p:cNvSpPr/>
+          <p:nvPr/>
+        </p:nvSpPr>
+        <p:spPr>
+          <a:xfrm>
+            <a:off x="9235440" y="4392777"/>
+            <a:ext cx="854964" cy="590702"/>
+          </a:xfrm>
+          <a:prstGeom prst="ellipse">
+            <a:avLst/>
+          </a:prstGeom>
+          <a:solidFill>
+            <a:srgbClr val="FCD116"/>
+          </a:solidFill>
+          <a:ln w="10160">
+            <a:solidFill>
+              <a:srgbClr val="D90000"/>
+            </a:solidFill>
+          </a:ln>
+        </p:spPr>
+        <p:style>
+          <a:lnRef idx="1">
+            <a:schemeClr val="accent1"/>
+          </a:lnRef>
+          <a:fillRef idx="3">
+            <a:schemeClr val="accent1"/>
+          </a:fillRef>
+          <a:effectRef idx="2">
+            <a:schemeClr val="accent1"/>
+          </a:effectRef>
+          <a:fontRef idx="minor">
+            <a:schemeClr val="lt1"/>
+          </a:fontRef>
+        </p:style>
+        <p:txBody>
+          <a:bodyPr rtlCol="0" anchor="ctr"/>
+          <a:lstStyle/>
+          <a:p>
+            <a:pPr algn="ctr"/>
+          </a:p>
+        </p:txBody>
+      </p:sp>
+      <p:sp>
+        <p:nvSpPr>
+          <p:cNvPr id="28" name="Rounded Rectangle 27"/>
+          <p:cNvSpPr/>
+          <p:nvPr/>
+        </p:nvSpPr>
+        <p:spPr>
+          <a:xfrm>
+            <a:off x="1645919" y="5705856"/>
+            <a:ext cx="2758440" cy="713232"/>
+          </a:xfrm>
+          <a:prstGeom prst="roundRect">
+            <a:avLst/>
+          </a:prstGeom>
+          <a:solidFill>
+            <a:srgbClr val="FFFFFF"/>
+          </a:solidFill>
+          <a:ln w="11430">
+            <a:solidFill>
+              <a:srgbClr val="D97706"/>
+            </a:solidFill>
+          </a:ln>
+        </p:spPr>
+        <p:style>
+          <a:lnRef idx="1">
+            <a:schemeClr val="accent1"/>
+          </a:lnRef>
+          <a:fillRef idx="3">
+            <a:schemeClr val="accent1"/>
+          </a:fillRef>
+          <a:effectRef idx="2">
+            <a:schemeClr val="accent1"/>
+          </a:effectRef>
+          <a:fontRef idx="minor">
+            <a:schemeClr val="lt1"/>
+          </a:fontRef>
+        </p:style>
+        <p:txBody>
+          <a:bodyPr rtlCol="0" anchor="ctr"/>
+          <a:lstStyle/>
+          <a:p>
+            <a:pPr algn="ctr"/>
+          </a:p>
+        </p:txBody>
+      </p:sp>
+      <p:sp>
+        <p:nvSpPr>
+          <p:cNvPr id="29" name="TextBox 28"/>
           <p:cNvSpPr txBox="1"/>
           <p:nvPr/>
         </p:nvSpPr>
         <p:spPr>
           <a:xfrm>
-            <a:off x="4782312" y="3785616"/>
-            <a:ext cx="2697480" cy="402336"/>
+            <a:off x="1755648" y="5843016"/>
+            <a:ext cx="2538984" cy="329184"/>
           </a:xfrm>
           <a:prstGeom prst="rect">
             <a:avLst/>
@@ -7611,24 +9276,24 @@
       </p:sp>
       <p:sp>
         <p:nvSpPr>
-          <p:cNvPr id="16" name="Oval 15"/>
-          <p:cNvSpPr/>
-          <p:nvPr/>
-        </p:nvSpPr>
-        <p:spPr>
-          <a:xfrm>
-            <a:off x="4251959" y="4910328"/>
-            <a:ext cx="822960" cy="822960"/>
-          </a:xfrm>
-          <a:prstGeom prst="ellipse">
-            <a:avLst/>
-          </a:prstGeom>
-          <a:solidFill>
-            <a:srgbClr val="D90000"/>
-          </a:solidFill>
-          <a:ln w="13970">
+          <p:cNvPr id="30" name="Rounded Rectangle 29"/>
+          <p:cNvSpPr/>
+          <p:nvPr/>
+        </p:nvSpPr>
+        <p:spPr>
+          <a:xfrm>
+            <a:off x="4724400" y="5705856"/>
+            <a:ext cx="2758440" cy="713232"/>
+          </a:xfrm>
+          <a:prstGeom prst="roundRect">
+            <a:avLst/>
+          </a:prstGeom>
+          <a:solidFill>
+            <a:srgbClr val="FFFFFF"/>
+          </a:solidFill>
+          <a:ln w="11430">
             <a:solidFill>
-              <a:srgbClr val="111827"/>
+              <a:srgbClr val="D97706"/>
             </a:solidFill>
           </a:ln>
         </p:spPr>
@@ -7647,32 +9312,23 @@
           </a:fontRef>
         </p:style>
         <p:txBody>
-          <a:bodyPr rtlCol="0" anchor="ctr" wrap="square" lIns="101600" rIns="101600" tIns="38100" bIns="38100"/>
-          <a:lstStyle/>
-          <a:p>
-            <a:pPr algn="ctr"/>
-            <a:r>
-              <a:rPr sz="1300" b="1">
-                <a:solidFill>
-                  <a:srgbClr val="FFFFFF"/>
-                </a:solidFill>
-                <a:latin typeface="Arial"/>
-              </a:rPr>
-              <a:t>2</a:t>
-            </a:r>
-          </a:p>
-        </p:txBody>
-      </p:sp>
-      <p:sp>
-        <p:nvSpPr>
-          <p:cNvPr id="17" name="TextBox 16"/>
+          <a:bodyPr rtlCol="0" anchor="ctr"/>
+          <a:lstStyle/>
+          <a:p>
+            <a:pPr algn="ctr"/>
+          </a:p>
+        </p:txBody>
+      </p:sp>
+      <p:sp>
+        <p:nvSpPr>
+          <p:cNvPr id="31" name="TextBox 30"/>
           <p:cNvSpPr txBox="1"/>
           <p:nvPr/>
         </p:nvSpPr>
         <p:spPr>
           <a:xfrm>
-            <a:off x="3319271" y="5843016"/>
-            <a:ext cx="2697480" cy="402336"/>
+            <a:off x="4834128" y="5843016"/>
+            <a:ext cx="2538984" cy="329184"/>
           </a:xfrm>
           <a:prstGeom prst="rect">
             <a:avLst/>
@@ -7700,24 +9356,24 @@
       </p:sp>
       <p:sp>
         <p:nvSpPr>
-          <p:cNvPr id="18" name="Oval 17"/>
-          <p:cNvSpPr/>
-          <p:nvPr/>
-        </p:nvSpPr>
-        <p:spPr>
-          <a:xfrm>
-            <a:off x="7178040" y="4910328"/>
-            <a:ext cx="822960" cy="822960"/>
-          </a:xfrm>
-          <a:prstGeom prst="ellipse">
-            <a:avLst/>
-          </a:prstGeom>
-          <a:solidFill>
-            <a:srgbClr val="1B7F3A"/>
-          </a:solidFill>
-          <a:ln w="13970">
+          <p:cNvPr id="32" name="Rounded Rectangle 31"/>
+          <p:cNvSpPr/>
+          <p:nvPr/>
+        </p:nvSpPr>
+        <p:spPr>
+          <a:xfrm>
+            <a:off x="7802880" y="5705856"/>
+            <a:ext cx="2758440" cy="713232"/>
+          </a:xfrm>
+          <a:prstGeom prst="roundRect">
+            <a:avLst/>
+          </a:prstGeom>
+          <a:solidFill>
+            <a:srgbClr val="FFFFFF"/>
+          </a:solidFill>
+          <a:ln w="11430">
             <a:solidFill>
-              <a:srgbClr val="111827"/>
+              <a:srgbClr val="D97706"/>
             </a:solidFill>
           </a:ln>
         </p:spPr>
@@ -7736,32 +9392,23 @@
           </a:fontRef>
         </p:style>
         <p:txBody>
-          <a:bodyPr rtlCol="0" anchor="ctr" wrap="square" lIns="101600" rIns="101600" tIns="38100" bIns="38100"/>
-          <a:lstStyle/>
-          <a:p>
-            <a:pPr algn="ctr"/>
-            <a:r>
-              <a:rPr sz="1300" b="1">
-                <a:solidFill>
-                  <a:srgbClr val="FFFFFF"/>
-                </a:solidFill>
-                <a:latin typeface="Arial"/>
-              </a:rPr>
-              <a:t>3</a:t>
-            </a:r>
-          </a:p>
-        </p:txBody>
-      </p:sp>
-      <p:sp>
-        <p:nvSpPr>
-          <p:cNvPr id="19" name="TextBox 18"/>
+          <a:bodyPr rtlCol="0" anchor="ctr"/>
+          <a:lstStyle/>
+          <a:p>
+            <a:pPr algn="ctr"/>
+          </a:p>
+        </p:txBody>
+      </p:sp>
+      <p:sp>
+        <p:nvSpPr>
+          <p:cNvPr id="33" name="TextBox 32"/>
           <p:cNvSpPr txBox="1"/>
           <p:nvPr/>
         </p:nvSpPr>
         <p:spPr>
           <a:xfrm>
-            <a:off x="6245352" y="5843016"/>
-            <a:ext cx="2697480" cy="402336"/>
+            <a:off x="7912608" y="5843016"/>
+            <a:ext cx="2538984" cy="329184"/>
           </a:xfrm>
           <a:prstGeom prst="rect">
             <a:avLst/>
@@ -7789,7 +9436,7 @@
       </p:sp>
       <p:sp>
         <p:nvSpPr>
-          <p:cNvPr id="20" name="TextBox 19"/>
+          <p:cNvPr id="34" name="TextBox 33"/>
           <p:cNvSpPr txBox="1"/>
           <p:nvPr/>
         </p:nvSpPr>
@@ -9561,8 +11208,8 @@
         </p:nvSpPr>
         <p:spPr>
           <a:xfrm>
-            <a:off x="1417319" y="2322576"/>
-            <a:ext cx="9372600" cy="411480"/>
+            <a:off x="1417319" y="2286000"/>
+            <a:ext cx="9372600" cy="310896"/>
           </a:xfrm>
           <a:prstGeom prst="rect">
             <a:avLst/>
@@ -9577,7 +11224,7 @@
           <a:p>
             <a:pPr algn="ctr"/>
             <a:r>
-              <a:rPr sz="1800" b="1">
+              <a:rPr sz="1700" b="1">
                 <a:solidFill>
                   <a:srgbClr val="111827"/>
                 </a:solidFill>
@@ -9590,22 +11237,65 @@
       </p:sp>
       <p:sp>
         <p:nvSpPr>
-          <p:cNvPr id="13" name="Isosceles Triangle 12"/>
-          <p:cNvSpPr/>
-          <p:nvPr/>
-        </p:nvSpPr>
-        <p:spPr>
-          <a:xfrm>
-            <a:off x="4754879" y="2990088"/>
-            <a:ext cx="2651760" cy="2651760"/>
-          </a:xfrm>
-          <a:prstGeom prst="triangle">
-            <a:avLst/>
-          </a:prstGeom>
-          <a:solidFill>
-            <a:srgbClr val="FFF7E0"/>
-          </a:solidFill>
-          <a:ln w="22860">
+          <p:cNvPr id="13" name="Rectangle 12"/>
+          <p:cNvSpPr/>
+          <p:nvPr/>
+        </p:nvSpPr>
+        <p:spPr>
+          <a:xfrm>
+            <a:off x="2194560" y="4178808"/>
+            <a:ext cx="146304" cy="658368"/>
+          </a:xfrm>
+          <a:prstGeom prst="rect">
+            <a:avLst/>
+          </a:prstGeom>
+          <a:solidFill>
+            <a:srgbClr val="78350F"/>
+          </a:solidFill>
+          <a:ln>
+            <a:noFill/>
+          </a:ln>
+        </p:spPr>
+        <p:style>
+          <a:lnRef idx="1">
+            <a:schemeClr val="accent1"/>
+          </a:lnRef>
+          <a:fillRef idx="3">
+            <a:schemeClr val="accent1"/>
+          </a:fillRef>
+          <a:effectRef idx="2">
+            <a:schemeClr val="accent1"/>
+          </a:effectRef>
+          <a:fontRef idx="minor">
+            <a:schemeClr val="lt1"/>
+          </a:fontRef>
+        </p:style>
+        <p:txBody>
+          <a:bodyPr rtlCol="0" anchor="ctr"/>
+          <a:lstStyle/>
+          <a:p>
+            <a:pPr algn="ctr"/>
+          </a:p>
+        </p:txBody>
+      </p:sp>
+      <p:sp>
+        <p:nvSpPr>
+          <p:cNvPr id="14" name="Oval 13"/>
+          <p:cNvSpPr/>
+          <p:nvPr/>
+        </p:nvSpPr>
+        <p:spPr>
+          <a:xfrm>
+            <a:off x="1874519" y="3584448"/>
+            <a:ext cx="786384" cy="786384"/>
+          </a:xfrm>
+          <a:prstGeom prst="ellipse">
+            <a:avLst/>
+          </a:prstGeom>
+          <a:solidFill>
+            <a:srgbClr val="1B7F3A"/>
+          </a:solidFill>
+          <a:ln w="7620">
             <a:solidFill>
               <a:srgbClr val="111827"/>
             </a:solidFill>
@@ -9635,22 +11325,65 @@
       </p:sp>
       <p:sp>
         <p:nvSpPr>
-          <p:cNvPr id="14" name="Oval 13"/>
-          <p:cNvSpPr/>
-          <p:nvPr/>
-        </p:nvSpPr>
-        <p:spPr>
-          <a:xfrm>
-            <a:off x="5715000" y="2852928"/>
-            <a:ext cx="822960" cy="822960"/>
+          <p:cNvPr id="15" name="Rectangle 14"/>
+          <p:cNvSpPr/>
+          <p:nvPr/>
+        </p:nvSpPr>
+        <p:spPr>
+          <a:xfrm>
+            <a:off x="3259836" y="4347972"/>
+            <a:ext cx="131673" cy="592531"/>
+          </a:xfrm>
+          <a:prstGeom prst="rect">
+            <a:avLst/>
+          </a:prstGeom>
+          <a:solidFill>
+            <a:srgbClr val="78350F"/>
+          </a:solidFill>
+          <a:ln>
+            <a:noFill/>
+          </a:ln>
+        </p:spPr>
+        <p:style>
+          <a:lnRef idx="1">
+            <a:schemeClr val="accent1"/>
+          </a:lnRef>
+          <a:fillRef idx="3">
+            <a:schemeClr val="accent1"/>
+          </a:fillRef>
+          <a:effectRef idx="2">
+            <a:schemeClr val="accent1"/>
+          </a:effectRef>
+          <a:fontRef idx="minor">
+            <a:schemeClr val="lt1"/>
+          </a:fontRef>
+        </p:style>
+        <p:txBody>
+          <a:bodyPr rtlCol="0" anchor="ctr"/>
+          <a:lstStyle/>
+          <a:p>
+            <a:pPr algn="ctr"/>
+          </a:p>
+        </p:txBody>
+      </p:sp>
+      <p:sp>
+        <p:nvSpPr>
+          <p:cNvPr id="16" name="Oval 15"/>
+          <p:cNvSpPr/>
+          <p:nvPr/>
+        </p:nvSpPr>
+        <p:spPr>
+          <a:xfrm>
+            <a:off x="2971800" y="3813048"/>
+            <a:ext cx="707745" cy="707745"/>
           </a:xfrm>
           <a:prstGeom prst="ellipse">
             <a:avLst/>
           </a:prstGeom>
           <a:solidFill>
-            <a:srgbClr val="FCD116"/>
-          </a:solidFill>
-          <a:ln w="13970">
+            <a:srgbClr val="1B7F3A"/>
+          </a:solidFill>
+          <a:ln w="7620">
             <a:solidFill>
               <a:srgbClr val="111827"/>
             </a:solidFill>
@@ -9671,32 +11404,513 @@
           </a:fontRef>
         </p:style>
         <p:txBody>
-          <a:bodyPr rtlCol="0" anchor="ctr" wrap="square" lIns="101600" rIns="101600" tIns="38100" bIns="38100"/>
-          <a:lstStyle/>
-          <a:p>
-            <a:pPr algn="ctr"/>
-            <a:r>
-              <a:rPr sz="1300" b="1">
-                <a:solidFill>
-                  <a:srgbClr val="111827"/>
-                </a:solidFill>
-                <a:latin typeface="Arial"/>
-              </a:rPr>
-              <a:t>1</a:t>
-            </a:r>
-          </a:p>
-        </p:txBody>
-      </p:sp>
-      <p:sp>
-        <p:nvSpPr>
-          <p:cNvPr id="15" name="TextBox 14"/>
+          <a:bodyPr rtlCol="0" anchor="ctr"/>
+          <a:lstStyle/>
+          <a:p>
+            <a:pPr algn="ctr"/>
+          </a:p>
+        </p:txBody>
+      </p:sp>
+      <p:cxnSp>
+        <p:nvCxnSpPr>
+          <p:cNvPr id="17" name="Connector 16"/>
+          <p:cNvCxnSpPr/>
+          <p:nvPr/>
+        </p:nvCxnSpPr>
+        <p:spPr>
+          <a:xfrm flipV="1">
+            <a:off x="4434840" y="3401568"/>
+            <a:ext cx="1920239" cy="320040"/>
+          </a:xfrm>
+          <a:prstGeom prst="line">
+            <a:avLst/>
+          </a:prstGeom>
+          <a:ln w="22860">
+            <a:solidFill>
+              <a:srgbClr val="1D4ED8"/>
+            </a:solidFill>
+          </a:ln>
+        </p:spPr>
+        <p:style>
+          <a:lnRef idx="2">
+            <a:schemeClr val="accent1"/>
+          </a:lnRef>
+          <a:fillRef idx="0">
+            <a:schemeClr val="accent1"/>
+          </a:fillRef>
+          <a:effectRef idx="1">
+            <a:schemeClr val="accent1"/>
+          </a:effectRef>
+          <a:fontRef idx="minor">
+            <a:schemeClr val="tx1"/>
+          </a:fontRef>
+        </p:style>
+      </p:cxnSp>
+      <p:cxnSp>
+        <p:nvCxnSpPr>
+          <p:cNvPr id="18" name="Connector 17"/>
+          <p:cNvCxnSpPr/>
+          <p:nvPr/>
+        </p:nvCxnSpPr>
+        <p:spPr>
+          <a:xfrm flipV="1">
+            <a:off x="4434840" y="3813048"/>
+            <a:ext cx="1920239" cy="320040"/>
+          </a:xfrm>
+          <a:prstGeom prst="line">
+            <a:avLst/>
+          </a:prstGeom>
+          <a:ln w="22860">
+            <a:solidFill>
+              <a:srgbClr val="1D4ED8"/>
+            </a:solidFill>
+          </a:ln>
+        </p:spPr>
+        <p:style>
+          <a:lnRef idx="2">
+            <a:schemeClr val="accent1"/>
+          </a:lnRef>
+          <a:fillRef idx="0">
+            <a:schemeClr val="accent1"/>
+          </a:fillRef>
+          <a:effectRef idx="1">
+            <a:schemeClr val="accent1"/>
+          </a:effectRef>
+          <a:fontRef idx="minor">
+            <a:schemeClr val="tx1"/>
+          </a:fontRef>
+        </p:style>
+      </p:cxnSp>
+      <p:cxnSp>
+        <p:nvCxnSpPr>
+          <p:cNvPr id="19" name="Connector 18"/>
+          <p:cNvCxnSpPr/>
+          <p:nvPr/>
+        </p:nvCxnSpPr>
+        <p:spPr>
+          <a:xfrm flipV="1">
+            <a:off x="4434840" y="4224528"/>
+            <a:ext cx="1920239" cy="320040"/>
+          </a:xfrm>
+          <a:prstGeom prst="line">
+            <a:avLst/>
+          </a:prstGeom>
+          <a:ln w="22860">
+            <a:solidFill>
+              <a:srgbClr val="1D4ED8"/>
+            </a:solidFill>
+          </a:ln>
+        </p:spPr>
+        <p:style>
+          <a:lnRef idx="2">
+            <a:schemeClr val="accent1"/>
+          </a:lnRef>
+          <a:fillRef idx="0">
+            <a:schemeClr val="accent1"/>
+          </a:fillRef>
+          <a:effectRef idx="1">
+            <a:schemeClr val="accent1"/>
+          </a:effectRef>
+          <a:fontRef idx="minor">
+            <a:schemeClr val="tx1"/>
+          </a:fontRef>
+        </p:style>
+      </p:cxnSp>
+      <p:sp>
+        <p:nvSpPr>
+          <p:cNvPr id="20" name="Oval 19"/>
+          <p:cNvSpPr/>
+          <p:nvPr/>
+        </p:nvSpPr>
+        <p:spPr>
+          <a:xfrm>
+            <a:off x="7156094" y="3767328"/>
+            <a:ext cx="181051" cy="197510"/>
+          </a:xfrm>
+          <a:prstGeom prst="ellipse">
+            <a:avLst/>
+          </a:prstGeom>
+          <a:solidFill>
+            <a:srgbClr val="FCD116"/>
+          </a:solidFill>
+          <a:ln w="7620">
+            <a:solidFill>
+              <a:srgbClr val="111827"/>
+            </a:solidFill>
+          </a:ln>
+        </p:spPr>
+        <p:style>
+          <a:lnRef idx="1">
+            <a:schemeClr val="accent1"/>
+          </a:lnRef>
+          <a:fillRef idx="3">
+            <a:schemeClr val="accent1"/>
+          </a:fillRef>
+          <a:effectRef idx="2">
+            <a:schemeClr val="accent1"/>
+          </a:effectRef>
+          <a:fontRef idx="minor">
+            <a:schemeClr val="lt1"/>
+          </a:fontRef>
+        </p:style>
+        <p:txBody>
+          <a:bodyPr rtlCol="0" anchor="ctr"/>
+          <a:lstStyle/>
+          <a:p>
+            <a:pPr algn="ctr"/>
+          </a:p>
+        </p:txBody>
+      </p:sp>
+      <p:sp>
+        <p:nvSpPr>
+          <p:cNvPr id="21" name="Rounded Rectangle 20"/>
+          <p:cNvSpPr/>
+          <p:nvPr/>
+        </p:nvSpPr>
+        <p:spPr>
+          <a:xfrm>
+            <a:off x="7120890" y="4004340"/>
+            <a:ext cx="251460" cy="395020"/>
+          </a:xfrm>
+          <a:prstGeom prst="roundRect">
+            <a:avLst/>
+          </a:prstGeom>
+          <a:solidFill>
+            <a:srgbClr val="D90000"/>
+          </a:solidFill>
+          <a:ln w="7620">
+            <a:solidFill>
+              <a:srgbClr val="111827"/>
+            </a:solidFill>
+          </a:ln>
+        </p:spPr>
+        <p:style>
+          <a:lnRef idx="1">
+            <a:schemeClr val="accent1"/>
+          </a:lnRef>
+          <a:fillRef idx="3">
+            <a:schemeClr val="accent1"/>
+          </a:fillRef>
+          <a:effectRef idx="2">
+            <a:schemeClr val="accent1"/>
+          </a:effectRef>
+          <a:fontRef idx="minor">
+            <a:schemeClr val="lt1"/>
+          </a:fontRef>
+        </p:style>
+        <p:txBody>
+          <a:bodyPr rtlCol="0" anchor="ctr"/>
+          <a:lstStyle/>
+          <a:p>
+            <a:pPr algn="ctr"/>
+          </a:p>
+        </p:txBody>
+      </p:sp>
+      <p:cxnSp>
+        <p:nvCxnSpPr>
+          <p:cNvPr id="22" name="Connector 21"/>
+          <p:cNvCxnSpPr/>
+          <p:nvPr/>
+        </p:nvCxnSpPr>
+        <p:spPr>
+          <a:xfrm flipH="1">
+            <a:off x="7135977" y="4379610"/>
+            <a:ext cx="110643" cy="375270"/>
+          </a:xfrm>
+          <a:prstGeom prst="line">
+            <a:avLst/>
+          </a:prstGeom>
+          <a:ln w="12700">
+            <a:solidFill>
+              <a:srgbClr val="111827"/>
+            </a:solidFill>
+          </a:ln>
+        </p:spPr>
+        <p:style>
+          <a:lnRef idx="2">
+            <a:schemeClr val="accent1"/>
+          </a:lnRef>
+          <a:fillRef idx="0">
+            <a:schemeClr val="accent1"/>
+          </a:fillRef>
+          <a:effectRef idx="1">
+            <a:schemeClr val="accent1"/>
+          </a:effectRef>
+          <a:fontRef idx="minor">
+            <a:schemeClr val="tx1"/>
+          </a:fontRef>
+        </p:style>
+      </p:cxnSp>
+      <p:cxnSp>
+        <p:nvCxnSpPr>
+          <p:cNvPr id="23" name="Connector 22"/>
+          <p:cNvCxnSpPr/>
+          <p:nvPr/>
+        </p:nvCxnSpPr>
+        <p:spPr>
+          <a:xfrm>
+            <a:off x="7246620" y="4379610"/>
+            <a:ext cx="110642" cy="375270"/>
+          </a:xfrm>
+          <a:prstGeom prst="line">
+            <a:avLst/>
+          </a:prstGeom>
+          <a:ln w="12700">
+            <a:solidFill>
+              <a:srgbClr val="111827"/>
+            </a:solidFill>
+          </a:ln>
+        </p:spPr>
+        <p:style>
+          <a:lnRef idx="2">
+            <a:schemeClr val="accent1"/>
+          </a:lnRef>
+          <a:fillRef idx="0">
+            <a:schemeClr val="accent1"/>
+          </a:fillRef>
+          <a:effectRef idx="1">
+            <a:schemeClr val="accent1"/>
+          </a:effectRef>
+          <a:fontRef idx="minor">
+            <a:schemeClr val="tx1"/>
+          </a:fontRef>
+        </p:style>
+      </p:cxnSp>
+      <p:sp>
+        <p:nvSpPr>
+          <p:cNvPr id="24" name="Oval 23"/>
+          <p:cNvSpPr/>
+          <p:nvPr/>
+        </p:nvSpPr>
+        <p:spPr>
+          <a:xfrm>
+            <a:off x="8458200" y="4548225"/>
+            <a:ext cx="652881" cy="528523"/>
+          </a:xfrm>
+          <a:prstGeom prst="ellipse">
+            <a:avLst/>
+          </a:prstGeom>
+          <a:solidFill>
+            <a:srgbClr val="475569"/>
+          </a:solidFill>
+          <a:ln w="7620">
+            <a:solidFill>
+              <a:srgbClr val="111827"/>
+            </a:solidFill>
+          </a:ln>
+        </p:spPr>
+        <p:style>
+          <a:lnRef idx="1">
+            <a:schemeClr val="accent1"/>
+          </a:lnRef>
+          <a:fillRef idx="3">
+            <a:schemeClr val="accent1"/>
+          </a:fillRef>
+          <a:effectRef idx="2">
+            <a:schemeClr val="accent1"/>
+          </a:effectRef>
+          <a:fontRef idx="minor">
+            <a:schemeClr val="lt1"/>
+          </a:fontRef>
+        </p:style>
+        <p:txBody>
+          <a:bodyPr rtlCol="0" anchor="ctr"/>
+          <a:lstStyle/>
+          <a:p>
+            <a:pPr algn="ctr"/>
+          </a:p>
+        </p:txBody>
+      </p:sp>
+      <p:sp>
+        <p:nvSpPr>
+          <p:cNvPr id="25" name="Oval 24"/>
+          <p:cNvSpPr/>
+          <p:nvPr/>
+        </p:nvSpPr>
+        <p:spPr>
+          <a:xfrm>
+            <a:off x="9359798" y="3584448"/>
+            <a:ext cx="652881" cy="528523"/>
+          </a:xfrm>
+          <a:prstGeom prst="ellipse">
+            <a:avLst/>
+          </a:prstGeom>
+          <a:solidFill>
+            <a:srgbClr val="475569"/>
+          </a:solidFill>
+          <a:ln w="7620">
+            <a:solidFill>
+              <a:srgbClr val="111827"/>
+            </a:solidFill>
+          </a:ln>
+        </p:spPr>
+        <p:style>
+          <a:lnRef idx="1">
+            <a:schemeClr val="accent1"/>
+          </a:lnRef>
+          <a:fillRef idx="3">
+            <a:schemeClr val="accent1"/>
+          </a:fillRef>
+          <a:effectRef idx="2">
+            <a:schemeClr val="accent1"/>
+          </a:effectRef>
+          <a:fontRef idx="minor">
+            <a:schemeClr val="lt1"/>
+          </a:fontRef>
+        </p:style>
+        <p:txBody>
+          <a:bodyPr rtlCol="0" anchor="ctr"/>
+          <a:lstStyle/>
+          <a:p>
+            <a:pPr algn="ctr"/>
+          </a:p>
+        </p:txBody>
+      </p:sp>
+      <p:sp>
+        <p:nvSpPr>
+          <p:cNvPr id="26" name="Oval 25"/>
+          <p:cNvSpPr/>
+          <p:nvPr/>
+        </p:nvSpPr>
+        <p:spPr>
+          <a:xfrm>
+            <a:off x="10261396" y="4548225"/>
+            <a:ext cx="652881" cy="528523"/>
+          </a:xfrm>
+          <a:prstGeom prst="ellipse">
+            <a:avLst/>
+          </a:prstGeom>
+          <a:solidFill>
+            <a:srgbClr val="475569"/>
+          </a:solidFill>
+          <a:ln w="7620">
+            <a:solidFill>
+              <a:srgbClr val="111827"/>
+            </a:solidFill>
+          </a:ln>
+        </p:spPr>
+        <p:style>
+          <a:lnRef idx="1">
+            <a:schemeClr val="accent1"/>
+          </a:lnRef>
+          <a:fillRef idx="3">
+            <a:schemeClr val="accent1"/>
+          </a:fillRef>
+          <a:effectRef idx="2">
+            <a:schemeClr val="accent1"/>
+          </a:effectRef>
+          <a:fontRef idx="minor">
+            <a:schemeClr val="lt1"/>
+          </a:fontRef>
+        </p:style>
+        <p:txBody>
+          <a:bodyPr rtlCol="0" anchor="ctr"/>
+          <a:lstStyle/>
+          <a:p>
+            <a:pPr algn="ctr"/>
+          </a:p>
+        </p:txBody>
+      </p:sp>
+      <p:sp>
+        <p:nvSpPr>
+          <p:cNvPr id="27" name="Oval 26"/>
+          <p:cNvSpPr/>
+          <p:nvPr/>
+        </p:nvSpPr>
+        <p:spPr>
+          <a:xfrm>
+            <a:off x="9235440" y="4392777"/>
+            <a:ext cx="854964" cy="590702"/>
+          </a:xfrm>
+          <a:prstGeom prst="ellipse">
+            <a:avLst/>
+          </a:prstGeom>
+          <a:solidFill>
+            <a:srgbClr val="FCD116"/>
+          </a:solidFill>
+          <a:ln w="10160">
+            <a:solidFill>
+              <a:srgbClr val="D90000"/>
+            </a:solidFill>
+          </a:ln>
+        </p:spPr>
+        <p:style>
+          <a:lnRef idx="1">
+            <a:schemeClr val="accent1"/>
+          </a:lnRef>
+          <a:fillRef idx="3">
+            <a:schemeClr val="accent1"/>
+          </a:fillRef>
+          <a:effectRef idx="2">
+            <a:schemeClr val="accent1"/>
+          </a:effectRef>
+          <a:fontRef idx="minor">
+            <a:schemeClr val="lt1"/>
+          </a:fontRef>
+        </p:style>
+        <p:txBody>
+          <a:bodyPr rtlCol="0" anchor="ctr"/>
+          <a:lstStyle/>
+          <a:p>
+            <a:pPr algn="ctr"/>
+          </a:p>
+        </p:txBody>
+      </p:sp>
+      <p:sp>
+        <p:nvSpPr>
+          <p:cNvPr id="28" name="Rounded Rectangle 27"/>
+          <p:cNvSpPr/>
+          <p:nvPr/>
+        </p:nvSpPr>
+        <p:spPr>
+          <a:xfrm>
+            <a:off x="1645919" y="5705856"/>
+            <a:ext cx="2758440" cy="713232"/>
+          </a:xfrm>
+          <a:prstGeom prst="roundRect">
+            <a:avLst/>
+          </a:prstGeom>
+          <a:solidFill>
+            <a:srgbClr val="FFFFFF"/>
+          </a:solidFill>
+          <a:ln w="11430">
+            <a:solidFill>
+              <a:srgbClr val="1B7F3A"/>
+            </a:solidFill>
+          </a:ln>
+        </p:spPr>
+        <p:style>
+          <a:lnRef idx="1">
+            <a:schemeClr val="accent1"/>
+          </a:lnRef>
+          <a:fillRef idx="3">
+            <a:schemeClr val="accent1"/>
+          </a:fillRef>
+          <a:effectRef idx="2">
+            <a:schemeClr val="accent1"/>
+          </a:effectRef>
+          <a:fontRef idx="minor">
+            <a:schemeClr val="lt1"/>
+          </a:fontRef>
+        </p:style>
+        <p:txBody>
+          <a:bodyPr rtlCol="0" anchor="ctr"/>
+          <a:lstStyle/>
+          <a:p>
+            <a:pPr algn="ctr"/>
+          </a:p>
+        </p:txBody>
+      </p:sp>
+      <p:sp>
+        <p:nvSpPr>
+          <p:cNvPr id="29" name="TextBox 28"/>
           <p:cNvSpPr txBox="1"/>
           <p:nvPr/>
         </p:nvSpPr>
         <p:spPr>
           <a:xfrm>
-            <a:off x="4782312" y="3785616"/>
-            <a:ext cx="2697480" cy="402336"/>
+            <a:off x="1755648" y="5843016"/>
+            <a:ext cx="2538984" cy="329184"/>
           </a:xfrm>
           <a:prstGeom prst="rect">
             <a:avLst/>
@@ -9724,24 +11938,24 @@
       </p:sp>
       <p:sp>
         <p:nvSpPr>
-          <p:cNvPr id="16" name="Oval 15"/>
-          <p:cNvSpPr/>
-          <p:nvPr/>
-        </p:nvSpPr>
-        <p:spPr>
-          <a:xfrm>
-            <a:off x="4251959" y="4910328"/>
-            <a:ext cx="822960" cy="822960"/>
-          </a:xfrm>
-          <a:prstGeom prst="ellipse">
-            <a:avLst/>
-          </a:prstGeom>
-          <a:solidFill>
-            <a:srgbClr val="D90000"/>
-          </a:solidFill>
-          <a:ln w="13970">
+          <p:cNvPr id="30" name="Rounded Rectangle 29"/>
+          <p:cNvSpPr/>
+          <p:nvPr/>
+        </p:nvSpPr>
+        <p:spPr>
+          <a:xfrm>
+            <a:off x="4724400" y="5705856"/>
+            <a:ext cx="2758440" cy="713232"/>
+          </a:xfrm>
+          <a:prstGeom prst="roundRect">
+            <a:avLst/>
+          </a:prstGeom>
+          <a:solidFill>
+            <a:srgbClr val="FFFFFF"/>
+          </a:solidFill>
+          <a:ln w="11430">
             <a:solidFill>
-              <a:srgbClr val="111827"/>
+              <a:srgbClr val="1B7F3A"/>
             </a:solidFill>
           </a:ln>
         </p:spPr>
@@ -9760,32 +11974,23 @@
           </a:fontRef>
         </p:style>
         <p:txBody>
-          <a:bodyPr rtlCol="0" anchor="ctr" wrap="square" lIns="101600" rIns="101600" tIns="38100" bIns="38100"/>
-          <a:lstStyle/>
-          <a:p>
-            <a:pPr algn="ctr"/>
-            <a:r>
-              <a:rPr sz="1300" b="1">
-                <a:solidFill>
-                  <a:srgbClr val="FFFFFF"/>
-                </a:solidFill>
-                <a:latin typeface="Arial"/>
-              </a:rPr>
-              <a:t>2</a:t>
-            </a:r>
-          </a:p>
-        </p:txBody>
-      </p:sp>
-      <p:sp>
-        <p:nvSpPr>
-          <p:cNvPr id="17" name="TextBox 16"/>
+          <a:bodyPr rtlCol="0" anchor="ctr"/>
+          <a:lstStyle/>
+          <a:p>
+            <a:pPr algn="ctr"/>
+          </a:p>
+        </p:txBody>
+      </p:sp>
+      <p:sp>
+        <p:nvSpPr>
+          <p:cNvPr id="31" name="TextBox 30"/>
           <p:cNvSpPr txBox="1"/>
           <p:nvPr/>
         </p:nvSpPr>
         <p:spPr>
           <a:xfrm>
-            <a:off x="3319271" y="5843016"/>
-            <a:ext cx="2697480" cy="402336"/>
+            <a:off x="4834128" y="5843016"/>
+            <a:ext cx="2538984" cy="329184"/>
           </a:xfrm>
           <a:prstGeom prst="rect">
             <a:avLst/>
@@ -9813,24 +12018,24 @@
       </p:sp>
       <p:sp>
         <p:nvSpPr>
-          <p:cNvPr id="18" name="Oval 17"/>
-          <p:cNvSpPr/>
-          <p:nvPr/>
-        </p:nvSpPr>
-        <p:spPr>
-          <a:xfrm>
-            <a:off x="7178040" y="4910328"/>
-            <a:ext cx="822960" cy="822960"/>
-          </a:xfrm>
-          <a:prstGeom prst="ellipse">
-            <a:avLst/>
-          </a:prstGeom>
-          <a:solidFill>
-            <a:srgbClr val="1B7F3A"/>
-          </a:solidFill>
-          <a:ln w="13970">
+          <p:cNvPr id="32" name="Rounded Rectangle 31"/>
+          <p:cNvSpPr/>
+          <p:nvPr/>
+        </p:nvSpPr>
+        <p:spPr>
+          <a:xfrm>
+            <a:off x="7802880" y="5705856"/>
+            <a:ext cx="2758440" cy="713232"/>
+          </a:xfrm>
+          <a:prstGeom prst="roundRect">
+            <a:avLst/>
+          </a:prstGeom>
+          <a:solidFill>
+            <a:srgbClr val="FFFFFF"/>
+          </a:solidFill>
+          <a:ln w="11430">
             <a:solidFill>
-              <a:srgbClr val="111827"/>
+              <a:srgbClr val="1B7F3A"/>
             </a:solidFill>
           </a:ln>
         </p:spPr>
@@ -9849,32 +12054,23 @@
           </a:fontRef>
         </p:style>
         <p:txBody>
-          <a:bodyPr rtlCol="0" anchor="ctr" wrap="square" lIns="101600" rIns="101600" tIns="38100" bIns="38100"/>
-          <a:lstStyle/>
-          <a:p>
-            <a:pPr algn="ctr"/>
-            <a:r>
-              <a:rPr sz="1300" b="1">
-                <a:solidFill>
-                  <a:srgbClr val="FFFFFF"/>
-                </a:solidFill>
-                <a:latin typeface="Arial"/>
-              </a:rPr>
-              <a:t>3</a:t>
-            </a:r>
-          </a:p>
-        </p:txBody>
-      </p:sp>
-      <p:sp>
-        <p:nvSpPr>
-          <p:cNvPr id="19" name="TextBox 18"/>
+          <a:bodyPr rtlCol="0" anchor="ctr"/>
+          <a:lstStyle/>
+          <a:p>
+            <a:pPr algn="ctr"/>
+          </a:p>
+        </p:txBody>
+      </p:sp>
+      <p:sp>
+        <p:nvSpPr>
+          <p:cNvPr id="33" name="TextBox 32"/>
           <p:cNvSpPr txBox="1"/>
           <p:nvPr/>
         </p:nvSpPr>
         <p:spPr>
           <a:xfrm>
-            <a:off x="6245352" y="5843016"/>
-            <a:ext cx="2697480" cy="402336"/>
+            <a:off x="7912608" y="5843016"/>
+            <a:ext cx="2538984" cy="329184"/>
           </a:xfrm>
           <a:prstGeom prst="rect">
             <a:avLst/>
@@ -9902,7 +12098,7 @@
       </p:sp>
       <p:sp>
         <p:nvSpPr>
-          <p:cNvPr id="20" name="Rounded Rectangle 19"/>
+          <p:cNvPr id="34" name="Rounded Rectangle 33"/>
           <p:cNvSpPr/>
           <p:nvPr/>
         </p:nvSpPr>
@@ -9947,7 +12143,7 @@
       </p:sp>
       <p:sp>
         <p:nvSpPr>
-          <p:cNvPr id="21" name="TextBox 20"/>
+          <p:cNvPr id="35" name="TextBox 34"/>
           <p:cNvSpPr txBox="1"/>
           <p:nvPr/>
         </p:nvSpPr>
@@ -9982,7 +12178,7 @@
       </p:sp>
       <p:sp>
         <p:nvSpPr>
-          <p:cNvPr id="22" name="TextBox 21"/>
+          <p:cNvPr id="36" name="TextBox 35"/>
           <p:cNvSpPr txBox="1"/>
           <p:nvPr/>
         </p:nvSpPr>

</xml_diff>